<commit_message>
Scheduled snapshot t29 (2026-09-04): fresh IG/FB/YT/TT + rebuilt decks
Co-Authored-By: Claude Opus 4.7 (1M context) <noreply@anthropic.com>
</commit_message>
<xml_diff>
--- a/OVERALL_REPORT.pptx
+++ b/OVERALL_REPORT.pptx
@@ -3277,7 +3277,7 @@
                 </a:solidFill>
                 <a:latin typeface="Georgia"/>
               </a:rPr>
-              <a:t>Since Jun 8, 2026 · 2026-08-26</a:t>
+              <a:t>Since Jun 8, 2026 · 2026-09-04</a:t>
             </a:r>
           </a:p>
         </p:txBody>
@@ -3578,7 +3578,7 @@
                 </a:solidFill>
                 <a:latin typeface="Georgia"/>
               </a:rPr>
-              <a:t>496,706</a:t>
+              <a:t>523,196</a:t>
             </a:r>
           </a:p>
         </p:txBody>
@@ -3769,7 +3769,7 @@
                 </a:solidFill>
                 <a:latin typeface="Georgia"/>
               </a:rPr>
-              <a:t>407</a:t>
+              <a:t>459</a:t>
             </a:r>
           </a:p>
         </p:txBody>
@@ -3925,7 +3925,7 @@
                 </a:solidFill>
                 <a:latin typeface="Georgia"/>
               </a:rPr>
-              <a:t>15,732</a:t>
+              <a:t>16,902</a:t>
             </a:r>
           </a:p>
         </p:txBody>
@@ -4081,7 +4081,7 @@
                 </a:solidFill>
                 <a:latin typeface="Georgia"/>
               </a:rPr>
-              <a:t>1,220</a:t>
+              <a:t>1,139</a:t>
             </a:r>
           </a:p>
         </p:txBody>
@@ -4401,7 +4401,7 @@
                 </a:solidFill>
                 <a:latin typeface="Georgia"/>
               </a:rPr>
-              <a:t>138,759</a:t>
+              <a:t>151,078</a:t>
             </a:r>
           </a:p>
         </p:txBody>
@@ -4469,7 +4469,7 @@
                 </a:solidFill>
                 <a:latin typeface="Helvetica Neue"/>
               </a:rPr>
-              <a:t>131 posts</a:t>
+              <a:t>148 posts</a:t>
             </a:r>
           </a:p>
         </p:txBody>
@@ -4503,7 +4503,7 @@
                 </a:solidFill>
                 <a:latin typeface="Helvetica Neue"/>
               </a:rPr>
-              <a:t>1,059 avg views/post</a:t>
+              <a:t>1,021 avg views/post</a:t>
             </a:r>
           </a:p>
         </p:txBody>
@@ -4659,7 +4659,7 @@
                 </a:solidFill>
                 <a:latin typeface="Georgia"/>
               </a:rPr>
-              <a:t>224,919</a:t>
+              <a:t>229,691</a:t>
             </a:r>
           </a:p>
         </p:txBody>
@@ -4727,7 +4727,7 @@
                 </a:solidFill>
                 <a:latin typeface="Helvetica Neue"/>
               </a:rPr>
-              <a:t>120 posts</a:t>
+              <a:t>136 posts</a:t>
             </a:r>
           </a:p>
         </p:txBody>
@@ -4761,7 +4761,7 @@
                 </a:solidFill>
                 <a:latin typeface="Helvetica Neue"/>
               </a:rPr>
-              <a:t>1,874 avg views/post</a:t>
+              <a:t>1,689 avg views/post</a:t>
             </a:r>
           </a:p>
         </p:txBody>
@@ -4917,7 +4917,7 @@
                 </a:solidFill>
                 <a:latin typeface="Georgia"/>
               </a:rPr>
-              <a:t>131,720</a:t>
+              <a:t>141,021</a:t>
             </a:r>
           </a:p>
         </p:txBody>
@@ -4985,7 +4985,7 @@
                 </a:solidFill>
                 <a:latin typeface="Helvetica Neue"/>
               </a:rPr>
-              <a:t>144 posts</a:t>
+              <a:t>162 posts</a:t>
             </a:r>
           </a:p>
         </p:txBody>
@@ -5019,7 +5019,7 @@
                 </a:solidFill>
                 <a:latin typeface="Helvetica Neue"/>
               </a:rPr>
-              <a:t>915 avg views/post</a:t>
+              <a:t>870 avg views/post</a:t>
             </a:r>
           </a:p>
         </p:txBody>
@@ -5175,7 +5175,7 @@
                 </a:solidFill>
                 <a:latin typeface="Georgia"/>
               </a:rPr>
-              <a:t>1,308</a:t>
+              <a:t>1,406</a:t>
             </a:r>
           </a:p>
         </p:txBody>
@@ -5243,7 +5243,7 @@
                 </a:solidFill>
                 <a:latin typeface="Helvetica Neue"/>
               </a:rPr>
-              <a:t>12 posts</a:t>
+              <a:t>13 posts</a:t>
             </a:r>
           </a:p>
         </p:txBody>
@@ -5277,7 +5277,7 @@
                 </a:solidFill>
                 <a:latin typeface="Helvetica Neue"/>
               </a:rPr>
-              <a:t>109 avg views/post</a:t>
+              <a:t>108 avg views/post</a:t>
             </a:r>
           </a:p>
         </p:txBody>
@@ -5587,7 +5587,7 @@
                 </a:solidFill>
                 <a:latin typeface="Helvetica Neue"/>
               </a:rPr>
-              <a:t>92,714   (60 posts · 1,545 avg)</a:t>
+              <a:t>92,787   (60 posts · 1,546 avg)</a:t>
             </a:r>
           </a:p>
         </p:txBody>
@@ -5621,7 +5621,7 @@
                 </a:solidFill>
                 <a:latin typeface="Helvetica Neue"/>
               </a:rPr>
-              <a:t>military_service</a:t>
+              <a:t>Other</a:t>
             </a:r>
           </a:p>
         </p:txBody>
@@ -5635,7 +5635,7 @@
         <p:spPr>
           <a:xfrm>
             <a:off x="3383280" y="2532888"/>
-            <a:ext cx="4625085" cy="192024"/>
+            <a:ext cx="4674293" cy="192024"/>
           </a:xfrm>
           <a:prstGeom prst="rect">
             <a:avLst/>
@@ -5678,7 +5678,7 @@
         </p:nvSpPr>
         <p:spPr>
           <a:xfrm>
-            <a:off x="8099805" y="2505456"/>
+            <a:off x="8149013" y="2505456"/>
             <a:ext cx="2286000" cy="329184"/>
           </a:xfrm>
           <a:prstGeom prst="rect">
@@ -5699,7 +5699,7 @@
                 </a:solidFill>
                 <a:latin typeface="Helvetica Neue"/>
               </a:rPr>
-              <a:t>62,527   (20 posts · 3,126 avg)</a:t>
+              <a:t>63,242   (134 posts · 472 avg)</a:t>
             </a:r>
           </a:p>
         </p:txBody>
@@ -5733,7 +5733,7 @@
                 </a:solidFill>
                 <a:latin typeface="Helvetica Neue"/>
               </a:rPr>
-              <a:t>Other</a:t>
+              <a:t>military_service</a:t>
             </a:r>
           </a:p>
         </p:txBody>
@@ -5747,7 +5747,7 @@
         <p:spPr>
           <a:xfrm>
             <a:off x="3383280" y="2862072"/>
-            <a:ext cx="3762971" cy="192024"/>
+            <a:ext cx="4621890" cy="192024"/>
           </a:xfrm>
           <a:prstGeom prst="rect">
             <a:avLst/>
@@ -5790,7 +5790,7 @@
         </p:nvSpPr>
         <p:spPr>
           <a:xfrm>
-            <a:off x="7237691" y="2834640"/>
+            <a:off x="8096610" y="2834640"/>
             <a:ext cx="2286000" cy="329184"/>
           </a:xfrm>
           <a:prstGeom prst="rect">
@@ -5811,7 +5811,7 @@
                 </a:solidFill>
                 <a:latin typeface="Helvetica Neue"/>
               </a:rPr>
-              <a:t>50,872   (105 posts · 484 avg)</a:t>
+              <a:t>62,533   (20 posts · 3,127 avg)</a:t>
             </a:r>
           </a:p>
         </p:txBody>
@@ -5859,7 +5859,7 @@
         <p:spPr>
           <a:xfrm>
             <a:off x="3383280" y="3191256"/>
-            <a:ext cx="3655198" cy="192024"/>
+            <a:ext cx="3652322" cy="192024"/>
           </a:xfrm>
           <a:prstGeom prst="rect">
             <a:avLst/>
@@ -5902,7 +5902,7 @@
         </p:nvSpPr>
         <p:spPr>
           <a:xfrm>
-            <a:off x="7129918" y="3163824"/>
+            <a:off x="7127042" y="3163824"/>
             <a:ext cx="2286000" cy="329184"/>
           </a:xfrm>
           <a:prstGeom prst="rect">
@@ -5971,7 +5971,7 @@
         <p:spPr>
           <a:xfrm>
             <a:off x="3383280" y="3520440"/>
-            <a:ext cx="3526639" cy="192024"/>
+            <a:ext cx="3523865" cy="192024"/>
           </a:xfrm>
           <a:prstGeom prst="rect">
             <a:avLst/>
@@ -6014,7 +6014,7 @@
         </p:nvSpPr>
         <p:spPr>
           <a:xfrm>
-            <a:off x="7001359" y="3493008"/>
+            <a:off x="6998585" y="3493008"/>
             <a:ext cx="2286000" cy="329184"/>
           </a:xfrm>
           <a:prstGeom prst="rect">
@@ -6083,7 +6083,7 @@
         <p:spPr>
           <a:xfrm>
             <a:off x="3383280" y="3849624"/>
-            <a:ext cx="3044507" cy="192024"/>
+            <a:ext cx="3042111" cy="192024"/>
           </a:xfrm>
           <a:prstGeom prst="rect">
             <a:avLst/>
@@ -6126,7 +6126,7 @@
         </p:nvSpPr>
         <p:spPr>
           <a:xfrm>
-            <a:off x="6519227" y="3822192"/>
+            <a:off x="6516831" y="3822192"/>
             <a:ext cx="2286000" cy="329184"/>
           </a:xfrm>
           <a:prstGeom prst="rect">
@@ -6195,7 +6195,7 @@
         <p:spPr>
           <a:xfrm>
             <a:off x="3383280" y="4178807"/>
-            <a:ext cx="2273006" cy="192024"/>
+            <a:ext cx="2271291" cy="192024"/>
           </a:xfrm>
           <a:prstGeom prst="rect">
             <a:avLst/>
@@ -6238,7 +6238,7 @@
         </p:nvSpPr>
         <p:spPr>
           <a:xfrm>
-            <a:off x="5747726" y="4151376"/>
+            <a:off x="5746011" y="4151376"/>
             <a:ext cx="2286000" cy="329184"/>
           </a:xfrm>
           <a:prstGeom prst="rect">
@@ -6259,7 +6259,7 @@
                 </a:solidFill>
                 <a:latin typeface="Helvetica Neue"/>
               </a:rPr>
-              <a:t>30,729   (30 posts · 1,024 avg)</a:t>
+              <a:t>30,730   (30 posts · 1,024 avg)</a:t>
             </a:r>
           </a:p>
         </p:txBody>
@@ -6307,7 +6307,7 @@
         <p:spPr>
           <a:xfrm>
             <a:off x="3383280" y="4507992"/>
-            <a:ext cx="1548031" cy="192024"/>
+            <a:ext cx="1546813" cy="192024"/>
           </a:xfrm>
           <a:prstGeom prst="rect">
             <a:avLst/>
@@ -6350,7 +6350,7 @@
         </p:nvSpPr>
         <p:spPr>
           <a:xfrm>
-            <a:off x="5022751" y="4480560"/>
+            <a:off x="5021533" y="4480560"/>
             <a:ext cx="2286000" cy="329184"/>
           </a:xfrm>
           <a:prstGeom prst="rect">
@@ -6405,7 +6405,7 @@
                 </a:solidFill>
                 <a:latin typeface="Helvetica Neue"/>
               </a:rPr>
-              <a:t>Politics (other)</a:t>
+              <a:t>Judicial</a:t>
             </a:r>
           </a:p>
         </p:txBody>
@@ -6419,7 +6419,7 @@
         <p:spPr>
           <a:xfrm>
             <a:off x="3383280" y="4837176"/>
-            <a:ext cx="1271534" cy="192024"/>
+            <a:ext cx="1435355" cy="192024"/>
           </a:xfrm>
           <a:prstGeom prst="rect">
             <a:avLst/>
@@ -6462,7 +6462,7 @@
         </p:nvSpPr>
         <p:spPr>
           <a:xfrm>
-            <a:off x="4746254" y="4809744"/>
+            <a:off x="4910075" y="4809744"/>
             <a:ext cx="2286000" cy="329184"/>
           </a:xfrm>
           <a:prstGeom prst="rect">
@@ -6483,7 +6483,7 @@
                 </a:solidFill>
                 <a:latin typeface="Helvetica Neue"/>
               </a:rPr>
-              <a:t>17,190   (16 posts · 1,074 avg)</a:t>
+              <a:t>19,420   (49 posts · 396 avg)</a:t>
             </a:r>
           </a:p>
         </p:txBody>
@@ -6517,7 +6517,7 @@
                 </a:solidFill>
                 <a:latin typeface="Helvetica Neue"/>
               </a:rPr>
-              <a:t>AI Fake News</a:t>
+              <a:t>Politics (other)</a:t>
             </a:r>
           </a:p>
         </p:txBody>
@@ -6531,7 +6531,119 @@
         <p:spPr>
           <a:xfrm>
             <a:off x="3383280" y="5166359"/>
-            <a:ext cx="956202" cy="192024"/>
+            <a:ext cx="1271272" cy="192024"/>
+          </a:xfrm>
+          <a:prstGeom prst="rect">
+            <a:avLst/>
+          </a:prstGeom>
+          <a:solidFill>
+            <a:srgbClr val="2F3C7E"/>
+          </a:solidFill>
+          <a:ln>
+            <a:noFill/>
+          </a:ln>
+          <a:effectLst/>
+        </p:spPr>
+        <p:style>
+          <a:lnRef idx="1">
+            <a:schemeClr val="accent1"/>
+          </a:lnRef>
+          <a:fillRef idx="3">
+            <a:schemeClr val="accent1"/>
+          </a:fillRef>
+          <a:effectRef idx="2">
+            <a:schemeClr val="accent1"/>
+          </a:effectRef>
+          <a:fontRef idx="minor">
+            <a:schemeClr val="lt1"/>
+          </a:fontRef>
+        </p:style>
+        <p:txBody>
+          <a:bodyPr rtlCol="0" anchor="ctr"/>
+          <a:lstStyle/>
+          <a:p>
+            <a:pPr algn="ctr"/>
+          </a:p>
+        </p:txBody>
+      </p:sp>
+      <p:sp>
+        <p:nvSpPr>
+          <p:cNvPr id="35" name="TextBox 34"/>
+          <p:cNvSpPr txBox="1"/>
+          <p:nvPr/>
+        </p:nvSpPr>
+        <p:spPr>
+          <a:xfrm>
+            <a:off x="4745992" y="5138928"/>
+            <a:ext cx="2286000" cy="329184"/>
+          </a:xfrm>
+          <a:prstGeom prst="rect">
+            <a:avLst/>
+          </a:prstGeom>
+          <a:noFill/>
+        </p:spPr>
+        <p:txBody>
+          <a:bodyPr wrap="square" lIns="0" rIns="0" tIns="0" bIns="0">
+            <a:spAutoFit/>
+          </a:bodyPr>
+          <a:lstStyle/>
+          <a:p>
+            <a:r>
+              <a:rPr sz="1000" b="0">
+                <a:solidFill>
+                  <a:srgbClr val="6B7082"/>
+                </a:solidFill>
+                <a:latin typeface="Helvetica Neue"/>
+              </a:rPr>
+              <a:t>17,200   (16 posts · 1,075 avg)</a:t>
+            </a:r>
+          </a:p>
+        </p:txBody>
+      </p:sp>
+      <p:sp>
+        <p:nvSpPr>
+          <p:cNvPr id="36" name="TextBox 35"/>
+          <p:cNvSpPr txBox="1"/>
+          <p:nvPr/>
+        </p:nvSpPr>
+        <p:spPr>
+          <a:xfrm>
+            <a:off x="731520" y="5468112"/>
+            <a:ext cx="2468880" cy="329184"/>
+          </a:xfrm>
+          <a:prstGeom prst="rect">
+            <a:avLst/>
+          </a:prstGeom>
+          <a:noFill/>
+        </p:spPr>
+        <p:txBody>
+          <a:bodyPr wrap="square" lIns="0" rIns="0" tIns="0" bIns="0">
+            <a:spAutoFit/>
+          </a:bodyPr>
+          <a:lstStyle/>
+          <a:p>
+            <a:r>
+              <a:rPr sz="1100" b="0">
+                <a:solidFill>
+                  <a:srgbClr val="141833"/>
+                </a:solidFill>
+                <a:latin typeface="Helvetica Neue"/>
+              </a:rPr>
+              <a:t>AI Fake News</a:t>
+            </a:r>
+          </a:p>
+        </p:txBody>
+      </p:sp>
+      <p:sp>
+        <p:nvSpPr>
+          <p:cNvPr id="37" name="Rectangle 36"/>
+          <p:cNvSpPr/>
+          <p:nvPr/>
+        </p:nvSpPr>
+        <p:spPr>
+          <a:xfrm>
+            <a:off x="3383280" y="5495543"/>
+            <a:ext cx="955450" cy="192024"/>
           </a:xfrm>
           <a:prstGeom prst="rect">
             <a:avLst/>
@@ -6568,13 +6680,13 @@
       </p:sp>
       <p:sp>
         <p:nvSpPr>
-          <p:cNvPr id="35" name="TextBox 34"/>
-          <p:cNvSpPr txBox="1"/>
-          <p:nvPr/>
-        </p:nvSpPr>
-        <p:spPr>
-          <a:xfrm>
-            <a:off x="4430922" y="5138928"/>
+          <p:cNvPr id="38" name="TextBox 37"/>
+          <p:cNvSpPr txBox="1"/>
+          <p:nvPr/>
+        </p:nvSpPr>
+        <p:spPr>
+          <a:xfrm>
+            <a:off x="4430170" y="5468112"/>
             <a:ext cx="2286000" cy="329184"/>
           </a:xfrm>
           <a:prstGeom prst="rect">
@@ -6602,13 +6714,13 @@
       </p:sp>
       <p:sp>
         <p:nvSpPr>
-          <p:cNvPr id="36" name="TextBox 35"/>
-          <p:cNvSpPr txBox="1"/>
-          <p:nvPr/>
-        </p:nvSpPr>
-        <p:spPr>
-          <a:xfrm>
-            <a:off x="731520" y="5468112"/>
+          <p:cNvPr id="39" name="TextBox 38"/>
+          <p:cNvSpPr txBox="1"/>
+          <p:nvPr/>
+        </p:nvSpPr>
+        <p:spPr>
+          <a:xfrm>
+            <a:off x="731520" y="5797296"/>
             <a:ext cx="2468880" cy="329184"/>
           </a:xfrm>
           <a:prstGeom prst="rect">
@@ -6636,14 +6748,14 @@
       </p:sp>
       <p:sp>
         <p:nvSpPr>
-          <p:cNvPr id="37" name="Rectangle 36"/>
+          <p:cNvPr id="40" name="Rectangle 39"/>
           <p:cNvSpPr/>
           <p:nvPr/>
         </p:nvSpPr>
         <p:spPr>
           <a:xfrm>
-            <a:off x="3383280" y="5495543"/>
-            <a:ext cx="871803" cy="192024"/>
+            <a:off x="3383280" y="5824728"/>
+            <a:ext cx="871117" cy="192024"/>
           </a:xfrm>
           <a:prstGeom prst="rect">
             <a:avLst/>
@@ -6680,13 +6792,13 @@
       </p:sp>
       <p:sp>
         <p:nvSpPr>
-          <p:cNvPr id="38" name="TextBox 37"/>
-          <p:cNvSpPr txBox="1"/>
-          <p:nvPr/>
-        </p:nvSpPr>
-        <p:spPr>
-          <a:xfrm>
-            <a:off x="4346523" y="5468112"/>
+          <p:cNvPr id="41" name="TextBox 40"/>
+          <p:cNvSpPr txBox="1"/>
+          <p:nvPr/>
+        </p:nvSpPr>
+        <p:spPr>
+          <a:xfrm>
+            <a:off x="4345837" y="5797296"/>
             <a:ext cx="2286000" cy="329184"/>
           </a:xfrm>
           <a:prstGeom prst="rect">
@@ -6708,118 +6820,6 @@
                 <a:latin typeface="Helvetica Neue"/>
               </a:rPr>
               <a:t>11,786   (8 posts · 1,473 avg)</a:t>
-            </a:r>
-          </a:p>
-        </p:txBody>
-      </p:sp>
-      <p:sp>
-        <p:nvSpPr>
-          <p:cNvPr id="39" name="TextBox 38"/>
-          <p:cNvSpPr txBox="1"/>
-          <p:nvPr/>
-        </p:nvSpPr>
-        <p:spPr>
-          <a:xfrm>
-            <a:off x="731520" y="5797296"/>
-            <a:ext cx="2468880" cy="329184"/>
-          </a:xfrm>
-          <a:prstGeom prst="rect">
-            <a:avLst/>
-          </a:prstGeom>
-          <a:noFill/>
-        </p:spPr>
-        <p:txBody>
-          <a:bodyPr wrap="square" lIns="0" rIns="0" tIns="0" bIns="0">
-            <a:spAutoFit/>
-          </a:bodyPr>
-          <a:lstStyle/>
-          <a:p>
-            <a:r>
-              <a:rPr sz="1100" b="0">
-                <a:solidFill>
-                  <a:srgbClr val="141833"/>
-                </a:solidFill>
-                <a:latin typeface="Helvetica Neue"/>
-              </a:rPr>
-              <a:t>Judicial</a:t>
-            </a:r>
-          </a:p>
-        </p:txBody>
-      </p:sp>
-      <p:sp>
-        <p:nvSpPr>
-          <p:cNvPr id="40" name="Rectangle 39"/>
-          <p:cNvSpPr/>
-          <p:nvPr/>
-        </p:nvSpPr>
-        <p:spPr>
-          <a:xfrm>
-            <a:off x="3383280" y="5824728"/>
-            <a:ext cx="737549" cy="192024"/>
-          </a:xfrm>
-          <a:prstGeom prst="rect">
-            <a:avLst/>
-          </a:prstGeom>
-          <a:solidFill>
-            <a:srgbClr val="2F3C7E"/>
-          </a:solidFill>
-          <a:ln>
-            <a:noFill/>
-          </a:ln>
-          <a:effectLst/>
-        </p:spPr>
-        <p:style>
-          <a:lnRef idx="1">
-            <a:schemeClr val="accent1"/>
-          </a:lnRef>
-          <a:fillRef idx="3">
-            <a:schemeClr val="accent1"/>
-          </a:fillRef>
-          <a:effectRef idx="2">
-            <a:schemeClr val="accent1"/>
-          </a:effectRef>
-          <a:fontRef idx="minor">
-            <a:schemeClr val="lt1"/>
-          </a:fontRef>
-        </p:style>
-        <p:txBody>
-          <a:bodyPr rtlCol="0" anchor="ctr"/>
-          <a:lstStyle/>
-          <a:p>
-            <a:pPr algn="ctr"/>
-          </a:p>
-        </p:txBody>
-      </p:sp>
-      <p:sp>
-        <p:nvSpPr>
-          <p:cNvPr id="41" name="TextBox 40"/>
-          <p:cNvSpPr txBox="1"/>
-          <p:nvPr/>
-        </p:nvSpPr>
-        <p:spPr>
-          <a:xfrm>
-            <a:off x="4212269" y="5797296"/>
-            <a:ext cx="2286000" cy="329184"/>
-          </a:xfrm>
-          <a:prstGeom prst="rect">
-            <a:avLst/>
-          </a:prstGeom>
-          <a:noFill/>
-        </p:spPr>
-        <p:txBody>
-          <a:bodyPr wrap="square" lIns="0" rIns="0" tIns="0" bIns="0">
-            <a:spAutoFit/>
-          </a:bodyPr>
-          <a:lstStyle/>
-          <a:p>
-            <a:r>
-              <a:rPr sz="1000" b="0">
-                <a:solidFill>
-                  <a:srgbClr val="6B7082"/>
-                </a:solidFill>
-                <a:latin typeface="Helvetica Neue"/>
-              </a:rPr>
-              <a:t>9,971   (35 posts · 285 avg)</a:t>
             </a:r>
           </a:p>
         </p:txBody>

</xml_diff>

<commit_message>
Scheduled snapshot t30 (2026-09-07): fresh IG/FB/YT/TT + rebuilt decks
Co-Authored-By: Claude Opus 4.7 (1M context) <noreply@anthropic.com>
</commit_message>
<xml_diff>
--- a/OVERALL_REPORT.pptx
+++ b/OVERALL_REPORT.pptx
@@ -3277,7 +3277,7 @@
                 </a:solidFill>
                 <a:latin typeface="Georgia"/>
               </a:rPr>
-              <a:t>Since Jun 8, 2026 · 2026-09-04</a:t>
+              <a:t>Since Jun 8, 2026 · 2026-09-07</a:t>
             </a:r>
           </a:p>
         </p:txBody>
@@ -3578,7 +3578,7 @@
                 </a:solidFill>
                 <a:latin typeface="Georgia"/>
               </a:rPr>
-              <a:t>523,196</a:t>
+              <a:t>530,958</a:t>
             </a:r>
           </a:p>
         </p:txBody>
@@ -3769,7 +3769,7 @@
                 </a:solidFill>
                 <a:latin typeface="Georgia"/>
               </a:rPr>
-              <a:t>459</a:t>
+              <a:t>462</a:t>
             </a:r>
           </a:p>
         </p:txBody>
@@ -3925,7 +3925,7 @@
                 </a:solidFill>
                 <a:latin typeface="Georgia"/>
               </a:rPr>
-              <a:t>16,902</a:t>
+              <a:t>17,187</a:t>
             </a:r>
           </a:p>
         </p:txBody>
@@ -4081,7 +4081,7 @@
                 </a:solidFill>
                 <a:latin typeface="Georgia"/>
               </a:rPr>
-              <a:t>1,139</a:t>
+              <a:t>1,149</a:t>
             </a:r>
           </a:p>
         </p:txBody>
@@ -4401,7 +4401,7 @@
                 </a:solidFill>
                 <a:latin typeface="Georgia"/>
               </a:rPr>
-              <a:t>151,078</a:t>
+              <a:t>155,668</a:t>
             </a:r>
           </a:p>
         </p:txBody>
@@ -4469,7 +4469,7 @@
                 </a:solidFill>
                 <a:latin typeface="Helvetica Neue"/>
               </a:rPr>
-              <a:t>148 posts</a:t>
+              <a:t>149 posts</a:t>
             </a:r>
           </a:p>
         </p:txBody>
@@ -4503,7 +4503,7 @@
                 </a:solidFill>
                 <a:latin typeface="Helvetica Neue"/>
               </a:rPr>
-              <a:t>1,021 avg views/post</a:t>
+              <a:t>1,045 avg views/post</a:t>
             </a:r>
           </a:p>
         </p:txBody>
@@ -4659,7 +4659,7 @@
                 </a:solidFill>
                 <a:latin typeface="Georgia"/>
               </a:rPr>
-              <a:t>229,691</a:t>
+              <a:t>232,176</a:t>
             </a:r>
           </a:p>
         </p:txBody>
@@ -4727,7 +4727,7 @@
                 </a:solidFill>
                 <a:latin typeface="Helvetica Neue"/>
               </a:rPr>
-              <a:t>136 posts</a:t>
+              <a:t>137 posts</a:t>
             </a:r>
           </a:p>
         </p:txBody>
@@ -4761,7 +4761,7 @@
                 </a:solidFill>
                 <a:latin typeface="Helvetica Neue"/>
               </a:rPr>
-              <a:t>1,689 avg views/post</a:t>
+              <a:t>1,695 avg views/post</a:t>
             </a:r>
           </a:p>
         </p:txBody>
@@ -4917,7 +4917,7 @@
                 </a:solidFill>
                 <a:latin typeface="Georgia"/>
               </a:rPr>
-              <a:t>141,021</a:t>
+              <a:t>141,684</a:t>
             </a:r>
           </a:p>
         </p:txBody>
@@ -4985,7 +4985,7 @@
                 </a:solidFill>
                 <a:latin typeface="Helvetica Neue"/>
               </a:rPr>
-              <a:t>162 posts</a:t>
+              <a:t>163 posts</a:t>
             </a:r>
           </a:p>
         </p:txBody>
@@ -5019,7 +5019,7 @@
                 </a:solidFill>
                 <a:latin typeface="Helvetica Neue"/>
               </a:rPr>
-              <a:t>870 avg views/post</a:t>
+              <a:t>869 avg views/post</a:t>
             </a:r>
           </a:p>
         </p:txBody>
@@ -5175,7 +5175,7 @@
                 </a:solidFill>
                 <a:latin typeface="Georgia"/>
               </a:rPr>
-              <a:t>1,406</a:t>
+              <a:t>1,430</a:t>
             </a:r>
           </a:p>
         </p:txBody>
@@ -5277,7 +5277,7 @@
                 </a:solidFill>
                 <a:latin typeface="Helvetica Neue"/>
               </a:rPr>
-              <a:t>108 avg views/post</a:t>
+              <a:t>110 avg views/post</a:t>
             </a:r>
           </a:p>
         </p:txBody>
@@ -5587,7 +5587,7 @@
                 </a:solidFill>
                 <a:latin typeface="Helvetica Neue"/>
               </a:rPr>
-              <a:t>92,787   (60 posts · 1,546 avg)</a:t>
+              <a:t>93,657   (61 posts · 1,535 avg)</a:t>
             </a:r>
           </a:p>
         </p:txBody>
@@ -5635,7 +5635,7 @@
         <p:spPr>
           <a:xfrm>
             <a:off x="3383280" y="2532888"/>
-            <a:ext cx="4674293" cy="192024"/>
+            <a:ext cx="5104123" cy="192024"/>
           </a:xfrm>
           <a:prstGeom prst="rect">
             <a:avLst/>
@@ -5678,7 +5678,7 @@
         </p:nvSpPr>
         <p:spPr>
           <a:xfrm>
-            <a:off x="8149013" y="2505456"/>
+            <a:off x="8578843" y="2505456"/>
             <a:ext cx="2286000" cy="329184"/>
           </a:xfrm>
           <a:prstGeom prst="rect">
@@ -5699,7 +5699,7 @@
                 </a:solidFill>
                 <a:latin typeface="Helvetica Neue"/>
               </a:rPr>
-              <a:t>63,242   (134 posts · 472 avg)</a:t>
+              <a:t>69,705   (136 posts · 513 avg)</a:t>
             </a:r>
           </a:p>
         </p:txBody>
@@ -5747,7 +5747,7 @@
         <p:spPr>
           <a:xfrm>
             <a:off x="3383280" y="2862072"/>
-            <a:ext cx="4621890" cy="192024"/>
+            <a:ext cx="4579029" cy="192024"/>
           </a:xfrm>
           <a:prstGeom prst="rect">
             <a:avLst/>
@@ -5790,7 +5790,7 @@
         </p:nvSpPr>
         <p:spPr>
           <a:xfrm>
-            <a:off x="8096610" y="2834640"/>
+            <a:off x="8053749" y="2834640"/>
             <a:ext cx="2286000" cy="329184"/>
           </a:xfrm>
           <a:prstGeom prst="rect">
@@ -5811,7 +5811,7 @@
                 </a:solidFill>
                 <a:latin typeface="Helvetica Neue"/>
               </a:rPr>
-              <a:t>62,533   (20 posts · 3,127 avg)</a:t>
+              <a:t>62,534   (20 posts · 3,127 avg)</a:t>
             </a:r>
           </a:p>
         </p:txBody>
@@ -5859,7 +5859,7 @@
         <p:spPr>
           <a:xfrm>
             <a:off x="3383280" y="3191256"/>
-            <a:ext cx="3652322" cy="192024"/>
+            <a:ext cx="3618395" cy="192024"/>
           </a:xfrm>
           <a:prstGeom prst="rect">
             <a:avLst/>
@@ -5902,7 +5902,7 @@
         </p:nvSpPr>
         <p:spPr>
           <a:xfrm>
-            <a:off x="7127042" y="3163824"/>
+            <a:off x="7093115" y="3163824"/>
             <a:ext cx="2286000" cy="329184"/>
           </a:xfrm>
           <a:prstGeom prst="rect">
@@ -5971,7 +5971,7 @@
         <p:spPr>
           <a:xfrm>
             <a:off x="3383280" y="3520440"/>
-            <a:ext cx="3523865" cy="192024"/>
+            <a:ext cx="3491131" cy="192024"/>
           </a:xfrm>
           <a:prstGeom prst="rect">
             <a:avLst/>
@@ -6014,7 +6014,7 @@
         </p:nvSpPr>
         <p:spPr>
           <a:xfrm>
-            <a:off x="6998585" y="3493008"/>
+            <a:off x="6965851" y="3493008"/>
             <a:ext cx="2286000" cy="329184"/>
           </a:xfrm>
           <a:prstGeom prst="rect">
@@ -6083,7 +6083,7 @@
         <p:spPr>
           <a:xfrm>
             <a:off x="3383280" y="3849624"/>
-            <a:ext cx="3042111" cy="192024"/>
+            <a:ext cx="3013852" cy="192024"/>
           </a:xfrm>
           <a:prstGeom prst="rect">
             <a:avLst/>
@@ -6126,7 +6126,7 @@
         </p:nvSpPr>
         <p:spPr>
           <a:xfrm>
-            <a:off x="6516831" y="3822192"/>
+            <a:off x="6488572" y="3822192"/>
             <a:ext cx="2286000" cy="329184"/>
           </a:xfrm>
           <a:prstGeom prst="rect">
@@ -6195,7 +6195,7 @@
         <p:spPr>
           <a:xfrm>
             <a:off x="3383280" y="4178807"/>
-            <a:ext cx="2271291" cy="192024"/>
+            <a:ext cx="2250193" cy="192024"/>
           </a:xfrm>
           <a:prstGeom prst="rect">
             <a:avLst/>
@@ -6238,7 +6238,7 @@
         </p:nvSpPr>
         <p:spPr>
           <a:xfrm>
-            <a:off x="5746011" y="4151376"/>
+            <a:off x="5724913" y="4151376"/>
             <a:ext cx="2286000" cy="329184"/>
           </a:xfrm>
           <a:prstGeom prst="rect">
@@ -6307,7 +6307,7 @@
         <p:spPr>
           <a:xfrm>
             <a:off x="3383280" y="4507992"/>
-            <a:ext cx="1546813" cy="192024"/>
+            <a:ext cx="1532445" cy="192024"/>
           </a:xfrm>
           <a:prstGeom prst="rect">
             <a:avLst/>
@@ -6350,7 +6350,7 @@
         </p:nvSpPr>
         <p:spPr>
           <a:xfrm>
-            <a:off x="5021533" y="4480560"/>
+            <a:off x="5007165" y="4480560"/>
             <a:ext cx="2286000" cy="329184"/>
           </a:xfrm>
           <a:prstGeom prst="rect">
@@ -6419,7 +6419,7 @@
         <p:spPr>
           <a:xfrm>
             <a:off x="3383280" y="4837176"/>
-            <a:ext cx="1435355" cy="192024"/>
+            <a:ext cx="1449335" cy="192024"/>
           </a:xfrm>
           <a:prstGeom prst="rect">
             <a:avLst/>
@@ -6462,7 +6462,7 @@
         </p:nvSpPr>
         <p:spPr>
           <a:xfrm>
-            <a:off x="4910075" y="4809744"/>
+            <a:off x="4924055" y="4809744"/>
             <a:ext cx="2286000" cy="329184"/>
           </a:xfrm>
           <a:prstGeom prst="rect">
@@ -6483,7 +6483,7 @@
                 </a:solidFill>
                 <a:latin typeface="Helvetica Neue"/>
               </a:rPr>
-              <a:t>19,420   (49 posts · 396 avg)</a:t>
+              <a:t>19,793   (49 posts · 404 avg)</a:t>
             </a:r>
           </a:p>
         </p:txBody>
@@ -6531,7 +6531,7 @@
         <p:spPr>
           <a:xfrm>
             <a:off x="3383280" y="5166359"/>
-            <a:ext cx="1271272" cy="192024"/>
+            <a:ext cx="1259903" cy="192024"/>
           </a:xfrm>
           <a:prstGeom prst="rect">
             <a:avLst/>
@@ -6574,7 +6574,7 @@
         </p:nvSpPr>
         <p:spPr>
           <a:xfrm>
-            <a:off x="4745992" y="5138928"/>
+            <a:off x="4734623" y="5138928"/>
             <a:ext cx="2286000" cy="329184"/>
           </a:xfrm>
           <a:prstGeom prst="rect">
@@ -6595,7 +6595,7 @@
                 </a:solidFill>
                 <a:latin typeface="Helvetica Neue"/>
               </a:rPr>
-              <a:t>17,200   (16 posts · 1,075 avg)</a:t>
+              <a:t>17,206   (16 posts · 1,075 avg)</a:t>
             </a:r>
           </a:p>
         </p:txBody>
@@ -6643,7 +6643,7 @@
         <p:spPr>
           <a:xfrm>
             <a:off x="3383280" y="5495543"/>
-            <a:ext cx="955450" cy="192024"/>
+            <a:ext cx="946648" cy="192024"/>
           </a:xfrm>
           <a:prstGeom prst="rect">
             <a:avLst/>
@@ -6686,7 +6686,7 @@
         </p:nvSpPr>
         <p:spPr>
           <a:xfrm>
-            <a:off x="4430170" y="5468112"/>
+            <a:off x="4421368" y="5468112"/>
             <a:ext cx="2286000" cy="329184"/>
           </a:xfrm>
           <a:prstGeom prst="rect">
@@ -6707,7 +6707,7 @@
                 </a:solidFill>
                 <a:latin typeface="Helvetica Neue"/>
               </a:rPr>
-              <a:t>12,927   (7 posts · 1,847 avg)</a:t>
+              <a:t>12,928   (7 posts · 1,847 avg)</a:t>
             </a:r>
           </a:p>
         </p:txBody>
@@ -6755,7 +6755,7 @@
         <p:spPr>
           <a:xfrm>
             <a:off x="3383280" y="5824728"/>
-            <a:ext cx="871117" cy="192024"/>
+            <a:ext cx="863025" cy="192024"/>
           </a:xfrm>
           <a:prstGeom prst="rect">
             <a:avLst/>
@@ -6798,7 +6798,7 @@
         </p:nvSpPr>
         <p:spPr>
           <a:xfrm>
-            <a:off x="4345837" y="5797296"/>
+            <a:off x="4337745" y="5797296"/>
             <a:ext cx="2286000" cy="329184"/>
           </a:xfrm>
           <a:prstGeom prst="rect">

</xml_diff>

<commit_message>
Scheduled snapshot t31 (2026-09-09): fresh IG/FB/YT/TT + rebuilt decks
Co-Authored-By: Claude Opus 4.7 (1M context) <noreply@anthropic.com>
</commit_message>
<xml_diff>
--- a/OVERALL_REPORT.pptx
+++ b/OVERALL_REPORT.pptx
@@ -3277,7 +3277,7 @@
                 </a:solidFill>
                 <a:latin typeface="Georgia"/>
               </a:rPr>
-              <a:t>Since Jun 8, 2026 · 2026-09-07</a:t>
+              <a:t>Since Jun 8, 2026 · 2026-09-09</a:t>
             </a:r>
           </a:p>
         </p:txBody>
@@ -3578,7 +3578,7 @@
                 </a:solidFill>
                 <a:latin typeface="Georgia"/>
               </a:rPr>
-              <a:t>530,958</a:t>
+              <a:t>537,031</a:t>
             </a:r>
           </a:p>
         </p:txBody>
@@ -3769,7 +3769,7 @@
                 </a:solidFill>
                 <a:latin typeface="Georgia"/>
               </a:rPr>
-              <a:t>462</a:t>
+              <a:t>473</a:t>
             </a:r>
           </a:p>
         </p:txBody>
@@ -3925,7 +3925,7 @@
                 </a:solidFill>
                 <a:latin typeface="Georgia"/>
               </a:rPr>
-              <a:t>17,187</a:t>
+              <a:t>17,340</a:t>
             </a:r>
           </a:p>
         </p:txBody>
@@ -4081,7 +4081,7 @@
                 </a:solidFill>
                 <a:latin typeface="Georgia"/>
               </a:rPr>
-              <a:t>1,149</a:t>
+              <a:t>1,135</a:t>
             </a:r>
           </a:p>
         </p:txBody>
@@ -4401,7 +4401,7 @@
                 </a:solidFill>
                 <a:latin typeface="Georgia"/>
               </a:rPr>
-              <a:t>155,668</a:t>
+              <a:t>158,660</a:t>
             </a:r>
           </a:p>
         </p:txBody>
@@ -4469,7 +4469,7 @@
                 </a:solidFill>
                 <a:latin typeface="Helvetica Neue"/>
               </a:rPr>
-              <a:t>149 posts</a:t>
+              <a:t>152 posts</a:t>
             </a:r>
           </a:p>
         </p:txBody>
@@ -4503,7 +4503,7 @@
                 </a:solidFill>
                 <a:latin typeface="Helvetica Neue"/>
               </a:rPr>
-              <a:t>1,045 avg views/post</a:t>
+              <a:t>1,044 avg views/post</a:t>
             </a:r>
           </a:p>
         </p:txBody>
@@ -4659,7 +4659,7 @@
                 </a:solidFill>
                 <a:latin typeface="Georgia"/>
               </a:rPr>
-              <a:t>232,176</a:t>
+              <a:t>233,861</a:t>
             </a:r>
           </a:p>
         </p:txBody>
@@ -4727,7 +4727,7 @@
                 </a:solidFill>
                 <a:latin typeface="Helvetica Neue"/>
               </a:rPr>
-              <a:t>137 posts</a:t>
+              <a:t>140 posts</a:t>
             </a:r>
           </a:p>
         </p:txBody>
@@ -4761,7 +4761,7 @@
                 </a:solidFill>
                 <a:latin typeface="Helvetica Neue"/>
               </a:rPr>
-              <a:t>1,695 avg views/post</a:t>
+              <a:t>1,670 avg views/post</a:t>
             </a:r>
           </a:p>
         </p:txBody>
@@ -4917,7 +4917,7 @@
                 </a:solidFill>
                 <a:latin typeface="Georgia"/>
               </a:rPr>
-              <a:t>141,684</a:t>
+              <a:t>142,973</a:t>
             </a:r>
           </a:p>
         </p:txBody>
@@ -4985,7 +4985,7 @@
                 </a:solidFill>
                 <a:latin typeface="Helvetica Neue"/>
               </a:rPr>
-              <a:t>163 posts</a:t>
+              <a:t>166 posts</a:t>
             </a:r>
           </a:p>
         </p:txBody>
@@ -5019,7 +5019,7 @@
                 </a:solidFill>
                 <a:latin typeface="Helvetica Neue"/>
               </a:rPr>
-              <a:t>869 avg views/post</a:t>
+              <a:t>861 avg views/post</a:t>
             </a:r>
           </a:p>
         </p:txBody>
@@ -5175,7 +5175,7 @@
                 </a:solidFill>
                 <a:latin typeface="Georgia"/>
               </a:rPr>
-              <a:t>1,430</a:t>
+              <a:t>1,537</a:t>
             </a:r>
           </a:p>
         </p:txBody>
@@ -5243,7 +5243,7 @@
                 </a:solidFill>
                 <a:latin typeface="Helvetica Neue"/>
               </a:rPr>
-              <a:t>13 posts</a:t>
+              <a:t>15 posts</a:t>
             </a:r>
           </a:p>
         </p:txBody>
@@ -5277,7 +5277,7 @@
                 </a:solidFill>
                 <a:latin typeface="Helvetica Neue"/>
               </a:rPr>
-              <a:t>110 avg views/post</a:t>
+              <a:t>102 avg views/post</a:t>
             </a:r>
           </a:p>
         </p:txBody>
@@ -5587,7 +5587,7 @@
                 </a:solidFill>
                 <a:latin typeface="Helvetica Neue"/>
               </a:rPr>
-              <a:t>93,657   (61 posts · 1,535 avg)</a:t>
+              <a:t>93,713   (61 posts · 1,536 avg)</a:t>
             </a:r>
           </a:p>
         </p:txBody>
@@ -5635,7 +5635,7 @@
         <p:spPr>
           <a:xfrm>
             <a:off x="3383280" y="2532888"/>
-            <a:ext cx="5104123" cy="192024"/>
+            <a:ext cx="5346448" cy="192024"/>
           </a:xfrm>
           <a:prstGeom prst="rect">
             <a:avLst/>
@@ -5678,7 +5678,7 @@
         </p:nvSpPr>
         <p:spPr>
           <a:xfrm>
-            <a:off x="8578843" y="2505456"/>
+            <a:off x="8821168" y="2505456"/>
             <a:ext cx="2286000" cy="329184"/>
           </a:xfrm>
           <a:prstGeom prst="rect">
@@ -5699,7 +5699,7 @@
                 </a:solidFill>
                 <a:latin typeface="Helvetica Neue"/>
               </a:rPr>
-              <a:t>69,705   (136 posts · 513 avg)</a:t>
+              <a:t>73,058   (139 posts · 526 avg)</a:t>
             </a:r>
           </a:p>
         </p:txBody>
@@ -5747,7 +5747,7 @@
         <p:spPr>
           <a:xfrm>
             <a:off x="3383280" y="2862072"/>
-            <a:ext cx="4579029" cy="192024"/>
+            <a:ext cx="4576293" cy="192024"/>
           </a:xfrm>
           <a:prstGeom prst="rect">
             <a:avLst/>
@@ -5790,7 +5790,7 @@
         </p:nvSpPr>
         <p:spPr>
           <a:xfrm>
-            <a:off x="8053749" y="2834640"/>
+            <a:off x="8051013" y="2834640"/>
             <a:ext cx="2286000" cy="329184"/>
           </a:xfrm>
           <a:prstGeom prst="rect">
@@ -5859,7 +5859,7 @@
         <p:spPr>
           <a:xfrm>
             <a:off x="3383280" y="3191256"/>
-            <a:ext cx="3618395" cy="192024"/>
+            <a:ext cx="3718247" cy="192024"/>
           </a:xfrm>
           <a:prstGeom prst="rect">
             <a:avLst/>
@@ -5902,7 +5902,7 @@
         </p:nvSpPr>
         <p:spPr>
           <a:xfrm>
-            <a:off x="7093115" y="3163824"/>
+            <a:off x="7192967" y="3163824"/>
             <a:ext cx="2286000" cy="329184"/>
           </a:xfrm>
           <a:prstGeom prst="rect">
@@ -5923,7 +5923,7 @@
                 </a:solidFill>
                 <a:latin typeface="Helvetica Neue"/>
               </a:rPr>
-              <a:t>49,415   (13 posts · 3,801 avg)</a:t>
+              <a:t>50,809   (16 posts · 3,176 avg)</a:t>
             </a:r>
           </a:p>
         </p:txBody>
@@ -5971,7 +5971,7 @@
         <p:spPr>
           <a:xfrm>
             <a:off x="3383280" y="3520440"/>
-            <a:ext cx="3491131" cy="192024"/>
+            <a:ext cx="3489044" cy="192024"/>
           </a:xfrm>
           <a:prstGeom prst="rect">
             <a:avLst/>
@@ -6014,7 +6014,7 @@
         </p:nvSpPr>
         <p:spPr>
           <a:xfrm>
-            <a:off x="6965851" y="3493008"/>
+            <a:off x="6963764" y="3493008"/>
             <a:ext cx="2286000" cy="329184"/>
           </a:xfrm>
           <a:prstGeom prst="rect">
@@ -6083,7 +6083,7 @@
         <p:spPr>
           <a:xfrm>
             <a:off x="3383280" y="3849624"/>
-            <a:ext cx="3013852" cy="192024"/>
+            <a:ext cx="3012051" cy="192024"/>
           </a:xfrm>
           <a:prstGeom prst="rect">
             <a:avLst/>
@@ -6126,7 +6126,7 @@
         </p:nvSpPr>
         <p:spPr>
           <a:xfrm>
-            <a:off x="6488572" y="3822192"/>
+            <a:off x="6486771" y="3822192"/>
             <a:ext cx="2286000" cy="329184"/>
           </a:xfrm>
           <a:prstGeom prst="rect">
@@ -6195,7 +6195,7 @@
         <p:spPr>
           <a:xfrm>
             <a:off x="3383280" y="4178807"/>
-            <a:ext cx="2250193" cy="192024"/>
+            <a:ext cx="2248848" cy="192024"/>
           </a:xfrm>
           <a:prstGeom prst="rect">
             <a:avLst/>
@@ -6238,7 +6238,7 @@
         </p:nvSpPr>
         <p:spPr>
           <a:xfrm>
-            <a:off x="5724913" y="4151376"/>
+            <a:off x="5723568" y="4151376"/>
             <a:ext cx="2286000" cy="329184"/>
           </a:xfrm>
           <a:prstGeom prst="rect">
@@ -6307,7 +6307,7 @@
         <p:spPr>
           <a:xfrm>
             <a:off x="3383280" y="4507992"/>
-            <a:ext cx="1532445" cy="192024"/>
+            <a:ext cx="1531529" cy="192024"/>
           </a:xfrm>
           <a:prstGeom prst="rect">
             <a:avLst/>
@@ -6350,7 +6350,7 @@
         </p:nvSpPr>
         <p:spPr>
           <a:xfrm>
-            <a:off x="5007165" y="4480560"/>
+            <a:off x="5006249" y="4480560"/>
             <a:ext cx="2286000" cy="329184"/>
           </a:xfrm>
           <a:prstGeom prst="rect">
@@ -6419,7 +6419,7 @@
         <p:spPr>
           <a:xfrm>
             <a:off x="3383280" y="4837176"/>
-            <a:ext cx="1449335" cy="192024"/>
+            <a:ext cx="1461349" cy="192024"/>
           </a:xfrm>
           <a:prstGeom prst="rect">
             <a:avLst/>
@@ -6462,7 +6462,7 @@
         </p:nvSpPr>
         <p:spPr>
           <a:xfrm>
-            <a:off x="4924055" y="4809744"/>
+            <a:off x="4936069" y="4809744"/>
             <a:ext cx="2286000" cy="329184"/>
           </a:xfrm>
           <a:prstGeom prst="rect">
@@ -6483,7 +6483,7 @@
                 </a:solidFill>
                 <a:latin typeface="Helvetica Neue"/>
               </a:rPr>
-              <a:t>19,793   (49 posts · 404 avg)</a:t>
+              <a:t>19,969   (49 posts · 408 avg)</a:t>
             </a:r>
           </a:p>
         </p:txBody>
@@ -6531,7 +6531,7 @@
         <p:spPr>
           <a:xfrm>
             <a:off x="3383280" y="5166359"/>
-            <a:ext cx="1259903" cy="192024"/>
+            <a:ext cx="1259442" cy="192024"/>
           </a:xfrm>
           <a:prstGeom prst="rect">
             <a:avLst/>
@@ -6574,7 +6574,7 @@
         </p:nvSpPr>
         <p:spPr>
           <a:xfrm>
-            <a:off x="4734623" y="5138928"/>
+            <a:off x="4734162" y="5138928"/>
             <a:ext cx="2286000" cy="329184"/>
           </a:xfrm>
           <a:prstGeom prst="rect">
@@ -6595,7 +6595,7 @@
                 </a:solidFill>
                 <a:latin typeface="Helvetica Neue"/>
               </a:rPr>
-              <a:t>17,206   (16 posts · 1,075 avg)</a:t>
+              <a:t>17,210   (16 posts · 1,076 avg)</a:t>
             </a:r>
           </a:p>
         </p:txBody>
@@ -6643,7 +6643,7 @@
         <p:spPr>
           <a:xfrm>
             <a:off x="3383280" y="5495543"/>
-            <a:ext cx="946648" cy="192024"/>
+            <a:ext cx="946155" cy="192024"/>
           </a:xfrm>
           <a:prstGeom prst="rect">
             <a:avLst/>
@@ -6686,7 +6686,7 @@
         </p:nvSpPr>
         <p:spPr>
           <a:xfrm>
-            <a:off x="4421368" y="5468112"/>
+            <a:off x="4420875" y="5468112"/>
             <a:ext cx="2286000" cy="329184"/>
           </a:xfrm>
           <a:prstGeom prst="rect">
@@ -6707,7 +6707,7 @@
                 </a:solidFill>
                 <a:latin typeface="Helvetica Neue"/>
               </a:rPr>
-              <a:t>12,928   (7 posts · 1,847 avg)</a:t>
+              <a:t>12,929   (7 posts · 1,847 avg)</a:t>
             </a:r>
           </a:p>
         </p:txBody>
@@ -6755,7 +6755,7 @@
         <p:spPr>
           <a:xfrm>
             <a:off x="3383280" y="5824728"/>
-            <a:ext cx="863025" cy="192024"/>
+            <a:ext cx="862509" cy="192024"/>
           </a:xfrm>
           <a:prstGeom prst="rect">
             <a:avLst/>
@@ -6798,7 +6798,7 @@
         </p:nvSpPr>
         <p:spPr>
           <a:xfrm>
-            <a:off x="4337745" y="5797296"/>
+            <a:off x="4337229" y="5797296"/>
             <a:ext cx="2286000" cy="329184"/>
           </a:xfrm>
           <a:prstGeom prst="rect">

</xml_diff>

<commit_message>
Scheduled snapshot t32 (2026-09-11): fresh IG/FB/YT/TT + rebuilt decks
Co-Authored-By: Claude Opus 4.7 (1M context) <noreply@anthropic.com>
</commit_message>
<xml_diff>
--- a/OVERALL_REPORT.pptx
+++ b/OVERALL_REPORT.pptx
@@ -3277,7 +3277,7 @@
                 </a:solidFill>
                 <a:latin typeface="Georgia"/>
               </a:rPr>
-              <a:t>Since Jun 8, 2026 · 2026-09-09</a:t>
+              <a:t>Since Jun 8, 2026 · 2026-09-11</a:t>
             </a:r>
           </a:p>
         </p:txBody>
@@ -3578,7 +3578,7 @@
                 </a:solidFill>
                 <a:latin typeface="Georgia"/>
               </a:rPr>
-              <a:t>537,031</a:t>
+              <a:t>545,758</a:t>
             </a:r>
           </a:p>
         </p:txBody>
@@ -3769,7 +3769,7 @@
                 </a:solidFill>
                 <a:latin typeface="Georgia"/>
               </a:rPr>
-              <a:t>473</a:t>
+              <a:t>487</a:t>
             </a:r>
           </a:p>
         </p:txBody>
@@ -3925,7 +3925,7 @@
                 </a:solidFill>
                 <a:latin typeface="Georgia"/>
               </a:rPr>
-              <a:t>17,340</a:t>
+              <a:t>17,598</a:t>
             </a:r>
           </a:p>
         </p:txBody>
@@ -4081,7 +4081,7 @@
                 </a:solidFill>
                 <a:latin typeface="Georgia"/>
               </a:rPr>
-              <a:t>1,135</a:t>
+              <a:t>1,120</a:t>
             </a:r>
           </a:p>
         </p:txBody>
@@ -4401,7 +4401,7 @@
                 </a:solidFill>
                 <a:latin typeface="Georgia"/>
               </a:rPr>
-              <a:t>158,660</a:t>
+              <a:t>161,282</a:t>
             </a:r>
           </a:p>
         </p:txBody>
@@ -4469,7 +4469,7 @@
                 </a:solidFill>
                 <a:latin typeface="Helvetica Neue"/>
               </a:rPr>
-              <a:t>152 posts</a:t>
+              <a:t>156 posts</a:t>
             </a:r>
           </a:p>
         </p:txBody>
@@ -4503,7 +4503,7 @@
                 </a:solidFill>
                 <a:latin typeface="Helvetica Neue"/>
               </a:rPr>
-              <a:t>1,044 avg views/post</a:t>
+              <a:t>1,034 avg views/post</a:t>
             </a:r>
           </a:p>
         </p:txBody>
@@ -4659,7 +4659,7 @@
                 </a:solidFill>
                 <a:latin typeface="Georgia"/>
               </a:rPr>
-              <a:t>233,861</a:t>
+              <a:t>235,400</a:t>
             </a:r>
           </a:p>
         </p:txBody>
@@ -4727,7 +4727,7 @@
                 </a:solidFill>
                 <a:latin typeface="Helvetica Neue"/>
               </a:rPr>
-              <a:t>140 posts</a:t>
+              <a:t>144 posts</a:t>
             </a:r>
           </a:p>
         </p:txBody>
@@ -4761,7 +4761,7 @@
                 </a:solidFill>
                 <a:latin typeface="Helvetica Neue"/>
               </a:rPr>
-              <a:t>1,670 avg views/post</a:t>
+              <a:t>1,635 avg views/post</a:t>
             </a:r>
           </a:p>
         </p:txBody>
@@ -4917,7 +4917,7 @@
                 </a:solidFill>
                 <a:latin typeface="Georgia"/>
               </a:rPr>
-              <a:t>142,973</a:t>
+              <a:t>147,440</a:t>
             </a:r>
           </a:p>
         </p:txBody>
@@ -4985,7 +4985,7 @@
                 </a:solidFill>
                 <a:latin typeface="Helvetica Neue"/>
               </a:rPr>
-              <a:t>166 posts</a:t>
+              <a:t>172 posts</a:t>
             </a:r>
           </a:p>
         </p:txBody>
@@ -5019,7 +5019,7 @@
                 </a:solidFill>
                 <a:latin typeface="Helvetica Neue"/>
               </a:rPr>
-              <a:t>861 avg views/post</a:t>
+              <a:t>857 avg views/post</a:t>
             </a:r>
           </a:p>
         </p:txBody>
@@ -5175,7 +5175,7 @@
                 </a:solidFill>
                 <a:latin typeface="Georgia"/>
               </a:rPr>
-              <a:t>1,537</a:t>
+              <a:t>1,636</a:t>
             </a:r>
           </a:p>
         </p:txBody>
@@ -5277,7 +5277,7 @@
                 </a:solidFill>
                 <a:latin typeface="Helvetica Neue"/>
               </a:rPr>
-              <a:t>102 avg views/post</a:t>
+              <a:t>109 avg views/post</a:t>
             </a:r>
           </a:p>
         </p:txBody>
@@ -5587,7 +5587,7 @@
                 </a:solidFill>
                 <a:latin typeface="Helvetica Neue"/>
               </a:rPr>
-              <a:t>93,713   (61 posts · 1,536 avg)</a:t>
+              <a:t>93,759   (61 posts · 1,537 avg)</a:t>
             </a:r>
           </a:p>
         </p:txBody>
@@ -5635,7 +5635,7 @@
         <p:spPr>
           <a:xfrm>
             <a:off x="3383280" y="2532888"/>
-            <a:ext cx="5346448" cy="192024"/>
+            <a:ext cx="5426333" cy="192024"/>
           </a:xfrm>
           <a:prstGeom prst="rect">
             <a:avLst/>
@@ -5678,7 +5678,7 @@
         </p:nvSpPr>
         <p:spPr>
           <a:xfrm>
-            <a:off x="8821168" y="2505456"/>
+            <a:off x="8901053" y="2505456"/>
             <a:ext cx="2286000" cy="329184"/>
           </a:xfrm>
           <a:prstGeom prst="rect">
@@ -5699,7 +5699,7 @@
                 </a:solidFill>
                 <a:latin typeface="Helvetica Neue"/>
               </a:rPr>
-              <a:t>73,058   (139 posts · 526 avg)</a:t>
+              <a:t>74,186   (140 posts · 530 avg)</a:t>
             </a:r>
           </a:p>
         </p:txBody>
@@ -5747,7 +5747,7 @@
         <p:spPr>
           <a:xfrm>
             <a:off x="3383280" y="2862072"/>
-            <a:ext cx="4576293" cy="192024"/>
+            <a:ext cx="4574048" cy="192024"/>
           </a:xfrm>
           <a:prstGeom prst="rect">
             <a:avLst/>
@@ -5790,7 +5790,7 @@
         </p:nvSpPr>
         <p:spPr>
           <a:xfrm>
-            <a:off x="8051013" y="2834640"/>
+            <a:off x="8048768" y="2834640"/>
             <a:ext cx="2286000" cy="329184"/>
           </a:xfrm>
           <a:prstGeom prst="rect">
@@ -5859,7 +5859,7 @@
         <p:spPr>
           <a:xfrm>
             <a:off x="3383280" y="3191256"/>
-            <a:ext cx="3718247" cy="192024"/>
+            <a:ext cx="3725346" cy="192024"/>
           </a:xfrm>
           <a:prstGeom prst="rect">
             <a:avLst/>
@@ -5902,7 +5902,7 @@
         </p:nvSpPr>
         <p:spPr>
           <a:xfrm>
-            <a:off x="7192967" y="3163824"/>
+            <a:off x="7200066" y="3163824"/>
             <a:ext cx="2286000" cy="329184"/>
           </a:xfrm>
           <a:prstGeom prst="rect">
@@ -5923,7 +5923,7 @@
                 </a:solidFill>
                 <a:latin typeface="Helvetica Neue"/>
               </a:rPr>
-              <a:t>50,809   (16 posts · 3,176 avg)</a:t>
+              <a:t>50,931   (16 posts · 3,183 avg)</a:t>
             </a:r>
           </a:p>
         </p:txBody>
@@ -5971,7 +5971,7 @@
         <p:spPr>
           <a:xfrm>
             <a:off x="3383280" y="3520440"/>
-            <a:ext cx="3489044" cy="192024"/>
+            <a:ext cx="3487333" cy="192024"/>
           </a:xfrm>
           <a:prstGeom prst="rect">
             <a:avLst/>
@@ -6014,7 +6014,7 @@
         </p:nvSpPr>
         <p:spPr>
           <a:xfrm>
-            <a:off x="6963764" y="3493008"/>
+            <a:off x="6962053" y="3493008"/>
             <a:ext cx="2286000" cy="329184"/>
           </a:xfrm>
           <a:prstGeom prst="rect">
@@ -6083,7 +6083,7 @@
         <p:spPr>
           <a:xfrm>
             <a:off x="3383280" y="3849624"/>
-            <a:ext cx="3012051" cy="192024"/>
+            <a:ext cx="3010574" cy="192024"/>
           </a:xfrm>
           <a:prstGeom prst="rect">
             <a:avLst/>
@@ -6126,7 +6126,7 @@
         </p:nvSpPr>
         <p:spPr>
           <a:xfrm>
-            <a:off x="6486771" y="3822192"/>
+            <a:off x="6485294" y="3822192"/>
             <a:ext cx="2286000" cy="329184"/>
           </a:xfrm>
           <a:prstGeom prst="rect">
@@ -6195,7 +6195,7 @@
         <p:spPr>
           <a:xfrm>
             <a:off x="3383280" y="4178807"/>
-            <a:ext cx="2248848" cy="192024"/>
+            <a:ext cx="2286950" cy="192024"/>
           </a:xfrm>
           <a:prstGeom prst="rect">
             <a:avLst/>
@@ -6238,7 +6238,7 @@
         </p:nvSpPr>
         <p:spPr>
           <a:xfrm>
-            <a:off x="5723568" y="4151376"/>
+            <a:off x="5761670" y="4151376"/>
             <a:ext cx="2286000" cy="329184"/>
           </a:xfrm>
           <a:prstGeom prst="rect">
@@ -6259,7 +6259,7 @@
                 </a:solidFill>
                 <a:latin typeface="Helvetica Neue"/>
               </a:rPr>
-              <a:t>30,730   (30 posts · 1,024 avg)</a:t>
+              <a:t>31,266   (32 posts · 977 avg)</a:t>
             </a:r>
           </a:p>
         </p:txBody>
@@ -6307,7 +6307,7 @@
         <p:spPr>
           <a:xfrm>
             <a:off x="3383280" y="4507992"/>
-            <a:ext cx="1531529" cy="192024"/>
+            <a:ext cx="1530778" cy="192024"/>
           </a:xfrm>
           <a:prstGeom prst="rect">
             <a:avLst/>
@@ -6350,7 +6350,7 @@
         </p:nvSpPr>
         <p:spPr>
           <a:xfrm>
-            <a:off x="5006249" y="4480560"/>
+            <a:off x="5005498" y="4480560"/>
             <a:ext cx="2286000" cy="329184"/>
           </a:xfrm>
           <a:prstGeom prst="rect">
@@ -6419,7 +6419,7 @@
         <p:spPr>
           <a:xfrm>
             <a:off x="3383280" y="4837176"/>
-            <a:ext cx="1461349" cy="192024"/>
+            <a:ext cx="1467507" cy="192024"/>
           </a:xfrm>
           <a:prstGeom prst="rect">
             <a:avLst/>
@@ -6462,7 +6462,7 @@
         </p:nvSpPr>
         <p:spPr>
           <a:xfrm>
-            <a:off x="4936069" y="4809744"/>
+            <a:off x="4942227" y="4809744"/>
             <a:ext cx="2286000" cy="329184"/>
           </a:xfrm>
           <a:prstGeom prst="rect">
@@ -6483,7 +6483,7 @@
                 </a:solidFill>
                 <a:latin typeface="Helvetica Neue"/>
               </a:rPr>
-              <a:t>19,969   (49 posts · 408 avg)</a:t>
+              <a:t>20,063   (49 posts · 409 avg)</a:t>
             </a:r>
           </a:p>
         </p:txBody>
@@ -6531,7 +6531,7 @@
         <p:spPr>
           <a:xfrm>
             <a:off x="3383280" y="5166359"/>
-            <a:ext cx="1259442" cy="192024"/>
+            <a:ext cx="1259044" cy="192024"/>
           </a:xfrm>
           <a:prstGeom prst="rect">
             <a:avLst/>
@@ -6574,7 +6574,7 @@
         </p:nvSpPr>
         <p:spPr>
           <a:xfrm>
-            <a:off x="4734162" y="5138928"/>
+            <a:off x="4733764" y="5138928"/>
             <a:ext cx="2286000" cy="329184"/>
           </a:xfrm>
           <a:prstGeom prst="rect">
@@ -6595,7 +6595,7 @@
                 </a:solidFill>
                 <a:latin typeface="Helvetica Neue"/>
               </a:rPr>
-              <a:t>17,210   (16 posts · 1,076 avg)</a:t>
+              <a:t>17,213   (16 posts · 1,076 avg)</a:t>
             </a:r>
           </a:p>
         </p:txBody>
@@ -6643,7 +6643,7 @@
         <p:spPr>
           <a:xfrm>
             <a:off x="3383280" y="5495543"/>
-            <a:ext cx="946155" cy="192024"/>
+            <a:ext cx="945764" cy="192024"/>
           </a:xfrm>
           <a:prstGeom prst="rect">
             <a:avLst/>
@@ -6686,7 +6686,7 @@
         </p:nvSpPr>
         <p:spPr>
           <a:xfrm>
-            <a:off x="4420875" y="5468112"/>
+            <a:off x="4420484" y="5468112"/>
             <a:ext cx="2286000" cy="329184"/>
           </a:xfrm>
           <a:prstGeom prst="rect">
@@ -6707,7 +6707,7 @@
                 </a:solidFill>
                 <a:latin typeface="Helvetica Neue"/>
               </a:rPr>
-              <a:t>12,929   (7 posts · 1,847 avg)</a:t>
+              <a:t>12,930   (7 posts · 1,847 avg)</a:t>
             </a:r>
           </a:p>
         </p:txBody>
@@ -6741,7 +6741,7 @@
                 </a:solidFill>
                 <a:latin typeface="Helvetica Neue"/>
               </a:rPr>
-              <a:t>FIFA — Critique</a:t>
+              <a:t>Political Highlight</a:t>
             </a:r>
           </a:p>
         </p:txBody>
@@ -6755,13 +6755,13 @@
         <p:spPr>
           <a:xfrm>
             <a:off x="3383280" y="5824728"/>
-            <a:ext cx="862509" cy="192024"/>
+            <a:ext cx="919139" cy="192024"/>
           </a:xfrm>
           <a:prstGeom prst="rect">
             <a:avLst/>
           </a:prstGeom>
           <a:solidFill>
-            <a:srgbClr val="6B7082"/>
+            <a:srgbClr val="2E86AB"/>
           </a:solidFill>
           <a:ln>
             <a:noFill/>
@@ -6798,7 +6798,7 @@
         </p:nvSpPr>
         <p:spPr>
           <a:xfrm>
-            <a:off x="4337229" y="5797296"/>
+            <a:off x="4393859" y="5797296"/>
             <a:ext cx="2286000" cy="329184"/>
           </a:xfrm>
           <a:prstGeom prst="rect">
@@ -6819,7 +6819,7 @@
                 </a:solidFill>
                 <a:latin typeface="Helvetica Neue"/>
               </a:rPr>
-              <a:t>11,786   (8 posts · 1,473 avg)</a:t>
+              <a:t>12,566   (22 posts · 571 avg)</a:t>
             </a:r>
           </a:p>
         </p:txBody>

</xml_diff>

<commit_message>
Scheduled snapshot t33 (2026-09-14): fresh IG/FB/YT/TT + rebuilt decks
Co-Authored-By: Claude Opus 4.7 (1M context) <noreply@anthropic.com>
</commit_message>
<xml_diff>
--- a/OVERALL_REPORT.pptx
+++ b/OVERALL_REPORT.pptx
@@ -3277,7 +3277,7 @@
                 </a:solidFill>
                 <a:latin typeface="Georgia"/>
               </a:rPr>
-              <a:t>Since Jun 8, 2026 · 2026-09-11</a:t>
+              <a:t>Since Jun 8, 2026 · 2026-09-14</a:t>
             </a:r>
           </a:p>
         </p:txBody>
@@ -3578,7 +3578,7 @@
                 </a:solidFill>
                 <a:latin typeface="Georgia"/>
               </a:rPr>
-              <a:t>545,758</a:t>
+              <a:t>573,256</a:t>
             </a:r>
           </a:p>
         </p:txBody>
@@ -3769,7 +3769,7 @@
                 </a:solidFill>
                 <a:latin typeface="Georgia"/>
               </a:rPr>
-              <a:t>487</a:t>
+              <a:t>497</a:t>
             </a:r>
           </a:p>
         </p:txBody>
@@ -3925,7 +3925,7 @@
                 </a:solidFill>
                 <a:latin typeface="Georgia"/>
               </a:rPr>
-              <a:t>17,598</a:t>
+              <a:t>18,006</a:t>
             </a:r>
           </a:p>
         </p:txBody>
@@ -4081,7 +4081,7 @@
                 </a:solidFill>
                 <a:latin typeface="Georgia"/>
               </a:rPr>
-              <a:t>1,120</a:t>
+              <a:t>1,153</a:t>
             </a:r>
           </a:p>
         </p:txBody>
@@ -4401,7 +4401,7 @@
                 </a:solidFill>
                 <a:latin typeface="Georgia"/>
               </a:rPr>
-              <a:t>161,282</a:t>
+              <a:t>172,216</a:t>
             </a:r>
           </a:p>
         </p:txBody>
@@ -4469,7 +4469,7 @@
                 </a:solidFill>
                 <a:latin typeface="Helvetica Neue"/>
               </a:rPr>
-              <a:t>156 posts</a:t>
+              <a:t>160 posts</a:t>
             </a:r>
           </a:p>
         </p:txBody>
@@ -4503,7 +4503,7 @@
                 </a:solidFill>
                 <a:latin typeface="Helvetica Neue"/>
               </a:rPr>
-              <a:t>1,034 avg views/post</a:t>
+              <a:t>1,076 avg views/post</a:t>
             </a:r>
           </a:p>
         </p:txBody>
@@ -4659,7 +4659,7 @@
                 </a:solidFill>
                 <a:latin typeface="Georgia"/>
               </a:rPr>
-              <a:t>235,400</a:t>
+              <a:t>237,437</a:t>
             </a:r>
           </a:p>
         </p:txBody>
@@ -4727,7 +4727,7 @@
                 </a:solidFill>
                 <a:latin typeface="Helvetica Neue"/>
               </a:rPr>
-              <a:t>144 posts</a:t>
+              <a:t>146 posts</a:t>
             </a:r>
           </a:p>
         </p:txBody>
@@ -4761,7 +4761,7 @@
                 </a:solidFill>
                 <a:latin typeface="Helvetica Neue"/>
               </a:rPr>
-              <a:t>1,635 avg views/post</a:t>
+              <a:t>1,626 avg views/post</a:t>
             </a:r>
           </a:p>
         </p:txBody>
@@ -4917,7 +4917,7 @@
                 </a:solidFill>
                 <a:latin typeface="Georgia"/>
               </a:rPr>
-              <a:t>147,440</a:t>
+              <a:t>161,899</a:t>
             </a:r>
           </a:p>
         </p:txBody>
@@ -4985,7 +4985,7 @@
                 </a:solidFill>
                 <a:latin typeface="Helvetica Neue"/>
               </a:rPr>
-              <a:t>172 posts</a:t>
+              <a:t>176 posts</a:t>
             </a:r>
           </a:p>
         </p:txBody>
@@ -5019,7 +5019,7 @@
                 </a:solidFill>
                 <a:latin typeface="Helvetica Neue"/>
               </a:rPr>
-              <a:t>857 avg views/post</a:t>
+              <a:t>920 avg views/post</a:t>
             </a:r>
           </a:p>
         </p:txBody>
@@ -5175,7 +5175,7 @@
                 </a:solidFill>
                 <a:latin typeface="Georgia"/>
               </a:rPr>
-              <a:t>1,636</a:t>
+              <a:t>1,704</a:t>
             </a:r>
           </a:p>
         </p:txBody>
@@ -5277,7 +5277,7 @@
                 </a:solidFill>
                 <a:latin typeface="Helvetica Neue"/>
               </a:rPr>
-              <a:t>109 avg views/post</a:t>
+              <a:t>114 avg views/post</a:t>
             </a:r>
           </a:p>
         </p:txBody>
@@ -5587,7 +5587,7 @@
                 </a:solidFill>
                 <a:latin typeface="Helvetica Neue"/>
               </a:rPr>
-              <a:t>93,759   (61 posts · 1,537 avg)</a:t>
+              <a:t>93,782   (61 posts · 1,537 avg)</a:t>
             </a:r>
           </a:p>
         </p:txBody>
@@ -5635,7 +5635,7 @@
         <p:spPr>
           <a:xfrm>
             <a:off x="3383280" y="2532888"/>
-            <a:ext cx="5426333" cy="192024"/>
+            <a:ext cx="5634877" cy="192024"/>
           </a:xfrm>
           <a:prstGeom prst="rect">
             <a:avLst/>
@@ -5678,7 +5678,7 @@
         </p:nvSpPr>
         <p:spPr>
           <a:xfrm>
-            <a:off x="8901053" y="2505456"/>
+            <a:off x="9109597" y="2505456"/>
             <a:ext cx="2286000" cy="329184"/>
           </a:xfrm>
           <a:prstGeom prst="rect">
@@ -5699,7 +5699,7 @@
                 </a:solidFill>
                 <a:latin typeface="Helvetica Neue"/>
               </a:rPr>
-              <a:t>74,186   (140 posts · 530 avg)</a:t>
+              <a:t>77,056   (141 posts · 546 avg)</a:t>
             </a:r>
           </a:p>
         </p:txBody>
@@ -5747,7 +5747,7 @@
         <p:spPr>
           <a:xfrm>
             <a:off x="3383280" y="2862072"/>
-            <a:ext cx="4574048" cy="192024"/>
+            <a:ext cx="4572999" cy="192024"/>
           </a:xfrm>
           <a:prstGeom prst="rect">
             <a:avLst/>
@@ -5790,7 +5790,7 @@
         </p:nvSpPr>
         <p:spPr>
           <a:xfrm>
-            <a:off x="8048768" y="2834640"/>
+            <a:off x="8047719" y="2834640"/>
             <a:ext cx="2286000" cy="329184"/>
           </a:xfrm>
           <a:prstGeom prst="rect">
@@ -5811,7 +5811,7 @@
                 </a:solidFill>
                 <a:latin typeface="Helvetica Neue"/>
               </a:rPr>
-              <a:t>62,534   (20 posts · 3,127 avg)</a:t>
+              <a:t>62,535   (22 posts · 2,842 avg)</a:t>
             </a:r>
           </a:p>
         </p:txBody>
@@ -5859,7 +5859,7 @@
         <p:spPr>
           <a:xfrm>
             <a:off x="3383280" y="3191256"/>
-            <a:ext cx="3725346" cy="192024"/>
+            <a:ext cx="3734524" cy="192024"/>
           </a:xfrm>
           <a:prstGeom prst="rect">
             <a:avLst/>
@@ -5902,7 +5902,7 @@
         </p:nvSpPr>
         <p:spPr>
           <a:xfrm>
-            <a:off x="7200066" y="3163824"/>
+            <a:off x="7209244" y="3163824"/>
             <a:ext cx="2286000" cy="329184"/>
           </a:xfrm>
           <a:prstGeom prst="rect">
@@ -5923,7 +5923,7 @@
                 </a:solidFill>
                 <a:latin typeface="Helvetica Neue"/>
               </a:rPr>
-              <a:t>50,931   (16 posts · 3,183 avg)</a:t>
+              <a:t>51,069   (16 posts · 3,192 avg)</a:t>
             </a:r>
           </a:p>
         </p:txBody>
@@ -5971,7 +5971,7 @@
         <p:spPr>
           <a:xfrm>
             <a:off x="3383280" y="3520440"/>
-            <a:ext cx="3487333" cy="192024"/>
+            <a:ext cx="3486477" cy="192024"/>
           </a:xfrm>
           <a:prstGeom prst="rect">
             <a:avLst/>
@@ -6014,7 +6014,7 @@
         </p:nvSpPr>
         <p:spPr>
           <a:xfrm>
-            <a:off x="6962053" y="3493008"/>
+            <a:off x="6961197" y="3493008"/>
             <a:ext cx="2286000" cy="329184"/>
           </a:xfrm>
           <a:prstGeom prst="rect">
@@ -6035,7 +6035,7 @@
                 </a:solidFill>
                 <a:latin typeface="Helvetica Neue"/>
               </a:rPr>
-              <a:t>47,677   (16 posts · 2,980 avg)</a:t>
+              <a:t>47,677   (18 posts · 2,649 avg)</a:t>
             </a:r>
           </a:p>
         </p:txBody>
@@ -6083,7 +6083,7 @@
         <p:spPr>
           <a:xfrm>
             <a:off x="3383280" y="3849624"/>
-            <a:ext cx="3010574" cy="192024"/>
+            <a:ext cx="3010055" cy="192024"/>
           </a:xfrm>
           <a:prstGeom prst="rect">
             <a:avLst/>
@@ -6126,7 +6126,7 @@
         </p:nvSpPr>
         <p:spPr>
           <a:xfrm>
-            <a:off x="6485294" y="3822192"/>
+            <a:off x="6484775" y="3822192"/>
             <a:ext cx="2286000" cy="329184"/>
           </a:xfrm>
           <a:prstGeom prst="rect">
@@ -6147,7 +6147,7 @@
                 </a:solidFill>
                 <a:latin typeface="Helvetica Neue"/>
               </a:rPr>
-              <a:t>41,159   (18 posts · 2,287 avg)</a:t>
+              <a:t>41,162   (18 posts · 2,287 avg)</a:t>
             </a:r>
           </a:p>
         </p:txBody>
@@ -6195,7 +6195,7 @@
         <p:spPr>
           <a:xfrm>
             <a:off x="3383280" y="4178807"/>
-            <a:ext cx="2286950" cy="192024"/>
+            <a:ext cx="2320247" cy="192024"/>
           </a:xfrm>
           <a:prstGeom prst="rect">
             <a:avLst/>
@@ -6238,7 +6238,7 @@
         </p:nvSpPr>
         <p:spPr>
           <a:xfrm>
-            <a:off x="5761670" y="4151376"/>
+            <a:off x="5794967" y="4151376"/>
             <a:ext cx="2286000" cy="329184"/>
           </a:xfrm>
           <a:prstGeom prst="rect">
@@ -6259,7 +6259,7 @@
                 </a:solidFill>
                 <a:latin typeface="Helvetica Neue"/>
               </a:rPr>
-              <a:t>31,266   (32 posts · 977 avg)</a:t>
+              <a:t>31,729   (32 posts · 992 avg)</a:t>
             </a:r>
           </a:p>
         </p:txBody>
@@ -6293,7 +6293,7 @@
                 </a:solidFill>
                 <a:latin typeface="Helvetica Neue"/>
               </a:rPr>
-              <a:t>Council Chaos</a:t>
+              <a:t>Politics (other)</a:t>
             </a:r>
           </a:p>
         </p:txBody>
@@ -6307,7 +6307,119 @@
         <p:spPr>
           <a:xfrm>
             <a:off x="3383280" y="4507992"/>
-            <a:ext cx="1530778" cy="192024"/>
+            <a:ext cx="2085875" cy="192024"/>
+          </a:xfrm>
+          <a:prstGeom prst="rect">
+            <a:avLst/>
+          </a:prstGeom>
+          <a:solidFill>
+            <a:srgbClr val="2F3C7E"/>
+          </a:solidFill>
+          <a:ln>
+            <a:noFill/>
+          </a:ln>
+          <a:effectLst/>
+        </p:spPr>
+        <p:style>
+          <a:lnRef idx="1">
+            <a:schemeClr val="accent1"/>
+          </a:lnRef>
+          <a:fillRef idx="3">
+            <a:schemeClr val="accent1"/>
+          </a:fillRef>
+          <a:effectRef idx="2">
+            <a:schemeClr val="accent1"/>
+          </a:effectRef>
+          <a:fontRef idx="minor">
+            <a:schemeClr val="lt1"/>
+          </a:fontRef>
+        </p:style>
+        <p:txBody>
+          <a:bodyPr rtlCol="0" anchor="ctr"/>
+          <a:lstStyle/>
+          <a:p>
+            <a:pPr algn="ctr"/>
+          </a:p>
+        </p:txBody>
+      </p:sp>
+      <p:sp>
+        <p:nvSpPr>
+          <p:cNvPr id="29" name="TextBox 28"/>
+          <p:cNvSpPr txBox="1"/>
+          <p:nvPr/>
+        </p:nvSpPr>
+        <p:spPr>
+          <a:xfrm>
+            <a:off x="5560595" y="4480560"/>
+            <a:ext cx="2286000" cy="329184"/>
+          </a:xfrm>
+          <a:prstGeom prst="rect">
+            <a:avLst/>
+          </a:prstGeom>
+          <a:noFill/>
+        </p:spPr>
+        <p:txBody>
+          <a:bodyPr wrap="square" lIns="0" rIns="0" tIns="0" bIns="0">
+            <a:spAutoFit/>
+          </a:bodyPr>
+          <a:lstStyle/>
+          <a:p>
+            <a:r>
+              <a:rPr sz="1000" b="0">
+                <a:solidFill>
+                  <a:srgbClr val="6B7082"/>
+                </a:solidFill>
+                <a:latin typeface="Helvetica Neue"/>
+              </a:rPr>
+              <a:t>28,524   (18 posts · 1,585 avg)</a:t>
+            </a:r>
+          </a:p>
+        </p:txBody>
+      </p:sp>
+      <p:sp>
+        <p:nvSpPr>
+          <p:cNvPr id="30" name="TextBox 29"/>
+          <p:cNvSpPr txBox="1"/>
+          <p:nvPr/>
+        </p:nvSpPr>
+        <p:spPr>
+          <a:xfrm>
+            <a:off x="731520" y="4809744"/>
+            <a:ext cx="2468880" cy="329184"/>
+          </a:xfrm>
+          <a:prstGeom prst="rect">
+            <a:avLst/>
+          </a:prstGeom>
+          <a:noFill/>
+        </p:spPr>
+        <p:txBody>
+          <a:bodyPr wrap="square" lIns="0" rIns="0" tIns="0" bIns="0">
+            <a:spAutoFit/>
+          </a:bodyPr>
+          <a:lstStyle/>
+          <a:p>
+            <a:r>
+              <a:rPr sz="1100" b="0">
+                <a:solidFill>
+                  <a:srgbClr val="141833"/>
+                </a:solidFill>
+                <a:latin typeface="Helvetica Neue"/>
+              </a:rPr>
+              <a:t>Council Chaos</a:t>
+            </a:r>
+          </a:p>
+        </p:txBody>
+      </p:sp>
+      <p:sp>
+        <p:nvSpPr>
+          <p:cNvPr id="31" name="Rectangle 30"/>
+          <p:cNvSpPr/>
+          <p:nvPr/>
+        </p:nvSpPr>
+        <p:spPr>
+          <a:xfrm>
+            <a:off x="3383280" y="4837176"/>
+            <a:ext cx="2046021" cy="192024"/>
           </a:xfrm>
           <a:prstGeom prst="rect">
             <a:avLst/>
@@ -6344,13 +6456,13 @@
       </p:sp>
       <p:sp>
         <p:nvSpPr>
-          <p:cNvPr id="29" name="TextBox 28"/>
-          <p:cNvSpPr txBox="1"/>
-          <p:nvPr/>
-        </p:nvSpPr>
-        <p:spPr>
-          <a:xfrm>
-            <a:off x="5005498" y="4480560"/>
+          <p:cNvPr id="32" name="TextBox 31"/>
+          <p:cNvSpPr txBox="1"/>
+          <p:nvPr/>
+        </p:nvSpPr>
+        <p:spPr>
+          <a:xfrm>
+            <a:off x="5520741" y="4809744"/>
             <a:ext cx="2286000" cy="329184"/>
           </a:xfrm>
           <a:prstGeom prst="rect">
@@ -6371,20 +6483,20 @@
                 </a:solidFill>
                 <a:latin typeface="Helvetica Neue"/>
               </a:rPr>
-              <a:t>20,928   (5 posts · 4,186 avg)</a:t>
-            </a:r>
-          </a:p>
-        </p:txBody>
-      </p:sp>
-      <p:sp>
-        <p:nvSpPr>
-          <p:cNvPr id="30" name="TextBox 29"/>
-          <p:cNvSpPr txBox="1"/>
-          <p:nvPr/>
-        </p:nvSpPr>
-        <p:spPr>
-          <a:xfrm>
-            <a:off x="731520" y="4809744"/>
+              <a:t>27,979   (6 posts · 4,663 avg)</a:t>
+            </a:r>
+          </a:p>
+        </p:txBody>
+      </p:sp>
+      <p:sp>
+        <p:nvSpPr>
+          <p:cNvPr id="33" name="TextBox 32"/>
+          <p:cNvSpPr txBox="1"/>
+          <p:nvPr/>
+        </p:nvSpPr>
+        <p:spPr>
+          <a:xfrm>
+            <a:off x="731520" y="5138928"/>
             <a:ext cx="2468880" cy="329184"/>
           </a:xfrm>
           <a:prstGeom prst="rect">
@@ -6412,14 +6524,14 @@
       </p:sp>
       <p:sp>
         <p:nvSpPr>
-          <p:cNvPr id="31" name="Rectangle 30"/>
+          <p:cNvPr id="34" name="Rectangle 33"/>
           <p:cNvSpPr/>
           <p:nvPr/>
         </p:nvSpPr>
         <p:spPr>
           <a:xfrm>
-            <a:off x="3383280" y="4837176"/>
-            <a:ext cx="1467507" cy="192024"/>
+            <a:off x="3383280" y="5166359"/>
+            <a:ext cx="1487403" cy="192024"/>
           </a:xfrm>
           <a:prstGeom prst="rect">
             <a:avLst/>
@@ -6456,13 +6568,13 @@
       </p:sp>
       <p:sp>
         <p:nvSpPr>
-          <p:cNvPr id="32" name="TextBox 31"/>
-          <p:cNvSpPr txBox="1"/>
-          <p:nvPr/>
-        </p:nvSpPr>
-        <p:spPr>
-          <a:xfrm>
-            <a:off x="4942227" y="4809744"/>
+          <p:cNvPr id="35" name="TextBox 34"/>
+          <p:cNvSpPr txBox="1"/>
+          <p:nvPr/>
+        </p:nvSpPr>
+        <p:spPr>
+          <a:xfrm>
+            <a:off x="4962123" y="5138928"/>
             <a:ext cx="2286000" cy="329184"/>
           </a:xfrm>
           <a:prstGeom prst="rect">
@@ -6483,20 +6595,20 @@
                 </a:solidFill>
                 <a:latin typeface="Helvetica Neue"/>
               </a:rPr>
-              <a:t>20,063   (49 posts · 409 avg)</a:t>
-            </a:r>
-          </a:p>
-        </p:txBody>
-      </p:sp>
-      <p:sp>
-        <p:nvSpPr>
-          <p:cNvPr id="33" name="TextBox 32"/>
-          <p:cNvSpPr txBox="1"/>
-          <p:nvPr/>
-        </p:nvSpPr>
-        <p:spPr>
-          <a:xfrm>
-            <a:off x="731520" y="5138928"/>
+              <a:t>20,340   (49 posts · 415 avg)</a:t>
+            </a:r>
+          </a:p>
+        </p:txBody>
+      </p:sp>
+      <p:sp>
+        <p:nvSpPr>
+          <p:cNvPr id="36" name="TextBox 35"/>
+          <p:cNvSpPr txBox="1"/>
+          <p:nvPr/>
+        </p:nvSpPr>
+        <p:spPr>
+          <a:xfrm>
+            <a:off x="731520" y="5468112"/>
             <a:ext cx="2468880" cy="329184"/>
           </a:xfrm>
           <a:prstGeom prst="rect">
@@ -6517,21 +6629,133 @@
                 </a:solidFill>
                 <a:latin typeface="Helvetica Neue"/>
               </a:rPr>
-              <a:t>Politics (other)</a:t>
-            </a:r>
-          </a:p>
-        </p:txBody>
-      </p:sp>
-      <p:sp>
-        <p:nvSpPr>
-          <p:cNvPr id="34" name="Rectangle 33"/>
+              <a:t>Political Highlight</a:t>
+            </a:r>
+          </a:p>
+        </p:txBody>
+      </p:sp>
+      <p:sp>
+        <p:nvSpPr>
+          <p:cNvPr id="37" name="Rectangle 36"/>
           <p:cNvSpPr/>
           <p:nvPr/>
         </p:nvSpPr>
         <p:spPr>
           <a:xfrm>
-            <a:off x="3383280" y="5166359"/>
-            <a:ext cx="1259044" cy="192024"/>
+            <a:off x="3383280" y="5495543"/>
+            <a:ext cx="1155114" cy="192024"/>
+          </a:xfrm>
+          <a:prstGeom prst="rect">
+            <a:avLst/>
+          </a:prstGeom>
+          <a:solidFill>
+            <a:srgbClr val="2E86AB"/>
+          </a:solidFill>
+          <a:ln>
+            <a:noFill/>
+          </a:ln>
+          <a:effectLst/>
+        </p:spPr>
+        <p:style>
+          <a:lnRef idx="1">
+            <a:schemeClr val="accent1"/>
+          </a:lnRef>
+          <a:fillRef idx="3">
+            <a:schemeClr val="accent1"/>
+          </a:fillRef>
+          <a:effectRef idx="2">
+            <a:schemeClr val="accent1"/>
+          </a:effectRef>
+          <a:fontRef idx="minor">
+            <a:schemeClr val="lt1"/>
+          </a:fontRef>
+        </p:style>
+        <p:txBody>
+          <a:bodyPr rtlCol="0" anchor="ctr"/>
+          <a:lstStyle/>
+          <a:p>
+            <a:pPr algn="ctr"/>
+          </a:p>
+        </p:txBody>
+      </p:sp>
+      <p:sp>
+        <p:nvSpPr>
+          <p:cNvPr id="38" name="TextBox 37"/>
+          <p:cNvSpPr txBox="1"/>
+          <p:nvPr/>
+        </p:nvSpPr>
+        <p:spPr>
+          <a:xfrm>
+            <a:off x="4629834" y="5468112"/>
+            <a:ext cx="2286000" cy="329184"/>
+          </a:xfrm>
+          <a:prstGeom prst="rect">
+            <a:avLst/>
+          </a:prstGeom>
+          <a:noFill/>
+        </p:spPr>
+        <p:txBody>
+          <a:bodyPr wrap="square" lIns="0" rIns="0" tIns="0" bIns="0">
+            <a:spAutoFit/>
+          </a:bodyPr>
+          <a:lstStyle/>
+          <a:p>
+            <a:r>
+              <a:rPr sz="1000" b="0">
+                <a:solidFill>
+                  <a:srgbClr val="6B7082"/>
+                </a:solidFill>
+                <a:latin typeface="Helvetica Neue"/>
+              </a:rPr>
+              <a:t>15,796   (22 posts · 718 avg)</a:t>
+            </a:r>
+          </a:p>
+        </p:txBody>
+      </p:sp>
+      <p:sp>
+        <p:nvSpPr>
+          <p:cNvPr id="39" name="TextBox 38"/>
+          <p:cNvSpPr txBox="1"/>
+          <p:nvPr/>
+        </p:nvSpPr>
+        <p:spPr>
+          <a:xfrm>
+            <a:off x="731520" y="5797296"/>
+            <a:ext cx="2468880" cy="329184"/>
+          </a:xfrm>
+          <a:prstGeom prst="rect">
+            <a:avLst/>
+          </a:prstGeom>
+          <a:noFill/>
+        </p:spPr>
+        <p:txBody>
+          <a:bodyPr wrap="square" lIns="0" rIns="0" tIns="0" bIns="0">
+            <a:spAutoFit/>
+          </a:bodyPr>
+          <a:lstStyle/>
+          <a:p>
+            <a:r>
+              <a:rPr sz="1100" b="0">
+                <a:solidFill>
+                  <a:srgbClr val="141833"/>
+                </a:solidFill>
+                <a:latin typeface="Helvetica Neue"/>
+              </a:rPr>
+              <a:t>Elections</a:t>
+            </a:r>
+          </a:p>
+        </p:txBody>
+      </p:sp>
+      <p:sp>
+        <p:nvSpPr>
+          <p:cNvPr id="40" name="Rectangle 39"/>
+          <p:cNvSpPr/>
+          <p:nvPr/>
+        </p:nvSpPr>
+        <p:spPr>
+          <a:xfrm>
+            <a:off x="3383280" y="5824728"/>
+            <a:ext cx="968713" cy="192024"/>
           </a:xfrm>
           <a:prstGeom prst="rect">
             <a:avLst/>
@@ -6568,13 +6792,13 @@
       </p:sp>
       <p:sp>
         <p:nvSpPr>
-          <p:cNvPr id="35" name="TextBox 34"/>
-          <p:cNvSpPr txBox="1"/>
-          <p:nvPr/>
-        </p:nvSpPr>
-        <p:spPr>
-          <a:xfrm>
-            <a:off x="4733764" y="5138928"/>
+          <p:cNvPr id="41" name="TextBox 40"/>
+          <p:cNvSpPr txBox="1"/>
+          <p:nvPr/>
+        </p:nvSpPr>
+        <p:spPr>
+          <a:xfrm>
+            <a:off x="4443433" y="5797296"/>
             <a:ext cx="2286000" cy="329184"/>
           </a:xfrm>
           <a:prstGeom prst="rect">
@@ -6595,231 +6819,7 @@
                 </a:solidFill>
                 <a:latin typeface="Helvetica Neue"/>
               </a:rPr>
-              <a:t>17,213   (16 posts · 1,076 avg)</a:t>
-            </a:r>
-          </a:p>
-        </p:txBody>
-      </p:sp>
-      <p:sp>
-        <p:nvSpPr>
-          <p:cNvPr id="36" name="TextBox 35"/>
-          <p:cNvSpPr txBox="1"/>
-          <p:nvPr/>
-        </p:nvSpPr>
-        <p:spPr>
-          <a:xfrm>
-            <a:off x="731520" y="5468112"/>
-            <a:ext cx="2468880" cy="329184"/>
-          </a:xfrm>
-          <a:prstGeom prst="rect">
-            <a:avLst/>
-          </a:prstGeom>
-          <a:noFill/>
-        </p:spPr>
-        <p:txBody>
-          <a:bodyPr wrap="square" lIns="0" rIns="0" tIns="0" bIns="0">
-            <a:spAutoFit/>
-          </a:bodyPr>
-          <a:lstStyle/>
-          <a:p>
-            <a:r>
-              <a:rPr sz="1100" b="0">
-                <a:solidFill>
-                  <a:srgbClr val="141833"/>
-                </a:solidFill>
-                <a:latin typeface="Helvetica Neue"/>
-              </a:rPr>
-              <a:t>AI Fake News</a:t>
-            </a:r>
-          </a:p>
-        </p:txBody>
-      </p:sp>
-      <p:sp>
-        <p:nvSpPr>
-          <p:cNvPr id="37" name="Rectangle 36"/>
-          <p:cNvSpPr/>
-          <p:nvPr/>
-        </p:nvSpPr>
-        <p:spPr>
-          <a:xfrm>
-            <a:off x="3383280" y="5495543"/>
-            <a:ext cx="945764" cy="192024"/>
-          </a:xfrm>
-          <a:prstGeom prst="rect">
-            <a:avLst/>
-          </a:prstGeom>
-          <a:solidFill>
-            <a:srgbClr val="990011"/>
-          </a:solidFill>
-          <a:ln>
-            <a:noFill/>
-          </a:ln>
-          <a:effectLst/>
-        </p:spPr>
-        <p:style>
-          <a:lnRef idx="1">
-            <a:schemeClr val="accent1"/>
-          </a:lnRef>
-          <a:fillRef idx="3">
-            <a:schemeClr val="accent1"/>
-          </a:fillRef>
-          <a:effectRef idx="2">
-            <a:schemeClr val="accent1"/>
-          </a:effectRef>
-          <a:fontRef idx="minor">
-            <a:schemeClr val="lt1"/>
-          </a:fontRef>
-        </p:style>
-        <p:txBody>
-          <a:bodyPr rtlCol="0" anchor="ctr"/>
-          <a:lstStyle/>
-          <a:p>
-            <a:pPr algn="ctr"/>
-          </a:p>
-        </p:txBody>
-      </p:sp>
-      <p:sp>
-        <p:nvSpPr>
-          <p:cNvPr id="38" name="TextBox 37"/>
-          <p:cNvSpPr txBox="1"/>
-          <p:nvPr/>
-        </p:nvSpPr>
-        <p:spPr>
-          <a:xfrm>
-            <a:off x="4420484" y="5468112"/>
-            <a:ext cx="2286000" cy="329184"/>
-          </a:xfrm>
-          <a:prstGeom prst="rect">
-            <a:avLst/>
-          </a:prstGeom>
-          <a:noFill/>
-        </p:spPr>
-        <p:txBody>
-          <a:bodyPr wrap="square" lIns="0" rIns="0" tIns="0" bIns="0">
-            <a:spAutoFit/>
-          </a:bodyPr>
-          <a:lstStyle/>
-          <a:p>
-            <a:r>
-              <a:rPr sz="1000" b="0">
-                <a:solidFill>
-                  <a:srgbClr val="6B7082"/>
-                </a:solidFill>
-                <a:latin typeface="Helvetica Neue"/>
-              </a:rPr>
-              <a:t>12,930   (7 posts · 1,847 avg)</a:t>
-            </a:r>
-          </a:p>
-        </p:txBody>
-      </p:sp>
-      <p:sp>
-        <p:nvSpPr>
-          <p:cNvPr id="39" name="TextBox 38"/>
-          <p:cNvSpPr txBox="1"/>
-          <p:nvPr/>
-        </p:nvSpPr>
-        <p:spPr>
-          <a:xfrm>
-            <a:off x="731520" y="5797296"/>
-            <a:ext cx="2468880" cy="329184"/>
-          </a:xfrm>
-          <a:prstGeom prst="rect">
-            <a:avLst/>
-          </a:prstGeom>
-          <a:noFill/>
-        </p:spPr>
-        <p:txBody>
-          <a:bodyPr wrap="square" lIns="0" rIns="0" tIns="0" bIns="0">
-            <a:spAutoFit/>
-          </a:bodyPr>
-          <a:lstStyle/>
-          <a:p>
-            <a:r>
-              <a:rPr sz="1100" b="0">
-                <a:solidFill>
-                  <a:srgbClr val="141833"/>
-                </a:solidFill>
-                <a:latin typeface="Helvetica Neue"/>
-              </a:rPr>
-              <a:t>Political Highlight</a:t>
-            </a:r>
-          </a:p>
-        </p:txBody>
-      </p:sp>
-      <p:sp>
-        <p:nvSpPr>
-          <p:cNvPr id="40" name="Rectangle 39"/>
-          <p:cNvSpPr/>
-          <p:nvPr/>
-        </p:nvSpPr>
-        <p:spPr>
-          <a:xfrm>
-            <a:off x="3383280" y="5824728"/>
-            <a:ext cx="919139" cy="192024"/>
-          </a:xfrm>
-          <a:prstGeom prst="rect">
-            <a:avLst/>
-          </a:prstGeom>
-          <a:solidFill>
-            <a:srgbClr val="2E86AB"/>
-          </a:solidFill>
-          <a:ln>
-            <a:noFill/>
-          </a:ln>
-          <a:effectLst/>
-        </p:spPr>
-        <p:style>
-          <a:lnRef idx="1">
-            <a:schemeClr val="accent1"/>
-          </a:lnRef>
-          <a:fillRef idx="3">
-            <a:schemeClr val="accent1"/>
-          </a:fillRef>
-          <a:effectRef idx="2">
-            <a:schemeClr val="accent1"/>
-          </a:effectRef>
-          <a:fontRef idx="minor">
-            <a:schemeClr val="lt1"/>
-          </a:fontRef>
-        </p:style>
-        <p:txBody>
-          <a:bodyPr rtlCol="0" anchor="ctr"/>
-          <a:lstStyle/>
-          <a:p>
-            <a:pPr algn="ctr"/>
-          </a:p>
-        </p:txBody>
-      </p:sp>
-      <p:sp>
-        <p:nvSpPr>
-          <p:cNvPr id="41" name="TextBox 40"/>
-          <p:cNvSpPr txBox="1"/>
-          <p:nvPr/>
-        </p:nvSpPr>
-        <p:spPr>
-          <a:xfrm>
-            <a:off x="4393859" y="5797296"/>
-            <a:ext cx="2286000" cy="329184"/>
-          </a:xfrm>
-          <a:prstGeom prst="rect">
-            <a:avLst/>
-          </a:prstGeom>
-          <a:noFill/>
-        </p:spPr>
-        <p:txBody>
-          <a:bodyPr wrap="square" lIns="0" rIns="0" tIns="0" bIns="0">
-            <a:spAutoFit/>
-          </a:bodyPr>
-          <a:lstStyle/>
-          <a:p>
-            <a:r>
-              <a:rPr sz="1000" b="0">
-                <a:solidFill>
-                  <a:srgbClr val="6B7082"/>
-                </a:solidFill>
-                <a:latin typeface="Helvetica Neue"/>
-              </a:rPr>
-              <a:t>12,566   (22 posts · 571 avg)</a:t>
+              <a:t>13,247   (16 posts · 828 avg)</a:t>
             </a:r>
           </a:p>
         </p:txBody>
@@ -8369,7 +8369,7 @@
                 </a:solidFill>
                 <a:latin typeface="Helvetica Neue"/>
               </a:rPr>
-              <a:t>TT</a:t>
+              <a:t>FB</a:t>
             </a:r>
           </a:p>
         </p:txBody>
@@ -8403,7 +8403,7 @@
                 </a:solidFill>
                 <a:latin typeface="Helvetica Neue"/>
               </a:rPr>
-              <a:t>Grew up in Huntington Park and still own property there. The city's o...</a:t>
+              <a:t>Chaos erupted at a council meeting when Ms. Rivera began screaming, refusing to </a:t>
             </a:r>
           </a:p>
         </p:txBody>
@@ -8437,7 +8437,7 @@
                 </a:solidFill>
                 <a:latin typeface="Helvetica Neue"/>
               </a:rPr>
-              <a:t>9,839</a:t>
+              <a:t>10,067</a:t>
             </a:r>
           </a:p>
         </p:txBody>
@@ -8471,7 +8471,7 @@
                 </a:solidFill>
                 <a:latin typeface="Helvetica Neue"/>
               </a:rPr>
-              <a:t>548</a:t>
+              <a:t>43</a:t>
             </a:r>
           </a:p>
         </p:txBody>
@@ -8505,7 +8505,7 @@
                 </a:solidFill>
                 <a:latin typeface="Helvetica Neue"/>
               </a:rPr>
-              <a:t>Trujillo Scandal</a:t>
+              <a:t>Politics Other</a:t>
             </a:r>
           </a:p>
         </p:txBody>
@@ -8651,7 +8651,7 @@
                 </a:solidFill>
                 <a:latin typeface="Helvetica Neue"/>
               </a:rPr>
-              <a:t>Pop's Wings just opened and it's a must-try! Their pastrami sandwich with sweet </a:t>
+              <a:t>Grew up in Huntington Park and still own property there. The city's o...</a:t>
             </a:r>
           </a:p>
         </p:txBody>
@@ -8685,7 +8685,7 @@
                 </a:solidFill>
                 <a:latin typeface="Helvetica Neue"/>
               </a:rPr>
-              <a:t>8,352</a:t>
+              <a:t>9,839</a:t>
             </a:r>
           </a:p>
         </p:txBody>
@@ -8719,7 +8719,7 @@
                 </a:solidFill>
                 <a:latin typeface="Helvetica Neue"/>
               </a:rPr>
-              <a:t>405</a:t>
+              <a:t>548</a:t>
             </a:r>
           </a:p>
         </p:txBody>
@@ -8753,7 +8753,7 @@
                 </a:solidFill>
                 <a:latin typeface="Helvetica Neue"/>
               </a:rPr>
-              <a:t>Food</a:t>
+              <a:t>Trujillo Scandal</a:t>
             </a:r>
           </a:p>
         </p:txBody>
@@ -8821,7 +8821,7 @@
                 </a:solidFill>
                 <a:latin typeface="Helvetica Neue"/>
               </a:rPr>
-              <a:t>IG</a:t>
+              <a:t>TT</a:t>
             </a:r>
           </a:p>
         </p:txBody>
@@ -8855,7 +8855,7 @@
                 </a:solidFill>
                 <a:latin typeface="Helvetica Neue"/>
               </a:rPr>
-              <a:t>25,000+ people gathered for a watch party at Stonewood Mall! Despite the $300k c</a:t>
+              <a:t>Pop's Wings just opened and it's a must-try! Their pastrami sandwich with sweet </a:t>
             </a:r>
           </a:p>
         </p:txBody>
@@ -8889,7 +8889,7 @@
                 </a:solidFill>
                 <a:latin typeface="Helvetica Neue"/>
               </a:rPr>
-              <a:t>7,180</a:t>
+              <a:t>8,352</a:t>
             </a:r>
           </a:p>
         </p:txBody>
@@ -8923,7 +8923,7 @@
                 </a:solidFill>
                 <a:latin typeface="Helvetica Neue"/>
               </a:rPr>
-              <a:t>264</a:t>
+              <a:t>405</a:t>
             </a:r>
           </a:p>
         </p:txBody>
@@ -8957,7 +8957,7 @@
                 </a:solidFill>
                 <a:latin typeface="Helvetica Neue"/>
               </a:rPr>
-              <a:t>Fifa Positive</a:t>
+              <a:t>Food</a:t>
             </a:r>
           </a:p>
         </p:txBody>
@@ -9103,7 +9103,7 @@
                 </a:solidFill>
                 <a:latin typeface="Helvetica Neue"/>
               </a:rPr>
-              <a:t>A woman's outburst at a city council meeting, repeatedly warned by the mayor, le</a:t>
+              <a:t>25,000+ people gathered for a watch party at Stonewood Mall! Despite the $300k c</a:t>
             </a:r>
           </a:p>
         </p:txBody>
@@ -9137,7 +9137,7 @@
                 </a:solidFill>
                 <a:latin typeface="Helvetica Neue"/>
               </a:rPr>
-              <a:t>7,031</a:t>
+              <a:t>7,180</a:t>
             </a:r>
           </a:p>
         </p:txBody>
@@ -9171,7 +9171,7 @@
                 </a:solidFill>
                 <a:latin typeface="Helvetica Neue"/>
               </a:rPr>
-              <a:t>93</a:t>
+              <a:t>264</a:t>
             </a:r>
           </a:p>
         </p:txBody>
@@ -9205,7 +9205,7 @@
                 </a:solidFill>
                 <a:latin typeface="Helvetica Neue"/>
               </a:rPr>
-              <a:t>Council Chaos</a:t>
+              <a:t>Fifa Positive</a:t>
             </a:r>
           </a:p>
         </p:txBody>
@@ -9273,7 +9273,7 @@
                 </a:solidFill>
                 <a:latin typeface="Helvetica Neue"/>
               </a:rPr>
-              <a:t>FB</a:t>
+              <a:t>IG</a:t>
             </a:r>
           </a:p>
         </p:txBody>
@@ -9307,7 +9307,7 @@
                 </a:solidFill>
                 <a:latin typeface="Helvetica Neue"/>
               </a:rPr>
-              <a:t>After admitting 'I messed up,' a city councilman's inappropriate conduct is unde</a:t>
+              <a:t>Chaos erupted! Lissette Rivera refused to calm down, escalating until she was es</a:t>
             </a:r>
           </a:p>
         </p:txBody>
@@ -9341,7 +9341,7 @@
                 </a:solidFill>
                 <a:latin typeface="Helvetica Neue"/>
               </a:rPr>
-              <a:t>6,363</a:t>
+              <a:t>7,051</a:t>
             </a:r>
           </a:p>
         </p:txBody>
@@ -9375,7 +9375,7 @@
                 </a:solidFill>
                 <a:latin typeface="Helvetica Neue"/>
               </a:rPr>
-              <a:t>42</a:t>
+              <a:t>100</a:t>
             </a:r>
           </a:p>
         </p:txBody>
@@ -9521,7 +9521,7 @@
                 </a:solidFill>
                 <a:latin typeface="Helvetica Neue"/>
               </a:rPr>
-              <a:t>FB</a:t>
+              <a:t>IG</a:t>
             </a:r>
           </a:p>
         </p:txBody>
@@ -9555,7 +9555,7 @@
                 </a:solidFill>
                 <a:latin typeface="Helvetica Neue"/>
               </a:rPr>
-              <a:t>Over 25,000 people gathered at Stonewood Mall for a massive watch party. Despite</a:t>
+              <a:t>A woman's outburst at a city council meeting, repeatedly warned by the mayor, le</a:t>
             </a:r>
           </a:p>
         </p:txBody>
@@ -9589,7 +9589,7 @@
                 </a:solidFill>
                 <a:latin typeface="Helvetica Neue"/>
               </a:rPr>
-              <a:t>6,355</a:t>
+              <a:t>7,031</a:t>
             </a:r>
           </a:p>
         </p:txBody>
@@ -9623,7 +9623,7 @@
                 </a:solidFill>
                 <a:latin typeface="Helvetica Neue"/>
               </a:rPr>
-              <a:t>46</a:t>
+              <a:t>93</a:t>
             </a:r>
           </a:p>
         </p:txBody>
@@ -9657,7 +9657,7 @@
                 </a:solidFill>
                 <a:latin typeface="Helvetica Neue"/>
               </a:rPr>
-              <a:t>Fifa Positive</a:t>
+              <a:t>Council Chaos</a:t>
             </a:r>
           </a:p>
         </p:txBody>

</xml_diff>

<commit_message>
Scheduled snapshot t34 (2026-09-16): fresh IG/FB/YT/TT + rebuilt decks
Co-Authored-By: Claude Opus 4.7 (1M context) <noreply@anthropic.com>
</commit_message>
<xml_diff>
--- a/OVERALL_REPORT.pptx
+++ b/OVERALL_REPORT.pptx
@@ -3277,7 +3277,7 @@
                 </a:solidFill>
                 <a:latin typeface="Georgia"/>
               </a:rPr>
-              <a:t>Since Jun 8, 2026 · 2026-09-14</a:t>
+              <a:t>Since Jun 8, 2026 · 2026-09-16</a:t>
             </a:r>
           </a:p>
         </p:txBody>
@@ -3578,7 +3578,7 @@
                 </a:solidFill>
                 <a:latin typeface="Georgia"/>
               </a:rPr>
-              <a:t>573,256</a:t>
+              <a:t>592,661</a:t>
             </a:r>
           </a:p>
         </p:txBody>
@@ -3769,7 +3769,7 @@
                 </a:solidFill>
                 <a:latin typeface="Georgia"/>
               </a:rPr>
-              <a:t>497</a:t>
+              <a:t>510</a:t>
             </a:r>
           </a:p>
         </p:txBody>
@@ -3925,7 +3925,7 @@
                 </a:solidFill>
                 <a:latin typeface="Georgia"/>
               </a:rPr>
-              <a:t>18,006</a:t>
+              <a:t>18,369</a:t>
             </a:r>
           </a:p>
         </p:txBody>
@@ -4081,7 +4081,7 @@
                 </a:solidFill>
                 <a:latin typeface="Georgia"/>
               </a:rPr>
-              <a:t>1,153</a:t>
+              <a:t>1,162</a:t>
             </a:r>
           </a:p>
         </p:txBody>
@@ -4401,7 +4401,7 @@
                 </a:solidFill>
                 <a:latin typeface="Georgia"/>
               </a:rPr>
-              <a:t>172,216</a:t>
+              <a:t>179,414</a:t>
             </a:r>
           </a:p>
         </p:txBody>
@@ -4469,7 +4469,7 @@
                 </a:solidFill>
                 <a:latin typeface="Helvetica Neue"/>
               </a:rPr>
-              <a:t>160 posts</a:t>
+              <a:t>164 posts</a:t>
             </a:r>
           </a:p>
         </p:txBody>
@@ -4503,7 +4503,7 @@
                 </a:solidFill>
                 <a:latin typeface="Helvetica Neue"/>
               </a:rPr>
-              <a:t>1,076 avg views/post</a:t>
+              <a:t>1,094 avg views/post</a:t>
             </a:r>
           </a:p>
         </p:txBody>
@@ -4659,7 +4659,7 @@
                 </a:solidFill>
                 <a:latin typeface="Georgia"/>
               </a:rPr>
-              <a:t>237,437</a:t>
+              <a:t>240,398</a:t>
             </a:r>
           </a:p>
         </p:txBody>
@@ -4727,7 +4727,7 @@
                 </a:solidFill>
                 <a:latin typeface="Helvetica Neue"/>
               </a:rPr>
-              <a:t>146 posts</a:t>
+              <a:t>150 posts</a:t>
             </a:r>
           </a:p>
         </p:txBody>
@@ -4761,7 +4761,7 @@
                 </a:solidFill>
                 <a:latin typeface="Helvetica Neue"/>
               </a:rPr>
-              <a:t>1,626 avg views/post</a:t>
+              <a:t>1,603 avg views/post</a:t>
             </a:r>
           </a:p>
         </p:txBody>
@@ -4917,7 +4917,7 @@
                 </a:solidFill>
                 <a:latin typeface="Georgia"/>
               </a:rPr>
-              <a:t>161,899</a:t>
+              <a:t>171,109</a:t>
             </a:r>
           </a:p>
         </p:txBody>
@@ -4985,7 +4985,7 @@
                 </a:solidFill>
                 <a:latin typeface="Helvetica Neue"/>
               </a:rPr>
-              <a:t>176 posts</a:t>
+              <a:t>181 posts</a:t>
             </a:r>
           </a:p>
         </p:txBody>
@@ -5019,7 +5019,7 @@
                 </a:solidFill>
                 <a:latin typeface="Helvetica Neue"/>
               </a:rPr>
-              <a:t>920 avg views/post</a:t>
+              <a:t>945 avg views/post</a:t>
             </a:r>
           </a:p>
         </p:txBody>
@@ -5175,7 +5175,7 @@
                 </a:solidFill>
                 <a:latin typeface="Georgia"/>
               </a:rPr>
-              <a:t>1,704</a:t>
+              <a:t>1,740</a:t>
             </a:r>
           </a:p>
         </p:txBody>
@@ -5277,7 +5277,7 @@
                 </a:solidFill>
                 <a:latin typeface="Helvetica Neue"/>
               </a:rPr>
-              <a:t>114 avg views/post</a:t>
+              <a:t>116 avg views/post</a:t>
             </a:r>
           </a:p>
         </p:txBody>
@@ -5587,7 +5587,7 @@
                 </a:solidFill>
                 <a:latin typeface="Helvetica Neue"/>
               </a:rPr>
-              <a:t>93,782   (61 posts · 1,537 avg)</a:t>
+              <a:t>93,789   (61 posts · 1,538 avg)</a:t>
             </a:r>
           </a:p>
         </p:txBody>
@@ -5635,7 +5635,7 @@
         <p:spPr>
           <a:xfrm>
             <a:off x="3383280" y="2532888"/>
-            <a:ext cx="5634877" cy="192024"/>
+            <a:ext cx="5879706" cy="192024"/>
           </a:xfrm>
           <a:prstGeom prst="rect">
             <a:avLst/>
@@ -5678,7 +5678,7 @@
         </p:nvSpPr>
         <p:spPr>
           <a:xfrm>
-            <a:off x="9109597" y="2505456"/>
+            <a:off x="9354426" y="2505456"/>
             <a:ext cx="2286000" cy="329184"/>
           </a:xfrm>
           <a:prstGeom prst="rect">
@@ -5699,7 +5699,7 @@
                 </a:solidFill>
                 <a:latin typeface="Helvetica Neue"/>
               </a:rPr>
-              <a:t>77,056   (141 posts · 546 avg)</a:t>
+              <a:t>80,410   (147 posts · 547 avg)</a:t>
             </a:r>
           </a:p>
         </p:txBody>
@@ -5747,7 +5747,7 @@
         <p:spPr>
           <a:xfrm>
             <a:off x="3383280" y="2862072"/>
-            <a:ext cx="4572999" cy="192024"/>
+            <a:ext cx="4572731" cy="192024"/>
           </a:xfrm>
           <a:prstGeom prst="rect">
             <a:avLst/>
@@ -5790,7 +5790,7 @@
         </p:nvSpPr>
         <p:spPr>
           <a:xfrm>
-            <a:off x="8047719" y="2834640"/>
+            <a:off x="8047451" y="2834640"/>
             <a:ext cx="2286000" cy="329184"/>
           </a:xfrm>
           <a:prstGeom prst="rect">
@@ -5811,7 +5811,7 @@
                 </a:solidFill>
                 <a:latin typeface="Helvetica Neue"/>
               </a:rPr>
-              <a:t>62,535   (22 posts · 2,842 avg)</a:t>
+              <a:t>62,536   (22 posts · 2,843 avg)</a:t>
             </a:r>
           </a:p>
         </p:txBody>
@@ -5859,7 +5859,7 @@
         <p:spPr>
           <a:xfrm>
             <a:off x="3383280" y="3191256"/>
-            <a:ext cx="3734524" cy="192024"/>
+            <a:ext cx="3738487" cy="192024"/>
           </a:xfrm>
           <a:prstGeom prst="rect">
             <a:avLst/>
@@ -5902,7 +5902,7 @@
         </p:nvSpPr>
         <p:spPr>
           <a:xfrm>
-            <a:off x="7209244" y="3163824"/>
+            <a:off x="7213207" y="3163824"/>
             <a:ext cx="2286000" cy="329184"/>
           </a:xfrm>
           <a:prstGeom prst="rect">
@@ -5923,7 +5923,7 @@
                 </a:solidFill>
                 <a:latin typeface="Helvetica Neue"/>
               </a:rPr>
-              <a:t>51,069   (16 posts · 3,192 avg)</a:t>
+              <a:t>51,127   (16 posts · 3,195 avg)</a:t>
             </a:r>
           </a:p>
         </p:txBody>
@@ -5971,7 +5971,7 @@
         <p:spPr>
           <a:xfrm>
             <a:off x="3383280" y="3520440"/>
-            <a:ext cx="3486477" cy="192024"/>
+            <a:ext cx="3486217" cy="192024"/>
           </a:xfrm>
           <a:prstGeom prst="rect">
             <a:avLst/>
@@ -6014,7 +6014,7 @@
         </p:nvSpPr>
         <p:spPr>
           <a:xfrm>
-            <a:off x="6961197" y="3493008"/>
+            <a:off x="6960937" y="3493008"/>
             <a:ext cx="2286000" cy="329184"/>
           </a:xfrm>
           <a:prstGeom prst="rect">
@@ -6083,7 +6083,7 @@
         <p:spPr>
           <a:xfrm>
             <a:off x="3383280" y="3849624"/>
-            <a:ext cx="3010055" cy="192024"/>
+            <a:ext cx="3009830" cy="192024"/>
           </a:xfrm>
           <a:prstGeom prst="rect">
             <a:avLst/>
@@ -6126,7 +6126,7 @@
         </p:nvSpPr>
         <p:spPr>
           <a:xfrm>
-            <a:off x="6484775" y="3822192"/>
+            <a:off x="6484550" y="3822192"/>
             <a:ext cx="2286000" cy="329184"/>
           </a:xfrm>
           <a:prstGeom prst="rect">
@@ -6195,7 +6195,7 @@
         <p:spPr>
           <a:xfrm>
             <a:off x="3383280" y="4178807"/>
-            <a:ext cx="2320247" cy="192024"/>
+            <a:ext cx="2328044" cy="192024"/>
           </a:xfrm>
           <a:prstGeom prst="rect">
             <a:avLst/>
@@ -6238,7 +6238,7 @@
         </p:nvSpPr>
         <p:spPr>
           <a:xfrm>
-            <a:off x="5794967" y="4151376"/>
+            <a:off x="5802764" y="4151376"/>
             <a:ext cx="2286000" cy="329184"/>
           </a:xfrm>
           <a:prstGeom prst="rect">
@@ -6259,7 +6259,7 @@
                 </a:solidFill>
                 <a:latin typeface="Helvetica Neue"/>
               </a:rPr>
-              <a:t>31,729   (32 posts · 992 avg)</a:t>
+              <a:t>31,838   (32 posts · 995 avg)</a:t>
             </a:r>
           </a:p>
         </p:txBody>
@@ -6307,7 +6307,7 @@
         <p:spPr>
           <a:xfrm>
             <a:off x="3383280" y="4507992"/>
-            <a:ext cx="2085875" cy="192024"/>
+            <a:ext cx="2164545" cy="192024"/>
           </a:xfrm>
           <a:prstGeom prst="rect">
             <a:avLst/>
@@ -6350,7 +6350,7 @@
         </p:nvSpPr>
         <p:spPr>
           <a:xfrm>
-            <a:off x="5560595" y="4480560"/>
+            <a:off x="5639265" y="4480560"/>
             <a:ext cx="2286000" cy="329184"/>
           </a:xfrm>
           <a:prstGeom prst="rect">
@@ -6371,7 +6371,7 @@
                 </a:solidFill>
                 <a:latin typeface="Helvetica Neue"/>
               </a:rPr>
-              <a:t>28,524   (18 posts · 1,585 avg)</a:t>
+              <a:t>29,602   (18 posts · 1,645 avg)</a:t>
             </a:r>
           </a:p>
         </p:txBody>
@@ -6419,7 +6419,7 @@
         <p:spPr>
           <a:xfrm>
             <a:off x="3383280" y="4837176"/>
-            <a:ext cx="2046021" cy="192024"/>
+            <a:ext cx="2080382" cy="192024"/>
           </a:xfrm>
           <a:prstGeom prst="rect">
             <a:avLst/>
@@ -6462,7 +6462,7 @@
         </p:nvSpPr>
         <p:spPr>
           <a:xfrm>
-            <a:off x="5520741" y="4809744"/>
+            <a:off x="5555102" y="4809744"/>
             <a:ext cx="2286000" cy="329184"/>
           </a:xfrm>
           <a:prstGeom prst="rect">
@@ -6483,7 +6483,7 @@
                 </a:solidFill>
                 <a:latin typeface="Helvetica Neue"/>
               </a:rPr>
-              <a:t>27,979   (6 posts · 4,663 avg)</a:t>
+              <a:t>28,451   (6 posts · 4,742 avg)</a:t>
             </a:r>
           </a:p>
         </p:txBody>
@@ -6517,7 +6517,7 @@
                 </a:solidFill>
                 <a:latin typeface="Helvetica Neue"/>
               </a:rPr>
-              <a:t>Judicial</a:t>
+              <a:t>Political Highlight</a:t>
             </a:r>
           </a:p>
         </p:txBody>
@@ -6531,7 +6531,119 @@
         <p:spPr>
           <a:xfrm>
             <a:off x="3383280" y="5166359"/>
-            <a:ext cx="1487403" cy="192024"/>
+            <a:ext cx="1657373" cy="192024"/>
+          </a:xfrm>
+          <a:prstGeom prst="rect">
+            <a:avLst/>
+          </a:prstGeom>
+          <a:solidFill>
+            <a:srgbClr val="2E86AB"/>
+          </a:solidFill>
+          <a:ln>
+            <a:noFill/>
+          </a:ln>
+          <a:effectLst/>
+        </p:spPr>
+        <p:style>
+          <a:lnRef idx="1">
+            <a:schemeClr val="accent1"/>
+          </a:lnRef>
+          <a:fillRef idx="3">
+            <a:schemeClr val="accent1"/>
+          </a:fillRef>
+          <a:effectRef idx="2">
+            <a:schemeClr val="accent1"/>
+          </a:effectRef>
+          <a:fontRef idx="minor">
+            <a:schemeClr val="lt1"/>
+          </a:fontRef>
+        </p:style>
+        <p:txBody>
+          <a:bodyPr rtlCol="0" anchor="ctr"/>
+          <a:lstStyle/>
+          <a:p>
+            <a:pPr algn="ctr"/>
+          </a:p>
+        </p:txBody>
+      </p:sp>
+      <p:sp>
+        <p:nvSpPr>
+          <p:cNvPr id="35" name="TextBox 34"/>
+          <p:cNvSpPr txBox="1"/>
+          <p:nvPr/>
+        </p:nvSpPr>
+        <p:spPr>
+          <a:xfrm>
+            <a:off x="5132093" y="5138928"/>
+            <a:ext cx="2286000" cy="329184"/>
+          </a:xfrm>
+          <a:prstGeom prst="rect">
+            <a:avLst/>
+          </a:prstGeom>
+          <a:noFill/>
+        </p:spPr>
+        <p:txBody>
+          <a:bodyPr wrap="square" lIns="0" rIns="0" tIns="0" bIns="0">
+            <a:spAutoFit/>
+          </a:bodyPr>
+          <a:lstStyle/>
+          <a:p>
+            <a:r>
+              <a:rPr sz="1000" b="0">
+                <a:solidFill>
+                  <a:srgbClr val="6B7082"/>
+                </a:solidFill>
+                <a:latin typeface="Helvetica Neue"/>
+              </a:rPr>
+              <a:t>22,666   (27 posts · 839 avg)</a:t>
+            </a:r>
+          </a:p>
+        </p:txBody>
+      </p:sp>
+      <p:sp>
+        <p:nvSpPr>
+          <p:cNvPr id="36" name="TextBox 35"/>
+          <p:cNvSpPr txBox="1"/>
+          <p:nvPr/>
+        </p:nvSpPr>
+        <p:spPr>
+          <a:xfrm>
+            <a:off x="731520" y="5468112"/>
+            <a:ext cx="2468880" cy="329184"/>
+          </a:xfrm>
+          <a:prstGeom prst="rect">
+            <a:avLst/>
+          </a:prstGeom>
+          <a:noFill/>
+        </p:spPr>
+        <p:txBody>
+          <a:bodyPr wrap="square" lIns="0" rIns="0" tIns="0" bIns="0">
+            <a:spAutoFit/>
+          </a:bodyPr>
+          <a:lstStyle/>
+          <a:p>
+            <a:r>
+              <a:rPr sz="1100" b="0">
+                <a:solidFill>
+                  <a:srgbClr val="141833"/>
+                </a:solidFill>
+                <a:latin typeface="Helvetica Neue"/>
+              </a:rPr>
+              <a:t>Judicial</a:t>
+            </a:r>
+          </a:p>
+        </p:txBody>
+      </p:sp>
+      <p:sp>
+        <p:nvSpPr>
+          <p:cNvPr id="37" name="Rectangle 36"/>
+          <p:cNvSpPr/>
+          <p:nvPr/>
+        </p:nvSpPr>
+        <p:spPr>
+          <a:xfrm>
+            <a:off x="3383280" y="5495543"/>
+            <a:ext cx="1493800" cy="192024"/>
           </a:xfrm>
           <a:prstGeom prst="rect">
             <a:avLst/>
@@ -6568,13 +6680,13 @@
       </p:sp>
       <p:sp>
         <p:nvSpPr>
-          <p:cNvPr id="35" name="TextBox 34"/>
-          <p:cNvSpPr txBox="1"/>
-          <p:nvPr/>
-        </p:nvSpPr>
-        <p:spPr>
-          <a:xfrm>
-            <a:off x="4962123" y="5138928"/>
+          <p:cNvPr id="38" name="TextBox 37"/>
+          <p:cNvSpPr txBox="1"/>
+          <p:nvPr/>
+        </p:nvSpPr>
+        <p:spPr>
+          <a:xfrm>
+            <a:off x="4968520" y="5468112"/>
             <a:ext cx="2286000" cy="329184"/>
           </a:xfrm>
           <a:prstGeom prst="rect">
@@ -6595,20 +6707,20 @@
                 </a:solidFill>
                 <a:latin typeface="Helvetica Neue"/>
               </a:rPr>
-              <a:t>20,340   (49 posts · 415 avg)</a:t>
-            </a:r>
-          </a:p>
-        </p:txBody>
-      </p:sp>
-      <p:sp>
-        <p:nvSpPr>
-          <p:cNvPr id="36" name="TextBox 35"/>
-          <p:cNvSpPr txBox="1"/>
-          <p:nvPr/>
-        </p:nvSpPr>
-        <p:spPr>
-          <a:xfrm>
-            <a:off x="731520" y="5468112"/>
+              <a:t>20,429   (49 posts · 417 avg)</a:t>
+            </a:r>
+          </a:p>
+        </p:txBody>
+      </p:sp>
+      <p:sp>
+        <p:nvSpPr>
+          <p:cNvPr id="39" name="TextBox 38"/>
+          <p:cNvSpPr txBox="1"/>
+          <p:nvPr/>
+        </p:nvSpPr>
+        <p:spPr>
+          <a:xfrm>
+            <a:off x="731520" y="5797296"/>
             <a:ext cx="2468880" cy="329184"/>
           </a:xfrm>
           <a:prstGeom prst="rect">
@@ -6629,27 +6741,27 @@
                 </a:solidFill>
                 <a:latin typeface="Helvetica Neue"/>
               </a:rPr>
-              <a:t>Political Highlight</a:t>
-            </a:r>
-          </a:p>
-        </p:txBody>
-      </p:sp>
-      <p:sp>
-        <p:nvSpPr>
-          <p:cNvPr id="37" name="Rectangle 36"/>
+              <a:t>Community Events</a:t>
+            </a:r>
+          </a:p>
+        </p:txBody>
+      </p:sp>
+      <p:sp>
+        <p:nvSpPr>
+          <p:cNvPr id="40" name="Rectangle 39"/>
           <p:cNvSpPr/>
           <p:nvPr/>
         </p:nvSpPr>
         <p:spPr>
           <a:xfrm>
-            <a:off x="3383280" y="5495543"/>
-            <a:ext cx="1155114" cy="192024"/>
+            <a:off x="3383280" y="5824728"/>
+            <a:ext cx="1209650" cy="192024"/>
           </a:xfrm>
           <a:prstGeom prst="rect">
             <a:avLst/>
           </a:prstGeom>
           <a:solidFill>
-            <a:srgbClr val="2E86AB"/>
+            <a:srgbClr val="141833"/>
           </a:solidFill>
           <a:ln>
             <a:noFill/>
@@ -6680,13 +6792,13 @@
       </p:sp>
       <p:sp>
         <p:nvSpPr>
-          <p:cNvPr id="38" name="TextBox 37"/>
-          <p:cNvSpPr txBox="1"/>
-          <p:nvPr/>
-        </p:nvSpPr>
-        <p:spPr>
-          <a:xfrm>
-            <a:off x="4629834" y="5468112"/>
+          <p:cNvPr id="41" name="TextBox 40"/>
+          <p:cNvSpPr txBox="1"/>
+          <p:nvPr/>
+        </p:nvSpPr>
+        <p:spPr>
+          <a:xfrm>
+            <a:off x="4684370" y="5797296"/>
             <a:ext cx="2286000" cy="329184"/>
           </a:xfrm>
           <a:prstGeom prst="rect">
@@ -6707,119 +6819,7 @@
                 </a:solidFill>
                 <a:latin typeface="Helvetica Neue"/>
               </a:rPr>
-              <a:t>15,796   (22 posts · 718 avg)</a:t>
-            </a:r>
-          </a:p>
-        </p:txBody>
-      </p:sp>
-      <p:sp>
-        <p:nvSpPr>
-          <p:cNvPr id="39" name="TextBox 38"/>
-          <p:cNvSpPr txBox="1"/>
-          <p:nvPr/>
-        </p:nvSpPr>
-        <p:spPr>
-          <a:xfrm>
-            <a:off x="731520" y="5797296"/>
-            <a:ext cx="2468880" cy="329184"/>
-          </a:xfrm>
-          <a:prstGeom prst="rect">
-            <a:avLst/>
-          </a:prstGeom>
-          <a:noFill/>
-        </p:spPr>
-        <p:txBody>
-          <a:bodyPr wrap="square" lIns="0" rIns="0" tIns="0" bIns="0">
-            <a:spAutoFit/>
-          </a:bodyPr>
-          <a:lstStyle/>
-          <a:p>
-            <a:r>
-              <a:rPr sz="1100" b="0">
-                <a:solidFill>
-                  <a:srgbClr val="141833"/>
-                </a:solidFill>
-                <a:latin typeface="Helvetica Neue"/>
-              </a:rPr>
-              <a:t>Elections</a:t>
-            </a:r>
-          </a:p>
-        </p:txBody>
-      </p:sp>
-      <p:sp>
-        <p:nvSpPr>
-          <p:cNvPr id="40" name="Rectangle 39"/>
-          <p:cNvSpPr/>
-          <p:nvPr/>
-        </p:nvSpPr>
-        <p:spPr>
-          <a:xfrm>
-            <a:off x="3383280" y="5824728"/>
-            <a:ext cx="968713" cy="192024"/>
-          </a:xfrm>
-          <a:prstGeom prst="rect">
-            <a:avLst/>
-          </a:prstGeom>
-          <a:solidFill>
-            <a:srgbClr val="2F3C7E"/>
-          </a:solidFill>
-          <a:ln>
-            <a:noFill/>
-          </a:ln>
-          <a:effectLst/>
-        </p:spPr>
-        <p:style>
-          <a:lnRef idx="1">
-            <a:schemeClr val="accent1"/>
-          </a:lnRef>
-          <a:fillRef idx="3">
-            <a:schemeClr val="accent1"/>
-          </a:fillRef>
-          <a:effectRef idx="2">
-            <a:schemeClr val="accent1"/>
-          </a:effectRef>
-          <a:fontRef idx="minor">
-            <a:schemeClr val="lt1"/>
-          </a:fontRef>
-        </p:style>
-        <p:txBody>
-          <a:bodyPr rtlCol="0" anchor="ctr"/>
-          <a:lstStyle/>
-          <a:p>
-            <a:pPr algn="ctr"/>
-          </a:p>
-        </p:txBody>
-      </p:sp>
-      <p:sp>
-        <p:nvSpPr>
-          <p:cNvPr id="41" name="TextBox 40"/>
-          <p:cNvSpPr txBox="1"/>
-          <p:nvPr/>
-        </p:nvSpPr>
-        <p:spPr>
-          <a:xfrm>
-            <a:off x="4443433" y="5797296"/>
-            <a:ext cx="2286000" cy="329184"/>
-          </a:xfrm>
-          <a:prstGeom prst="rect">
-            <a:avLst/>
-          </a:prstGeom>
-          <a:noFill/>
-        </p:spPr>
-        <p:txBody>
-          <a:bodyPr wrap="square" lIns="0" rIns="0" tIns="0" bIns="0">
-            <a:spAutoFit/>
-          </a:bodyPr>
-          <a:lstStyle/>
-          <a:p>
-            <a:r>
-              <a:rPr sz="1000" b="0">
-                <a:solidFill>
-                  <a:srgbClr val="6B7082"/>
-                </a:solidFill>
-                <a:latin typeface="Helvetica Neue"/>
-              </a:rPr>
-              <a:t>13,247   (16 posts · 828 avg)</a:t>
+              <a:t>16,543   (24 posts · 689 avg)</a:t>
             </a:r>
           </a:p>
         </p:txBody>
@@ -8437,7 +8437,7 @@
                 </a:solidFill>
                 <a:latin typeface="Helvetica Neue"/>
               </a:rPr>
-              <a:t>10,067</a:t>
+              <a:t>10,958</a:t>
             </a:r>
           </a:p>
         </p:txBody>
@@ -8471,7 +8471,7 @@
                 </a:solidFill>
                 <a:latin typeface="Helvetica Neue"/>
               </a:rPr>
-              <a:t>43</a:t>
+              <a:t>46</a:t>
             </a:r>
           </a:p>
         </p:txBody>
@@ -9103,7 +9103,7 @@
                 </a:solidFill>
                 <a:latin typeface="Helvetica Neue"/>
               </a:rPr>
-              <a:t>25,000+ people gathered for a watch party at Stonewood Mall! Despite the $300k c</a:t>
+              <a:t>Chaos erupted! Lissette Rivera refused to calm down, escalating until she was es</a:t>
             </a:r>
           </a:p>
         </p:txBody>
@@ -9137,7 +9137,7 @@
                 </a:solidFill>
                 <a:latin typeface="Helvetica Neue"/>
               </a:rPr>
-              <a:t>7,180</a:t>
+              <a:t>7,523</a:t>
             </a:r>
           </a:p>
         </p:txBody>
@@ -9171,7 +9171,7 @@
                 </a:solidFill>
                 <a:latin typeface="Helvetica Neue"/>
               </a:rPr>
-              <a:t>264</a:t>
+              <a:t>106</a:t>
             </a:r>
           </a:p>
         </p:txBody>
@@ -9205,7 +9205,7 @@
                 </a:solidFill>
                 <a:latin typeface="Helvetica Neue"/>
               </a:rPr>
-              <a:t>Fifa Positive</a:t>
+              <a:t>Council Chaos</a:t>
             </a:r>
           </a:p>
         </p:txBody>
@@ -9307,7 +9307,7 @@
                 </a:solidFill>
                 <a:latin typeface="Helvetica Neue"/>
               </a:rPr>
-              <a:t>Chaos erupted! Lissette Rivera refused to calm down, escalating until she was es</a:t>
+              <a:t>25,000+ people gathered for a watch party at Stonewood Mall! Despite the $300k c</a:t>
             </a:r>
           </a:p>
         </p:txBody>
@@ -9341,7 +9341,7 @@
                 </a:solidFill>
                 <a:latin typeface="Helvetica Neue"/>
               </a:rPr>
-              <a:t>7,051</a:t>
+              <a:t>7,180</a:t>
             </a:r>
           </a:p>
         </p:txBody>
@@ -9375,7 +9375,7 @@
                 </a:solidFill>
                 <a:latin typeface="Helvetica Neue"/>
               </a:rPr>
-              <a:t>100</a:t>
+              <a:t>264</a:t>
             </a:r>
           </a:p>
         </p:txBody>
@@ -9409,7 +9409,7 @@
                 </a:solidFill>
                 <a:latin typeface="Helvetica Neue"/>
               </a:rPr>
-              <a:t>Council Chaos</a:t>
+              <a:t>Fifa Positive</a:t>
             </a:r>
           </a:p>
         </p:txBody>

</xml_diff>

<commit_message>
Scheduled snapshot t35 (2026-09-18): fresh IG/FB/YT/TT + rebuilt decks
Co-Authored-By: Claude Opus 4.7 (1M context) <noreply@anthropic.com>
</commit_message>
<xml_diff>
--- a/OVERALL_REPORT.pptx
+++ b/OVERALL_REPORT.pptx
@@ -3277,7 +3277,7 @@
                 </a:solidFill>
                 <a:latin typeface="Georgia"/>
               </a:rPr>
-              <a:t>Since Jun 8, 2026 · 2026-09-16</a:t>
+              <a:t>Since Jun 8, 2026 · 2026-09-18</a:t>
             </a:r>
           </a:p>
         </p:txBody>
@@ -3578,7 +3578,7 @@
                 </a:solidFill>
                 <a:latin typeface="Georgia"/>
               </a:rPr>
-              <a:t>592,661</a:t>
+              <a:t>607,269</a:t>
             </a:r>
           </a:p>
         </p:txBody>
@@ -3769,7 +3769,7 @@
                 </a:solidFill>
                 <a:latin typeface="Georgia"/>
               </a:rPr>
-              <a:t>510</a:t>
+              <a:t>523</a:t>
             </a:r>
           </a:p>
         </p:txBody>
@@ -3925,7 +3925,7 @@
                 </a:solidFill>
                 <a:latin typeface="Georgia"/>
               </a:rPr>
-              <a:t>18,369</a:t>
+              <a:t>18,625</a:t>
             </a:r>
           </a:p>
         </p:txBody>
@@ -4081,7 +4081,7 @@
                 </a:solidFill>
                 <a:latin typeface="Georgia"/>
               </a:rPr>
-              <a:t>1,162</a:t>
+              <a:t>1,161</a:t>
             </a:r>
           </a:p>
         </p:txBody>
@@ -4401,7 +4401,7 @@
                 </a:solidFill>
                 <a:latin typeface="Georgia"/>
               </a:rPr>
-              <a:t>179,414</a:t>
+              <a:t>183,251</a:t>
             </a:r>
           </a:p>
         </p:txBody>
@@ -4469,7 +4469,7 @@
                 </a:solidFill>
                 <a:latin typeface="Helvetica Neue"/>
               </a:rPr>
-              <a:t>164 posts</a:t>
+              <a:t>168 posts</a:t>
             </a:r>
           </a:p>
         </p:txBody>
@@ -4503,7 +4503,7 @@
                 </a:solidFill>
                 <a:latin typeface="Helvetica Neue"/>
               </a:rPr>
-              <a:t>1,094 avg views/post</a:t>
+              <a:t>1,091 avg views/post</a:t>
             </a:r>
           </a:p>
         </p:txBody>
@@ -4659,7 +4659,7 @@
                 </a:solidFill>
                 <a:latin typeface="Georgia"/>
               </a:rPr>
-              <a:t>240,398</a:t>
+              <a:t>242,581</a:t>
             </a:r>
           </a:p>
         </p:txBody>
@@ -4727,7 +4727,7 @@
                 </a:solidFill>
                 <a:latin typeface="Helvetica Neue"/>
               </a:rPr>
-              <a:t>150 posts</a:t>
+              <a:t>154 posts</a:t>
             </a:r>
           </a:p>
         </p:txBody>
@@ -4761,7 +4761,7 @@
                 </a:solidFill>
                 <a:latin typeface="Helvetica Neue"/>
               </a:rPr>
-              <a:t>1,603 avg views/post</a:t>
+              <a:t>1,575 avg views/post</a:t>
             </a:r>
           </a:p>
         </p:txBody>
@@ -4917,7 +4917,7 @@
                 </a:solidFill>
                 <a:latin typeface="Georgia"/>
               </a:rPr>
-              <a:t>171,109</a:t>
+              <a:t>179,664</a:t>
             </a:r>
           </a:p>
         </p:txBody>
@@ -4985,7 +4985,7 @@
                 </a:solidFill>
                 <a:latin typeface="Helvetica Neue"/>
               </a:rPr>
-              <a:t>181 posts</a:t>
+              <a:t>186 posts</a:t>
             </a:r>
           </a:p>
         </p:txBody>
@@ -5019,7 +5019,7 @@
                 </a:solidFill>
                 <a:latin typeface="Helvetica Neue"/>
               </a:rPr>
-              <a:t>945 avg views/post</a:t>
+              <a:t>966 avg views/post</a:t>
             </a:r>
           </a:p>
         </p:txBody>
@@ -5175,7 +5175,7 @@
                 </a:solidFill>
                 <a:latin typeface="Georgia"/>
               </a:rPr>
-              <a:t>1,740</a:t>
+              <a:t>1,773</a:t>
             </a:r>
           </a:p>
         </p:txBody>
@@ -5277,7 +5277,7 @@
                 </a:solidFill>
                 <a:latin typeface="Helvetica Neue"/>
               </a:rPr>
-              <a:t>116 avg views/post</a:t>
+              <a:t>118 avg views/post</a:t>
             </a:r>
           </a:p>
         </p:txBody>
@@ -5587,7 +5587,7 @@
                 </a:solidFill>
                 <a:latin typeface="Helvetica Neue"/>
               </a:rPr>
-              <a:t>93,789   (61 posts · 1,538 avg)</a:t>
+              <a:t>93,797   (61 posts · 1,538 avg)</a:t>
             </a:r>
           </a:p>
         </p:txBody>
@@ -5635,7 +5635,7 @@
         <p:spPr>
           <a:xfrm>
             <a:off x="3383280" y="2532888"/>
-            <a:ext cx="5879706" cy="192024"/>
+            <a:ext cx="6361546" cy="192024"/>
           </a:xfrm>
           <a:prstGeom prst="rect">
             <a:avLst/>
@@ -5678,7 +5678,7 @@
         </p:nvSpPr>
         <p:spPr>
           <a:xfrm>
-            <a:off x="9354426" y="2505456"/>
+            <a:off x="9836266" y="2505456"/>
             <a:ext cx="2286000" cy="329184"/>
           </a:xfrm>
           <a:prstGeom prst="rect">
@@ -5699,7 +5699,7 @@
                 </a:solidFill>
                 <a:latin typeface="Helvetica Neue"/>
               </a:rPr>
-              <a:t>80,410   (147 posts · 547 avg)</a:t>
+              <a:t>87,007   (154 posts · 565 avg)</a:t>
             </a:r>
           </a:p>
         </p:txBody>
@@ -5747,7 +5747,7 @@
         <p:spPr>
           <a:xfrm>
             <a:off x="3383280" y="2862072"/>
-            <a:ext cx="4572731" cy="192024"/>
+            <a:ext cx="4572341" cy="192024"/>
           </a:xfrm>
           <a:prstGeom prst="rect">
             <a:avLst/>
@@ -5790,7 +5790,7 @@
         </p:nvSpPr>
         <p:spPr>
           <a:xfrm>
-            <a:off x="8047451" y="2834640"/>
+            <a:off x="8047061" y="2834640"/>
             <a:ext cx="2286000" cy="329184"/>
           </a:xfrm>
           <a:prstGeom prst="rect">
@@ -5859,7 +5859,7 @@
         <p:spPr>
           <a:xfrm>
             <a:off x="3383280" y="3191256"/>
-            <a:ext cx="3738487" cy="192024"/>
+            <a:ext cx="3740288" cy="192024"/>
           </a:xfrm>
           <a:prstGeom prst="rect">
             <a:avLst/>
@@ -5902,7 +5902,7 @@
         </p:nvSpPr>
         <p:spPr>
           <a:xfrm>
-            <a:off x="7213207" y="3163824"/>
+            <a:off x="7215008" y="3163824"/>
             <a:ext cx="2286000" cy="329184"/>
           </a:xfrm>
           <a:prstGeom prst="rect">
@@ -5923,7 +5923,7 @@
                 </a:solidFill>
                 <a:latin typeface="Helvetica Neue"/>
               </a:rPr>
-              <a:t>51,127   (16 posts · 3,195 avg)</a:t>
+              <a:t>51,156   (16 posts · 3,197 avg)</a:t>
             </a:r>
           </a:p>
         </p:txBody>
@@ -5971,7 +5971,7 @@
         <p:spPr>
           <a:xfrm>
             <a:off x="3383280" y="3520440"/>
-            <a:ext cx="3486217" cy="192024"/>
+            <a:ext cx="3485920" cy="192024"/>
           </a:xfrm>
           <a:prstGeom prst="rect">
             <a:avLst/>
@@ -6014,7 +6014,7 @@
         </p:nvSpPr>
         <p:spPr>
           <a:xfrm>
-            <a:off x="6960937" y="3493008"/>
+            <a:off x="6960640" y="3493008"/>
             <a:ext cx="2286000" cy="329184"/>
           </a:xfrm>
           <a:prstGeom prst="rect">
@@ -6083,7 +6083,7 @@
         <p:spPr>
           <a:xfrm>
             <a:off x="3383280" y="3849624"/>
-            <a:ext cx="3009830" cy="192024"/>
+            <a:ext cx="3009573" cy="192024"/>
           </a:xfrm>
           <a:prstGeom prst="rect">
             <a:avLst/>
@@ -6126,7 +6126,7 @@
         </p:nvSpPr>
         <p:spPr>
           <a:xfrm>
-            <a:off x="6484550" y="3822192"/>
+            <a:off x="6484293" y="3822192"/>
             <a:ext cx="2286000" cy="329184"/>
           </a:xfrm>
           <a:prstGeom prst="rect">
@@ -6195,7 +6195,7 @@
         <p:spPr>
           <a:xfrm>
             <a:off x="3383280" y="4178807"/>
-            <a:ext cx="2328044" cy="192024"/>
+            <a:ext cx="2330478" cy="192024"/>
           </a:xfrm>
           <a:prstGeom prst="rect">
             <a:avLst/>
@@ -6238,7 +6238,7 @@
         </p:nvSpPr>
         <p:spPr>
           <a:xfrm>
-            <a:off x="5802764" y="4151376"/>
+            <a:off x="5805198" y="4151376"/>
             <a:ext cx="2286000" cy="329184"/>
           </a:xfrm>
           <a:prstGeom prst="rect">
@@ -6259,7 +6259,7 @@
                 </a:solidFill>
                 <a:latin typeface="Helvetica Neue"/>
               </a:rPr>
-              <a:t>31,838   (32 posts · 995 avg)</a:t>
+              <a:t>31,874   (32 posts · 996 avg)</a:t>
             </a:r>
           </a:p>
         </p:txBody>
@@ -6307,7 +6307,7 @@
         <p:spPr>
           <a:xfrm>
             <a:off x="3383280" y="4507992"/>
-            <a:ext cx="2164545" cy="192024"/>
+            <a:ext cx="2211666" cy="192024"/>
           </a:xfrm>
           <a:prstGeom prst="rect">
             <a:avLst/>
@@ -6350,7 +6350,7 @@
         </p:nvSpPr>
         <p:spPr>
           <a:xfrm>
-            <a:off x="5639265" y="4480560"/>
+            <a:off x="5686386" y="4480560"/>
             <a:ext cx="2286000" cy="329184"/>
           </a:xfrm>
           <a:prstGeom prst="rect">
@@ -6371,7 +6371,7 @@
                 </a:solidFill>
                 <a:latin typeface="Helvetica Neue"/>
               </a:rPr>
-              <a:t>29,602   (18 posts · 1,645 avg)</a:t>
+              <a:t>30,249   (18 posts · 1,680 avg)</a:t>
             </a:r>
           </a:p>
         </p:txBody>
@@ -6419,7 +6419,7 @@
         <p:spPr>
           <a:xfrm>
             <a:off x="3383280" y="4837176"/>
-            <a:ext cx="2080382" cy="192024"/>
+            <a:ext cx="2086711" cy="192024"/>
           </a:xfrm>
           <a:prstGeom prst="rect">
             <a:avLst/>
@@ -6462,7 +6462,7 @@
         </p:nvSpPr>
         <p:spPr>
           <a:xfrm>
-            <a:off x="5555102" y="4809744"/>
+            <a:off x="5561431" y="4809744"/>
             <a:ext cx="2286000" cy="329184"/>
           </a:xfrm>
           <a:prstGeom prst="rect">
@@ -6483,7 +6483,7 @@
                 </a:solidFill>
                 <a:latin typeface="Helvetica Neue"/>
               </a:rPr>
-              <a:t>28,451   (6 posts · 4,742 avg)</a:t>
+              <a:t>28,540   (6 posts · 4,757 avg)</a:t>
             </a:r>
           </a:p>
         </p:txBody>
@@ -6531,7 +6531,7 @@
         <p:spPr>
           <a:xfrm>
             <a:off x="3383280" y="5166359"/>
-            <a:ext cx="1657373" cy="192024"/>
+            <a:ext cx="1815088" cy="192024"/>
           </a:xfrm>
           <a:prstGeom prst="rect">
             <a:avLst/>
@@ -6574,7 +6574,7 @@
         </p:nvSpPr>
         <p:spPr>
           <a:xfrm>
-            <a:off x="5132093" y="5138928"/>
+            <a:off x="5289808" y="5138928"/>
             <a:ext cx="2286000" cy="329184"/>
           </a:xfrm>
           <a:prstGeom prst="rect">
@@ -6595,7 +6595,7 @@
                 </a:solidFill>
                 <a:latin typeface="Helvetica Neue"/>
               </a:rPr>
-              <a:t>22,666   (27 posts · 839 avg)</a:t>
+              <a:t>24,825   (28 posts · 887 avg)</a:t>
             </a:r>
           </a:p>
         </p:txBody>
@@ -6643,7 +6643,7 @@
         <p:spPr>
           <a:xfrm>
             <a:off x="3383280" y="5495543"/>
-            <a:ext cx="1493800" cy="192024"/>
+            <a:ext cx="1495720" cy="192024"/>
           </a:xfrm>
           <a:prstGeom prst="rect">
             <a:avLst/>
@@ -6686,7 +6686,7 @@
         </p:nvSpPr>
         <p:spPr>
           <a:xfrm>
-            <a:off x="4968520" y="5468112"/>
+            <a:off x="4970440" y="5468112"/>
             <a:ext cx="2286000" cy="329184"/>
           </a:xfrm>
           <a:prstGeom prst="rect">
@@ -6707,7 +6707,7 @@
                 </a:solidFill>
                 <a:latin typeface="Helvetica Neue"/>
               </a:rPr>
-              <a:t>20,429   (49 posts · 417 avg)</a:t>
+              <a:t>20,457   (49 posts · 417 avg)</a:t>
             </a:r>
           </a:p>
         </p:txBody>
@@ -6741,7 +6741,7 @@
                 </a:solidFill>
                 <a:latin typeface="Helvetica Neue"/>
               </a:rPr>
-              <a:t>Community Events</a:t>
+              <a:t>Elections</a:t>
             </a:r>
           </a:p>
         </p:txBody>
@@ -6755,13 +6755,13 @@
         <p:spPr>
           <a:xfrm>
             <a:off x="3383280" y="5824728"/>
-            <a:ext cx="1209650" cy="192024"/>
+            <a:ext cx="1291801" cy="192024"/>
           </a:xfrm>
           <a:prstGeom prst="rect">
             <a:avLst/>
           </a:prstGeom>
           <a:solidFill>
-            <a:srgbClr val="141833"/>
+            <a:srgbClr val="2F3C7E"/>
           </a:solidFill>
           <a:ln>
             <a:noFill/>
@@ -6798,7 +6798,7 @@
         </p:nvSpPr>
         <p:spPr>
           <a:xfrm>
-            <a:off x="4684370" y="5797296"/>
+            <a:off x="4766521" y="5797296"/>
             <a:ext cx="2286000" cy="329184"/>
           </a:xfrm>
           <a:prstGeom prst="rect">
@@ -6819,7 +6819,7 @@
                 </a:solidFill>
                 <a:latin typeface="Helvetica Neue"/>
               </a:rPr>
-              <a:t>16,543   (24 posts · 689 avg)</a:t>
+              <a:t>17,668   (21 posts · 841 avg)</a:t>
             </a:r>
           </a:p>
         </p:txBody>
@@ -8437,7 +8437,7 @@
                 </a:solidFill>
                 <a:latin typeface="Helvetica Neue"/>
               </a:rPr>
-              <a:t>10,958</a:t>
+              <a:t>11,517</a:t>
             </a:r>
           </a:p>
         </p:txBody>
@@ -9137,7 +9137,7 @@
                 </a:solidFill>
                 <a:latin typeface="Helvetica Neue"/>
               </a:rPr>
-              <a:t>7,523</a:t>
+              <a:t>7,612</a:t>
             </a:r>
           </a:p>
         </p:txBody>
@@ -9171,7 +9171,7 @@
                 </a:solidFill>
                 <a:latin typeface="Helvetica Neue"/>
               </a:rPr>
-              <a:t>106</a:t>
+              <a:t>108</a:t>
             </a:r>
           </a:p>
         </p:txBody>

</xml_diff>

<commit_message>
Scheduled snapshot t36 (2026-09-21): fresh IG/FB/YT/TT + rebuilt decks
Co-Authored-By: Claude Opus 4.7 (1M context) <noreply@anthropic.com>
</commit_message>
<xml_diff>
--- a/OVERALL_REPORT.pptx
+++ b/OVERALL_REPORT.pptx
@@ -3277,7 +3277,7 @@
                 </a:solidFill>
                 <a:latin typeface="Georgia"/>
               </a:rPr>
-              <a:t>Since Jun 8, 2026 · 2026-09-18</a:t>
+              <a:t>Since Jun 8, 2026 · 2026-09-21</a:t>
             </a:r>
           </a:p>
         </p:txBody>
@@ -3578,7 +3578,7 @@
                 </a:solidFill>
                 <a:latin typeface="Georgia"/>
               </a:rPr>
-              <a:t>607,269</a:t>
+              <a:t>616,433</a:t>
             </a:r>
           </a:p>
         </p:txBody>
@@ -3769,7 +3769,7 @@
                 </a:solidFill>
                 <a:latin typeface="Georgia"/>
               </a:rPr>
-              <a:t>523</a:t>
+              <a:t>530</a:t>
             </a:r>
           </a:p>
         </p:txBody>
@@ -3925,7 +3925,7 @@
                 </a:solidFill>
                 <a:latin typeface="Georgia"/>
               </a:rPr>
-              <a:t>18,625</a:t>
+              <a:t>18,763</a:t>
             </a:r>
           </a:p>
         </p:txBody>
@@ -4081,7 +4081,7 @@
                 </a:solidFill>
                 <a:latin typeface="Georgia"/>
               </a:rPr>
-              <a:t>1,161</a:t>
+              <a:t>1,163</a:t>
             </a:r>
           </a:p>
         </p:txBody>
@@ -4401,7 +4401,7 @@
                 </a:solidFill>
                 <a:latin typeface="Georgia"/>
               </a:rPr>
-              <a:t>183,251</a:t>
+              <a:t>186,066</a:t>
             </a:r>
           </a:p>
         </p:txBody>
@@ -4469,7 +4469,7 @@
                 </a:solidFill>
                 <a:latin typeface="Helvetica Neue"/>
               </a:rPr>
-              <a:t>168 posts</a:t>
+              <a:t>170 posts</a:t>
             </a:r>
           </a:p>
         </p:txBody>
@@ -4503,7 +4503,7 @@
                 </a:solidFill>
                 <a:latin typeface="Helvetica Neue"/>
               </a:rPr>
-              <a:t>1,091 avg views/post</a:t>
+              <a:t>1,095 avg views/post</a:t>
             </a:r>
           </a:p>
         </p:txBody>
@@ -4659,7 +4659,7 @@
                 </a:solidFill>
                 <a:latin typeface="Georgia"/>
               </a:rPr>
-              <a:t>242,581</a:t>
+              <a:t>244,123</a:t>
             </a:r>
           </a:p>
         </p:txBody>
@@ -4727,7 +4727,7 @@
                 </a:solidFill>
                 <a:latin typeface="Helvetica Neue"/>
               </a:rPr>
-              <a:t>154 posts</a:t>
+              <a:t>156 posts</a:t>
             </a:r>
           </a:p>
         </p:txBody>
@@ -4761,7 +4761,7 @@
                 </a:solidFill>
                 <a:latin typeface="Helvetica Neue"/>
               </a:rPr>
-              <a:t>1,575 avg views/post</a:t>
+              <a:t>1,565 avg views/post</a:t>
             </a:r>
           </a:p>
         </p:txBody>
@@ -4917,7 +4917,7 @@
                 </a:solidFill>
                 <a:latin typeface="Georgia"/>
               </a:rPr>
-              <a:t>179,664</a:t>
+              <a:t>184,420</a:t>
             </a:r>
           </a:p>
         </p:txBody>
@@ -4985,7 +4985,7 @@
                 </a:solidFill>
                 <a:latin typeface="Helvetica Neue"/>
               </a:rPr>
-              <a:t>186 posts</a:t>
+              <a:t>189 posts</a:t>
             </a:r>
           </a:p>
         </p:txBody>
@@ -5019,7 +5019,7 @@
                 </a:solidFill>
                 <a:latin typeface="Helvetica Neue"/>
               </a:rPr>
-              <a:t>966 avg views/post</a:t>
+              <a:t>976 avg views/post</a:t>
             </a:r>
           </a:p>
         </p:txBody>
@@ -5175,7 +5175,7 @@
                 </a:solidFill>
                 <a:latin typeface="Georgia"/>
               </a:rPr>
-              <a:t>1,773</a:t>
+              <a:t>1,824</a:t>
             </a:r>
           </a:p>
         </p:txBody>
@@ -5277,7 +5277,7 @@
                 </a:solidFill>
                 <a:latin typeface="Helvetica Neue"/>
               </a:rPr>
-              <a:t>118 avg views/post</a:t>
+              <a:t>122 avg views/post</a:t>
             </a:r>
           </a:p>
         </p:txBody>
@@ -5587,7 +5587,7 @@
                 </a:solidFill>
                 <a:latin typeface="Helvetica Neue"/>
               </a:rPr>
-              <a:t>93,797   (61 posts · 1,538 avg)</a:t>
+              <a:t>93,815   (61 posts · 1,538 avg)</a:t>
             </a:r>
           </a:p>
         </p:txBody>
@@ -5635,7 +5635,7 @@
         <p:spPr>
           <a:xfrm>
             <a:off x="3383280" y="2532888"/>
-            <a:ext cx="6361546" cy="192024"/>
+            <a:ext cx="6579557" cy="192024"/>
           </a:xfrm>
           <a:prstGeom prst="rect">
             <a:avLst/>
@@ -5678,7 +5678,7 @@
         </p:nvSpPr>
         <p:spPr>
           <a:xfrm>
-            <a:off x="9836266" y="2505456"/>
+            <a:off x="10054277" y="2505456"/>
             <a:ext cx="2286000" cy="329184"/>
           </a:xfrm>
           <a:prstGeom prst="rect">
@@ -5699,7 +5699,7 @@
                 </a:solidFill>
                 <a:latin typeface="Helvetica Neue"/>
               </a:rPr>
-              <a:t>87,007   (154 posts · 565 avg)</a:t>
+              <a:t>90,006   (156 posts · 577 avg)</a:t>
             </a:r>
           </a:p>
         </p:txBody>
@@ -5747,7 +5747,7 @@
         <p:spPr>
           <a:xfrm>
             <a:off x="3383280" y="2862072"/>
-            <a:ext cx="4572341" cy="192024"/>
+            <a:ext cx="4571463" cy="192024"/>
           </a:xfrm>
           <a:prstGeom prst="rect">
             <a:avLst/>
@@ -5790,7 +5790,7 @@
         </p:nvSpPr>
         <p:spPr>
           <a:xfrm>
-            <a:off x="8047061" y="2834640"/>
+            <a:off x="8046183" y="2834640"/>
             <a:ext cx="2286000" cy="329184"/>
           </a:xfrm>
           <a:prstGeom prst="rect">
@@ -5859,7 +5859,7 @@
         <p:spPr>
           <a:xfrm>
             <a:off x="3383280" y="3191256"/>
-            <a:ext cx="3740288" cy="192024"/>
+            <a:ext cx="3774951" cy="192024"/>
           </a:xfrm>
           <a:prstGeom prst="rect">
             <a:avLst/>
@@ -5902,7 +5902,7 @@
         </p:nvSpPr>
         <p:spPr>
           <a:xfrm>
-            <a:off x="7215008" y="3163824"/>
+            <a:off x="7249671" y="3163824"/>
             <a:ext cx="2286000" cy="329184"/>
           </a:xfrm>
           <a:prstGeom prst="rect">
@@ -5923,7 +5923,7 @@
                 </a:solidFill>
                 <a:latin typeface="Helvetica Neue"/>
               </a:rPr>
-              <a:t>51,156   (16 posts · 3,197 avg)</a:t>
+              <a:t>51,640   (17 posts · 3,038 avg)</a:t>
             </a:r>
           </a:p>
         </p:txBody>
@@ -5971,7 +5971,7 @@
         <p:spPr>
           <a:xfrm>
             <a:off x="3383280" y="3520440"/>
-            <a:ext cx="3485920" cy="192024"/>
+            <a:ext cx="3485251" cy="192024"/>
           </a:xfrm>
           <a:prstGeom prst="rect">
             <a:avLst/>
@@ -6014,7 +6014,7 @@
         </p:nvSpPr>
         <p:spPr>
           <a:xfrm>
-            <a:off x="6960640" y="3493008"/>
+            <a:off x="6959971" y="3493008"/>
             <a:ext cx="2286000" cy="329184"/>
           </a:xfrm>
           <a:prstGeom prst="rect">
@@ -6083,7 +6083,7 @@
         <p:spPr>
           <a:xfrm>
             <a:off x="3383280" y="3849624"/>
-            <a:ext cx="3009573" cy="192024"/>
+            <a:ext cx="3009069" cy="192024"/>
           </a:xfrm>
           <a:prstGeom prst="rect">
             <a:avLst/>
@@ -6126,7 +6126,7 @@
         </p:nvSpPr>
         <p:spPr>
           <a:xfrm>
-            <a:off x="6484293" y="3822192"/>
+            <a:off x="6483789" y="3822192"/>
             <a:ext cx="2286000" cy="329184"/>
           </a:xfrm>
           <a:prstGeom prst="rect">
@@ -6147,7 +6147,7 @@
                 </a:solidFill>
                 <a:latin typeface="Helvetica Neue"/>
               </a:rPr>
-              <a:t>41,162   (18 posts · 2,287 avg)</a:t>
+              <a:t>41,163   (18 posts · 2,287 avg)</a:t>
             </a:r>
           </a:p>
         </p:txBody>
@@ -6195,7 +6195,7 @@
         <p:spPr>
           <a:xfrm>
             <a:off x="3383280" y="4178807"/>
-            <a:ext cx="2330478" cy="192024"/>
+            <a:ext cx="2407445" cy="192024"/>
           </a:xfrm>
           <a:prstGeom prst="rect">
             <a:avLst/>
@@ -6238,7 +6238,7 @@
         </p:nvSpPr>
         <p:spPr>
           <a:xfrm>
-            <a:off x="5805198" y="4151376"/>
+            <a:off x="5882165" y="4151376"/>
             <a:ext cx="2286000" cy="329184"/>
           </a:xfrm>
           <a:prstGeom prst="rect">
@@ -6259,7 +6259,7 @@
                 </a:solidFill>
                 <a:latin typeface="Helvetica Neue"/>
               </a:rPr>
-              <a:t>31,874   (32 posts · 996 avg)</a:t>
+              <a:t>32,933   (33 posts · 998 avg)</a:t>
             </a:r>
           </a:p>
         </p:txBody>
@@ -6307,7 +6307,7 @@
         <p:spPr>
           <a:xfrm>
             <a:off x="3383280" y="4507992"/>
-            <a:ext cx="2211666" cy="192024"/>
+            <a:ext cx="2231271" cy="192024"/>
           </a:xfrm>
           <a:prstGeom prst="rect">
             <a:avLst/>
@@ -6350,7 +6350,7 @@
         </p:nvSpPr>
         <p:spPr>
           <a:xfrm>
-            <a:off x="5686386" y="4480560"/>
+            <a:off x="5705991" y="4480560"/>
             <a:ext cx="2286000" cy="329184"/>
           </a:xfrm>
           <a:prstGeom prst="rect">
@@ -6371,7 +6371,7 @@
                 </a:solidFill>
                 <a:latin typeface="Helvetica Neue"/>
               </a:rPr>
-              <a:t>30,249   (18 posts · 1,680 avg)</a:t>
+              <a:t>30,523   (19 posts · 1,606 avg)</a:t>
             </a:r>
           </a:p>
         </p:txBody>
@@ -6419,7 +6419,7 @@
         <p:spPr>
           <a:xfrm>
             <a:off x="3383280" y="4837176"/>
-            <a:ext cx="2086711" cy="192024"/>
+            <a:ext cx="2090770" cy="192024"/>
           </a:xfrm>
           <a:prstGeom prst="rect">
             <a:avLst/>
@@ -6462,7 +6462,7 @@
         </p:nvSpPr>
         <p:spPr>
           <a:xfrm>
-            <a:off x="5561431" y="4809744"/>
+            <a:off x="5565490" y="4809744"/>
             <a:ext cx="2286000" cy="329184"/>
           </a:xfrm>
           <a:prstGeom prst="rect">
@@ -6483,7 +6483,7 @@
                 </a:solidFill>
                 <a:latin typeface="Helvetica Neue"/>
               </a:rPr>
-              <a:t>28,540   (6 posts · 4,757 avg)</a:t>
+              <a:t>28,601   (6 posts · 4,767 avg)</a:t>
             </a:r>
           </a:p>
         </p:txBody>
@@ -6531,7 +6531,7 @@
         <p:spPr>
           <a:xfrm>
             <a:off x="3383280" y="5166359"/>
-            <a:ext cx="1815088" cy="192024"/>
+            <a:ext cx="1948442" cy="192024"/>
           </a:xfrm>
           <a:prstGeom prst="rect">
             <a:avLst/>
@@ -6574,7 +6574,7 @@
         </p:nvSpPr>
         <p:spPr>
           <a:xfrm>
-            <a:off x="5289808" y="5138928"/>
+            <a:off x="5423162" y="5138928"/>
             <a:ext cx="2286000" cy="329184"/>
           </a:xfrm>
           <a:prstGeom prst="rect">
@@ -6595,7 +6595,7 @@
                 </a:solidFill>
                 <a:latin typeface="Helvetica Neue"/>
               </a:rPr>
-              <a:t>24,825   (28 posts · 887 avg)</a:t>
+              <a:t>26,654   (30 posts · 888 avg)</a:t>
             </a:r>
           </a:p>
         </p:txBody>
@@ -6643,7 +6643,7 @@
         <p:spPr>
           <a:xfrm>
             <a:off x="3383280" y="5495543"/>
-            <a:ext cx="1495720" cy="192024"/>
+            <a:ext cx="1497334" cy="192024"/>
           </a:xfrm>
           <a:prstGeom prst="rect">
             <a:avLst/>
@@ -6686,7 +6686,7 @@
         </p:nvSpPr>
         <p:spPr>
           <a:xfrm>
-            <a:off x="4970440" y="5468112"/>
+            <a:off x="4972054" y="5468112"/>
             <a:ext cx="2286000" cy="329184"/>
           </a:xfrm>
           <a:prstGeom prst="rect">
@@ -6707,7 +6707,7 @@
                 </a:solidFill>
                 <a:latin typeface="Helvetica Neue"/>
               </a:rPr>
-              <a:t>20,457   (49 posts · 417 avg)</a:t>
+              <a:t>20,483   (49 posts · 418 avg)</a:t>
             </a:r>
           </a:p>
         </p:txBody>
@@ -6755,7 +6755,7 @@
         <p:spPr>
           <a:xfrm>
             <a:off x="3383280" y="5824728"/>
-            <a:ext cx="1291801" cy="192024"/>
+            <a:ext cx="1435782" cy="192024"/>
           </a:xfrm>
           <a:prstGeom prst="rect">
             <a:avLst/>
@@ -6798,7 +6798,7 @@
         </p:nvSpPr>
         <p:spPr>
           <a:xfrm>
-            <a:off x="4766521" y="5797296"/>
+            <a:off x="4910502" y="5797296"/>
             <a:ext cx="2286000" cy="329184"/>
           </a:xfrm>
           <a:prstGeom prst="rect">
@@ -6819,7 +6819,7 @@
                 </a:solidFill>
                 <a:latin typeface="Helvetica Neue"/>
               </a:rPr>
-              <a:t>17,668   (21 posts · 841 avg)</a:t>
+              <a:t>19,641   (21 posts · 935 avg)</a:t>
             </a:r>
           </a:p>
         </p:txBody>
@@ -8437,7 +8437,7 @@
                 </a:solidFill>
                 <a:latin typeface="Helvetica Neue"/>
               </a:rPr>
-              <a:t>11,517</a:t>
+              <a:t>11,662</a:t>
             </a:r>
           </a:p>
         </p:txBody>
@@ -9137,7 +9137,7 @@
                 </a:solidFill>
                 <a:latin typeface="Helvetica Neue"/>
               </a:rPr>
-              <a:t>7,612</a:t>
+              <a:t>7,673</a:t>
             </a:r>
           </a:p>
         </p:txBody>

</xml_diff>

<commit_message>
Scheduled snapshot t37 (2026-09-23): fresh IG/FB/YT/TT + rebuilt decks
Co-Authored-By: Claude Opus 4.7 (1M context) <noreply@anthropic.com>
</commit_message>
<xml_diff>
--- a/OVERALL_REPORT.pptx
+++ b/OVERALL_REPORT.pptx
@@ -3277,7 +3277,7 @@
                 </a:solidFill>
                 <a:latin typeface="Georgia"/>
               </a:rPr>
-              <a:t>Since Jun 8, 2026 · 2026-09-21</a:t>
+              <a:t>Since Jun 8, 2026 · 2026-09-23</a:t>
             </a:r>
           </a:p>
         </p:txBody>
@@ -3578,7 +3578,7 @@
                 </a:solidFill>
                 <a:latin typeface="Georgia"/>
               </a:rPr>
-              <a:t>616,433</a:t>
+              <a:t>619,066</a:t>
             </a:r>
           </a:p>
         </p:txBody>
@@ -3769,7 +3769,7 @@
                 </a:solidFill>
                 <a:latin typeface="Georgia"/>
               </a:rPr>
-              <a:t>530</a:t>
+              <a:t>532</a:t>
             </a:r>
           </a:p>
         </p:txBody>
@@ -3925,7 +3925,7 @@
                 </a:solidFill>
                 <a:latin typeface="Georgia"/>
               </a:rPr>
-              <a:t>18,763</a:t>
+              <a:t>18,822</a:t>
             </a:r>
           </a:p>
         </p:txBody>
@@ -4401,7 +4401,7 @@
                 </a:solidFill>
                 <a:latin typeface="Georgia"/>
               </a:rPr>
-              <a:t>186,066</a:t>
+              <a:t>186,864</a:t>
             </a:r>
           </a:p>
         </p:txBody>
@@ -4503,7 +4503,7 @@
                 </a:solidFill>
                 <a:latin typeface="Helvetica Neue"/>
               </a:rPr>
-              <a:t>1,095 avg views/post</a:t>
+              <a:t>1,099 avg views/post</a:t>
             </a:r>
           </a:p>
         </p:txBody>
@@ -4659,7 +4659,7 @@
                 </a:solidFill>
                 <a:latin typeface="Georgia"/>
               </a:rPr>
-              <a:t>244,123</a:t>
+              <a:t>244,800</a:t>
             </a:r>
           </a:p>
         </p:txBody>
@@ -4761,7 +4761,7 @@
                 </a:solidFill>
                 <a:latin typeface="Helvetica Neue"/>
               </a:rPr>
-              <a:t>1,565 avg views/post</a:t>
+              <a:t>1,569 avg views/post</a:t>
             </a:r>
           </a:p>
         </p:txBody>
@@ -4917,7 +4917,7 @@
                 </a:solidFill>
                 <a:latin typeface="Georgia"/>
               </a:rPr>
-              <a:t>184,420</a:t>
+              <a:t>185,548</a:t>
             </a:r>
           </a:p>
         </p:txBody>
@@ -4985,7 +4985,7 @@
                 </a:solidFill>
                 <a:latin typeface="Helvetica Neue"/>
               </a:rPr>
-              <a:t>189 posts</a:t>
+              <a:t>191 posts</a:t>
             </a:r>
           </a:p>
         </p:txBody>
@@ -5019,7 +5019,7 @@
                 </a:solidFill>
                 <a:latin typeface="Helvetica Neue"/>
               </a:rPr>
-              <a:t>976 avg views/post</a:t>
+              <a:t>971 avg views/post</a:t>
             </a:r>
           </a:p>
         </p:txBody>
@@ -5175,7 +5175,7 @@
                 </a:solidFill>
                 <a:latin typeface="Georgia"/>
               </a:rPr>
-              <a:t>1,824</a:t>
+              <a:t>1,854</a:t>
             </a:r>
           </a:p>
         </p:txBody>
@@ -5277,7 +5277,7 @@
                 </a:solidFill>
                 <a:latin typeface="Helvetica Neue"/>
               </a:rPr>
-              <a:t>122 avg views/post</a:t>
+              <a:t>124 avg views/post</a:t>
             </a:r>
           </a:p>
         </p:txBody>
@@ -5587,7 +5587,7 @@
                 </a:solidFill>
                 <a:latin typeface="Helvetica Neue"/>
               </a:rPr>
-              <a:t>93,815   (61 posts · 1,538 avg)</a:t>
+              <a:t>93,817   (61 posts · 1,538 avg)</a:t>
             </a:r>
           </a:p>
         </p:txBody>
@@ -5635,7 +5635,7 @@
         <p:spPr>
           <a:xfrm>
             <a:off x="3383280" y="2532888"/>
-            <a:ext cx="6579557" cy="192024"/>
+            <a:ext cx="6647253" cy="192024"/>
           </a:xfrm>
           <a:prstGeom prst="rect">
             <a:avLst/>
@@ -5678,7 +5678,7 @@
         </p:nvSpPr>
         <p:spPr>
           <a:xfrm>
-            <a:off x="10054277" y="2505456"/>
+            <a:off x="10121973" y="2505456"/>
             <a:ext cx="2286000" cy="329184"/>
           </a:xfrm>
           <a:prstGeom prst="rect">
@@ -5699,7 +5699,7 @@
                 </a:solidFill>
                 <a:latin typeface="Helvetica Neue"/>
               </a:rPr>
-              <a:t>90,006   (156 posts · 577 avg)</a:t>
+              <a:t>90,934   (158 posts · 576 avg)</a:t>
             </a:r>
           </a:p>
         </p:txBody>
@@ -5747,7 +5747,7 @@
         <p:spPr>
           <a:xfrm>
             <a:off x="3383280" y="2862072"/>
-            <a:ext cx="4571463" cy="192024"/>
+            <a:ext cx="4571366" cy="192024"/>
           </a:xfrm>
           <a:prstGeom prst="rect">
             <a:avLst/>
@@ -5790,7 +5790,7 @@
         </p:nvSpPr>
         <p:spPr>
           <a:xfrm>
-            <a:off x="8046183" y="2834640"/>
+            <a:off x="8046086" y="2834640"/>
             <a:ext cx="2286000" cy="329184"/>
           </a:xfrm>
           <a:prstGeom prst="rect">
@@ -5859,7 +5859,7 @@
         <p:spPr>
           <a:xfrm>
             <a:off x="3383280" y="3191256"/>
-            <a:ext cx="3774951" cy="192024"/>
+            <a:ext cx="3781523" cy="192024"/>
           </a:xfrm>
           <a:prstGeom prst="rect">
             <a:avLst/>
@@ -5902,7 +5902,7 @@
         </p:nvSpPr>
         <p:spPr>
           <a:xfrm>
-            <a:off x="7249671" y="3163824"/>
+            <a:off x="7256243" y="3163824"/>
             <a:ext cx="2286000" cy="329184"/>
           </a:xfrm>
           <a:prstGeom prst="rect">
@@ -5923,7 +5923,7 @@
                 </a:solidFill>
                 <a:latin typeface="Helvetica Neue"/>
               </a:rPr>
-              <a:t>51,640   (17 posts · 3,038 avg)</a:t>
+              <a:t>51,731   (17 posts · 3,043 avg)</a:t>
             </a:r>
           </a:p>
         </p:txBody>
@@ -5971,7 +5971,7 @@
         <p:spPr>
           <a:xfrm>
             <a:off x="3383280" y="3520440"/>
-            <a:ext cx="3485251" cy="192024"/>
+            <a:ext cx="3485177" cy="192024"/>
           </a:xfrm>
           <a:prstGeom prst="rect">
             <a:avLst/>
@@ -6014,7 +6014,7 @@
         </p:nvSpPr>
         <p:spPr>
           <a:xfrm>
-            <a:off x="6959971" y="3493008"/>
+            <a:off x="6959897" y="3493008"/>
             <a:ext cx="2286000" cy="329184"/>
           </a:xfrm>
           <a:prstGeom prst="rect">
@@ -6083,7 +6083,7 @@
         <p:spPr>
           <a:xfrm>
             <a:off x="3383280" y="3849624"/>
-            <a:ext cx="3009069" cy="192024"/>
+            <a:ext cx="3009005" cy="192024"/>
           </a:xfrm>
           <a:prstGeom prst="rect">
             <a:avLst/>
@@ -6126,7 +6126,7 @@
         </p:nvSpPr>
         <p:spPr>
           <a:xfrm>
-            <a:off x="6483789" y="3822192"/>
+            <a:off x="6483725" y="3822192"/>
             <a:ext cx="2286000" cy="329184"/>
           </a:xfrm>
           <a:prstGeom prst="rect">
@@ -6195,7 +6195,7 @@
         <p:spPr>
           <a:xfrm>
             <a:off x="3383280" y="4178807"/>
-            <a:ext cx="2407445" cy="192024"/>
+            <a:ext cx="2414923" cy="192024"/>
           </a:xfrm>
           <a:prstGeom prst="rect">
             <a:avLst/>
@@ -6238,7 +6238,7 @@
         </p:nvSpPr>
         <p:spPr>
           <a:xfrm>
-            <a:off x="5882165" y="4151376"/>
+            <a:off x="5889643" y="4151376"/>
             <a:ext cx="2286000" cy="329184"/>
           </a:xfrm>
           <a:prstGeom prst="rect">
@@ -6259,7 +6259,7 @@
                 </a:solidFill>
                 <a:latin typeface="Helvetica Neue"/>
               </a:rPr>
-              <a:t>32,933   (33 posts · 998 avg)</a:t>
+              <a:t>33,036   (33 posts · 1,001 avg)</a:t>
             </a:r>
           </a:p>
         </p:txBody>
@@ -6307,7 +6307,7 @@
         <p:spPr>
           <a:xfrm>
             <a:off x="3383280" y="4507992"/>
-            <a:ext cx="2231271" cy="192024"/>
+            <a:ext cx="2243139" cy="192024"/>
           </a:xfrm>
           <a:prstGeom prst="rect">
             <a:avLst/>
@@ -6350,7 +6350,7 @@
         </p:nvSpPr>
         <p:spPr>
           <a:xfrm>
-            <a:off x="5705991" y="4480560"/>
+            <a:off x="5717859" y="4480560"/>
             <a:ext cx="2286000" cy="329184"/>
           </a:xfrm>
           <a:prstGeom prst="rect">
@@ -6371,7 +6371,7 @@
                 </a:solidFill>
                 <a:latin typeface="Helvetica Neue"/>
               </a:rPr>
-              <a:t>30,523   (19 posts · 1,606 avg)</a:t>
+              <a:t>30,686   (19 posts · 1,615 avg)</a:t>
             </a:r>
           </a:p>
         </p:txBody>
@@ -6419,7 +6419,7 @@
         <p:spPr>
           <a:xfrm>
             <a:off x="3383280" y="4837176"/>
-            <a:ext cx="2090770" cy="192024"/>
+            <a:ext cx="2092992" cy="192024"/>
           </a:xfrm>
           <a:prstGeom prst="rect">
             <a:avLst/>
@@ -6462,7 +6462,7 @@
         </p:nvSpPr>
         <p:spPr>
           <a:xfrm>
-            <a:off x="5565490" y="4809744"/>
+            <a:off x="5567712" y="4809744"/>
             <a:ext cx="2286000" cy="329184"/>
           </a:xfrm>
           <a:prstGeom prst="rect">
@@ -6483,7 +6483,7 @@
                 </a:solidFill>
                 <a:latin typeface="Helvetica Neue"/>
               </a:rPr>
-              <a:t>28,601   (6 posts · 4,767 avg)</a:t>
+              <a:t>28,632   (6 posts · 4,772 avg)</a:t>
             </a:r>
           </a:p>
         </p:txBody>
@@ -6531,7 +6531,7 @@
         <p:spPr>
           <a:xfrm>
             <a:off x="3383280" y="5166359"/>
-            <a:ext cx="1948442" cy="192024"/>
+            <a:ext cx="2000667" cy="192024"/>
           </a:xfrm>
           <a:prstGeom prst="rect">
             <a:avLst/>
@@ -6574,7 +6574,7 @@
         </p:nvSpPr>
         <p:spPr>
           <a:xfrm>
-            <a:off x="5423162" y="5138928"/>
+            <a:off x="5475387" y="5138928"/>
             <a:ext cx="2286000" cy="329184"/>
           </a:xfrm>
           <a:prstGeom prst="rect">
@@ -6595,7 +6595,7 @@
                 </a:solidFill>
                 <a:latin typeface="Helvetica Neue"/>
               </a:rPr>
-              <a:t>26,654   (30 posts · 888 avg)</a:t>
+              <a:t>27,369   (30 posts · 912 avg)</a:t>
             </a:r>
           </a:p>
         </p:txBody>
@@ -6643,7 +6643,7 @@
         <p:spPr>
           <a:xfrm>
             <a:off x="3383280" y="5495543"/>
-            <a:ext cx="1497334" cy="192024"/>
+            <a:ext cx="1498398" cy="192024"/>
           </a:xfrm>
           <a:prstGeom prst="rect">
             <a:avLst/>
@@ -6686,7 +6686,7 @@
         </p:nvSpPr>
         <p:spPr>
           <a:xfrm>
-            <a:off x="4972054" y="5468112"/>
+            <a:off x="4973118" y="5468112"/>
             <a:ext cx="2286000" cy="329184"/>
           </a:xfrm>
           <a:prstGeom prst="rect">
@@ -6707,7 +6707,7 @@
                 </a:solidFill>
                 <a:latin typeface="Helvetica Neue"/>
               </a:rPr>
-              <a:t>20,483   (49 posts · 418 avg)</a:t>
+              <a:t>20,498   (49 posts · 418 avg)</a:t>
             </a:r>
           </a:p>
         </p:txBody>
@@ -6755,7 +6755,7 @@
         <p:spPr>
           <a:xfrm>
             <a:off x="3383280" y="5824728"/>
-            <a:ext cx="1435782" cy="192024"/>
+            <a:ext cx="1469012" cy="192024"/>
           </a:xfrm>
           <a:prstGeom prst="rect">
             <a:avLst/>
@@ -6798,7 +6798,7 @@
         </p:nvSpPr>
         <p:spPr>
           <a:xfrm>
-            <a:off x="4910502" y="5797296"/>
+            <a:off x="4943732" y="5797296"/>
             <a:ext cx="2286000" cy="329184"/>
           </a:xfrm>
           <a:prstGeom prst="rect">
@@ -6819,7 +6819,7 @@
                 </a:solidFill>
                 <a:latin typeface="Helvetica Neue"/>
               </a:rPr>
-              <a:t>19,641   (21 posts · 935 avg)</a:t>
+              <a:t>20,096   (21 posts · 957 avg)</a:t>
             </a:r>
           </a:p>
         </p:txBody>
@@ -8437,7 +8437,7 @@
                 </a:solidFill>
                 <a:latin typeface="Helvetica Neue"/>
               </a:rPr>
-              <a:t>11,662</a:t>
+              <a:t>11,710</a:t>
             </a:r>
           </a:p>
         </p:txBody>
@@ -9137,7 +9137,7 @@
                 </a:solidFill>
                 <a:latin typeface="Helvetica Neue"/>
               </a:rPr>
-              <a:t>7,673</a:t>
+              <a:t>7,704</a:t>
             </a:r>
           </a:p>
         </p:txBody>
@@ -9171,7 +9171,7 @@
                 </a:solidFill>
                 <a:latin typeface="Helvetica Neue"/>
               </a:rPr>
-              <a:t>108</a:t>
+              <a:t>109</a:t>
             </a:r>
           </a:p>
         </p:txBody>

</xml_diff>

<commit_message>
Scheduled snapshot t38 (2026-09-25): fresh IG/FB/YT/TT + rebuilt decks
Co-Authored-By: Claude Opus 4.7 (1M context) <noreply@anthropic.com>
</commit_message>
<xml_diff>
--- a/OVERALL_REPORT.pptx
+++ b/OVERALL_REPORT.pptx
@@ -3277,7 +3277,7 @@
                 </a:solidFill>
                 <a:latin typeface="Georgia"/>
               </a:rPr>
-              <a:t>Since Jun 8, 2026 · 2026-09-23</a:t>
+              <a:t>Since Jun 8, 2026 · 2026-09-25</a:t>
             </a:r>
           </a:p>
         </p:txBody>
@@ -3578,7 +3578,7 @@
                 </a:solidFill>
                 <a:latin typeface="Georgia"/>
               </a:rPr>
-              <a:t>619,066</a:t>
+              <a:t>620,010</a:t>
             </a:r>
           </a:p>
         </p:txBody>
@@ -3925,7 +3925,7 @@
                 </a:solidFill>
                 <a:latin typeface="Georgia"/>
               </a:rPr>
-              <a:t>18,822</a:t>
+              <a:t>18,833</a:t>
             </a:r>
           </a:p>
         </p:txBody>
@@ -4081,7 +4081,7 @@
                 </a:solidFill>
                 <a:latin typeface="Georgia"/>
               </a:rPr>
-              <a:t>1,163</a:t>
+              <a:t>1,165</a:t>
             </a:r>
           </a:p>
         </p:txBody>
@@ -4401,7 +4401,7 @@
                 </a:solidFill>
                 <a:latin typeface="Georgia"/>
               </a:rPr>
-              <a:t>186,864</a:t>
+              <a:t>187,156</a:t>
             </a:r>
           </a:p>
         </p:txBody>
@@ -4503,7 +4503,7 @@
                 </a:solidFill>
                 <a:latin typeface="Helvetica Neue"/>
               </a:rPr>
-              <a:t>1,099 avg views/post</a:t>
+              <a:t>1,101 avg views/post</a:t>
             </a:r>
           </a:p>
         </p:txBody>
@@ -4659,7 +4659,7 @@
                 </a:solidFill>
                 <a:latin typeface="Georgia"/>
               </a:rPr>
-              <a:t>244,800</a:t>
+              <a:t>245,109</a:t>
             </a:r>
           </a:p>
         </p:txBody>
@@ -4761,7 +4761,7 @@
                 </a:solidFill>
                 <a:latin typeface="Helvetica Neue"/>
               </a:rPr>
-              <a:t>1,569 avg views/post</a:t>
+              <a:t>1,571 avg views/post</a:t>
             </a:r>
           </a:p>
         </p:txBody>
@@ -4917,7 +4917,7 @@
                 </a:solidFill>
                 <a:latin typeface="Georgia"/>
               </a:rPr>
-              <a:t>185,548</a:t>
+              <a:t>185,885</a:t>
             </a:r>
           </a:p>
         </p:txBody>
@@ -5019,7 +5019,7 @@
                 </a:solidFill>
                 <a:latin typeface="Helvetica Neue"/>
               </a:rPr>
-              <a:t>971 avg views/post</a:t>
+              <a:t>973 avg views/post</a:t>
             </a:r>
           </a:p>
         </p:txBody>
@@ -5175,7 +5175,7 @@
                 </a:solidFill>
                 <a:latin typeface="Georgia"/>
               </a:rPr>
-              <a:t>1,854</a:t>
+              <a:t>1,860</a:t>
             </a:r>
           </a:p>
         </p:txBody>
@@ -5635,7 +5635,7 @@
         <p:spPr>
           <a:xfrm>
             <a:off x="3383280" y="2532888"/>
-            <a:ext cx="6647253" cy="192024"/>
+            <a:ext cx="6674154" cy="192024"/>
           </a:xfrm>
           <a:prstGeom prst="rect">
             <a:avLst/>
@@ -5678,7 +5678,7 @@
         </p:nvSpPr>
         <p:spPr>
           <a:xfrm>
-            <a:off x="10121973" y="2505456"/>
+            <a:off x="10148874" y="2505456"/>
             <a:ext cx="2286000" cy="329184"/>
           </a:xfrm>
           <a:prstGeom prst="rect">
@@ -5699,7 +5699,7 @@
                 </a:solidFill>
                 <a:latin typeface="Helvetica Neue"/>
               </a:rPr>
-              <a:t>90,934   (158 posts · 576 avg)</a:t>
+              <a:t>91,302   (158 posts · 578 avg)</a:t>
             </a:r>
           </a:p>
         </p:txBody>
@@ -5859,7 +5859,7 @@
         <p:spPr>
           <a:xfrm>
             <a:off x="3383280" y="3191256"/>
-            <a:ext cx="3781523" cy="192024"/>
+            <a:ext cx="3783131" cy="192024"/>
           </a:xfrm>
           <a:prstGeom prst="rect">
             <a:avLst/>
@@ -5902,7 +5902,7 @@
         </p:nvSpPr>
         <p:spPr>
           <a:xfrm>
-            <a:off x="7256243" y="3163824"/>
+            <a:off x="7257851" y="3163824"/>
             <a:ext cx="2286000" cy="329184"/>
           </a:xfrm>
           <a:prstGeom prst="rect">
@@ -5923,7 +5923,7 @@
                 </a:solidFill>
                 <a:latin typeface="Helvetica Neue"/>
               </a:rPr>
-              <a:t>51,731   (17 posts · 3,043 avg)</a:t>
+              <a:t>51,753   (17 posts · 3,044 avg)</a:t>
             </a:r>
           </a:p>
         </p:txBody>
@@ -6195,7 +6195,7 @@
         <p:spPr>
           <a:xfrm>
             <a:off x="3383280" y="4178807"/>
-            <a:ext cx="2414923" cy="192024"/>
+            <a:ext cx="2417555" cy="192024"/>
           </a:xfrm>
           <a:prstGeom prst="rect">
             <a:avLst/>
@@ -6238,7 +6238,7 @@
         </p:nvSpPr>
         <p:spPr>
           <a:xfrm>
-            <a:off x="5889643" y="4151376"/>
+            <a:off x="5892275" y="4151376"/>
             <a:ext cx="2286000" cy="329184"/>
           </a:xfrm>
           <a:prstGeom prst="rect">
@@ -6259,7 +6259,7 @@
                 </a:solidFill>
                 <a:latin typeface="Helvetica Neue"/>
               </a:rPr>
-              <a:t>33,036   (33 posts · 1,001 avg)</a:t>
+              <a:t>33,072   (33 posts · 1,002 avg)</a:t>
             </a:r>
           </a:p>
         </p:txBody>
@@ -6307,7 +6307,7 @@
         <p:spPr>
           <a:xfrm>
             <a:off x="3383280" y="4507992"/>
-            <a:ext cx="2243139" cy="192024"/>
+            <a:ext cx="2251545" cy="192024"/>
           </a:xfrm>
           <a:prstGeom prst="rect">
             <a:avLst/>
@@ -6350,7 +6350,7 @@
         </p:nvSpPr>
         <p:spPr>
           <a:xfrm>
-            <a:off x="5717859" y="4480560"/>
+            <a:off x="5726265" y="4480560"/>
             <a:ext cx="2286000" cy="329184"/>
           </a:xfrm>
           <a:prstGeom prst="rect">
@@ -6371,7 +6371,7 @@
                 </a:solidFill>
                 <a:latin typeface="Helvetica Neue"/>
               </a:rPr>
-              <a:t>30,686   (19 posts · 1,615 avg)</a:t>
+              <a:t>30,801   (19 posts · 1,621 avg)</a:t>
             </a:r>
           </a:p>
         </p:txBody>
@@ -6419,7 +6419,7 @@
         <p:spPr>
           <a:xfrm>
             <a:off x="3383280" y="4837176"/>
-            <a:ext cx="2092992" cy="192024"/>
+            <a:ext cx="2094746" cy="192024"/>
           </a:xfrm>
           <a:prstGeom prst="rect">
             <a:avLst/>
@@ -6462,7 +6462,7 @@
         </p:nvSpPr>
         <p:spPr>
           <a:xfrm>
-            <a:off x="5567712" y="4809744"/>
+            <a:off x="5569466" y="4809744"/>
             <a:ext cx="2286000" cy="329184"/>
           </a:xfrm>
           <a:prstGeom prst="rect">
@@ -6483,7 +6483,7 @@
                 </a:solidFill>
                 <a:latin typeface="Helvetica Neue"/>
               </a:rPr>
-              <a:t>28,632   (6 posts · 4,772 avg)</a:t>
+              <a:t>28,656   (6 posts · 4,776 avg)</a:t>
             </a:r>
           </a:p>
         </p:txBody>
@@ -6531,7 +6531,7 @@
         <p:spPr>
           <a:xfrm>
             <a:off x="3383280" y="5166359"/>
-            <a:ext cx="2000667" cy="192024"/>
+            <a:ext cx="2011851" cy="192024"/>
           </a:xfrm>
           <a:prstGeom prst="rect">
             <a:avLst/>
@@ -6574,7 +6574,7 @@
         </p:nvSpPr>
         <p:spPr>
           <a:xfrm>
-            <a:off x="5475387" y="5138928"/>
+            <a:off x="5486571" y="5138928"/>
             <a:ext cx="2286000" cy="329184"/>
           </a:xfrm>
           <a:prstGeom prst="rect">
@@ -6595,7 +6595,7 @@
                 </a:solidFill>
                 <a:latin typeface="Helvetica Neue"/>
               </a:rPr>
-              <a:t>27,369   (30 posts · 912 avg)</a:t>
+              <a:t>27,522   (30 posts · 917 avg)</a:t>
             </a:r>
           </a:p>
         </p:txBody>
@@ -6643,7 +6643,7 @@
         <p:spPr>
           <a:xfrm>
             <a:off x="3383280" y="5495543"/>
-            <a:ext cx="1498398" cy="192024"/>
+            <a:ext cx="1498983" cy="192024"/>
           </a:xfrm>
           <a:prstGeom prst="rect">
             <a:avLst/>
@@ -6686,7 +6686,7 @@
         </p:nvSpPr>
         <p:spPr>
           <a:xfrm>
-            <a:off x="4973118" y="5468112"/>
+            <a:off x="4973703" y="5468112"/>
             <a:ext cx="2286000" cy="329184"/>
           </a:xfrm>
           <a:prstGeom prst="rect">
@@ -6707,7 +6707,7 @@
                 </a:solidFill>
                 <a:latin typeface="Helvetica Neue"/>
               </a:rPr>
-              <a:t>20,498   (49 posts · 418 avg)</a:t>
+              <a:t>20,506   (49 posts · 418 avg)</a:t>
             </a:r>
           </a:p>
         </p:txBody>
@@ -6755,7 +6755,7 @@
         <p:spPr>
           <a:xfrm>
             <a:off x="3383280" y="5824728"/>
-            <a:ext cx="1469012" cy="192024"/>
+            <a:ext cx="1483194" cy="192024"/>
           </a:xfrm>
           <a:prstGeom prst="rect">
             <a:avLst/>
@@ -6798,7 +6798,7 @@
         </p:nvSpPr>
         <p:spPr>
           <a:xfrm>
-            <a:off x="4943732" y="5797296"/>
+            <a:off x="4957914" y="5797296"/>
             <a:ext cx="2286000" cy="329184"/>
           </a:xfrm>
           <a:prstGeom prst="rect">
@@ -6819,7 +6819,7 @@
                 </a:solidFill>
                 <a:latin typeface="Helvetica Neue"/>
               </a:rPr>
-              <a:t>20,096   (21 posts · 957 avg)</a:t>
+              <a:t>20,290   (21 posts · 966 avg)</a:t>
             </a:r>
           </a:p>
         </p:txBody>
@@ -8437,7 +8437,7 @@
                 </a:solidFill>
                 <a:latin typeface="Helvetica Neue"/>
               </a:rPr>
-              <a:t>11,710</a:t>
+              <a:t>11,780</a:t>
             </a:r>
           </a:p>
         </p:txBody>
@@ -8471,7 +8471,7 @@
                 </a:solidFill>
                 <a:latin typeface="Helvetica Neue"/>
               </a:rPr>
-              <a:t>46</a:t>
+              <a:t>47</a:t>
             </a:r>
           </a:p>
         </p:txBody>
@@ -9137,7 +9137,7 @@
                 </a:solidFill>
                 <a:latin typeface="Helvetica Neue"/>
               </a:rPr>
-              <a:t>7,704</a:t>
+              <a:t>7,728</a:t>
             </a:r>
           </a:p>
         </p:txBody>

</xml_diff>

<commit_message>
Scheduled snapshot t39 (2026-09-28): fresh IG/FB/YT/TT + rebuilt decks
Co-Authored-By: Claude Opus 4.7 (1M context) <noreply@anthropic.com>
</commit_message>
<xml_diff>
--- a/OVERALL_REPORT.pptx
+++ b/OVERALL_REPORT.pptx
@@ -3277,7 +3277,7 @@
                 </a:solidFill>
                 <a:latin typeface="Georgia"/>
               </a:rPr>
-              <a:t>Since Jun 8, 2026 · 2026-09-25</a:t>
+              <a:t>Since Jun 8, 2026 · 2026-09-28</a:t>
             </a:r>
           </a:p>
         </p:txBody>
@@ -3578,7 +3578,7 @@
                 </a:solidFill>
                 <a:latin typeface="Georgia"/>
               </a:rPr>
-              <a:t>620,010</a:t>
+              <a:t>620,976</a:t>
             </a:r>
           </a:p>
         </p:txBody>
@@ -3925,7 +3925,7 @@
                 </a:solidFill>
                 <a:latin typeface="Georgia"/>
               </a:rPr>
-              <a:t>18,833</a:t>
+              <a:t>18,868</a:t>
             </a:r>
           </a:p>
         </p:txBody>
@@ -4081,7 +4081,7 @@
                 </a:solidFill>
                 <a:latin typeface="Georgia"/>
               </a:rPr>
-              <a:t>1,165</a:t>
+              <a:t>1,167</a:t>
             </a:r>
           </a:p>
         </p:txBody>
@@ -4401,7 +4401,7 @@
                 </a:solidFill>
                 <a:latin typeface="Georgia"/>
               </a:rPr>
-              <a:t>187,156</a:t>
+              <a:t>187,501</a:t>
             </a:r>
           </a:p>
         </p:txBody>
@@ -4503,7 +4503,7 @@
                 </a:solidFill>
                 <a:latin typeface="Helvetica Neue"/>
               </a:rPr>
-              <a:t>1,101 avg views/post</a:t>
+              <a:t>1,103 avg views/post</a:t>
             </a:r>
           </a:p>
         </p:txBody>
@@ -4659,7 +4659,7 @@
                 </a:solidFill>
                 <a:latin typeface="Georgia"/>
               </a:rPr>
-              <a:t>245,109</a:t>
+              <a:t>245,471</a:t>
             </a:r>
           </a:p>
         </p:txBody>
@@ -4761,7 +4761,7 @@
                 </a:solidFill>
                 <a:latin typeface="Helvetica Neue"/>
               </a:rPr>
-              <a:t>1,571 avg views/post</a:t>
+              <a:t>1,574 avg views/post</a:t>
             </a:r>
           </a:p>
         </p:txBody>
@@ -4917,7 +4917,7 @@
                 </a:solidFill>
                 <a:latin typeface="Georgia"/>
               </a:rPr>
-              <a:t>185,885</a:t>
+              <a:t>186,122</a:t>
             </a:r>
           </a:p>
         </p:txBody>
@@ -5019,7 +5019,7 @@
                 </a:solidFill>
                 <a:latin typeface="Helvetica Neue"/>
               </a:rPr>
-              <a:t>973 avg views/post</a:t>
+              <a:t>974 avg views/post</a:t>
             </a:r>
           </a:p>
         </p:txBody>
@@ -5175,7 +5175,7 @@
                 </a:solidFill>
                 <a:latin typeface="Georgia"/>
               </a:rPr>
-              <a:t>1,860</a:t>
+              <a:t>1,882</a:t>
             </a:r>
           </a:p>
         </p:txBody>
@@ -5277,7 +5277,7 @@
                 </a:solidFill>
                 <a:latin typeface="Helvetica Neue"/>
               </a:rPr>
-              <a:t>124 avg views/post</a:t>
+              <a:t>125 avg views/post</a:t>
             </a:r>
           </a:p>
         </p:txBody>
@@ -5635,7 +5635,7 @@
         <p:spPr>
           <a:xfrm>
             <a:off x="3383280" y="2532888"/>
-            <a:ext cx="6674154" cy="192024"/>
+            <a:ext cx="6704636" cy="192024"/>
           </a:xfrm>
           <a:prstGeom prst="rect">
             <a:avLst/>
@@ -5678,7 +5678,7 @@
         </p:nvSpPr>
         <p:spPr>
           <a:xfrm>
-            <a:off x="10148874" y="2505456"/>
+            <a:off x="10179356" y="2505456"/>
             <a:ext cx="2286000" cy="329184"/>
           </a:xfrm>
           <a:prstGeom prst="rect">
@@ -5699,7 +5699,7 @@
                 </a:solidFill>
                 <a:latin typeface="Helvetica Neue"/>
               </a:rPr>
-              <a:t>91,302   (158 posts · 578 avg)</a:t>
+              <a:t>91,719   (158 posts · 580 avg)</a:t>
             </a:r>
           </a:p>
         </p:txBody>
@@ -5859,7 +5859,7 @@
         <p:spPr>
           <a:xfrm>
             <a:off x="3383280" y="3191256"/>
-            <a:ext cx="3783131" cy="192024"/>
+            <a:ext cx="3785178" cy="192024"/>
           </a:xfrm>
           <a:prstGeom prst="rect">
             <a:avLst/>
@@ -5902,7 +5902,7 @@
         </p:nvSpPr>
         <p:spPr>
           <a:xfrm>
-            <a:off x="7257851" y="3163824"/>
+            <a:off x="7259898" y="3163824"/>
             <a:ext cx="2286000" cy="329184"/>
           </a:xfrm>
           <a:prstGeom prst="rect">
@@ -5923,7 +5923,7 @@
                 </a:solidFill>
                 <a:latin typeface="Helvetica Neue"/>
               </a:rPr>
-              <a:t>51,753   (17 posts · 3,044 avg)</a:t>
+              <a:t>51,781   (17 posts · 3,046 avg)</a:t>
             </a:r>
           </a:p>
         </p:txBody>
@@ -6083,7 +6083,7 @@
         <p:spPr>
           <a:xfrm>
             <a:off x="3383280" y="3849624"/>
-            <a:ext cx="3009005" cy="192024"/>
+            <a:ext cx="3009078" cy="192024"/>
           </a:xfrm>
           <a:prstGeom prst="rect">
             <a:avLst/>
@@ -6126,7 +6126,7 @@
         </p:nvSpPr>
         <p:spPr>
           <a:xfrm>
-            <a:off x="6483725" y="3822192"/>
+            <a:off x="6483798" y="3822192"/>
             <a:ext cx="2286000" cy="329184"/>
           </a:xfrm>
           <a:prstGeom prst="rect">
@@ -6147,7 +6147,7 @@
                 </a:solidFill>
                 <a:latin typeface="Helvetica Neue"/>
               </a:rPr>
-              <a:t>41,163   (18 posts · 2,287 avg)</a:t>
+              <a:t>41,164   (18 posts · 2,287 avg)</a:t>
             </a:r>
           </a:p>
         </p:txBody>
@@ -6195,7 +6195,7 @@
         <p:spPr>
           <a:xfrm>
             <a:off x="3383280" y="4178807"/>
-            <a:ext cx="2417555" cy="192024"/>
+            <a:ext cx="2420332" cy="192024"/>
           </a:xfrm>
           <a:prstGeom prst="rect">
             <a:avLst/>
@@ -6238,7 +6238,7 @@
         </p:nvSpPr>
         <p:spPr>
           <a:xfrm>
-            <a:off x="5892275" y="4151376"/>
+            <a:off x="5895052" y="4151376"/>
             <a:ext cx="2286000" cy="329184"/>
           </a:xfrm>
           <a:prstGeom prst="rect">
@@ -6259,7 +6259,7 @@
                 </a:solidFill>
                 <a:latin typeface="Helvetica Neue"/>
               </a:rPr>
-              <a:t>33,072   (33 posts · 1,002 avg)</a:t>
+              <a:t>33,110   (33 posts · 1,003 avg)</a:t>
             </a:r>
           </a:p>
         </p:txBody>
@@ -6307,7 +6307,7 @@
         <p:spPr>
           <a:xfrm>
             <a:off x="3383280" y="4507992"/>
-            <a:ext cx="2251545" cy="192024"/>
+            <a:ext cx="2257686" cy="192024"/>
           </a:xfrm>
           <a:prstGeom prst="rect">
             <a:avLst/>
@@ -6350,7 +6350,7 @@
         </p:nvSpPr>
         <p:spPr>
           <a:xfrm>
-            <a:off x="5726265" y="4480560"/>
+            <a:off x="5732406" y="4480560"/>
             <a:ext cx="2286000" cy="329184"/>
           </a:xfrm>
           <a:prstGeom prst="rect">
@@ -6371,7 +6371,7 @@
                 </a:solidFill>
                 <a:latin typeface="Helvetica Neue"/>
               </a:rPr>
-              <a:t>30,801   (19 posts · 1,621 avg)</a:t>
+              <a:t>30,885   (19 posts · 1,626 avg)</a:t>
             </a:r>
           </a:p>
         </p:txBody>
@@ -6419,7 +6419,7 @@
         <p:spPr>
           <a:xfrm>
             <a:off x="3383280" y="4837176"/>
-            <a:ext cx="2094746" cy="192024"/>
+            <a:ext cx="2095477" cy="192024"/>
           </a:xfrm>
           <a:prstGeom prst="rect">
             <a:avLst/>
@@ -6462,7 +6462,7 @@
         </p:nvSpPr>
         <p:spPr>
           <a:xfrm>
-            <a:off x="5569466" y="4809744"/>
+            <a:off x="5570197" y="4809744"/>
             <a:ext cx="2286000" cy="329184"/>
           </a:xfrm>
           <a:prstGeom prst="rect">
@@ -6483,7 +6483,7 @@
                 </a:solidFill>
                 <a:latin typeface="Helvetica Neue"/>
               </a:rPr>
-              <a:t>28,656   (6 posts · 4,776 avg)</a:t>
+              <a:t>28,666   (6 posts · 4,778 avg)</a:t>
             </a:r>
           </a:p>
         </p:txBody>
@@ -6531,7 +6531,7 @@
         <p:spPr>
           <a:xfrm>
             <a:off x="3383280" y="5166359"/>
-            <a:ext cx="2011851" cy="192024"/>
+            <a:ext cx="2029468" cy="192024"/>
           </a:xfrm>
           <a:prstGeom prst="rect">
             <a:avLst/>
@@ -6574,7 +6574,7 @@
         </p:nvSpPr>
         <p:spPr>
           <a:xfrm>
-            <a:off x="5486571" y="5138928"/>
+            <a:off x="5504188" y="5138928"/>
             <a:ext cx="2286000" cy="329184"/>
           </a:xfrm>
           <a:prstGeom prst="rect">
@@ -6595,7 +6595,7 @@
                 </a:solidFill>
                 <a:latin typeface="Helvetica Neue"/>
               </a:rPr>
-              <a:t>27,522   (30 posts · 917 avg)</a:t>
+              <a:t>27,763   (30 posts · 925 avg)</a:t>
             </a:r>
           </a:p>
         </p:txBody>
@@ -6643,7 +6643,7 @@
         <p:spPr>
           <a:xfrm>
             <a:off x="3383280" y="5495543"/>
-            <a:ext cx="1498983" cy="192024"/>
+            <a:ext cx="1499641" cy="192024"/>
           </a:xfrm>
           <a:prstGeom prst="rect">
             <a:avLst/>
@@ -6686,7 +6686,7 @@
         </p:nvSpPr>
         <p:spPr>
           <a:xfrm>
-            <a:off x="4973703" y="5468112"/>
+            <a:off x="4974361" y="5468112"/>
             <a:ext cx="2286000" cy="329184"/>
           </a:xfrm>
           <a:prstGeom prst="rect">
@@ -6707,7 +6707,7 @@
                 </a:solidFill>
                 <a:latin typeface="Helvetica Neue"/>
               </a:rPr>
-              <a:t>20,506   (49 posts · 418 avg)</a:t>
+              <a:t>20,515   (49 posts · 419 avg)</a:t>
             </a:r>
           </a:p>
         </p:txBody>
@@ -6755,7 +6755,7 @@
         <p:spPr>
           <a:xfrm>
             <a:off x="3383280" y="5824728"/>
-            <a:ext cx="1483194" cy="192024"/>
+            <a:ext cx="1489773" cy="192024"/>
           </a:xfrm>
           <a:prstGeom prst="rect">
             <a:avLst/>
@@ -6798,7 +6798,7 @@
         </p:nvSpPr>
         <p:spPr>
           <a:xfrm>
-            <a:off x="4957914" y="5797296"/>
+            <a:off x="4964493" y="5797296"/>
             <a:ext cx="2286000" cy="329184"/>
           </a:xfrm>
           <a:prstGeom prst="rect">
@@ -6819,7 +6819,7 @@
                 </a:solidFill>
                 <a:latin typeface="Helvetica Neue"/>
               </a:rPr>
-              <a:t>20,290   (21 posts · 966 avg)</a:t>
+              <a:t>20,380   (21 posts · 970 avg)</a:t>
             </a:r>
           </a:p>
         </p:txBody>
@@ -8437,7 +8437,7 @@
                 </a:solidFill>
                 <a:latin typeface="Helvetica Neue"/>
               </a:rPr>
-              <a:t>11,780</a:t>
+              <a:t>11,811</a:t>
             </a:r>
           </a:p>
         </p:txBody>
@@ -9137,7 +9137,7 @@
                 </a:solidFill>
                 <a:latin typeface="Helvetica Neue"/>
               </a:rPr>
-              <a:t>7,728</a:t>
+              <a:t>7,738</a:t>
             </a:r>
           </a:p>
         </p:txBody>

</xml_diff>

<commit_message>
Scheduled snapshot t40 (2026-10-02): fresh IG/FB/YT/TT + rebuilt decks
Co-Authored-By: Claude Opus 4.7 (1M context) <noreply@anthropic.com>
</commit_message>
<xml_diff>
--- a/OVERALL_REPORT.pptx
+++ b/OVERALL_REPORT.pptx
@@ -3277,7 +3277,7 @@
                 </a:solidFill>
                 <a:latin typeface="Georgia"/>
               </a:rPr>
-              <a:t>Since Jun 8, 2026 · 2026-09-28</a:t>
+              <a:t>Since Jun 8, 2026 · 2026-10-02</a:t>
             </a:r>
           </a:p>
         </p:txBody>
@@ -3578,7 +3578,7 @@
                 </a:solidFill>
                 <a:latin typeface="Georgia"/>
               </a:rPr>
-              <a:t>620,976</a:t>
+              <a:t>806,526</a:t>
             </a:r>
           </a:p>
         </p:txBody>
@@ -3769,7 +3769,7 @@
                 </a:solidFill>
                 <a:latin typeface="Georgia"/>
               </a:rPr>
-              <a:t>532</a:t>
+              <a:t>559</a:t>
             </a:r>
           </a:p>
         </p:txBody>
@@ -3925,7 +3925,7 @@
                 </a:solidFill>
                 <a:latin typeface="Georgia"/>
               </a:rPr>
-              <a:t>18,868</a:t>
+              <a:t>24,792</a:t>
             </a:r>
           </a:p>
         </p:txBody>
@@ -4081,7 +4081,7 @@
                 </a:solidFill>
                 <a:latin typeface="Georgia"/>
               </a:rPr>
-              <a:t>1,167</a:t>
+              <a:t>1,442</a:t>
             </a:r>
           </a:p>
         </p:txBody>
@@ -4401,7 +4401,7 @@
                 </a:solidFill>
                 <a:latin typeface="Georgia"/>
               </a:rPr>
-              <a:t>187,501</a:t>
+              <a:t>346,207</a:t>
             </a:r>
           </a:p>
         </p:txBody>
@@ -4469,7 +4469,7 @@
                 </a:solidFill>
                 <a:latin typeface="Helvetica Neue"/>
               </a:rPr>
-              <a:t>170 posts</a:t>
+              <a:t>179 posts</a:t>
             </a:r>
           </a:p>
         </p:txBody>
@@ -4503,7 +4503,7 @@
                 </a:solidFill>
                 <a:latin typeface="Helvetica Neue"/>
               </a:rPr>
-              <a:t>1,103 avg views/post</a:t>
+              <a:t>1,934 avg views/post</a:t>
             </a:r>
           </a:p>
         </p:txBody>
@@ -4659,7 +4659,7 @@
                 </a:solidFill>
                 <a:latin typeface="Georgia"/>
               </a:rPr>
-              <a:t>245,471</a:t>
+              <a:t>268,675</a:t>
             </a:r>
           </a:p>
         </p:txBody>
@@ -4727,7 +4727,7 @@
                 </a:solidFill>
                 <a:latin typeface="Helvetica Neue"/>
               </a:rPr>
-              <a:t>156 posts</a:t>
+              <a:t>164 posts</a:t>
             </a:r>
           </a:p>
         </p:txBody>
@@ -4761,7 +4761,7 @@
                 </a:solidFill>
                 <a:latin typeface="Helvetica Neue"/>
               </a:rPr>
-              <a:t>1,574 avg views/post</a:t>
+              <a:t>1,638 avg views/post</a:t>
             </a:r>
           </a:p>
         </p:txBody>
@@ -4917,7 +4917,7 @@
                 </a:solidFill>
                 <a:latin typeface="Georgia"/>
               </a:rPr>
-              <a:t>186,122</a:t>
+              <a:t>189,412</a:t>
             </a:r>
           </a:p>
         </p:txBody>
@@ -4985,7 +4985,7 @@
                 </a:solidFill>
                 <a:latin typeface="Helvetica Neue"/>
               </a:rPr>
-              <a:t>191 posts</a:t>
+              <a:t>199 posts</a:t>
             </a:r>
           </a:p>
         </p:txBody>
@@ -5019,7 +5019,7 @@
                 </a:solidFill>
                 <a:latin typeface="Helvetica Neue"/>
               </a:rPr>
-              <a:t>974 avg views/post</a:t>
+              <a:t>952 avg views/post</a:t>
             </a:r>
           </a:p>
         </p:txBody>
@@ -5175,7 +5175,7 @@
                 </a:solidFill>
                 <a:latin typeface="Georgia"/>
               </a:rPr>
-              <a:t>1,882</a:t>
+              <a:t>2,232</a:t>
             </a:r>
           </a:p>
         </p:txBody>
@@ -5243,7 +5243,7 @@
                 </a:solidFill>
                 <a:latin typeface="Helvetica Neue"/>
               </a:rPr>
-              <a:t>15 posts</a:t>
+              <a:t>17 posts</a:t>
             </a:r>
           </a:p>
         </p:txBody>
@@ -5277,7 +5277,7 @@
                 </a:solidFill>
                 <a:latin typeface="Helvetica Neue"/>
               </a:rPr>
-              <a:t>125 avg views/post</a:t>
+              <a:t>131 avg views/post</a:t>
             </a:r>
           </a:p>
         </p:txBody>
@@ -5509,7 +5509,7 @@
                 </a:solidFill>
                 <a:latin typeface="Helvetica Neue"/>
               </a:rPr>
-              <a:t>Food</a:t>
+              <a:t>Other</a:t>
             </a:r>
           </a:p>
         </p:txBody>
@@ -5524,6 +5524,118 @@
           <a:xfrm>
             <a:off x="3383280" y="2203704"/>
             <a:ext cx="6858000" cy="192024"/>
+          </a:xfrm>
+          <a:prstGeom prst="rect">
+            <a:avLst/>
+          </a:prstGeom>
+          <a:solidFill>
+            <a:srgbClr val="6B7082"/>
+          </a:solidFill>
+          <a:ln>
+            <a:noFill/>
+          </a:ln>
+          <a:effectLst/>
+        </p:spPr>
+        <p:style>
+          <a:lnRef idx="1">
+            <a:schemeClr val="accent1"/>
+          </a:lnRef>
+          <a:fillRef idx="3">
+            <a:schemeClr val="accent1"/>
+          </a:fillRef>
+          <a:effectRef idx="2">
+            <a:schemeClr val="accent1"/>
+          </a:effectRef>
+          <a:fontRef idx="minor">
+            <a:schemeClr val="lt1"/>
+          </a:fontRef>
+        </p:style>
+        <p:txBody>
+          <a:bodyPr rtlCol="0" anchor="ctr"/>
+          <a:lstStyle/>
+          <a:p>
+            <a:pPr algn="ctr"/>
+          </a:p>
+        </p:txBody>
+      </p:sp>
+      <p:sp>
+        <p:nvSpPr>
+          <p:cNvPr id="8" name="TextBox 7"/>
+          <p:cNvSpPr txBox="1"/>
+          <p:nvPr/>
+        </p:nvSpPr>
+        <p:spPr>
+          <a:xfrm>
+            <a:off x="10332719" y="2176272"/>
+            <a:ext cx="2286000" cy="329184"/>
+          </a:xfrm>
+          <a:prstGeom prst="rect">
+            <a:avLst/>
+          </a:prstGeom>
+          <a:noFill/>
+        </p:spPr>
+        <p:txBody>
+          <a:bodyPr wrap="square" lIns="0" rIns="0" tIns="0" bIns="0">
+            <a:spAutoFit/>
+          </a:bodyPr>
+          <a:lstStyle/>
+          <a:p>
+            <a:r>
+              <a:rPr sz="1000" b="0">
+                <a:solidFill>
+                  <a:srgbClr val="6B7082"/>
+                </a:solidFill>
+                <a:latin typeface="Helvetica Neue"/>
+              </a:rPr>
+              <a:t>250,607   (174 posts · 1,440 avg)</a:t>
+            </a:r>
+          </a:p>
+        </p:txBody>
+      </p:sp>
+      <p:sp>
+        <p:nvSpPr>
+          <p:cNvPr id="9" name="TextBox 8"/>
+          <p:cNvSpPr txBox="1"/>
+          <p:nvPr/>
+        </p:nvSpPr>
+        <p:spPr>
+          <a:xfrm>
+            <a:off x="731520" y="2505456"/>
+            <a:ext cx="2468880" cy="329184"/>
+          </a:xfrm>
+          <a:prstGeom prst="rect">
+            <a:avLst/>
+          </a:prstGeom>
+          <a:noFill/>
+        </p:spPr>
+        <p:txBody>
+          <a:bodyPr wrap="square" lIns="0" rIns="0" tIns="0" bIns="0">
+            <a:spAutoFit/>
+          </a:bodyPr>
+          <a:lstStyle/>
+          <a:p>
+            <a:r>
+              <a:rPr sz="1100" b="1">
+                <a:solidFill>
+                  <a:srgbClr val="141833"/>
+                </a:solidFill>
+                <a:latin typeface="Helvetica Neue"/>
+              </a:rPr>
+              <a:t>Food</a:t>
+            </a:r>
+          </a:p>
+        </p:txBody>
+      </p:sp>
+      <p:sp>
+        <p:nvSpPr>
+          <p:cNvPr id="10" name="Rectangle 9"/>
+          <p:cNvSpPr/>
+          <p:nvPr/>
+        </p:nvSpPr>
+        <p:spPr>
+          <a:xfrm>
+            <a:off x="3383280" y="2532888"/>
+            <a:ext cx="2583582" cy="192024"/>
           </a:xfrm>
           <a:prstGeom prst="rect">
             <a:avLst/>
@@ -5560,13 +5672,13 @@
       </p:sp>
       <p:sp>
         <p:nvSpPr>
-          <p:cNvPr id="8" name="TextBox 7"/>
-          <p:cNvSpPr txBox="1"/>
-          <p:nvPr/>
-        </p:nvSpPr>
-        <p:spPr>
-          <a:xfrm>
-            <a:off x="10332719" y="2176272"/>
+          <p:cNvPr id="11" name="TextBox 10"/>
+          <p:cNvSpPr txBox="1"/>
+          <p:nvPr/>
+        </p:nvSpPr>
+        <p:spPr>
+          <a:xfrm>
+            <a:off x="6058302" y="2505456"/>
             <a:ext cx="2286000" cy="329184"/>
           </a:xfrm>
           <a:prstGeom prst="rect">
@@ -5587,20 +5699,20 @@
                 </a:solidFill>
                 <a:latin typeface="Helvetica Neue"/>
               </a:rPr>
-              <a:t>93,817   (61 posts · 1,538 avg)</a:t>
-            </a:r>
-          </a:p>
-        </p:txBody>
-      </p:sp>
-      <p:sp>
-        <p:nvSpPr>
-          <p:cNvPr id="9" name="TextBox 8"/>
-          <p:cNvSpPr txBox="1"/>
-          <p:nvPr/>
-        </p:nvSpPr>
-        <p:spPr>
-          <a:xfrm>
-            <a:off x="731520" y="2505456"/>
+              <a:t>94,410   (62 posts · 1,523 avg)</a:t>
+            </a:r>
+          </a:p>
+        </p:txBody>
+      </p:sp>
+      <p:sp>
+        <p:nvSpPr>
+          <p:cNvPr id="12" name="TextBox 11"/>
+          <p:cNvSpPr txBox="1"/>
+          <p:nvPr/>
+        </p:nvSpPr>
+        <p:spPr>
+          <a:xfrm>
+            <a:off x="731520" y="2834640"/>
             <a:ext cx="2468880" cy="329184"/>
           </a:xfrm>
           <a:prstGeom prst="rect">
@@ -5621,21 +5733,21 @@
                 </a:solidFill>
                 <a:latin typeface="Helvetica Neue"/>
               </a:rPr>
-              <a:t>Other</a:t>
-            </a:r>
-          </a:p>
-        </p:txBody>
-      </p:sp>
-      <p:sp>
-        <p:nvSpPr>
-          <p:cNvPr id="10" name="Rectangle 9"/>
+              <a:t>military_service</a:t>
+            </a:r>
+          </a:p>
+        </p:txBody>
+      </p:sp>
+      <p:sp>
+        <p:nvSpPr>
+          <p:cNvPr id="13" name="Rectangle 12"/>
           <p:cNvSpPr/>
           <p:nvPr/>
         </p:nvSpPr>
         <p:spPr>
           <a:xfrm>
-            <a:off x="3383280" y="2532888"/>
-            <a:ext cx="6704636" cy="192024"/>
+            <a:off x="3383280" y="2862072"/>
+            <a:ext cx="2363590" cy="192024"/>
           </a:xfrm>
           <a:prstGeom prst="rect">
             <a:avLst/>
@@ -5672,13 +5784,13 @@
       </p:sp>
       <p:sp>
         <p:nvSpPr>
-          <p:cNvPr id="11" name="TextBox 10"/>
-          <p:cNvSpPr txBox="1"/>
-          <p:nvPr/>
-        </p:nvSpPr>
-        <p:spPr>
-          <a:xfrm>
-            <a:off x="10179356" y="2505456"/>
+          <p:cNvPr id="14" name="TextBox 13"/>
+          <p:cNvSpPr txBox="1"/>
+          <p:nvPr/>
+        </p:nvSpPr>
+        <p:spPr>
+          <a:xfrm>
+            <a:off x="5838310" y="2834640"/>
             <a:ext cx="2286000" cy="329184"/>
           </a:xfrm>
           <a:prstGeom prst="rect">
@@ -5699,119 +5811,7 @@
                 </a:solidFill>
                 <a:latin typeface="Helvetica Neue"/>
               </a:rPr>
-              <a:t>91,719   (158 posts · 580 avg)</a:t>
-            </a:r>
-          </a:p>
-        </p:txBody>
-      </p:sp>
-      <p:sp>
-        <p:nvSpPr>
-          <p:cNvPr id="12" name="TextBox 11"/>
-          <p:cNvSpPr txBox="1"/>
-          <p:nvPr/>
-        </p:nvSpPr>
-        <p:spPr>
-          <a:xfrm>
-            <a:off x="731520" y="2834640"/>
-            <a:ext cx="2468880" cy="329184"/>
-          </a:xfrm>
-          <a:prstGeom prst="rect">
-            <a:avLst/>
-          </a:prstGeom>
-          <a:noFill/>
-        </p:spPr>
-        <p:txBody>
-          <a:bodyPr wrap="square" lIns="0" rIns="0" tIns="0" bIns="0">
-            <a:spAutoFit/>
-          </a:bodyPr>
-          <a:lstStyle/>
-          <a:p>
-            <a:r>
-              <a:rPr sz="1100" b="1">
-                <a:solidFill>
-                  <a:srgbClr val="141833"/>
-                </a:solidFill>
-                <a:latin typeface="Helvetica Neue"/>
-              </a:rPr>
-              <a:t>military_service</a:t>
-            </a:r>
-          </a:p>
-        </p:txBody>
-      </p:sp>
-      <p:sp>
-        <p:nvSpPr>
-          <p:cNvPr id="13" name="Rectangle 12"/>
-          <p:cNvSpPr/>
-          <p:nvPr/>
-        </p:nvSpPr>
-        <p:spPr>
-          <a:xfrm>
-            <a:off x="3383280" y="2862072"/>
-            <a:ext cx="4571366" cy="192024"/>
-          </a:xfrm>
-          <a:prstGeom prst="rect">
-            <a:avLst/>
-          </a:prstGeom>
-          <a:solidFill>
-            <a:srgbClr val="6B7082"/>
-          </a:solidFill>
-          <a:ln>
-            <a:noFill/>
-          </a:ln>
-          <a:effectLst/>
-        </p:spPr>
-        <p:style>
-          <a:lnRef idx="1">
-            <a:schemeClr val="accent1"/>
-          </a:lnRef>
-          <a:fillRef idx="3">
-            <a:schemeClr val="accent1"/>
-          </a:fillRef>
-          <a:effectRef idx="2">
-            <a:schemeClr val="accent1"/>
-          </a:effectRef>
-          <a:fontRef idx="minor">
-            <a:schemeClr val="lt1"/>
-          </a:fontRef>
-        </p:style>
-        <p:txBody>
-          <a:bodyPr rtlCol="0" anchor="ctr"/>
-          <a:lstStyle/>
-          <a:p>
-            <a:pPr algn="ctr"/>
-          </a:p>
-        </p:txBody>
-      </p:sp>
-      <p:sp>
-        <p:nvSpPr>
-          <p:cNvPr id="14" name="TextBox 13"/>
-          <p:cNvSpPr txBox="1"/>
-          <p:nvPr/>
-        </p:nvSpPr>
-        <p:spPr>
-          <a:xfrm>
-            <a:off x="8046086" y="2834640"/>
-            <a:ext cx="2286000" cy="329184"/>
-          </a:xfrm>
-          <a:prstGeom prst="rect">
-            <a:avLst/>
-          </a:prstGeom>
-          <a:noFill/>
-        </p:spPr>
-        <p:txBody>
-          <a:bodyPr wrap="square" lIns="0" rIns="0" tIns="0" bIns="0">
-            <a:spAutoFit/>
-          </a:bodyPr>
-          <a:lstStyle/>
-          <a:p>
-            <a:r>
-              <a:rPr sz="1000" b="0">
-                <a:solidFill>
-                  <a:srgbClr val="6B7082"/>
-                </a:solidFill>
-                <a:latin typeface="Helvetica Neue"/>
-              </a:rPr>
-              <a:t>62,536   (22 posts · 2,843 avg)</a:t>
+              <a:t>86,371   (28 posts · 3,085 avg)</a:t>
             </a:r>
           </a:p>
         </p:txBody>
@@ -5859,7 +5859,7 @@
         <p:spPr>
           <a:xfrm>
             <a:off x="3383280" y="3191256"/>
-            <a:ext cx="3785178" cy="192024"/>
+            <a:ext cx="1421750" cy="192024"/>
           </a:xfrm>
           <a:prstGeom prst="rect">
             <a:avLst/>
@@ -5902,7 +5902,7 @@
         </p:nvSpPr>
         <p:spPr>
           <a:xfrm>
-            <a:off x="7259898" y="3163824"/>
+            <a:off x="4896470" y="3163824"/>
             <a:ext cx="2286000" cy="329184"/>
           </a:xfrm>
           <a:prstGeom prst="rect">
@@ -5923,7 +5923,7 @@
                 </a:solidFill>
                 <a:latin typeface="Helvetica Neue"/>
               </a:rPr>
-              <a:t>51,781   (17 posts · 3,046 avg)</a:t>
+              <a:t>51,954   (17 posts · 3,056 avg)</a:t>
             </a:r>
           </a:p>
         </p:txBody>
@@ -5971,7 +5971,7 @@
         <p:spPr>
           <a:xfrm>
             <a:off x="3383280" y="3520440"/>
-            <a:ext cx="3485177" cy="192024"/>
+            <a:ext cx="1304707" cy="192024"/>
           </a:xfrm>
           <a:prstGeom prst="rect">
             <a:avLst/>
@@ -6014,7 +6014,7 @@
         </p:nvSpPr>
         <p:spPr>
           <a:xfrm>
-            <a:off x="6959897" y="3493008"/>
+            <a:off x="4779427" y="3493008"/>
             <a:ext cx="2286000" cy="329184"/>
           </a:xfrm>
           <a:prstGeom prst="rect">
@@ -6083,7 +6083,7 @@
         <p:spPr>
           <a:xfrm>
             <a:off x="3383280" y="3849624"/>
-            <a:ext cx="3009078" cy="192024"/>
+            <a:ext cx="1126503" cy="192024"/>
           </a:xfrm>
           <a:prstGeom prst="rect">
             <a:avLst/>
@@ -6126,7 +6126,7 @@
         </p:nvSpPr>
         <p:spPr>
           <a:xfrm>
-            <a:off x="6483798" y="3822192"/>
+            <a:off x="4601223" y="3822192"/>
             <a:ext cx="2286000" cy="329184"/>
           </a:xfrm>
           <a:prstGeom prst="rect">
@@ -6147,7 +6147,7 @@
                 </a:solidFill>
                 <a:latin typeface="Helvetica Neue"/>
               </a:rPr>
-              <a:t>41,164   (18 posts · 2,287 avg)</a:t>
+              <a:t>41,165   (18 posts · 2,287 avg)</a:t>
             </a:r>
           </a:p>
         </p:txBody>
@@ -6195,7 +6195,7 @@
         <p:spPr>
           <a:xfrm>
             <a:off x="3383280" y="4178807"/>
-            <a:ext cx="2420332" cy="192024"/>
+            <a:ext cx="927911" cy="192024"/>
           </a:xfrm>
           <a:prstGeom prst="rect">
             <a:avLst/>
@@ -6238,7 +6238,7 @@
         </p:nvSpPr>
         <p:spPr>
           <a:xfrm>
-            <a:off x="5895052" y="4151376"/>
+            <a:off x="4402631" y="4151376"/>
             <a:ext cx="2286000" cy="329184"/>
           </a:xfrm>
           <a:prstGeom prst="rect">
@@ -6259,7 +6259,7 @@
                 </a:solidFill>
                 <a:latin typeface="Helvetica Neue"/>
               </a:rPr>
-              <a:t>33,110   (33 posts · 1,003 avg)</a:t>
+              <a:t>33,908   (34 posts · 997 avg)</a:t>
             </a:r>
           </a:p>
         </p:txBody>
@@ -6307,7 +6307,7 @@
         <p:spPr>
           <a:xfrm>
             <a:off x="3383280" y="4507992"/>
-            <a:ext cx="2257686" cy="192024"/>
+            <a:ext cx="849098" cy="192024"/>
           </a:xfrm>
           <a:prstGeom prst="rect">
             <a:avLst/>
@@ -6350,7 +6350,7 @@
         </p:nvSpPr>
         <p:spPr>
           <a:xfrm>
-            <a:off x="5732406" y="4480560"/>
+            <a:off x="4323818" y="4480560"/>
             <a:ext cx="2286000" cy="329184"/>
           </a:xfrm>
           <a:prstGeom prst="rect">
@@ -6371,7 +6371,7 @@
                 </a:solidFill>
                 <a:latin typeface="Helvetica Neue"/>
               </a:rPr>
-              <a:t>30,885   (19 posts · 1,626 avg)</a:t>
+              <a:t>31,028   (21 posts · 1,478 avg)</a:t>
             </a:r>
           </a:p>
         </p:txBody>
@@ -6419,7 +6419,7 @@
         <p:spPr>
           <a:xfrm>
             <a:off x="3383280" y="4837176"/>
-            <a:ext cx="2095477" cy="192024"/>
+            <a:ext cx="785117" cy="192024"/>
           </a:xfrm>
           <a:prstGeom prst="rect">
             <a:avLst/>
@@ -6462,7 +6462,7 @@
         </p:nvSpPr>
         <p:spPr>
           <a:xfrm>
-            <a:off x="5570197" y="4809744"/>
+            <a:off x="4259837" y="4809744"/>
             <a:ext cx="2286000" cy="329184"/>
           </a:xfrm>
           <a:prstGeom prst="rect">
@@ -6483,7 +6483,7 @@
                 </a:solidFill>
                 <a:latin typeface="Helvetica Neue"/>
               </a:rPr>
-              <a:t>28,666   (6 posts · 4,778 avg)</a:t>
+              <a:t>28,690   (6 posts · 4,782 avg)</a:t>
             </a:r>
           </a:p>
         </p:txBody>
@@ -6531,7 +6531,7 @@
         <p:spPr>
           <a:xfrm>
             <a:off x="3383280" y="5166359"/>
-            <a:ext cx="2029468" cy="192024"/>
+            <a:ext cx="767521" cy="192024"/>
           </a:xfrm>
           <a:prstGeom prst="rect">
             <a:avLst/>
@@ -6574,7 +6574,7 @@
         </p:nvSpPr>
         <p:spPr>
           <a:xfrm>
-            <a:off x="5504188" y="5138928"/>
+            <a:off x="4242241" y="5138928"/>
             <a:ext cx="2286000" cy="329184"/>
           </a:xfrm>
           <a:prstGeom prst="rect">
@@ -6595,7 +6595,7 @@
                 </a:solidFill>
                 <a:latin typeface="Helvetica Neue"/>
               </a:rPr>
-              <a:t>27,763   (30 posts · 925 avg)</a:t>
+              <a:t>28,047   (30 posts · 935 avg)</a:t>
             </a:r>
           </a:p>
         </p:txBody>
@@ -6629,7 +6629,7 @@
                 </a:solidFill>
                 <a:latin typeface="Helvetica Neue"/>
               </a:rPr>
-              <a:t>Judicial</a:t>
+              <a:t>Elections</a:t>
             </a:r>
           </a:p>
         </p:txBody>
@@ -6643,7 +6643,7 @@
         <p:spPr>
           <a:xfrm>
             <a:off x="3383280" y="5495543"/>
-            <a:ext cx="1499641" cy="192024"/>
+            <a:ext cx="562499" cy="192024"/>
           </a:xfrm>
           <a:prstGeom prst="rect">
             <a:avLst/>
@@ -6686,7 +6686,7 @@
         </p:nvSpPr>
         <p:spPr>
           <a:xfrm>
-            <a:off x="4974361" y="5468112"/>
+            <a:off x="4037219" y="5468112"/>
             <a:ext cx="2286000" cy="329184"/>
           </a:xfrm>
           <a:prstGeom prst="rect">
@@ -6707,7 +6707,7 @@
                 </a:solidFill>
                 <a:latin typeface="Helvetica Neue"/>
               </a:rPr>
-              <a:t>20,515   (49 posts · 419 avg)</a:t>
+              <a:t>20,555   (21 posts · 979 avg)</a:t>
             </a:r>
           </a:p>
         </p:txBody>
@@ -6741,7 +6741,7 @@
                 </a:solidFill>
                 <a:latin typeface="Helvetica Neue"/>
               </a:rPr>
-              <a:t>Elections</a:t>
+              <a:t>Judicial</a:t>
             </a:r>
           </a:p>
         </p:txBody>
@@ -6755,7 +6755,7 @@
         <p:spPr>
           <a:xfrm>
             <a:off x="3383280" y="5824728"/>
-            <a:ext cx="1489773" cy="192024"/>
+            <a:ext cx="561650" cy="192024"/>
           </a:xfrm>
           <a:prstGeom prst="rect">
             <a:avLst/>
@@ -6798,7 +6798,7 @@
         </p:nvSpPr>
         <p:spPr>
           <a:xfrm>
-            <a:off x="4964493" y="5797296"/>
+            <a:off x="4036370" y="5797296"/>
             <a:ext cx="2286000" cy="329184"/>
           </a:xfrm>
           <a:prstGeom prst="rect">
@@ -6819,7 +6819,7 @@
                 </a:solidFill>
                 <a:latin typeface="Helvetica Neue"/>
               </a:rPr>
-              <a:t>20,380   (21 posts · 970 avg)</a:t>
+              <a:t>20,524   (49 posts · 419 avg)</a:t>
             </a:r>
           </a:p>
         </p:txBody>
@@ -7377,7 +7377,7 @@
                 </a:solidFill>
                 <a:latin typeface="Helvetica Neue"/>
               </a:rPr>
-              <a:t>TT</a:t>
+              <a:t>IG</a:t>
             </a:r>
           </a:p>
         </p:txBody>
@@ -7411,7 +7411,7 @@
                 </a:solidFill>
                 <a:latin typeface="Helvetica Neue"/>
               </a:rPr>
-              <a:t>Combat jobs aren't for everyone. See how your MOS determines deployment likeliho</a:t>
+              <a:t>Joined the National Guard for college tuition. Now a Battalion Commander after m</a:t>
             </a:r>
           </a:p>
         </p:txBody>
@@ -7445,7 +7445,7 @@
                 </a:solidFill>
                 <a:latin typeface="Helvetica Neue"/>
               </a:rPr>
-              <a:t>37,900</a:t>
+              <a:t>80,582</a:t>
             </a:r>
           </a:p>
         </p:txBody>
@@ -7479,7 +7479,7 @@
                 </a:solidFill>
                 <a:latin typeface="Helvetica Neue"/>
               </a:rPr>
-              <a:t>2,472</a:t>
+              <a:t>2,836</a:t>
             </a:r>
           </a:p>
         </p:txBody>
@@ -7513,7 +7513,7 @@
                 </a:solidFill>
                 <a:latin typeface="Helvetica Neue"/>
               </a:rPr>
-              <a:t>Military Service</a:t>
+              <a:t>Other</a:t>
             </a:r>
           </a:p>
         </p:txBody>
@@ -7669,7 +7669,7 @@
                 </a:solidFill>
                 <a:latin typeface="Helvetica Neue"/>
               </a:rPr>
-              <a:t>TT</a:t>
+              <a:t>IG</a:t>
             </a:r>
           </a:p>
         </p:txBody>
@@ -7703,7 +7703,7 @@
                 </a:solidFill>
                 <a:latin typeface="Helvetica Neue"/>
               </a:rPr>
-              <a:t>Get ready! Round One is taking over the old Sears at Stonewood Mall. This massiv</a:t>
+              <a:t>Visa issues left me without a country to study in. Malaysia or Singapore were th</a:t>
             </a:r>
           </a:p>
         </p:txBody>
@@ -7737,7 +7737,7 @@
                 </a:solidFill>
                 <a:latin typeface="Helvetica Neue"/>
               </a:rPr>
-              <a:t>29,200</a:t>
+              <a:t>69,069</a:t>
             </a:r>
           </a:p>
         </p:txBody>
@@ -7771,7 +7771,7 @@
                 </a:solidFill>
                 <a:latin typeface="Helvetica Neue"/>
               </a:rPr>
-              <a:t>2,513</a:t>
+              <a:t>1,988</a:t>
             </a:r>
           </a:p>
         </p:txBody>
@@ -7805,7 +7805,7 @@
                 </a:solidFill>
                 <a:latin typeface="Helvetica Neue"/>
               </a:rPr>
-              <a:t>Downtown Development</a:t>
+              <a:t>Other</a:t>
             </a:r>
           </a:p>
         </p:txBody>
@@ -7951,7 +7951,7 @@
                 </a:solidFill>
                 <a:latin typeface="Helvetica Neue"/>
               </a:rPr>
-              <a:t>Watch party in Stonewood Mall! Over 25,000 people showed up for this epic event.</a:t>
+              <a:t>Combat jobs aren't for everyone. See how your MOS determines deployment likeliho</a:t>
             </a:r>
           </a:p>
         </p:txBody>
@@ -7985,7 +7985,7 @@
                 </a:solidFill>
                 <a:latin typeface="Helvetica Neue"/>
               </a:rPr>
-              <a:t>27,400</a:t>
+              <a:t>37,900</a:t>
             </a:r>
           </a:p>
         </p:txBody>
@@ -8019,7 +8019,7 @@
                 </a:solidFill>
                 <a:latin typeface="Helvetica Neue"/>
               </a:rPr>
-              <a:t>806</a:t>
+              <a:t>2,472</a:t>
             </a:r>
           </a:p>
         </p:txBody>
@@ -8053,7 +8053,7 @@
                 </a:solidFill>
                 <a:latin typeface="Helvetica Neue"/>
               </a:rPr>
-              <a:t>Fifa Positive</a:t>
+              <a:t>Military Service</a:t>
             </a:r>
           </a:p>
         </p:txBody>
@@ -8199,7 +8199,7 @@
                 </a:solidFill>
                 <a:latin typeface="Helvetica Neue"/>
               </a:rPr>
-              <a:t>Mama Lu's is coming to Downey! Asian community favorite, famous for their tender</a:t>
+              <a:t>Get ready! Round One is taking over the old Sears at Stonewood Mall. This massiv</a:t>
             </a:r>
           </a:p>
         </p:txBody>
@@ -8233,7 +8233,7 @@
                 </a:solidFill>
                 <a:latin typeface="Helvetica Neue"/>
               </a:rPr>
-              <a:t>13,600</a:t>
+              <a:t>29,200</a:t>
             </a:r>
           </a:p>
         </p:txBody>
@@ -8267,7 +8267,7 @@
                 </a:solidFill>
                 <a:latin typeface="Helvetica Neue"/>
               </a:rPr>
-              <a:t>951</a:t>
+              <a:t>2,513</a:t>
             </a:r>
           </a:p>
         </p:txBody>
@@ -8301,7 +8301,7 @@
                 </a:solidFill>
                 <a:latin typeface="Helvetica Neue"/>
               </a:rPr>
-              <a:t>Food</a:t>
+              <a:t>Downtown Development</a:t>
             </a:r>
           </a:p>
         </p:txBody>
@@ -8369,7 +8369,7 @@
                 </a:solidFill>
                 <a:latin typeface="Helvetica Neue"/>
               </a:rPr>
-              <a:t>FB</a:t>
+              <a:t>TT</a:t>
             </a:r>
           </a:p>
         </p:txBody>
@@ -8403,7 +8403,7 @@
                 </a:solidFill>
                 <a:latin typeface="Helvetica Neue"/>
               </a:rPr>
-              <a:t>Chaos erupted at a council meeting when Ms. Rivera began screaming, refusing to </a:t>
+              <a:t>Watch party in Stonewood Mall! Over 25,000 people showed up for this epic event.</a:t>
             </a:r>
           </a:p>
         </p:txBody>
@@ -8437,7 +8437,7 @@
                 </a:solidFill>
                 <a:latin typeface="Helvetica Neue"/>
               </a:rPr>
-              <a:t>11,811</a:t>
+              <a:t>27,400</a:t>
             </a:r>
           </a:p>
         </p:txBody>
@@ -8471,7 +8471,7 @@
                 </a:solidFill>
                 <a:latin typeface="Helvetica Neue"/>
               </a:rPr>
-              <a:t>47</a:t>
+              <a:t>806</a:t>
             </a:r>
           </a:p>
         </p:txBody>
@@ -8505,7 +8505,7 @@
                 </a:solidFill>
                 <a:latin typeface="Helvetica Neue"/>
               </a:rPr>
-              <a:t>Politics Other</a:t>
+              <a:t>Fifa Positive</a:t>
             </a:r>
           </a:p>
         </p:txBody>
@@ -8651,7 +8651,7 @@
                 </a:solidFill>
                 <a:latin typeface="Helvetica Neue"/>
               </a:rPr>
-              <a:t>Grew up in Huntington Park and still own property there. The city's o...</a:t>
+              <a:t>From Las Vegas to Battalion Commander: A journey fueled by college dreams and mi</a:t>
             </a:r>
           </a:p>
         </p:txBody>
@@ -8685,7 +8685,7 @@
                 </a:solidFill>
                 <a:latin typeface="Helvetica Neue"/>
               </a:rPr>
-              <a:t>9,839</a:t>
+              <a:t>19,300</a:t>
             </a:r>
           </a:p>
         </p:txBody>
@@ -8719,7 +8719,7 @@
                 </a:solidFill>
                 <a:latin typeface="Helvetica Neue"/>
               </a:rPr>
-              <a:t>548</a:t>
+              <a:t>692</a:t>
             </a:r>
           </a:p>
         </p:txBody>
@@ -8753,7 +8753,7 @@
                 </a:solidFill>
                 <a:latin typeface="Helvetica Neue"/>
               </a:rPr>
-              <a:t>Trujillo Scandal</a:t>
+              <a:t>Military Service</a:t>
             </a:r>
           </a:p>
         </p:txBody>
@@ -8855,7 +8855,7 @@
                 </a:solidFill>
                 <a:latin typeface="Helvetica Neue"/>
               </a:rPr>
-              <a:t>Pop's Wings just opened and it's a must-try! Their pastrami sandwich with sweet </a:t>
+              <a:t>Mama Lu's is coming to Downey! Asian community favorite, famous for their tender</a:t>
             </a:r>
           </a:p>
         </p:txBody>
@@ -8889,7 +8889,7 @@
                 </a:solidFill>
                 <a:latin typeface="Helvetica Neue"/>
               </a:rPr>
-              <a:t>8,352</a:t>
+              <a:t>13,600</a:t>
             </a:r>
           </a:p>
         </p:txBody>
@@ -8923,7 +8923,7 @@
                 </a:solidFill>
                 <a:latin typeface="Helvetica Neue"/>
               </a:rPr>
-              <a:t>405</a:t>
+              <a:t>951</a:t>
             </a:r>
           </a:p>
         </p:txBody>
@@ -9069,7 +9069,7 @@
                 </a:solidFill>
                 <a:latin typeface="Helvetica Neue"/>
               </a:rPr>
-              <a:t>IG</a:t>
+              <a:t>FB</a:t>
             </a:r>
           </a:p>
         </p:txBody>
@@ -9103,7 +9103,7 @@
                 </a:solidFill>
                 <a:latin typeface="Helvetica Neue"/>
               </a:rPr>
-              <a:t>Chaos erupted! Lissette Rivera refused to calm down, escalating until she was es</a:t>
+              <a:t>Chaos erupted at a council meeting when Ms. Rivera began screaming, refusing to </a:t>
             </a:r>
           </a:p>
         </p:txBody>
@@ -9137,7 +9137,7 @@
                 </a:solidFill>
                 <a:latin typeface="Helvetica Neue"/>
               </a:rPr>
-              <a:t>7,738</a:t>
+              <a:t>11,860</a:t>
             </a:r>
           </a:p>
         </p:txBody>
@@ -9171,7 +9171,7 @@
                 </a:solidFill>
                 <a:latin typeface="Helvetica Neue"/>
               </a:rPr>
-              <a:t>109</a:t>
+              <a:t>47</a:t>
             </a:r>
           </a:p>
         </p:txBody>
@@ -9205,7 +9205,7 @@
                 </a:solidFill>
                 <a:latin typeface="Helvetica Neue"/>
               </a:rPr>
-              <a:t>Council Chaos</a:t>
+              <a:t>Politics Other</a:t>
             </a:r>
           </a:p>
         </p:txBody>
@@ -9273,7 +9273,7 @@
                 </a:solidFill>
                 <a:latin typeface="Helvetica Neue"/>
               </a:rPr>
-              <a:t>IG</a:t>
+              <a:t>TT</a:t>
             </a:r>
           </a:p>
         </p:txBody>
@@ -9307,7 +9307,7 @@
                 </a:solidFill>
                 <a:latin typeface="Helvetica Neue"/>
               </a:rPr>
-              <a:t>25,000+ people gathered for a watch party at Stonewood Mall! Despite the $300k c</a:t>
+              <a:t>Grew up in Huntington Park and still own property there. The city's o...</a:t>
             </a:r>
           </a:p>
         </p:txBody>
@@ -9341,7 +9341,7 @@
                 </a:solidFill>
                 <a:latin typeface="Helvetica Neue"/>
               </a:rPr>
-              <a:t>7,180</a:t>
+              <a:t>9,839</a:t>
             </a:r>
           </a:p>
         </p:txBody>
@@ -9375,7 +9375,7 @@
                 </a:solidFill>
                 <a:latin typeface="Helvetica Neue"/>
               </a:rPr>
-              <a:t>264</a:t>
+              <a:t>548</a:t>
             </a:r>
           </a:p>
         </p:txBody>
@@ -9409,7 +9409,7 @@
                 </a:solidFill>
                 <a:latin typeface="Helvetica Neue"/>
               </a:rPr>
-              <a:t>Fifa Positive</a:t>
+              <a:t>Trujillo Scandal</a:t>
             </a:r>
           </a:p>
         </p:txBody>
@@ -9521,7 +9521,7 @@
                 </a:solidFill>
                 <a:latin typeface="Helvetica Neue"/>
               </a:rPr>
-              <a:t>IG</a:t>
+              <a:t>TT</a:t>
             </a:r>
           </a:p>
         </p:txBody>
@@ -9555,7 +9555,7 @@
                 </a:solidFill>
                 <a:latin typeface="Helvetica Neue"/>
               </a:rPr>
-              <a:t>A woman's outburst at a city council meeting, repeatedly warned by the mayor, le</a:t>
+              <a:t>Pop's Wings just opened and it's a must-try! Their pastrami sandwich with sweet </a:t>
             </a:r>
           </a:p>
         </p:txBody>
@@ -9589,7 +9589,7 @@
                 </a:solidFill>
                 <a:latin typeface="Helvetica Neue"/>
               </a:rPr>
-              <a:t>7,031</a:t>
+              <a:t>8,352</a:t>
             </a:r>
           </a:p>
         </p:txBody>
@@ -9623,7 +9623,7 @@
                 </a:solidFill>
                 <a:latin typeface="Helvetica Neue"/>
               </a:rPr>
-              <a:t>93</a:t>
+              <a:t>405</a:t>
             </a:r>
           </a:p>
         </p:txBody>
@@ -9657,7 +9657,7 @@
                 </a:solidFill>
                 <a:latin typeface="Helvetica Neue"/>
               </a:rPr>
-              <a:t>Council Chaos</a:t>
+              <a:t>Food</a:t>
             </a:r>
           </a:p>
         </p:txBody>

</xml_diff>

<commit_message>
Scheduled snapshot t41 (2026-10-09): fresh IG/FB/YT/TT + rebuilt decks
Co-Authored-By: Claude Opus 4.7 (1M context) <noreply@anthropic.com>
</commit_message>
<xml_diff>
--- a/OVERALL_REPORT.pptx
+++ b/OVERALL_REPORT.pptx
@@ -3277,7 +3277,7 @@
                 </a:solidFill>
                 <a:latin typeface="Georgia"/>
               </a:rPr>
-              <a:t>Since Jun 8, 2026 · 2026-10-02</a:t>
+              <a:t>Since Jun 8, 2026 · 2026-10-09</a:t>
             </a:r>
           </a:p>
         </p:txBody>
@@ -3578,7 +3578,7 @@
                 </a:solidFill>
                 <a:latin typeface="Georgia"/>
               </a:rPr>
-              <a:t>806,526</a:t>
+              <a:t>858,751</a:t>
             </a:r>
           </a:p>
         </p:txBody>
@@ -3769,7 +3769,7 @@
                 </a:solidFill>
                 <a:latin typeface="Georgia"/>
               </a:rPr>
-              <a:t>559</a:t>
+              <a:t>596</a:t>
             </a:r>
           </a:p>
         </p:txBody>
@@ -3925,7 +3925,7 @@
                 </a:solidFill>
                 <a:latin typeface="Georgia"/>
               </a:rPr>
-              <a:t>24,792</a:t>
+              <a:t>26,022</a:t>
             </a:r>
           </a:p>
         </p:txBody>
@@ -4081,7 +4081,7 @@
                 </a:solidFill>
                 <a:latin typeface="Georgia"/>
               </a:rPr>
-              <a:t>1,442</a:t>
+              <a:t>1,440</a:t>
             </a:r>
           </a:p>
         </p:txBody>
@@ -4401,7 +4401,7 @@
                 </a:solidFill>
                 <a:latin typeface="Georgia"/>
               </a:rPr>
-              <a:t>346,207</a:t>
+              <a:t>374,358</a:t>
             </a:r>
           </a:p>
         </p:txBody>
@@ -4469,7 +4469,7 @@
                 </a:solidFill>
                 <a:latin typeface="Helvetica Neue"/>
               </a:rPr>
-              <a:t>179 posts</a:t>
+              <a:t>193 posts</a:t>
             </a:r>
           </a:p>
         </p:txBody>
@@ -4503,7 +4503,7 @@
                 </a:solidFill>
                 <a:latin typeface="Helvetica Neue"/>
               </a:rPr>
-              <a:t>1,934 avg views/post</a:t>
+              <a:t>1,940 avg views/post</a:t>
             </a:r>
           </a:p>
         </p:txBody>
@@ -4659,7 +4659,7 @@
                 </a:solidFill>
                 <a:latin typeface="Georgia"/>
               </a:rPr>
-              <a:t>268,675</a:t>
+              <a:t>284,442</a:t>
             </a:r>
           </a:p>
         </p:txBody>
@@ -4727,7 +4727,7 @@
                 </a:solidFill>
                 <a:latin typeface="Helvetica Neue"/>
               </a:rPr>
-              <a:t>164 posts</a:t>
+              <a:t>174 posts</a:t>
             </a:r>
           </a:p>
         </p:txBody>
@@ -4761,7 +4761,7 @@
                 </a:solidFill>
                 <a:latin typeface="Helvetica Neue"/>
               </a:rPr>
-              <a:t>1,638 avg views/post</a:t>
+              <a:t>1,635 avg views/post</a:t>
             </a:r>
           </a:p>
         </p:txBody>
@@ -4917,7 +4917,7 @@
                 </a:solidFill>
                 <a:latin typeface="Georgia"/>
               </a:rPr>
-              <a:t>189,412</a:t>
+              <a:t>197,321</a:t>
             </a:r>
           </a:p>
         </p:txBody>
@@ -4985,7 +4985,7 @@
                 </a:solidFill>
                 <a:latin typeface="Helvetica Neue"/>
               </a:rPr>
-              <a:t>199 posts</a:t>
+              <a:t>211 posts</a:t>
             </a:r>
           </a:p>
         </p:txBody>
@@ -5019,7 +5019,7 @@
                 </a:solidFill>
                 <a:latin typeface="Helvetica Neue"/>
               </a:rPr>
-              <a:t>952 avg views/post</a:t>
+              <a:t>935 avg views/post</a:t>
             </a:r>
           </a:p>
         </p:txBody>
@@ -5175,7 +5175,7 @@
                 </a:solidFill>
                 <a:latin typeface="Georgia"/>
               </a:rPr>
-              <a:t>2,232</a:t>
+              <a:t>2,630</a:t>
             </a:r>
           </a:p>
         </p:txBody>
@@ -5243,7 +5243,7 @@
                 </a:solidFill>
                 <a:latin typeface="Helvetica Neue"/>
               </a:rPr>
-              <a:t>17 posts</a:t>
+              <a:t>18 posts</a:t>
             </a:r>
           </a:p>
         </p:txBody>
@@ -5277,7 +5277,7 @@
                 </a:solidFill>
                 <a:latin typeface="Helvetica Neue"/>
               </a:rPr>
-              <a:t>131 avg views/post</a:t>
+              <a:t>146 avg views/post</a:t>
             </a:r>
           </a:p>
         </p:txBody>
@@ -5587,7 +5587,7 @@
                 </a:solidFill>
                 <a:latin typeface="Helvetica Neue"/>
               </a:rPr>
-              <a:t>250,607   (174 posts · 1,440 avg)</a:t>
+              <a:t>280,258   (189 posts · 1,483 avg)</a:t>
             </a:r>
           </a:p>
         </p:txBody>
@@ -5635,7 +5635,7 @@
         <p:spPr>
           <a:xfrm>
             <a:off x="3383280" y="2532888"/>
-            <a:ext cx="2583582" cy="192024"/>
+            <a:ext cx="2427381" cy="192024"/>
           </a:xfrm>
           <a:prstGeom prst="rect">
             <a:avLst/>
@@ -5678,7 +5678,7 @@
         </p:nvSpPr>
         <p:spPr>
           <a:xfrm>
-            <a:off x="6058302" y="2505456"/>
+            <a:off x="5902101" y="2505456"/>
             <a:ext cx="2286000" cy="329184"/>
           </a:xfrm>
           <a:prstGeom prst="rect">
@@ -5699,7 +5699,7 @@
                 </a:solidFill>
                 <a:latin typeface="Helvetica Neue"/>
               </a:rPr>
-              <a:t>94,410   (62 posts · 1,523 avg)</a:t>
+              <a:t>99,197   (63 posts · 1,575 avg)</a:t>
             </a:r>
           </a:p>
         </p:txBody>
@@ -5747,7 +5747,7 @@
         <p:spPr>
           <a:xfrm>
             <a:off x="3383280" y="2862072"/>
-            <a:ext cx="2363590" cy="192024"/>
+            <a:ext cx="2266880" cy="192024"/>
           </a:xfrm>
           <a:prstGeom prst="rect">
             <a:avLst/>
@@ -5790,7 +5790,7 @@
         </p:nvSpPr>
         <p:spPr>
           <a:xfrm>
-            <a:off x="5838310" y="2834640"/>
+            <a:off x="5741600" y="2834640"/>
             <a:ext cx="2286000" cy="329184"/>
           </a:xfrm>
           <a:prstGeom prst="rect">
@@ -5811,7 +5811,7 @@
                 </a:solidFill>
                 <a:latin typeface="Helvetica Neue"/>
               </a:rPr>
-              <a:t>86,371   (28 posts · 3,085 avg)</a:t>
+              <a:t>92,638   (34 posts · 2,725 avg)</a:t>
             </a:r>
           </a:p>
         </p:txBody>
@@ -5859,7 +5859,7 @@
         <p:spPr>
           <a:xfrm>
             <a:off x="3383280" y="3191256"/>
-            <a:ext cx="1421750" cy="192024"/>
+            <a:ext cx="1272211" cy="192024"/>
           </a:xfrm>
           <a:prstGeom prst="rect">
             <a:avLst/>
@@ -5902,7 +5902,7 @@
         </p:nvSpPr>
         <p:spPr>
           <a:xfrm>
-            <a:off x="4896470" y="3163824"/>
+            <a:off x="4746931" y="3163824"/>
             <a:ext cx="2286000" cy="329184"/>
           </a:xfrm>
           <a:prstGeom prst="rect">
@@ -5923,7 +5923,7 @@
                 </a:solidFill>
                 <a:latin typeface="Helvetica Neue"/>
               </a:rPr>
-              <a:t>51,954   (17 posts · 3,056 avg)</a:t>
+              <a:t>51,990   (17 posts · 3,058 avg)</a:t>
             </a:r>
           </a:p>
         </p:txBody>
@@ -5971,7 +5971,7 @@
         <p:spPr>
           <a:xfrm>
             <a:off x="3383280" y="3520440"/>
-            <a:ext cx="1304707" cy="192024"/>
+            <a:ext cx="1248573" cy="192024"/>
           </a:xfrm>
           <a:prstGeom prst="rect">
             <a:avLst/>
@@ -6014,7 +6014,7 @@
         </p:nvSpPr>
         <p:spPr>
           <a:xfrm>
-            <a:off x="4779427" y="3493008"/>
+            <a:off x="4723293" y="3493008"/>
             <a:ext cx="2286000" cy="329184"/>
           </a:xfrm>
           <a:prstGeom prst="rect">
@@ -6035,7 +6035,7 @@
                 </a:solidFill>
                 <a:latin typeface="Helvetica Neue"/>
               </a:rPr>
-              <a:t>47,677   (18 posts · 2,649 avg)</a:t>
+              <a:t>51,024   (20 posts · 2,551 avg)</a:t>
             </a:r>
           </a:p>
         </p:txBody>
@@ -6083,7 +6083,7 @@
         <p:spPr>
           <a:xfrm>
             <a:off x="3383280" y="3849624"/>
-            <a:ext cx="1126503" cy="192024"/>
+            <a:ext cx="1007320" cy="192024"/>
           </a:xfrm>
           <a:prstGeom prst="rect">
             <a:avLst/>
@@ -6126,7 +6126,7 @@
         </p:nvSpPr>
         <p:spPr>
           <a:xfrm>
-            <a:off x="4601223" y="3822192"/>
+            <a:off x="4482040" y="3822192"/>
             <a:ext cx="2286000" cy="329184"/>
           </a:xfrm>
           <a:prstGeom prst="rect">
@@ -6195,7 +6195,7 @@
         <p:spPr>
           <a:xfrm>
             <a:off x="3383280" y="4178807"/>
-            <a:ext cx="927911" cy="192024"/>
+            <a:ext cx="964546" cy="192024"/>
           </a:xfrm>
           <a:prstGeom prst="rect">
             <a:avLst/>
@@ -6238,7 +6238,7 @@
         </p:nvSpPr>
         <p:spPr>
           <a:xfrm>
-            <a:off x="4402631" y="4151376"/>
+            <a:off x="4439266" y="4151376"/>
             <a:ext cx="2286000" cy="329184"/>
           </a:xfrm>
           <a:prstGeom prst="rect">
@@ -6259,7 +6259,7 @@
                 </a:solidFill>
                 <a:latin typeface="Helvetica Neue"/>
               </a:rPr>
-              <a:t>33,908   (34 posts · 997 avg)</a:t>
+              <a:t>39,417   (38 posts · 1,037 avg)</a:t>
             </a:r>
           </a:p>
         </p:txBody>
@@ -6307,7 +6307,7 @@
         <p:spPr>
           <a:xfrm>
             <a:off x="3383280" y="4507992"/>
-            <a:ext cx="849098" cy="192024"/>
+            <a:ext cx="760268" cy="192024"/>
           </a:xfrm>
           <a:prstGeom prst="rect">
             <a:avLst/>
@@ -6350,7 +6350,7 @@
         </p:nvSpPr>
         <p:spPr>
           <a:xfrm>
-            <a:off x="4323818" y="4480560"/>
+            <a:off x="4234988" y="4480560"/>
             <a:ext cx="2286000" cy="329184"/>
           </a:xfrm>
           <a:prstGeom prst="rect">
@@ -6371,7 +6371,7 @@
                 </a:solidFill>
                 <a:latin typeface="Helvetica Neue"/>
               </a:rPr>
-              <a:t>31,028   (21 posts · 1,478 avg)</a:t>
+              <a:t>31,069   (23 posts · 1,351 avg)</a:t>
             </a:r>
           </a:p>
         </p:txBody>
@@ -6405,7 +6405,7 @@
                 </a:solidFill>
                 <a:latin typeface="Helvetica Neue"/>
               </a:rPr>
-              <a:t>Council Chaos</a:t>
+              <a:t>Political Highlight</a:t>
             </a:r>
           </a:p>
         </p:txBody>
@@ -6419,7 +6419,119 @@
         <p:spPr>
           <a:xfrm>
             <a:off x="3383280" y="4837176"/>
-            <a:ext cx="785117" cy="192024"/>
+            <a:ext cx="708831" cy="192024"/>
+          </a:xfrm>
+          <a:prstGeom prst="rect">
+            <a:avLst/>
+          </a:prstGeom>
+          <a:solidFill>
+            <a:srgbClr val="2E86AB"/>
+          </a:solidFill>
+          <a:ln>
+            <a:noFill/>
+          </a:ln>
+          <a:effectLst/>
+        </p:spPr>
+        <p:style>
+          <a:lnRef idx="1">
+            <a:schemeClr val="accent1"/>
+          </a:lnRef>
+          <a:fillRef idx="3">
+            <a:schemeClr val="accent1"/>
+          </a:fillRef>
+          <a:effectRef idx="2">
+            <a:schemeClr val="accent1"/>
+          </a:effectRef>
+          <a:fontRef idx="minor">
+            <a:schemeClr val="lt1"/>
+          </a:fontRef>
+        </p:style>
+        <p:txBody>
+          <a:bodyPr rtlCol="0" anchor="ctr"/>
+          <a:lstStyle/>
+          <a:p>
+            <a:pPr algn="ctr"/>
+          </a:p>
+        </p:txBody>
+      </p:sp>
+      <p:sp>
+        <p:nvSpPr>
+          <p:cNvPr id="32" name="TextBox 31"/>
+          <p:cNvSpPr txBox="1"/>
+          <p:nvPr/>
+        </p:nvSpPr>
+        <p:spPr>
+          <a:xfrm>
+            <a:off x="4183551" y="4809744"/>
+            <a:ext cx="2286000" cy="329184"/>
+          </a:xfrm>
+          <a:prstGeom prst="rect">
+            <a:avLst/>
+          </a:prstGeom>
+          <a:noFill/>
+        </p:spPr>
+        <p:txBody>
+          <a:bodyPr wrap="square" lIns="0" rIns="0" tIns="0" bIns="0">
+            <a:spAutoFit/>
+          </a:bodyPr>
+          <a:lstStyle/>
+          <a:p>
+            <a:r>
+              <a:rPr sz="1000" b="0">
+                <a:solidFill>
+                  <a:srgbClr val="6B7082"/>
+                </a:solidFill>
+                <a:latin typeface="Helvetica Neue"/>
+              </a:rPr>
+              <a:t>28,967   (32 posts · 905 avg)</a:t>
+            </a:r>
+          </a:p>
+        </p:txBody>
+      </p:sp>
+      <p:sp>
+        <p:nvSpPr>
+          <p:cNvPr id="33" name="TextBox 32"/>
+          <p:cNvSpPr txBox="1"/>
+          <p:nvPr/>
+        </p:nvSpPr>
+        <p:spPr>
+          <a:xfrm>
+            <a:off x="731520" y="5138928"/>
+            <a:ext cx="2468880" cy="329184"/>
+          </a:xfrm>
+          <a:prstGeom prst="rect">
+            <a:avLst/>
+          </a:prstGeom>
+          <a:noFill/>
+        </p:spPr>
+        <p:txBody>
+          <a:bodyPr wrap="square" lIns="0" rIns="0" tIns="0" bIns="0">
+            <a:spAutoFit/>
+          </a:bodyPr>
+          <a:lstStyle/>
+          <a:p>
+            <a:r>
+              <a:rPr sz="1100" b="0">
+                <a:solidFill>
+                  <a:srgbClr val="141833"/>
+                </a:solidFill>
+                <a:latin typeface="Helvetica Neue"/>
+              </a:rPr>
+              <a:t>Council Chaos</a:t>
+            </a:r>
+          </a:p>
+        </p:txBody>
+      </p:sp>
+      <p:sp>
+        <p:nvSpPr>
+          <p:cNvPr id="34" name="Rectangle 33"/>
+          <p:cNvSpPr/>
+          <p:nvPr/>
+        </p:nvSpPr>
+        <p:spPr>
+          <a:xfrm>
+            <a:off x="3383280" y="5166359"/>
+            <a:ext cx="702053" cy="192024"/>
           </a:xfrm>
           <a:prstGeom prst="rect">
             <a:avLst/>
@@ -6456,13 +6568,13 @@
       </p:sp>
       <p:sp>
         <p:nvSpPr>
-          <p:cNvPr id="32" name="TextBox 31"/>
-          <p:cNvSpPr txBox="1"/>
-          <p:nvPr/>
-        </p:nvSpPr>
-        <p:spPr>
-          <a:xfrm>
-            <a:off x="4259837" y="4809744"/>
+          <p:cNvPr id="35" name="TextBox 34"/>
+          <p:cNvSpPr txBox="1"/>
+          <p:nvPr/>
+        </p:nvSpPr>
+        <p:spPr>
+          <a:xfrm>
+            <a:off x="4176773" y="5138928"/>
             <a:ext cx="2286000" cy="329184"/>
           </a:xfrm>
           <a:prstGeom prst="rect">
@@ -6484,118 +6596,6 @@
                 <a:latin typeface="Helvetica Neue"/>
               </a:rPr>
               <a:t>28,690   (6 posts · 4,782 avg)</a:t>
-            </a:r>
-          </a:p>
-        </p:txBody>
-      </p:sp>
-      <p:sp>
-        <p:nvSpPr>
-          <p:cNvPr id="33" name="TextBox 32"/>
-          <p:cNvSpPr txBox="1"/>
-          <p:nvPr/>
-        </p:nvSpPr>
-        <p:spPr>
-          <a:xfrm>
-            <a:off x="731520" y="5138928"/>
-            <a:ext cx="2468880" cy="329184"/>
-          </a:xfrm>
-          <a:prstGeom prst="rect">
-            <a:avLst/>
-          </a:prstGeom>
-          <a:noFill/>
-        </p:spPr>
-        <p:txBody>
-          <a:bodyPr wrap="square" lIns="0" rIns="0" tIns="0" bIns="0">
-            <a:spAutoFit/>
-          </a:bodyPr>
-          <a:lstStyle/>
-          <a:p>
-            <a:r>
-              <a:rPr sz="1100" b="0">
-                <a:solidFill>
-                  <a:srgbClr val="141833"/>
-                </a:solidFill>
-                <a:latin typeface="Helvetica Neue"/>
-              </a:rPr>
-              <a:t>Political Highlight</a:t>
-            </a:r>
-          </a:p>
-        </p:txBody>
-      </p:sp>
-      <p:sp>
-        <p:nvSpPr>
-          <p:cNvPr id="34" name="Rectangle 33"/>
-          <p:cNvSpPr/>
-          <p:nvPr/>
-        </p:nvSpPr>
-        <p:spPr>
-          <a:xfrm>
-            <a:off x="3383280" y="5166359"/>
-            <a:ext cx="767521" cy="192024"/>
-          </a:xfrm>
-          <a:prstGeom prst="rect">
-            <a:avLst/>
-          </a:prstGeom>
-          <a:solidFill>
-            <a:srgbClr val="2E86AB"/>
-          </a:solidFill>
-          <a:ln>
-            <a:noFill/>
-          </a:ln>
-          <a:effectLst/>
-        </p:spPr>
-        <p:style>
-          <a:lnRef idx="1">
-            <a:schemeClr val="accent1"/>
-          </a:lnRef>
-          <a:fillRef idx="3">
-            <a:schemeClr val="accent1"/>
-          </a:fillRef>
-          <a:effectRef idx="2">
-            <a:schemeClr val="accent1"/>
-          </a:effectRef>
-          <a:fontRef idx="minor">
-            <a:schemeClr val="lt1"/>
-          </a:fontRef>
-        </p:style>
-        <p:txBody>
-          <a:bodyPr rtlCol="0" anchor="ctr"/>
-          <a:lstStyle/>
-          <a:p>
-            <a:pPr algn="ctr"/>
-          </a:p>
-        </p:txBody>
-      </p:sp>
-      <p:sp>
-        <p:nvSpPr>
-          <p:cNvPr id="35" name="TextBox 34"/>
-          <p:cNvSpPr txBox="1"/>
-          <p:nvPr/>
-        </p:nvSpPr>
-        <p:spPr>
-          <a:xfrm>
-            <a:off x="4242241" y="5138928"/>
-            <a:ext cx="2286000" cy="329184"/>
-          </a:xfrm>
-          <a:prstGeom prst="rect">
-            <a:avLst/>
-          </a:prstGeom>
-          <a:noFill/>
-        </p:spPr>
-        <p:txBody>
-          <a:bodyPr wrap="square" lIns="0" rIns="0" tIns="0" bIns="0">
-            <a:spAutoFit/>
-          </a:bodyPr>
-          <a:lstStyle/>
-          <a:p>
-            <a:r>
-              <a:rPr sz="1000" b="0">
-                <a:solidFill>
-                  <a:srgbClr val="6B7082"/>
-                </a:solidFill>
-                <a:latin typeface="Helvetica Neue"/>
-              </a:rPr>
-              <a:t>28,047   (30 posts · 935 avg)</a:t>
             </a:r>
           </a:p>
         </p:txBody>
@@ -6643,7 +6643,7 @@
         <p:spPr>
           <a:xfrm>
             <a:off x="3383280" y="5495543"/>
-            <a:ext cx="562499" cy="192024"/>
+            <a:ext cx="538787" cy="192024"/>
           </a:xfrm>
           <a:prstGeom prst="rect">
             <a:avLst/>
@@ -6686,7 +6686,7 @@
         </p:nvSpPr>
         <p:spPr>
           <a:xfrm>
-            <a:off x="4037219" y="5468112"/>
+            <a:off x="4013507" y="5468112"/>
             <a:ext cx="2286000" cy="329184"/>
           </a:xfrm>
           <a:prstGeom prst="rect">
@@ -6707,7 +6707,7 @@
                 </a:solidFill>
                 <a:latin typeface="Helvetica Neue"/>
               </a:rPr>
-              <a:t>20,555   (21 posts · 979 avg)</a:t>
+              <a:t>22,018   (26 posts · 847 avg)</a:t>
             </a:r>
           </a:p>
         </p:txBody>
@@ -6755,7 +6755,7 @@
         <p:spPr>
           <a:xfrm>
             <a:off x="3383280" y="5824728"/>
-            <a:ext cx="561650" cy="192024"/>
+            <a:ext cx="504626" cy="192024"/>
           </a:xfrm>
           <a:prstGeom prst="rect">
             <a:avLst/>
@@ -6798,7 +6798,7 @@
         </p:nvSpPr>
         <p:spPr>
           <a:xfrm>
-            <a:off x="4036370" y="5797296"/>
+            <a:off x="3979346" y="5797296"/>
             <a:ext cx="2286000" cy="329184"/>
           </a:xfrm>
           <a:prstGeom prst="rect">
@@ -6819,7 +6819,7 @@
                 </a:solidFill>
                 <a:latin typeface="Helvetica Neue"/>
               </a:rPr>
-              <a:t>20,524   (49 posts · 419 avg)</a:t>
+              <a:t>20,622   (49 posts · 421 avg)</a:t>
             </a:r>
           </a:p>
         </p:txBody>
@@ -7445,7 +7445,7 @@
                 </a:solidFill>
                 <a:latin typeface="Helvetica Neue"/>
               </a:rPr>
-              <a:t>80,582</a:t>
+              <a:t>83,242</a:t>
             </a:r>
           </a:p>
         </p:txBody>
@@ -7479,7 +7479,7 @@
                 </a:solidFill>
                 <a:latin typeface="Helvetica Neue"/>
               </a:rPr>
-              <a:t>2,836</a:t>
+              <a:t>2,895</a:t>
             </a:r>
           </a:p>
         </p:txBody>
@@ -7737,7 +7737,7 @@
                 </a:solidFill>
                 <a:latin typeface="Helvetica Neue"/>
               </a:rPr>
-              <a:t>69,069</a:t>
+              <a:t>82,151</a:t>
             </a:r>
           </a:p>
         </p:txBody>
@@ -7771,7 +7771,7 @@
                 </a:solidFill>
                 <a:latin typeface="Helvetica Neue"/>
               </a:rPr>
-              <a:t>1,988</a:t>
+              <a:t>2,058</a:t>
             </a:r>
           </a:p>
         </p:txBody>
@@ -8685,7 +8685,7 @@
                 </a:solidFill>
                 <a:latin typeface="Helvetica Neue"/>
               </a:rPr>
-              <a:t>19,300</a:t>
+              <a:t>21,500</a:t>
             </a:r>
           </a:p>
         </p:txBody>
@@ -8719,7 +8719,7 @@
                 </a:solidFill>
                 <a:latin typeface="Helvetica Neue"/>
               </a:rPr>
-              <a:t>692</a:t>
+              <a:t>765</a:t>
             </a:r>
           </a:p>
         </p:txBody>

</xml_diff>

<commit_message>
Scheduled snapshot t42 (2026-10-14): fresh IG/FB/YT/TT + rebuilt decks
Co-Authored-By: Claude Opus 4.7 (1M context) <noreply@anthropic.com>
</commit_message>
<xml_diff>
--- a/OVERALL_REPORT.pptx
+++ b/OVERALL_REPORT.pptx
@@ -3277,7 +3277,7 @@
                 </a:solidFill>
                 <a:latin typeface="Georgia"/>
               </a:rPr>
-              <a:t>Since Jun 8, 2026 · 2026-10-09</a:t>
+              <a:t>Since Jun 8, 2026 · 2026-10-14</a:t>
             </a:r>
           </a:p>
         </p:txBody>
@@ -3578,7 +3578,7 @@
                 </a:solidFill>
                 <a:latin typeface="Georgia"/>
               </a:rPr>
-              <a:t>858,751</a:t>
+              <a:t>890,238</a:t>
             </a:r>
           </a:p>
         </p:txBody>
@@ -3769,7 +3769,7 @@
                 </a:solidFill>
                 <a:latin typeface="Georgia"/>
               </a:rPr>
-              <a:t>596</a:t>
+              <a:t>626</a:t>
             </a:r>
           </a:p>
         </p:txBody>
@@ -3925,7 +3925,7 @@
                 </a:solidFill>
                 <a:latin typeface="Georgia"/>
               </a:rPr>
-              <a:t>26,022</a:t>
+              <a:t>26,819</a:t>
             </a:r>
           </a:p>
         </p:txBody>
@@ -4081,7 +4081,7 @@
                 </a:solidFill>
                 <a:latin typeface="Georgia"/>
               </a:rPr>
-              <a:t>1,440</a:t>
+              <a:t>1,422</a:t>
             </a:r>
           </a:p>
         </p:txBody>
@@ -4401,7 +4401,7 @@
                 </a:solidFill>
                 <a:latin typeface="Georgia"/>
               </a:rPr>
-              <a:t>374,358</a:t>
+              <a:t>387,491</a:t>
             </a:r>
           </a:p>
         </p:txBody>
@@ -4469,7 +4469,7 @@
                 </a:solidFill>
                 <a:latin typeface="Helvetica Neue"/>
               </a:rPr>
-              <a:t>193 posts</a:t>
+              <a:t>205 posts</a:t>
             </a:r>
           </a:p>
         </p:txBody>
@@ -4503,7 +4503,7 @@
                 </a:solidFill>
                 <a:latin typeface="Helvetica Neue"/>
               </a:rPr>
-              <a:t>1,940 avg views/post</a:t>
+              <a:t>1,890 avg views/post</a:t>
             </a:r>
           </a:p>
         </p:txBody>
@@ -4659,7 +4659,7 @@
                 </a:solidFill>
                 <a:latin typeface="Georgia"/>
               </a:rPr>
-              <a:t>284,442</a:t>
+              <a:t>290,583</a:t>
             </a:r>
           </a:p>
         </p:txBody>
@@ -4727,7 +4727,7 @@
                 </a:solidFill>
                 <a:latin typeface="Helvetica Neue"/>
               </a:rPr>
-              <a:t>174 posts</a:t>
+              <a:t>180 posts</a:t>
             </a:r>
           </a:p>
         </p:txBody>
@@ -4761,7 +4761,7 @@
                 </a:solidFill>
                 <a:latin typeface="Helvetica Neue"/>
               </a:rPr>
-              <a:t>1,635 avg views/post</a:t>
+              <a:t>1,614 avg views/post</a:t>
             </a:r>
           </a:p>
         </p:txBody>
@@ -4917,7 +4917,7 @@
                 </a:solidFill>
                 <a:latin typeface="Georgia"/>
               </a:rPr>
-              <a:t>197,321</a:t>
+              <a:t>209,391</a:t>
             </a:r>
           </a:p>
         </p:txBody>
@@ -4985,7 +4985,7 @@
                 </a:solidFill>
                 <a:latin typeface="Helvetica Neue"/>
               </a:rPr>
-              <a:t>211 posts</a:t>
+              <a:t>222 posts</a:t>
             </a:r>
           </a:p>
         </p:txBody>
@@ -5019,7 +5019,7 @@
                 </a:solidFill>
                 <a:latin typeface="Helvetica Neue"/>
               </a:rPr>
-              <a:t>935 avg views/post</a:t>
+              <a:t>943 avg views/post</a:t>
             </a:r>
           </a:p>
         </p:txBody>
@@ -5175,7 +5175,7 @@
                 </a:solidFill>
                 <a:latin typeface="Georgia"/>
               </a:rPr>
-              <a:t>2,630</a:t>
+              <a:t>2,773</a:t>
             </a:r>
           </a:p>
         </p:txBody>
@@ -5243,7 +5243,7 @@
                 </a:solidFill>
                 <a:latin typeface="Helvetica Neue"/>
               </a:rPr>
-              <a:t>18 posts</a:t>
+              <a:t>19 posts</a:t>
             </a:r>
           </a:p>
         </p:txBody>
@@ -5587,7 +5587,7 @@
                 </a:solidFill>
                 <a:latin typeface="Helvetica Neue"/>
               </a:rPr>
-              <a:t>280,258   (189 posts · 1,483 avg)</a:t>
+              <a:t>285,293   (196 posts · 1,456 avg)</a:t>
             </a:r>
           </a:p>
         </p:txBody>
@@ -5621,7 +5621,7 @@
                 </a:solidFill>
                 <a:latin typeface="Helvetica Neue"/>
               </a:rPr>
-              <a:t>Food</a:t>
+              <a:t>military_service</a:t>
             </a:r>
           </a:p>
         </p:txBody>
@@ -5635,7 +5635,119 @@
         <p:spPr>
           <a:xfrm>
             <a:off x="3383280" y="2532888"/>
-            <a:ext cx="2427381" cy="192024"/>
+            <a:ext cx="2431296" cy="192024"/>
+          </a:xfrm>
+          <a:prstGeom prst="rect">
+            <a:avLst/>
+          </a:prstGeom>
+          <a:solidFill>
+            <a:srgbClr val="6B7082"/>
+          </a:solidFill>
+          <a:ln>
+            <a:noFill/>
+          </a:ln>
+          <a:effectLst/>
+        </p:spPr>
+        <p:style>
+          <a:lnRef idx="1">
+            <a:schemeClr val="accent1"/>
+          </a:lnRef>
+          <a:fillRef idx="3">
+            <a:schemeClr val="accent1"/>
+          </a:fillRef>
+          <a:effectRef idx="2">
+            <a:schemeClr val="accent1"/>
+          </a:effectRef>
+          <a:fontRef idx="minor">
+            <a:schemeClr val="lt1"/>
+          </a:fontRef>
+        </p:style>
+        <p:txBody>
+          <a:bodyPr rtlCol="0" anchor="ctr"/>
+          <a:lstStyle/>
+          <a:p>
+            <a:pPr algn="ctr"/>
+          </a:p>
+        </p:txBody>
+      </p:sp>
+      <p:sp>
+        <p:nvSpPr>
+          <p:cNvPr id="11" name="TextBox 10"/>
+          <p:cNvSpPr txBox="1"/>
+          <p:nvPr/>
+        </p:nvSpPr>
+        <p:spPr>
+          <a:xfrm>
+            <a:off x="5906016" y="2505456"/>
+            <a:ext cx="2286000" cy="329184"/>
+          </a:xfrm>
+          <a:prstGeom prst="rect">
+            <a:avLst/>
+          </a:prstGeom>
+          <a:noFill/>
+        </p:spPr>
+        <p:txBody>
+          <a:bodyPr wrap="square" lIns="0" rIns="0" tIns="0" bIns="0">
+            <a:spAutoFit/>
+          </a:bodyPr>
+          <a:lstStyle/>
+          <a:p>
+            <a:r>
+              <a:rPr sz="1000" b="0">
+                <a:solidFill>
+                  <a:srgbClr val="6B7082"/>
+                </a:solidFill>
+                <a:latin typeface="Helvetica Neue"/>
+              </a:rPr>
+              <a:t>101,142   (43 posts · 2,352 avg)</a:t>
+            </a:r>
+          </a:p>
+        </p:txBody>
+      </p:sp>
+      <p:sp>
+        <p:nvSpPr>
+          <p:cNvPr id="12" name="TextBox 11"/>
+          <p:cNvSpPr txBox="1"/>
+          <p:nvPr/>
+        </p:nvSpPr>
+        <p:spPr>
+          <a:xfrm>
+            <a:off x="731520" y="2834640"/>
+            <a:ext cx="2468880" cy="329184"/>
+          </a:xfrm>
+          <a:prstGeom prst="rect">
+            <a:avLst/>
+          </a:prstGeom>
+          <a:noFill/>
+        </p:spPr>
+        <p:txBody>
+          <a:bodyPr wrap="square" lIns="0" rIns="0" tIns="0" bIns="0">
+            <a:spAutoFit/>
+          </a:bodyPr>
+          <a:lstStyle/>
+          <a:p>
+            <a:r>
+              <a:rPr sz="1100" b="1">
+                <a:solidFill>
+                  <a:srgbClr val="141833"/>
+                </a:solidFill>
+                <a:latin typeface="Helvetica Neue"/>
+              </a:rPr>
+              <a:t>Food</a:t>
+            </a:r>
+          </a:p>
+        </p:txBody>
+      </p:sp>
+      <p:sp>
+        <p:nvSpPr>
+          <p:cNvPr id="13" name="Rectangle 12"/>
+          <p:cNvSpPr/>
+          <p:nvPr/>
+        </p:nvSpPr>
+        <p:spPr>
+          <a:xfrm>
+            <a:off x="3383280" y="2862072"/>
+            <a:ext cx="2405767" cy="192024"/>
           </a:xfrm>
           <a:prstGeom prst="rect">
             <a:avLst/>
@@ -5672,13 +5784,13 @@
       </p:sp>
       <p:sp>
         <p:nvSpPr>
-          <p:cNvPr id="11" name="TextBox 10"/>
-          <p:cNvSpPr txBox="1"/>
-          <p:nvPr/>
-        </p:nvSpPr>
-        <p:spPr>
-          <a:xfrm>
-            <a:off x="5902101" y="2505456"/>
+          <p:cNvPr id="14" name="TextBox 13"/>
+          <p:cNvSpPr txBox="1"/>
+          <p:nvPr/>
+        </p:nvSpPr>
+        <p:spPr>
+          <a:xfrm>
+            <a:off x="5880487" y="2834640"/>
             <a:ext cx="2286000" cy="329184"/>
           </a:xfrm>
           <a:prstGeom prst="rect">
@@ -5699,119 +5811,7 @@
                 </a:solidFill>
                 <a:latin typeface="Helvetica Neue"/>
               </a:rPr>
-              <a:t>99,197   (63 posts · 1,575 avg)</a:t>
-            </a:r>
-          </a:p>
-        </p:txBody>
-      </p:sp>
-      <p:sp>
-        <p:nvSpPr>
-          <p:cNvPr id="12" name="TextBox 11"/>
-          <p:cNvSpPr txBox="1"/>
-          <p:nvPr/>
-        </p:nvSpPr>
-        <p:spPr>
-          <a:xfrm>
-            <a:off x="731520" y="2834640"/>
-            <a:ext cx="2468880" cy="329184"/>
-          </a:xfrm>
-          <a:prstGeom prst="rect">
-            <a:avLst/>
-          </a:prstGeom>
-          <a:noFill/>
-        </p:spPr>
-        <p:txBody>
-          <a:bodyPr wrap="square" lIns="0" rIns="0" tIns="0" bIns="0">
-            <a:spAutoFit/>
-          </a:bodyPr>
-          <a:lstStyle/>
-          <a:p>
-            <a:r>
-              <a:rPr sz="1100" b="1">
-                <a:solidFill>
-                  <a:srgbClr val="141833"/>
-                </a:solidFill>
-                <a:latin typeface="Helvetica Neue"/>
-              </a:rPr>
-              <a:t>military_service</a:t>
-            </a:r>
-          </a:p>
-        </p:txBody>
-      </p:sp>
-      <p:sp>
-        <p:nvSpPr>
-          <p:cNvPr id="13" name="Rectangle 12"/>
-          <p:cNvSpPr/>
-          <p:nvPr/>
-        </p:nvSpPr>
-        <p:spPr>
-          <a:xfrm>
-            <a:off x="3383280" y="2862072"/>
-            <a:ext cx="2266880" cy="192024"/>
-          </a:xfrm>
-          <a:prstGeom prst="rect">
-            <a:avLst/>
-          </a:prstGeom>
-          <a:solidFill>
-            <a:srgbClr val="6B7082"/>
-          </a:solidFill>
-          <a:ln>
-            <a:noFill/>
-          </a:ln>
-          <a:effectLst/>
-        </p:spPr>
-        <p:style>
-          <a:lnRef idx="1">
-            <a:schemeClr val="accent1"/>
-          </a:lnRef>
-          <a:fillRef idx="3">
-            <a:schemeClr val="accent1"/>
-          </a:fillRef>
-          <a:effectRef idx="2">
-            <a:schemeClr val="accent1"/>
-          </a:effectRef>
-          <a:fontRef idx="minor">
-            <a:schemeClr val="lt1"/>
-          </a:fontRef>
-        </p:style>
-        <p:txBody>
-          <a:bodyPr rtlCol="0" anchor="ctr"/>
-          <a:lstStyle/>
-          <a:p>
-            <a:pPr algn="ctr"/>
-          </a:p>
-        </p:txBody>
-      </p:sp>
-      <p:sp>
-        <p:nvSpPr>
-          <p:cNvPr id="14" name="TextBox 13"/>
-          <p:cNvSpPr txBox="1"/>
-          <p:nvPr/>
-        </p:nvSpPr>
-        <p:spPr>
-          <a:xfrm>
-            <a:off x="5741600" y="2834640"/>
-            <a:ext cx="2286000" cy="329184"/>
-          </a:xfrm>
-          <a:prstGeom prst="rect">
-            <a:avLst/>
-          </a:prstGeom>
-          <a:noFill/>
-        </p:spPr>
-        <p:txBody>
-          <a:bodyPr wrap="square" lIns="0" rIns="0" tIns="0" bIns="0">
-            <a:spAutoFit/>
-          </a:bodyPr>
-          <a:lstStyle/>
-          <a:p>
-            <a:r>
-              <a:rPr sz="1000" b="0">
-                <a:solidFill>
-                  <a:srgbClr val="6B7082"/>
-                </a:solidFill>
-                <a:latin typeface="Helvetica Neue"/>
-              </a:rPr>
-              <a:t>92,638   (34 posts · 2,725 avg)</a:t>
+              <a:t>100,080   (63 posts · 1,589 avg)</a:t>
             </a:r>
           </a:p>
         </p:txBody>
@@ -5859,7 +5859,7 @@
         <p:spPr>
           <a:xfrm>
             <a:off x="3383280" y="3191256"/>
-            <a:ext cx="1272211" cy="192024"/>
+            <a:ext cx="1249758" cy="192024"/>
           </a:xfrm>
           <a:prstGeom prst="rect">
             <a:avLst/>
@@ -5902,7 +5902,7 @@
         </p:nvSpPr>
         <p:spPr>
           <a:xfrm>
-            <a:off x="4746931" y="3163824"/>
+            <a:off x="4724478" y="3163824"/>
             <a:ext cx="2286000" cy="329184"/>
           </a:xfrm>
           <a:prstGeom prst="rect">
@@ -5971,7 +5971,7 @@
         <p:spPr>
           <a:xfrm>
             <a:off x="3383280" y="3520440"/>
-            <a:ext cx="1248573" cy="192024"/>
+            <a:ext cx="1239614" cy="192024"/>
           </a:xfrm>
           <a:prstGeom prst="rect">
             <a:avLst/>
@@ -6014,7 +6014,7 @@
         </p:nvSpPr>
         <p:spPr>
           <a:xfrm>
-            <a:off x="4723293" y="3493008"/>
+            <a:off x="4714334" y="3493008"/>
             <a:ext cx="2286000" cy="329184"/>
           </a:xfrm>
           <a:prstGeom prst="rect">
@@ -6035,7 +6035,7 @@
                 </a:solidFill>
                 <a:latin typeface="Helvetica Neue"/>
               </a:rPr>
-              <a:t>51,024   (20 posts · 2,551 avg)</a:t>
+              <a:t>51,568   (20 posts · 2,578 avg)</a:t>
             </a:r>
           </a:p>
         </p:txBody>
@@ -6069,7 +6069,7 @@
                 </a:solidFill>
                 <a:latin typeface="Helvetica Neue"/>
               </a:rPr>
-              <a:t>Trujillo Scandal</a:t>
+              <a:t>Community Local</a:t>
             </a:r>
           </a:p>
         </p:txBody>
@@ -6083,7 +6083,119 @@
         <p:spPr>
           <a:xfrm>
             <a:off x="3383280" y="3849624"/>
-            <a:ext cx="1007320" cy="192024"/>
+            <a:ext cx="1155335" cy="192024"/>
+          </a:xfrm>
+          <a:prstGeom prst="rect">
+            <a:avLst/>
+          </a:prstGeom>
+          <a:solidFill>
+            <a:srgbClr val="141833"/>
+          </a:solidFill>
+          <a:ln>
+            <a:noFill/>
+          </a:ln>
+          <a:effectLst/>
+        </p:spPr>
+        <p:style>
+          <a:lnRef idx="1">
+            <a:schemeClr val="accent1"/>
+          </a:lnRef>
+          <a:fillRef idx="3">
+            <a:schemeClr val="accent1"/>
+          </a:fillRef>
+          <a:effectRef idx="2">
+            <a:schemeClr val="accent1"/>
+          </a:effectRef>
+          <a:fontRef idx="minor">
+            <a:schemeClr val="lt1"/>
+          </a:fontRef>
+        </p:style>
+        <p:txBody>
+          <a:bodyPr rtlCol="0" anchor="ctr"/>
+          <a:lstStyle/>
+          <a:p>
+            <a:pPr algn="ctr"/>
+          </a:p>
+        </p:txBody>
+      </p:sp>
+      <p:sp>
+        <p:nvSpPr>
+          <p:cNvPr id="23" name="TextBox 22"/>
+          <p:cNvSpPr txBox="1"/>
+          <p:nvPr/>
+        </p:nvSpPr>
+        <p:spPr>
+          <a:xfrm>
+            <a:off x="4630055" y="3822192"/>
+            <a:ext cx="2286000" cy="329184"/>
+          </a:xfrm>
+          <a:prstGeom prst="rect">
+            <a:avLst/>
+          </a:prstGeom>
+          <a:noFill/>
+        </p:spPr>
+        <p:txBody>
+          <a:bodyPr wrap="square" lIns="0" rIns="0" tIns="0" bIns="0">
+            <a:spAutoFit/>
+          </a:bodyPr>
+          <a:lstStyle/>
+          <a:p>
+            <a:r>
+              <a:rPr sz="1000" b="0">
+                <a:solidFill>
+                  <a:srgbClr val="6B7082"/>
+                </a:solidFill>
+                <a:latin typeface="Helvetica Neue"/>
+              </a:rPr>
+              <a:t>48,062   (43 posts · 1,118 avg)</a:t>
+            </a:r>
+          </a:p>
+        </p:txBody>
+      </p:sp>
+      <p:sp>
+        <p:nvSpPr>
+          <p:cNvPr id="24" name="TextBox 23"/>
+          <p:cNvSpPr txBox="1"/>
+          <p:nvPr/>
+        </p:nvSpPr>
+        <p:spPr>
+          <a:xfrm>
+            <a:off x="731520" y="4151376"/>
+            <a:ext cx="2468880" cy="329184"/>
+          </a:xfrm>
+          <a:prstGeom prst="rect">
+            <a:avLst/>
+          </a:prstGeom>
+          <a:noFill/>
+        </p:spPr>
+        <p:txBody>
+          <a:bodyPr wrap="square" lIns="0" rIns="0" tIns="0" bIns="0">
+            <a:spAutoFit/>
+          </a:bodyPr>
+          <a:lstStyle/>
+          <a:p>
+            <a:r>
+              <a:rPr sz="1100" b="0">
+                <a:solidFill>
+                  <a:srgbClr val="141833"/>
+                </a:solidFill>
+                <a:latin typeface="Helvetica Neue"/>
+              </a:rPr>
+              <a:t>Trujillo Scandal</a:t>
+            </a:r>
+          </a:p>
+        </p:txBody>
+      </p:sp>
+      <p:sp>
+        <p:nvSpPr>
+          <p:cNvPr id="25" name="Rectangle 24"/>
+          <p:cNvSpPr/>
+          <p:nvPr/>
+        </p:nvSpPr>
+        <p:spPr>
+          <a:xfrm>
+            <a:off x="3383280" y="4178807"/>
+            <a:ext cx="989590" cy="192024"/>
           </a:xfrm>
           <a:prstGeom prst="rect">
             <a:avLst/>
@@ -6120,13 +6232,13 @@
       </p:sp>
       <p:sp>
         <p:nvSpPr>
-          <p:cNvPr id="23" name="TextBox 22"/>
-          <p:cNvSpPr txBox="1"/>
-          <p:nvPr/>
-        </p:nvSpPr>
-        <p:spPr>
-          <a:xfrm>
-            <a:off x="4482040" y="3822192"/>
+          <p:cNvPr id="26" name="TextBox 25"/>
+          <p:cNvSpPr txBox="1"/>
+          <p:nvPr/>
+        </p:nvSpPr>
+        <p:spPr>
+          <a:xfrm>
+            <a:off x="4464310" y="4151376"/>
             <a:ext cx="2286000" cy="329184"/>
           </a:xfrm>
           <a:prstGeom prst="rect">
@@ -6147,119 +6259,7 @@
                 </a:solidFill>
                 <a:latin typeface="Helvetica Neue"/>
               </a:rPr>
-              <a:t>41,165   (18 posts · 2,287 avg)</a:t>
-            </a:r>
-          </a:p>
-        </p:txBody>
-      </p:sp>
-      <p:sp>
-        <p:nvSpPr>
-          <p:cNvPr id="24" name="TextBox 23"/>
-          <p:cNvSpPr txBox="1"/>
-          <p:nvPr/>
-        </p:nvSpPr>
-        <p:spPr>
-          <a:xfrm>
-            <a:off x="731520" y="4151376"/>
-            <a:ext cx="2468880" cy="329184"/>
-          </a:xfrm>
-          <a:prstGeom prst="rect">
-            <a:avLst/>
-          </a:prstGeom>
-          <a:noFill/>
-        </p:spPr>
-        <p:txBody>
-          <a:bodyPr wrap="square" lIns="0" rIns="0" tIns="0" bIns="0">
-            <a:spAutoFit/>
-          </a:bodyPr>
-          <a:lstStyle/>
-          <a:p>
-            <a:r>
-              <a:rPr sz="1100" b="0">
-                <a:solidFill>
-                  <a:srgbClr val="141833"/>
-                </a:solidFill>
-                <a:latin typeface="Helvetica Neue"/>
-              </a:rPr>
-              <a:t>Community Local</a:t>
-            </a:r>
-          </a:p>
-        </p:txBody>
-      </p:sp>
-      <p:sp>
-        <p:nvSpPr>
-          <p:cNvPr id="25" name="Rectangle 24"/>
-          <p:cNvSpPr/>
-          <p:nvPr/>
-        </p:nvSpPr>
-        <p:spPr>
-          <a:xfrm>
-            <a:off x="3383280" y="4178807"/>
-            <a:ext cx="964546" cy="192024"/>
-          </a:xfrm>
-          <a:prstGeom prst="rect">
-            <a:avLst/>
-          </a:prstGeom>
-          <a:solidFill>
-            <a:srgbClr val="141833"/>
-          </a:solidFill>
-          <a:ln>
-            <a:noFill/>
-          </a:ln>
-          <a:effectLst/>
-        </p:spPr>
-        <p:style>
-          <a:lnRef idx="1">
-            <a:schemeClr val="accent1"/>
-          </a:lnRef>
-          <a:fillRef idx="3">
-            <a:schemeClr val="accent1"/>
-          </a:fillRef>
-          <a:effectRef idx="2">
-            <a:schemeClr val="accent1"/>
-          </a:effectRef>
-          <a:fontRef idx="minor">
-            <a:schemeClr val="lt1"/>
-          </a:fontRef>
-        </p:style>
-        <p:txBody>
-          <a:bodyPr rtlCol="0" anchor="ctr"/>
-          <a:lstStyle/>
-          <a:p>
-            <a:pPr algn="ctr"/>
-          </a:p>
-        </p:txBody>
-      </p:sp>
-      <p:sp>
-        <p:nvSpPr>
-          <p:cNvPr id="26" name="TextBox 25"/>
-          <p:cNvSpPr txBox="1"/>
-          <p:nvPr/>
-        </p:nvSpPr>
-        <p:spPr>
-          <a:xfrm>
-            <a:off x="4439266" y="4151376"/>
-            <a:ext cx="2286000" cy="329184"/>
-          </a:xfrm>
-          <a:prstGeom prst="rect">
-            <a:avLst/>
-          </a:prstGeom>
-          <a:noFill/>
-        </p:spPr>
-        <p:txBody>
-          <a:bodyPr wrap="square" lIns="0" rIns="0" tIns="0" bIns="0">
-            <a:spAutoFit/>
-          </a:bodyPr>
-          <a:lstStyle/>
-          <a:p>
-            <a:r>
-              <a:rPr sz="1000" b="0">
-                <a:solidFill>
-                  <a:srgbClr val="6B7082"/>
-                </a:solidFill>
-                <a:latin typeface="Helvetica Neue"/>
-              </a:rPr>
-              <a:t>39,417   (38 posts · 1,037 avg)</a:t>
+              <a:t>41,167   (18 posts · 2,287 avg)</a:t>
             </a:r>
           </a:p>
         </p:txBody>
@@ -6307,7 +6307,7 @@
         <p:spPr>
           <a:xfrm>
             <a:off x="3383280" y="4507992"/>
-            <a:ext cx="760268" cy="192024"/>
+            <a:ext cx="764037" cy="192024"/>
           </a:xfrm>
           <a:prstGeom prst="rect">
             <a:avLst/>
@@ -6350,7 +6350,7 @@
         </p:nvSpPr>
         <p:spPr>
           <a:xfrm>
-            <a:off x="4234988" y="4480560"/>
+            <a:off x="4238757" y="4480560"/>
             <a:ext cx="2286000" cy="329184"/>
           </a:xfrm>
           <a:prstGeom prst="rect">
@@ -6371,7 +6371,7 @@
                 </a:solidFill>
                 <a:latin typeface="Helvetica Neue"/>
               </a:rPr>
-              <a:t>31,069   (23 posts · 1,351 avg)</a:t>
+              <a:t>31,784   (25 posts · 1,271 avg)</a:t>
             </a:r>
           </a:p>
         </p:txBody>
@@ -6419,7 +6419,7 @@
         <p:spPr>
           <a:xfrm>
             <a:off x="3383280" y="4837176"/>
-            <a:ext cx="708831" cy="192024"/>
+            <a:ext cx="714975" cy="192024"/>
           </a:xfrm>
           <a:prstGeom prst="rect">
             <a:avLst/>
@@ -6462,7 +6462,7 @@
         </p:nvSpPr>
         <p:spPr>
           <a:xfrm>
-            <a:off x="4183551" y="4809744"/>
+            <a:off x="4189695" y="4809744"/>
             <a:ext cx="2286000" cy="329184"/>
           </a:xfrm>
           <a:prstGeom prst="rect">
@@ -6483,7 +6483,7 @@
                 </a:solidFill>
                 <a:latin typeface="Helvetica Neue"/>
               </a:rPr>
-              <a:t>28,967   (32 posts · 905 avg)</a:t>
+              <a:t>29,743   (32 posts · 929 avg)</a:t>
             </a:r>
           </a:p>
         </p:txBody>
@@ -6531,7 +6531,7 @@
         <p:spPr>
           <a:xfrm>
             <a:off x="3383280" y="5166359"/>
-            <a:ext cx="702053" cy="192024"/>
+            <a:ext cx="689662" cy="192024"/>
           </a:xfrm>
           <a:prstGeom prst="rect">
             <a:avLst/>
@@ -6574,7 +6574,7 @@
         </p:nvSpPr>
         <p:spPr>
           <a:xfrm>
-            <a:off x="4176773" y="5138928"/>
+            <a:off x="4164382" y="5138928"/>
             <a:ext cx="2286000" cy="329184"/>
           </a:xfrm>
           <a:prstGeom prst="rect">
@@ -6643,7 +6643,7 @@
         <p:spPr>
           <a:xfrm>
             <a:off x="3383280" y="5495543"/>
-            <a:ext cx="538787" cy="192024"/>
+            <a:ext cx="606658" cy="192024"/>
           </a:xfrm>
           <a:prstGeom prst="rect">
             <a:avLst/>
@@ -6686,7 +6686,7 @@
         </p:nvSpPr>
         <p:spPr>
           <a:xfrm>
-            <a:off x="4013507" y="5468112"/>
+            <a:off x="4081378" y="5468112"/>
             <a:ext cx="2286000" cy="329184"/>
           </a:xfrm>
           <a:prstGeom prst="rect">
@@ -6707,7 +6707,7 @@
                 </a:solidFill>
                 <a:latin typeface="Helvetica Neue"/>
               </a:rPr>
-              <a:t>22,018   (26 posts · 847 avg)</a:t>
+              <a:t>25,237   (30 posts · 841 avg)</a:t>
             </a:r>
           </a:p>
         </p:txBody>
@@ -6755,7 +6755,7 @@
         <p:spPr>
           <a:xfrm>
             <a:off x="3383280" y="5824728"/>
-            <a:ext cx="504626" cy="192024"/>
+            <a:ext cx="497090" cy="192024"/>
           </a:xfrm>
           <a:prstGeom prst="rect">
             <a:avLst/>
@@ -6798,7 +6798,7 @@
         </p:nvSpPr>
         <p:spPr>
           <a:xfrm>
-            <a:off x="3979346" y="5797296"/>
+            <a:off x="3971810" y="5797296"/>
             <a:ext cx="2286000" cy="329184"/>
           </a:xfrm>
           <a:prstGeom prst="rect">
@@ -6819,7 +6819,7 @@
                 </a:solidFill>
                 <a:latin typeface="Helvetica Neue"/>
               </a:rPr>
-              <a:t>20,622   (49 posts · 421 avg)</a:t>
+              <a:t>20,679   (49 posts · 422 avg)</a:t>
             </a:r>
           </a:p>
         </p:txBody>
@@ -8685,7 +8685,7 @@
                 </a:solidFill>
                 <a:latin typeface="Helvetica Neue"/>
               </a:rPr>
-              <a:t>21,500</a:t>
+              <a:t>22,300</a:t>
             </a:r>
           </a:p>
         </p:txBody>
@@ -8719,7 +8719,7 @@
                 </a:solidFill>
                 <a:latin typeface="Helvetica Neue"/>
               </a:rPr>
-              <a:t>765</a:t>
+              <a:t>793</a:t>
             </a:r>
           </a:p>
         </p:txBody>

</xml_diff>

<commit_message>
Scheduled snapshot t43 (2026-10-16): fresh IG/FB/YT/TT + rebuilt decks
Co-Authored-By: Claude Opus 4.7 (1M context) <noreply@anthropic.com>
</commit_message>
<xml_diff>
--- a/OVERALL_REPORT.pptx
+++ b/OVERALL_REPORT.pptx
@@ -3277,7 +3277,7 @@
                 </a:solidFill>
                 <a:latin typeface="Georgia"/>
               </a:rPr>
-              <a:t>Since Jun 8, 2026 · 2026-10-14</a:t>
+              <a:t>Since Jun 8, 2026 · 2026-10-16</a:t>
             </a:r>
           </a:p>
         </p:txBody>
@@ -3578,7 +3578,7 @@
                 </a:solidFill>
                 <a:latin typeface="Georgia"/>
               </a:rPr>
-              <a:t>890,238</a:t>
+              <a:t>905,792</a:t>
             </a:r>
           </a:p>
         </p:txBody>
@@ -3769,7 +3769,7 @@
                 </a:solidFill>
                 <a:latin typeface="Georgia"/>
               </a:rPr>
-              <a:t>626</a:t>
+              <a:t>641</a:t>
             </a:r>
           </a:p>
         </p:txBody>
@@ -3925,7 +3925,7 @@
                 </a:solidFill>
                 <a:latin typeface="Georgia"/>
               </a:rPr>
-              <a:t>26,819</a:t>
+              <a:t>27,136</a:t>
             </a:r>
           </a:p>
         </p:txBody>
@@ -4081,7 +4081,7 @@
                 </a:solidFill>
                 <a:latin typeface="Georgia"/>
               </a:rPr>
-              <a:t>1,422</a:t>
+              <a:t>1,413</a:t>
             </a:r>
           </a:p>
         </p:txBody>
@@ -4401,7 +4401,7 @@
                 </a:solidFill>
                 <a:latin typeface="Georgia"/>
               </a:rPr>
-              <a:t>387,491</a:t>
+              <a:t>391,604</a:t>
             </a:r>
           </a:p>
         </p:txBody>
@@ -4469,7 +4469,7 @@
                 </a:solidFill>
                 <a:latin typeface="Helvetica Neue"/>
               </a:rPr>
-              <a:t>205 posts</a:t>
+              <a:t>210 posts</a:t>
             </a:r>
           </a:p>
         </p:txBody>
@@ -4503,7 +4503,7 @@
                 </a:solidFill>
                 <a:latin typeface="Helvetica Neue"/>
               </a:rPr>
-              <a:t>1,890 avg views/post</a:t>
+              <a:t>1,865 avg views/post</a:t>
             </a:r>
           </a:p>
         </p:txBody>
@@ -4659,7 +4659,7 @@
                 </a:solidFill>
                 <a:latin typeface="Georgia"/>
               </a:rPr>
-              <a:t>290,583</a:t>
+              <a:t>293,175</a:t>
             </a:r>
           </a:p>
         </p:txBody>
@@ -4727,7 +4727,7 @@
                 </a:solidFill>
                 <a:latin typeface="Helvetica Neue"/>
               </a:rPr>
-              <a:t>180 posts</a:t>
+              <a:t>184 posts</a:t>
             </a:r>
           </a:p>
         </p:txBody>
@@ -4761,7 +4761,7 @@
                 </a:solidFill>
                 <a:latin typeface="Helvetica Neue"/>
               </a:rPr>
-              <a:t>1,614 avg views/post</a:t>
+              <a:t>1,593 avg views/post</a:t>
             </a:r>
           </a:p>
         </p:txBody>
@@ -4917,7 +4917,7 @@
                 </a:solidFill>
                 <a:latin typeface="Georgia"/>
               </a:rPr>
-              <a:t>209,391</a:t>
+              <a:t>218,146</a:t>
             </a:r>
           </a:p>
         </p:txBody>
@@ -4985,7 +4985,7 @@
                 </a:solidFill>
                 <a:latin typeface="Helvetica Neue"/>
               </a:rPr>
-              <a:t>222 posts</a:t>
+              <a:t>227 posts</a:t>
             </a:r>
           </a:p>
         </p:txBody>
@@ -5019,7 +5019,7 @@
                 </a:solidFill>
                 <a:latin typeface="Helvetica Neue"/>
               </a:rPr>
-              <a:t>943 avg views/post</a:t>
+              <a:t>961 avg views/post</a:t>
             </a:r>
           </a:p>
         </p:txBody>
@@ -5175,7 +5175,7 @@
                 </a:solidFill>
                 <a:latin typeface="Georgia"/>
               </a:rPr>
-              <a:t>2,773</a:t>
+              <a:t>2,867</a:t>
             </a:r>
           </a:p>
         </p:txBody>
@@ -5243,7 +5243,7 @@
                 </a:solidFill>
                 <a:latin typeface="Helvetica Neue"/>
               </a:rPr>
-              <a:t>19 posts</a:t>
+              <a:t>20 posts</a:t>
             </a:r>
           </a:p>
         </p:txBody>
@@ -5277,7 +5277,7 @@
                 </a:solidFill>
                 <a:latin typeface="Helvetica Neue"/>
               </a:rPr>
-              <a:t>146 avg views/post</a:t>
+              <a:t>143 avg views/post</a:t>
             </a:r>
           </a:p>
         </p:txBody>
@@ -5587,7 +5587,7 @@
                 </a:solidFill>
                 <a:latin typeface="Helvetica Neue"/>
               </a:rPr>
-              <a:t>285,293   (196 posts · 1,456 avg)</a:t>
+              <a:t>289,251   (203 posts · 1,425 avg)</a:t>
             </a:r>
           </a:p>
         </p:txBody>
@@ -5635,7 +5635,7 @@
         <p:spPr>
           <a:xfrm>
             <a:off x="3383280" y="2532888"/>
-            <a:ext cx="2431296" cy="192024"/>
+            <a:ext cx="2435772" cy="192024"/>
           </a:xfrm>
           <a:prstGeom prst="rect">
             <a:avLst/>
@@ -5678,7 +5678,7 @@
         </p:nvSpPr>
         <p:spPr>
           <a:xfrm>
-            <a:off x="5906016" y="2505456"/>
+            <a:off x="5910492" y="2505456"/>
             <a:ext cx="2286000" cy="329184"/>
           </a:xfrm>
           <a:prstGeom prst="rect">
@@ -5699,7 +5699,7 @@
                 </a:solidFill>
                 <a:latin typeface="Helvetica Neue"/>
               </a:rPr>
-              <a:t>101,142   (43 posts · 2,352 avg)</a:t>
+              <a:t>102,734   (43 posts · 2,389 avg)</a:t>
             </a:r>
           </a:p>
         </p:txBody>
@@ -5747,7 +5747,7 @@
         <p:spPr>
           <a:xfrm>
             <a:off x="3383280" y="2862072"/>
-            <a:ext cx="2405767" cy="192024"/>
+            <a:ext cx="2379486" cy="192024"/>
           </a:xfrm>
           <a:prstGeom prst="rect">
             <a:avLst/>
@@ -5790,7 +5790,7 @@
         </p:nvSpPr>
         <p:spPr>
           <a:xfrm>
-            <a:off x="5880487" y="2834640"/>
+            <a:off x="5854206" y="2834640"/>
             <a:ext cx="2286000" cy="329184"/>
           </a:xfrm>
           <a:prstGeom prst="rect">
@@ -5811,7 +5811,7 @@
                 </a:solidFill>
                 <a:latin typeface="Helvetica Neue"/>
               </a:rPr>
-              <a:t>100,080   (63 posts · 1,589 avg)</a:t>
+              <a:t>100,360   (63 posts · 1,593 avg)</a:t>
             </a:r>
           </a:p>
         </p:txBody>
@@ -5845,7 +5845,7 @@
                 </a:solidFill>
                 <a:latin typeface="Helvetica Neue"/>
               </a:rPr>
-              <a:t>FIFA — Positive</a:t>
+              <a:t>Community Local</a:t>
             </a:r>
           </a:p>
         </p:txBody>
@@ -5859,7 +5859,119 @@
         <p:spPr>
           <a:xfrm>
             <a:off x="3383280" y="3191256"/>
-            <a:ext cx="1249758" cy="192024"/>
+            <a:ext cx="1260350" cy="192024"/>
+          </a:xfrm>
+          <a:prstGeom prst="rect">
+            <a:avLst/>
+          </a:prstGeom>
+          <a:solidFill>
+            <a:srgbClr val="141833"/>
+          </a:solidFill>
+          <a:ln>
+            <a:noFill/>
+          </a:ln>
+          <a:effectLst/>
+        </p:spPr>
+        <p:style>
+          <a:lnRef idx="1">
+            <a:schemeClr val="accent1"/>
+          </a:lnRef>
+          <a:fillRef idx="3">
+            <a:schemeClr val="accent1"/>
+          </a:fillRef>
+          <a:effectRef idx="2">
+            <a:schemeClr val="accent1"/>
+          </a:effectRef>
+          <a:fontRef idx="minor">
+            <a:schemeClr val="lt1"/>
+          </a:fontRef>
+        </p:style>
+        <p:txBody>
+          <a:bodyPr rtlCol="0" anchor="ctr"/>
+          <a:lstStyle/>
+          <a:p>
+            <a:pPr algn="ctr"/>
+          </a:p>
+        </p:txBody>
+      </p:sp>
+      <p:sp>
+        <p:nvSpPr>
+          <p:cNvPr id="17" name="TextBox 16"/>
+          <p:cNvSpPr txBox="1"/>
+          <p:nvPr/>
+        </p:nvSpPr>
+        <p:spPr>
+          <a:xfrm>
+            <a:off x="4735070" y="3163824"/>
+            <a:ext cx="2286000" cy="329184"/>
+          </a:xfrm>
+          <a:prstGeom prst="rect">
+            <a:avLst/>
+          </a:prstGeom>
+          <a:noFill/>
+        </p:spPr>
+        <p:txBody>
+          <a:bodyPr wrap="square" lIns="0" rIns="0" tIns="0" bIns="0">
+            <a:spAutoFit/>
+          </a:bodyPr>
+          <a:lstStyle/>
+          <a:p>
+            <a:r>
+              <a:rPr sz="1000" b="0">
+                <a:solidFill>
+                  <a:srgbClr val="6B7082"/>
+                </a:solidFill>
+                <a:latin typeface="Helvetica Neue"/>
+              </a:rPr>
+              <a:t>53,158   (44 posts · 1,208 avg)</a:t>
+            </a:r>
+          </a:p>
+        </p:txBody>
+      </p:sp>
+      <p:sp>
+        <p:nvSpPr>
+          <p:cNvPr id="18" name="TextBox 17"/>
+          <p:cNvSpPr txBox="1"/>
+          <p:nvPr/>
+        </p:nvSpPr>
+        <p:spPr>
+          <a:xfrm>
+            <a:off x="731520" y="3493008"/>
+            <a:ext cx="2468880" cy="329184"/>
+          </a:xfrm>
+          <a:prstGeom prst="rect">
+            <a:avLst/>
+          </a:prstGeom>
+          <a:noFill/>
+        </p:spPr>
+        <p:txBody>
+          <a:bodyPr wrap="square" lIns="0" rIns="0" tIns="0" bIns="0">
+            <a:spAutoFit/>
+          </a:bodyPr>
+          <a:lstStyle/>
+          <a:p>
+            <a:r>
+              <a:rPr sz="1100" b="0">
+                <a:solidFill>
+                  <a:srgbClr val="141833"/>
+                </a:solidFill>
+                <a:latin typeface="Helvetica Neue"/>
+              </a:rPr>
+              <a:t>FIFA — Positive</a:t>
+            </a:r>
+          </a:p>
+        </p:txBody>
+      </p:sp>
+      <p:sp>
+        <p:nvSpPr>
+          <p:cNvPr id="19" name="Rectangle 18"/>
+          <p:cNvSpPr/>
+          <p:nvPr/>
+        </p:nvSpPr>
+        <p:spPr>
+          <a:xfrm>
+            <a:off x="3383280" y="3520440"/>
+            <a:ext cx="1232657" cy="192024"/>
           </a:xfrm>
           <a:prstGeom prst="rect">
             <a:avLst/>
@@ -5896,13 +6008,13 @@
       </p:sp>
       <p:sp>
         <p:nvSpPr>
-          <p:cNvPr id="17" name="TextBox 16"/>
-          <p:cNvSpPr txBox="1"/>
-          <p:nvPr/>
-        </p:nvSpPr>
-        <p:spPr>
-          <a:xfrm>
-            <a:off x="4724478" y="3163824"/>
+          <p:cNvPr id="20" name="TextBox 19"/>
+          <p:cNvSpPr txBox="1"/>
+          <p:nvPr/>
+        </p:nvSpPr>
+        <p:spPr>
+          <a:xfrm>
+            <a:off x="4707377" y="3493008"/>
             <a:ext cx="2286000" cy="329184"/>
           </a:xfrm>
           <a:prstGeom prst="rect">
@@ -5930,13 +6042,13 @@
       </p:sp>
       <p:sp>
         <p:nvSpPr>
-          <p:cNvPr id="18" name="TextBox 17"/>
-          <p:cNvSpPr txBox="1"/>
-          <p:nvPr/>
-        </p:nvSpPr>
-        <p:spPr>
-          <a:xfrm>
-            <a:off x="731520" y="3493008"/>
+          <p:cNvPr id="21" name="TextBox 20"/>
+          <p:cNvSpPr txBox="1"/>
+          <p:nvPr/>
+        </p:nvSpPr>
+        <p:spPr>
+          <a:xfrm>
+            <a:off x="731520" y="3822192"/>
             <a:ext cx="2468880" cy="329184"/>
           </a:xfrm>
           <a:prstGeom prst="rect">
@@ -5964,14 +6076,14 @@
       </p:sp>
       <p:sp>
         <p:nvSpPr>
-          <p:cNvPr id="19" name="Rectangle 18"/>
+          <p:cNvPr id="22" name="Rectangle 21"/>
           <p:cNvSpPr/>
           <p:nvPr/>
         </p:nvSpPr>
         <p:spPr>
           <a:xfrm>
-            <a:off x="3383280" y="3520440"/>
-            <a:ext cx="1239614" cy="192024"/>
+            <a:off x="3383280" y="3849624"/>
+            <a:ext cx="1223956" cy="192024"/>
           </a:xfrm>
           <a:prstGeom prst="rect">
             <a:avLst/>
@@ -6008,13 +6120,13 @@
       </p:sp>
       <p:sp>
         <p:nvSpPr>
-          <p:cNvPr id="20" name="TextBox 19"/>
-          <p:cNvSpPr txBox="1"/>
-          <p:nvPr/>
-        </p:nvSpPr>
-        <p:spPr>
-          <a:xfrm>
-            <a:off x="4714334" y="3493008"/>
+          <p:cNvPr id="23" name="TextBox 22"/>
+          <p:cNvSpPr txBox="1"/>
+          <p:nvPr/>
+        </p:nvSpPr>
+        <p:spPr>
+          <a:xfrm>
+            <a:off x="4698676" y="3822192"/>
             <a:ext cx="2286000" cy="329184"/>
           </a:xfrm>
           <a:prstGeom prst="rect">
@@ -6035,119 +6147,7 @@
                 </a:solidFill>
                 <a:latin typeface="Helvetica Neue"/>
               </a:rPr>
-              <a:t>51,568   (20 posts · 2,578 avg)</a:t>
-            </a:r>
-          </a:p>
-        </p:txBody>
-      </p:sp>
-      <p:sp>
-        <p:nvSpPr>
-          <p:cNvPr id="21" name="TextBox 20"/>
-          <p:cNvSpPr txBox="1"/>
-          <p:nvPr/>
-        </p:nvSpPr>
-        <p:spPr>
-          <a:xfrm>
-            <a:off x="731520" y="3822192"/>
-            <a:ext cx="2468880" cy="329184"/>
-          </a:xfrm>
-          <a:prstGeom prst="rect">
-            <a:avLst/>
-          </a:prstGeom>
-          <a:noFill/>
-        </p:spPr>
-        <p:txBody>
-          <a:bodyPr wrap="square" lIns="0" rIns="0" tIns="0" bIns="0">
-            <a:spAutoFit/>
-          </a:bodyPr>
-          <a:lstStyle/>
-          <a:p>
-            <a:r>
-              <a:rPr sz="1100" b="0">
-                <a:solidFill>
-                  <a:srgbClr val="141833"/>
-                </a:solidFill>
-                <a:latin typeface="Helvetica Neue"/>
-              </a:rPr>
-              <a:t>Community Local</a:t>
-            </a:r>
-          </a:p>
-        </p:txBody>
-      </p:sp>
-      <p:sp>
-        <p:nvSpPr>
-          <p:cNvPr id="22" name="Rectangle 21"/>
-          <p:cNvSpPr/>
-          <p:nvPr/>
-        </p:nvSpPr>
-        <p:spPr>
-          <a:xfrm>
-            <a:off x="3383280" y="3849624"/>
-            <a:ext cx="1155335" cy="192024"/>
-          </a:xfrm>
-          <a:prstGeom prst="rect">
-            <a:avLst/>
-          </a:prstGeom>
-          <a:solidFill>
-            <a:srgbClr val="141833"/>
-          </a:solidFill>
-          <a:ln>
-            <a:noFill/>
-          </a:ln>
-          <a:effectLst/>
-        </p:spPr>
-        <p:style>
-          <a:lnRef idx="1">
-            <a:schemeClr val="accent1"/>
-          </a:lnRef>
-          <a:fillRef idx="3">
-            <a:schemeClr val="accent1"/>
-          </a:fillRef>
-          <a:effectRef idx="2">
-            <a:schemeClr val="accent1"/>
-          </a:effectRef>
-          <a:fontRef idx="minor">
-            <a:schemeClr val="lt1"/>
-          </a:fontRef>
-        </p:style>
-        <p:txBody>
-          <a:bodyPr rtlCol="0" anchor="ctr"/>
-          <a:lstStyle/>
-          <a:p>
-            <a:pPr algn="ctr"/>
-          </a:p>
-        </p:txBody>
-      </p:sp>
-      <p:sp>
-        <p:nvSpPr>
-          <p:cNvPr id="23" name="TextBox 22"/>
-          <p:cNvSpPr txBox="1"/>
-          <p:nvPr/>
-        </p:nvSpPr>
-        <p:spPr>
-          <a:xfrm>
-            <a:off x="4630055" y="3822192"/>
-            <a:ext cx="2286000" cy="329184"/>
-          </a:xfrm>
-          <a:prstGeom prst="rect">
-            <a:avLst/>
-          </a:prstGeom>
-          <a:noFill/>
-        </p:spPr>
-        <p:txBody>
-          <a:bodyPr wrap="square" lIns="0" rIns="0" tIns="0" bIns="0">
-            <a:spAutoFit/>
-          </a:bodyPr>
-          <a:lstStyle/>
-          <a:p>
-            <a:r>
-              <a:rPr sz="1000" b="0">
-                <a:solidFill>
-                  <a:srgbClr val="6B7082"/>
-                </a:solidFill>
-                <a:latin typeface="Helvetica Neue"/>
-              </a:rPr>
-              <a:t>48,062   (43 posts · 1,118 avg)</a:t>
+              <a:t>51,623   (20 posts · 2,581 avg)</a:t>
             </a:r>
           </a:p>
         </p:txBody>
@@ -6195,7 +6195,7 @@
         <p:spPr>
           <a:xfrm>
             <a:off x="3383280" y="4178807"/>
-            <a:ext cx="989590" cy="192024"/>
+            <a:ext cx="976073" cy="192024"/>
           </a:xfrm>
           <a:prstGeom prst="rect">
             <a:avLst/>
@@ -6238,7 +6238,7 @@
         </p:nvSpPr>
         <p:spPr>
           <a:xfrm>
-            <a:off x="4464310" y="4151376"/>
+            <a:off x="4450793" y="4151376"/>
             <a:ext cx="2286000" cy="329184"/>
           </a:xfrm>
           <a:prstGeom prst="rect">
@@ -6259,7 +6259,7 @@
                 </a:solidFill>
                 <a:latin typeface="Helvetica Neue"/>
               </a:rPr>
-              <a:t>41,167   (18 posts · 2,287 avg)</a:t>
+              <a:t>41,168   (18 posts · 2,287 avg)</a:t>
             </a:r>
           </a:p>
         </p:txBody>
@@ -6307,7 +6307,7 @@
         <p:spPr>
           <a:xfrm>
             <a:off x="3383280" y="4507992"/>
-            <a:ext cx="764037" cy="192024"/>
+            <a:ext cx="805222" cy="192024"/>
           </a:xfrm>
           <a:prstGeom prst="rect">
             <a:avLst/>
@@ -6350,7 +6350,7 @@
         </p:nvSpPr>
         <p:spPr>
           <a:xfrm>
-            <a:off x="4238757" y="4480560"/>
+            <a:off x="4279942" y="4480560"/>
             <a:ext cx="2286000" cy="329184"/>
           </a:xfrm>
           <a:prstGeom prst="rect">
@@ -6371,7 +6371,7 @@
                 </a:solidFill>
                 <a:latin typeface="Helvetica Neue"/>
               </a:rPr>
-              <a:t>31,784   (25 posts · 1,271 avg)</a:t>
+              <a:t>33,962   (29 posts · 1,171 avg)</a:t>
             </a:r>
           </a:p>
         </p:txBody>
@@ -6419,7 +6419,7 @@
         <p:spPr>
           <a:xfrm>
             <a:off x="3383280" y="4837176"/>
-            <a:ext cx="714975" cy="192024"/>
+            <a:ext cx="737033" cy="192024"/>
           </a:xfrm>
           <a:prstGeom prst="rect">
             <a:avLst/>
@@ -6462,7 +6462,7 @@
         </p:nvSpPr>
         <p:spPr>
           <a:xfrm>
-            <a:off x="4189695" y="4809744"/>
+            <a:off x="4211753" y="4809744"/>
             <a:ext cx="2286000" cy="329184"/>
           </a:xfrm>
           <a:prstGeom prst="rect">
@@ -6483,7 +6483,7 @@
                 </a:solidFill>
                 <a:latin typeface="Helvetica Neue"/>
               </a:rPr>
-              <a:t>29,743   (32 posts · 929 avg)</a:t>
+              <a:t>31,086   (34 posts · 914 avg)</a:t>
             </a:r>
           </a:p>
         </p:txBody>
@@ -6531,7 +6531,7 @@
         <p:spPr>
           <a:xfrm>
             <a:off x="3383280" y="5166359"/>
-            <a:ext cx="689662" cy="192024"/>
+            <a:ext cx="680225" cy="192024"/>
           </a:xfrm>
           <a:prstGeom prst="rect">
             <a:avLst/>
@@ -6574,7 +6574,7 @@
         </p:nvSpPr>
         <p:spPr>
           <a:xfrm>
-            <a:off x="4164382" y="5138928"/>
+            <a:off x="4154945" y="5138928"/>
             <a:ext cx="2286000" cy="329184"/>
           </a:xfrm>
           <a:prstGeom prst="rect">
@@ -6643,7 +6643,7 @@
         <p:spPr>
           <a:xfrm>
             <a:off x="3383280" y="5495543"/>
-            <a:ext cx="606658" cy="192024"/>
+            <a:ext cx="616328" cy="192024"/>
           </a:xfrm>
           <a:prstGeom prst="rect">
             <a:avLst/>
@@ -6686,7 +6686,7 @@
         </p:nvSpPr>
         <p:spPr>
           <a:xfrm>
-            <a:off x="4081378" y="5468112"/>
+            <a:off x="4091048" y="5468112"/>
             <a:ext cx="2286000" cy="329184"/>
           </a:xfrm>
           <a:prstGeom prst="rect">
@@ -6707,7 +6707,7 @@
                 </a:solidFill>
                 <a:latin typeface="Helvetica Neue"/>
               </a:rPr>
-              <a:t>25,237   (30 posts · 841 avg)</a:t>
+              <a:t>25,995   (31 posts · 839 avg)</a:t>
             </a:r>
           </a:p>
         </p:txBody>
@@ -6755,7 +6755,7 @@
         <p:spPr>
           <a:xfrm>
             <a:off x="3383280" y="5824728"/>
-            <a:ext cx="497090" cy="192024"/>
+            <a:ext cx="490644" cy="192024"/>
           </a:xfrm>
           <a:prstGeom prst="rect">
             <a:avLst/>
@@ -6798,7 +6798,7 @@
         </p:nvSpPr>
         <p:spPr>
           <a:xfrm>
-            <a:off x="3971810" y="5797296"/>
+            <a:off x="3965364" y="5797296"/>
             <a:ext cx="2286000" cy="329184"/>
           </a:xfrm>
           <a:prstGeom prst="rect">
@@ -6819,7 +6819,7 @@
                 </a:solidFill>
                 <a:latin typeface="Helvetica Neue"/>
               </a:rPr>
-              <a:t>20,679   (49 posts · 422 avg)</a:t>
+              <a:t>20,694   (49 posts · 422 avg)</a:t>
             </a:r>
           </a:p>
         </p:txBody>
@@ -8685,7 +8685,7 @@
                 </a:solidFill>
                 <a:latin typeface="Helvetica Neue"/>
               </a:rPr>
-              <a:t>22,300</a:t>
+              <a:t>22,600</a:t>
             </a:r>
           </a:p>
         </p:txBody>
@@ -8719,7 +8719,7 @@
                 </a:solidFill>
                 <a:latin typeface="Helvetica Neue"/>
               </a:rPr>
-              <a:t>793</a:t>
+              <a:t>805</a:t>
             </a:r>
           </a:p>
         </p:txBody>

</xml_diff>

<commit_message>
Scheduled snapshot t44 (2026-10-23): fresh IG/FB/YT/TT + rebuilt decks
Co-Authored-By: Claude Opus 4.7 (1M context) <noreply@anthropic.com>
</commit_message>
<xml_diff>
--- a/OVERALL_REPORT.pptx
+++ b/OVERALL_REPORT.pptx
@@ -3277,7 +3277,7 @@
                 </a:solidFill>
                 <a:latin typeface="Georgia"/>
               </a:rPr>
-              <a:t>Since Jun 8, 2026 · 2026-10-16</a:t>
+              <a:t>Since Jun 8, 2026 · 2026-10-23</a:t>
             </a:r>
           </a:p>
         </p:txBody>
@@ -3578,7 +3578,7 @@
                 </a:solidFill>
                 <a:latin typeface="Georgia"/>
               </a:rPr>
-              <a:t>905,792</a:t>
+              <a:t>930,426</a:t>
             </a:r>
           </a:p>
         </p:txBody>
@@ -3769,7 +3769,7 @@
                 </a:solidFill>
                 <a:latin typeface="Georgia"/>
               </a:rPr>
-              <a:t>641</a:t>
+              <a:t>677</a:t>
             </a:r>
           </a:p>
         </p:txBody>
@@ -3925,7 +3925,7 @@
                 </a:solidFill>
                 <a:latin typeface="Georgia"/>
               </a:rPr>
-              <a:t>27,136</a:t>
+              <a:t>27,607</a:t>
             </a:r>
           </a:p>
         </p:txBody>
@@ -4081,7 +4081,7 @@
                 </a:solidFill>
                 <a:latin typeface="Georgia"/>
               </a:rPr>
-              <a:t>1,413</a:t>
+              <a:t>1,374</a:t>
             </a:r>
           </a:p>
         </p:txBody>
@@ -4401,7 +4401,7 @@
                 </a:solidFill>
                 <a:latin typeface="Georgia"/>
               </a:rPr>
-              <a:t>391,604</a:t>
+              <a:t>400,377</a:t>
             </a:r>
           </a:p>
         </p:txBody>
@@ -4469,7 +4469,7 @@
                 </a:solidFill>
                 <a:latin typeface="Helvetica Neue"/>
               </a:rPr>
-              <a:t>210 posts</a:t>
+              <a:t>222 posts</a:t>
             </a:r>
           </a:p>
         </p:txBody>
@@ -4503,7 +4503,7 @@
                 </a:solidFill>
                 <a:latin typeface="Helvetica Neue"/>
               </a:rPr>
-              <a:t>1,865 avg views/post</a:t>
+              <a:t>1,804 avg views/post</a:t>
             </a:r>
           </a:p>
         </p:txBody>
@@ -4659,7 +4659,7 @@
                 </a:solidFill>
                 <a:latin typeface="Georgia"/>
               </a:rPr>
-              <a:t>293,175</a:t>
+              <a:t>298,203</a:t>
             </a:r>
           </a:p>
         </p:txBody>
@@ -4727,7 +4727,7 @@
                 </a:solidFill>
                 <a:latin typeface="Helvetica Neue"/>
               </a:rPr>
-              <a:t>184 posts</a:t>
+              <a:t>194 posts</a:t>
             </a:r>
           </a:p>
         </p:txBody>
@@ -4761,7 +4761,7 @@
                 </a:solidFill>
                 <a:latin typeface="Helvetica Neue"/>
               </a:rPr>
-              <a:t>1,593 avg views/post</a:t>
+              <a:t>1,537 avg views/post</a:t>
             </a:r>
           </a:p>
         </p:txBody>
@@ -4917,7 +4917,7 @@
                 </a:solidFill>
                 <a:latin typeface="Georgia"/>
               </a:rPr>
-              <a:t>218,146</a:t>
+              <a:t>228,526</a:t>
             </a:r>
           </a:p>
         </p:txBody>
@@ -4985,7 +4985,7 @@
                 </a:solidFill>
                 <a:latin typeface="Helvetica Neue"/>
               </a:rPr>
-              <a:t>227 posts</a:t>
+              <a:t>240 posts</a:t>
             </a:r>
           </a:p>
         </p:txBody>
@@ -5019,7 +5019,7 @@
                 </a:solidFill>
                 <a:latin typeface="Helvetica Neue"/>
               </a:rPr>
-              <a:t>961 avg views/post</a:t>
+              <a:t>952 avg views/post</a:t>
             </a:r>
           </a:p>
         </p:txBody>
@@ -5175,7 +5175,7 @@
                 </a:solidFill>
                 <a:latin typeface="Georgia"/>
               </a:rPr>
-              <a:t>2,867</a:t>
+              <a:t>3,320</a:t>
             </a:r>
           </a:p>
         </p:txBody>
@@ -5243,7 +5243,7 @@
                 </a:solidFill>
                 <a:latin typeface="Helvetica Neue"/>
               </a:rPr>
-              <a:t>20 posts</a:t>
+              <a:t>21 posts</a:t>
             </a:r>
           </a:p>
         </p:txBody>
@@ -5277,7 +5277,7 @@
                 </a:solidFill>
                 <a:latin typeface="Helvetica Neue"/>
               </a:rPr>
-              <a:t>143 avg views/post</a:t>
+              <a:t>158 avg views/post</a:t>
             </a:r>
           </a:p>
         </p:txBody>
@@ -5587,7 +5587,7 @@
                 </a:solidFill>
                 <a:latin typeface="Helvetica Neue"/>
               </a:rPr>
-              <a:t>289,251   (203 posts · 1,425 avg)</a:t>
+              <a:t>297,367   (214 posts · 1,390 avg)</a:t>
             </a:r>
           </a:p>
         </p:txBody>
@@ -5635,7 +5635,7 @@
         <p:spPr>
           <a:xfrm>
             <a:off x="3383280" y="2532888"/>
-            <a:ext cx="2435772" cy="192024"/>
+            <a:ext cx="2419477" cy="192024"/>
           </a:xfrm>
           <a:prstGeom prst="rect">
             <a:avLst/>
@@ -5678,7 +5678,7 @@
         </p:nvSpPr>
         <p:spPr>
           <a:xfrm>
-            <a:off x="5910492" y="2505456"/>
+            <a:off x="5894197" y="2505456"/>
             <a:ext cx="2286000" cy="329184"/>
           </a:xfrm>
           <a:prstGeom prst="rect">
@@ -5699,7 +5699,7 @@
                 </a:solidFill>
                 <a:latin typeface="Helvetica Neue"/>
               </a:rPr>
-              <a:t>102,734   (43 posts · 2,389 avg)</a:t>
+              <a:t>104,910   (48 posts · 2,186 avg)</a:t>
             </a:r>
           </a:p>
         </p:txBody>
@@ -5747,7 +5747,7 @@
         <p:spPr>
           <a:xfrm>
             <a:off x="3383280" y="2862072"/>
-            <a:ext cx="2379486" cy="192024"/>
+            <a:ext cx="2329234" cy="192024"/>
           </a:xfrm>
           <a:prstGeom prst="rect">
             <a:avLst/>
@@ -5790,7 +5790,7 @@
         </p:nvSpPr>
         <p:spPr>
           <a:xfrm>
-            <a:off x="5854206" y="2834640"/>
+            <a:off x="5803954" y="2834640"/>
             <a:ext cx="2286000" cy="329184"/>
           </a:xfrm>
           <a:prstGeom prst="rect">
@@ -5811,7 +5811,7 @@
                 </a:solidFill>
                 <a:latin typeface="Helvetica Neue"/>
               </a:rPr>
-              <a:t>100,360   (63 posts · 1,593 avg)</a:t>
+              <a:t>100,997   (63 posts · 1,603 avg)</a:t>
             </a:r>
           </a:p>
         </p:txBody>
@@ -5859,7 +5859,7 @@
         <p:spPr>
           <a:xfrm>
             <a:off x="3383280" y="3191256"/>
-            <a:ext cx="1260350" cy="192024"/>
+            <a:ext cx="1270554" cy="192024"/>
           </a:xfrm>
           <a:prstGeom prst="rect">
             <a:avLst/>
@@ -5902,7 +5902,7 @@
         </p:nvSpPr>
         <p:spPr>
           <a:xfrm>
-            <a:off x="4735070" y="3163824"/>
+            <a:off x="4745274" y="3163824"/>
             <a:ext cx="2286000" cy="329184"/>
           </a:xfrm>
           <a:prstGeom prst="rect">
@@ -5923,7 +5923,7 @@
                 </a:solidFill>
                 <a:latin typeface="Helvetica Neue"/>
               </a:rPr>
-              <a:t>53,158   (44 posts · 1,208 avg)</a:t>
+              <a:t>55,092   (45 posts · 1,224 avg)</a:t>
             </a:r>
           </a:p>
         </p:txBody>
@@ -5971,7 +5971,7 @@
         <p:spPr>
           <a:xfrm>
             <a:off x="3383280" y="3520440"/>
-            <a:ext cx="1232657" cy="192024"/>
+            <a:ext cx="1199014" cy="192024"/>
           </a:xfrm>
           <a:prstGeom prst="rect">
             <a:avLst/>
@@ -6014,7 +6014,7 @@
         </p:nvSpPr>
         <p:spPr>
           <a:xfrm>
-            <a:off x="4707377" y="3493008"/>
+            <a:off x="4673734" y="3493008"/>
             <a:ext cx="2286000" cy="329184"/>
           </a:xfrm>
           <a:prstGeom prst="rect">
@@ -6083,7 +6083,7 @@
         <p:spPr>
           <a:xfrm>
             <a:off x="3383280" y="3849624"/>
-            <a:ext cx="1223956" cy="192024"/>
+            <a:ext cx="1192557" cy="192024"/>
           </a:xfrm>
           <a:prstGeom prst="rect">
             <a:avLst/>
@@ -6126,7 +6126,7 @@
         </p:nvSpPr>
         <p:spPr>
           <a:xfrm>
-            <a:off x="4698676" y="3822192"/>
+            <a:off x="4667277" y="3822192"/>
             <a:ext cx="2286000" cy="329184"/>
           </a:xfrm>
           <a:prstGeom prst="rect">
@@ -6147,7 +6147,7 @@
                 </a:solidFill>
                 <a:latin typeface="Helvetica Neue"/>
               </a:rPr>
-              <a:t>51,623   (20 posts · 2,581 avg)</a:t>
+              <a:t>51,710   (20 posts · 2,586 avg)</a:t>
             </a:r>
           </a:p>
         </p:txBody>
@@ -6195,7 +6195,7 @@
         <p:spPr>
           <a:xfrm>
             <a:off x="3383280" y="4178807"/>
-            <a:ext cx="976073" cy="192024"/>
+            <a:ext cx="949502" cy="192024"/>
           </a:xfrm>
           <a:prstGeom prst="rect">
             <a:avLst/>
@@ -6238,7 +6238,7 @@
         </p:nvSpPr>
         <p:spPr>
           <a:xfrm>
-            <a:off x="4450793" y="4151376"/>
+            <a:off x="4424222" y="4151376"/>
             <a:ext cx="2286000" cy="329184"/>
           </a:xfrm>
           <a:prstGeom prst="rect">
@@ -6259,7 +6259,7 @@
                 </a:solidFill>
                 <a:latin typeface="Helvetica Neue"/>
               </a:rPr>
-              <a:t>41,168   (18 posts · 2,287 avg)</a:t>
+              <a:t>41,171   (18 posts · 2,287 avg)</a:t>
             </a:r>
           </a:p>
         </p:txBody>
@@ -6293,7 +6293,7 @@
                 </a:solidFill>
                 <a:latin typeface="Helvetica Neue"/>
               </a:rPr>
-              <a:t>Politics (other)</a:t>
+              <a:t>Political Highlight</a:t>
             </a:r>
           </a:p>
         </p:txBody>
@@ -6307,7 +6307,119 @@
         <p:spPr>
           <a:xfrm>
             <a:off x="3383280" y="4507992"/>
-            <a:ext cx="805222" cy="192024"/>
+            <a:ext cx="812419" cy="192024"/>
+          </a:xfrm>
+          <a:prstGeom prst="rect">
+            <a:avLst/>
+          </a:prstGeom>
+          <a:solidFill>
+            <a:srgbClr val="2E86AB"/>
+          </a:solidFill>
+          <a:ln>
+            <a:noFill/>
+          </a:ln>
+          <a:effectLst/>
+        </p:spPr>
+        <p:style>
+          <a:lnRef idx="1">
+            <a:schemeClr val="accent1"/>
+          </a:lnRef>
+          <a:fillRef idx="3">
+            <a:schemeClr val="accent1"/>
+          </a:fillRef>
+          <a:effectRef idx="2">
+            <a:schemeClr val="accent1"/>
+          </a:effectRef>
+          <a:fontRef idx="minor">
+            <a:schemeClr val="lt1"/>
+          </a:fontRef>
+        </p:style>
+        <p:txBody>
+          <a:bodyPr rtlCol="0" anchor="ctr"/>
+          <a:lstStyle/>
+          <a:p>
+            <a:pPr algn="ctr"/>
+          </a:p>
+        </p:txBody>
+      </p:sp>
+      <p:sp>
+        <p:nvSpPr>
+          <p:cNvPr id="29" name="TextBox 28"/>
+          <p:cNvSpPr txBox="1"/>
+          <p:nvPr/>
+        </p:nvSpPr>
+        <p:spPr>
+          <a:xfrm>
+            <a:off x="4287139" y="4480560"/>
+            <a:ext cx="2286000" cy="329184"/>
+          </a:xfrm>
+          <a:prstGeom prst="rect">
+            <a:avLst/>
+          </a:prstGeom>
+          <a:noFill/>
+        </p:spPr>
+        <p:txBody>
+          <a:bodyPr wrap="square" lIns="0" rIns="0" tIns="0" bIns="0">
+            <a:spAutoFit/>
+          </a:bodyPr>
+          <a:lstStyle/>
+          <a:p>
+            <a:r>
+              <a:rPr sz="1000" b="0">
+                <a:solidFill>
+                  <a:srgbClr val="6B7082"/>
+                </a:solidFill>
+                <a:latin typeface="Helvetica Neue"/>
+              </a:rPr>
+              <a:t>35,227   (37 posts · 952 avg)</a:t>
+            </a:r>
+          </a:p>
+        </p:txBody>
+      </p:sp>
+      <p:sp>
+        <p:nvSpPr>
+          <p:cNvPr id="30" name="TextBox 29"/>
+          <p:cNvSpPr txBox="1"/>
+          <p:nvPr/>
+        </p:nvSpPr>
+        <p:spPr>
+          <a:xfrm>
+            <a:off x="731520" y="4809744"/>
+            <a:ext cx="2468880" cy="329184"/>
+          </a:xfrm>
+          <a:prstGeom prst="rect">
+            <a:avLst/>
+          </a:prstGeom>
+          <a:noFill/>
+        </p:spPr>
+        <p:txBody>
+          <a:bodyPr wrap="square" lIns="0" rIns="0" tIns="0" bIns="0">
+            <a:spAutoFit/>
+          </a:bodyPr>
+          <a:lstStyle/>
+          <a:p>
+            <a:r>
+              <a:rPr sz="1100" b="0">
+                <a:solidFill>
+                  <a:srgbClr val="141833"/>
+                </a:solidFill>
+                <a:latin typeface="Helvetica Neue"/>
+              </a:rPr>
+              <a:t>Politics (other)</a:t>
+            </a:r>
+          </a:p>
+        </p:txBody>
+      </p:sp>
+      <p:sp>
+        <p:nvSpPr>
+          <p:cNvPr id="31" name="Rectangle 30"/>
+          <p:cNvSpPr/>
+          <p:nvPr/>
+        </p:nvSpPr>
+        <p:spPr>
+          <a:xfrm>
+            <a:off x="3383280" y="4837176"/>
+            <a:ext cx="792655" cy="192024"/>
           </a:xfrm>
           <a:prstGeom prst="rect">
             <a:avLst/>
@@ -6344,13 +6456,13 @@
       </p:sp>
       <p:sp>
         <p:nvSpPr>
-          <p:cNvPr id="29" name="TextBox 28"/>
-          <p:cNvSpPr txBox="1"/>
-          <p:nvPr/>
-        </p:nvSpPr>
-        <p:spPr>
-          <a:xfrm>
-            <a:off x="4279942" y="4480560"/>
+          <p:cNvPr id="32" name="TextBox 31"/>
+          <p:cNvSpPr txBox="1"/>
+          <p:nvPr/>
+        </p:nvSpPr>
+        <p:spPr>
+          <a:xfrm>
+            <a:off x="4267375" y="4809744"/>
             <a:ext cx="2286000" cy="329184"/>
           </a:xfrm>
           <a:prstGeom prst="rect">
@@ -6371,119 +6483,7 @@
                 </a:solidFill>
                 <a:latin typeface="Helvetica Neue"/>
               </a:rPr>
-              <a:t>33,962   (29 posts · 1,171 avg)</a:t>
-            </a:r>
-          </a:p>
-        </p:txBody>
-      </p:sp>
-      <p:sp>
-        <p:nvSpPr>
-          <p:cNvPr id="30" name="TextBox 29"/>
-          <p:cNvSpPr txBox="1"/>
-          <p:nvPr/>
-        </p:nvSpPr>
-        <p:spPr>
-          <a:xfrm>
-            <a:off x="731520" y="4809744"/>
-            <a:ext cx="2468880" cy="329184"/>
-          </a:xfrm>
-          <a:prstGeom prst="rect">
-            <a:avLst/>
-          </a:prstGeom>
-          <a:noFill/>
-        </p:spPr>
-        <p:txBody>
-          <a:bodyPr wrap="square" lIns="0" rIns="0" tIns="0" bIns="0">
-            <a:spAutoFit/>
-          </a:bodyPr>
-          <a:lstStyle/>
-          <a:p>
-            <a:r>
-              <a:rPr sz="1100" b="0">
-                <a:solidFill>
-                  <a:srgbClr val="141833"/>
-                </a:solidFill>
-                <a:latin typeface="Helvetica Neue"/>
-              </a:rPr>
-              <a:t>Political Highlight</a:t>
-            </a:r>
-          </a:p>
-        </p:txBody>
-      </p:sp>
-      <p:sp>
-        <p:nvSpPr>
-          <p:cNvPr id="31" name="Rectangle 30"/>
-          <p:cNvSpPr/>
-          <p:nvPr/>
-        </p:nvSpPr>
-        <p:spPr>
-          <a:xfrm>
-            <a:off x="3383280" y="4837176"/>
-            <a:ext cx="737033" cy="192024"/>
-          </a:xfrm>
-          <a:prstGeom prst="rect">
-            <a:avLst/>
-          </a:prstGeom>
-          <a:solidFill>
-            <a:srgbClr val="2E86AB"/>
-          </a:solidFill>
-          <a:ln>
-            <a:noFill/>
-          </a:ln>
-          <a:effectLst/>
-        </p:spPr>
-        <p:style>
-          <a:lnRef idx="1">
-            <a:schemeClr val="accent1"/>
-          </a:lnRef>
-          <a:fillRef idx="3">
-            <a:schemeClr val="accent1"/>
-          </a:fillRef>
-          <a:effectRef idx="2">
-            <a:schemeClr val="accent1"/>
-          </a:effectRef>
-          <a:fontRef idx="minor">
-            <a:schemeClr val="lt1"/>
-          </a:fontRef>
-        </p:style>
-        <p:txBody>
-          <a:bodyPr rtlCol="0" anchor="ctr"/>
-          <a:lstStyle/>
-          <a:p>
-            <a:pPr algn="ctr"/>
-          </a:p>
-        </p:txBody>
-      </p:sp>
-      <p:sp>
-        <p:nvSpPr>
-          <p:cNvPr id="32" name="TextBox 31"/>
-          <p:cNvSpPr txBox="1"/>
-          <p:nvPr/>
-        </p:nvSpPr>
-        <p:spPr>
-          <a:xfrm>
-            <a:off x="4211753" y="4809744"/>
-            <a:ext cx="2286000" cy="329184"/>
-          </a:xfrm>
-          <a:prstGeom prst="rect">
-            <a:avLst/>
-          </a:prstGeom>
-          <a:noFill/>
-        </p:spPr>
-        <p:txBody>
-          <a:bodyPr wrap="square" lIns="0" rIns="0" tIns="0" bIns="0">
-            <a:spAutoFit/>
-          </a:bodyPr>
-          <a:lstStyle/>
-          <a:p>
-            <a:r>
-              <a:rPr sz="1000" b="0">
-                <a:solidFill>
-                  <a:srgbClr val="6B7082"/>
-                </a:solidFill>
-                <a:latin typeface="Helvetica Neue"/>
-              </a:rPr>
-              <a:t>31,086   (34 posts · 914 avg)</a:t>
+              <a:t>34,370   (29 posts · 1,185 avg)</a:t>
             </a:r>
           </a:p>
         </p:txBody>
@@ -6531,7 +6531,7 @@
         <p:spPr>
           <a:xfrm>
             <a:off x="3383280" y="5166359"/>
-            <a:ext cx="680225" cy="192024"/>
+            <a:ext cx="661660" cy="192024"/>
           </a:xfrm>
           <a:prstGeom prst="rect">
             <a:avLst/>
@@ -6574,7 +6574,7 @@
         </p:nvSpPr>
         <p:spPr>
           <a:xfrm>
-            <a:off x="4154945" y="5138928"/>
+            <a:off x="4136380" y="5138928"/>
             <a:ext cx="2286000" cy="329184"/>
           </a:xfrm>
           <a:prstGeom prst="rect">
@@ -6643,7 +6643,7 @@
         <p:spPr>
           <a:xfrm>
             <a:off x="3383280" y="5495543"/>
-            <a:ext cx="616328" cy="192024"/>
+            <a:ext cx="635669" cy="192024"/>
           </a:xfrm>
           <a:prstGeom prst="rect">
             <a:avLst/>
@@ -6686,7 +6686,7 @@
         </p:nvSpPr>
         <p:spPr>
           <a:xfrm>
-            <a:off x="4091048" y="5468112"/>
+            <a:off x="4110389" y="5468112"/>
             <a:ext cx="2286000" cy="329184"/>
           </a:xfrm>
           <a:prstGeom prst="rect">
@@ -6707,7 +6707,7 @@
                 </a:solidFill>
                 <a:latin typeface="Helvetica Neue"/>
               </a:rPr>
-              <a:t>25,995   (31 posts · 839 avg)</a:t>
+              <a:t>27,563   (33 posts · 835 avg)</a:t>
             </a:r>
           </a:p>
         </p:txBody>
@@ -6755,7 +6755,7 @@
         <p:spPr>
           <a:xfrm>
             <a:off x="3383280" y="5824728"/>
-            <a:ext cx="490644" cy="192024"/>
+            <a:ext cx="479997" cy="192024"/>
           </a:xfrm>
           <a:prstGeom prst="rect">
             <a:avLst/>
@@ -6798,7 +6798,7 @@
         </p:nvSpPr>
         <p:spPr>
           <a:xfrm>
-            <a:off x="3965364" y="5797296"/>
+            <a:off x="3954717" y="5797296"/>
             <a:ext cx="2286000" cy="329184"/>
           </a:xfrm>
           <a:prstGeom prst="rect">
@@ -6819,7 +6819,7 @@
                 </a:solidFill>
                 <a:latin typeface="Helvetica Neue"/>
               </a:rPr>
-              <a:t>20,694   (49 posts · 422 avg)</a:t>
+              <a:t>20,813   (49 posts · 425 avg)</a:t>
             </a:r>
           </a:p>
         </p:txBody>

</xml_diff>

<commit_message>
Scheduled snapshot t45 (2026-10-23): fresh IG/FB/YT/TT + rebuilt decks
Co-Authored-By: Claude Opus 4.7 (1M context) <noreply@anthropic.com>
</commit_message>
<xml_diff>
--- a/OVERALL_REPORT.pptx
+++ b/OVERALL_REPORT.pptx
@@ -3578,7 +3578,7 @@
                 </a:solidFill>
                 <a:latin typeface="Georgia"/>
               </a:rPr>
-              <a:t>930,426</a:t>
+              <a:t>930,436</a:t>
             </a:r>
           </a:p>
         </p:txBody>
@@ -4401,7 +4401,7 @@
                 </a:solidFill>
                 <a:latin typeface="Georgia"/>
               </a:rPr>
-              <a:t>400,377</a:t>
+              <a:t>400,384</a:t>
             </a:r>
           </a:p>
         </p:txBody>
@@ -4659,7 +4659,7 @@
                 </a:solidFill>
                 <a:latin typeface="Georgia"/>
               </a:rPr>
-              <a:t>298,203</a:t>
+              <a:t>298,204</a:t>
             </a:r>
           </a:p>
         </p:txBody>
@@ -4917,7 +4917,7 @@
                 </a:solidFill>
                 <a:latin typeface="Georgia"/>
               </a:rPr>
-              <a:t>228,526</a:t>
+              <a:t>228,528</a:t>
             </a:r>
           </a:p>
         </p:txBody>
@@ -5587,7 +5587,7 @@
                 </a:solidFill>
                 <a:latin typeface="Helvetica Neue"/>
               </a:rPr>
-              <a:t>297,367   (214 posts · 1,390 avg)</a:t>
+              <a:t>297,372   (214 posts · 1,390 avg)</a:t>
             </a:r>
           </a:p>
         </p:txBody>
@@ -5635,7 +5635,7 @@
         <p:spPr>
           <a:xfrm>
             <a:off x="3383280" y="2532888"/>
-            <a:ext cx="2419477" cy="192024"/>
+            <a:ext cx="2419436" cy="192024"/>
           </a:xfrm>
           <a:prstGeom prst="rect">
             <a:avLst/>
@@ -5678,7 +5678,7 @@
         </p:nvSpPr>
         <p:spPr>
           <a:xfrm>
-            <a:off x="5894197" y="2505456"/>
+            <a:off x="5894156" y="2505456"/>
             <a:ext cx="2286000" cy="329184"/>
           </a:xfrm>
           <a:prstGeom prst="rect">
@@ -5747,7 +5747,7 @@
         <p:spPr>
           <a:xfrm>
             <a:off x="3383280" y="2862072"/>
-            <a:ext cx="2329234" cy="192024"/>
+            <a:ext cx="2329218" cy="192024"/>
           </a:xfrm>
           <a:prstGeom prst="rect">
             <a:avLst/>
@@ -5790,7 +5790,7 @@
         </p:nvSpPr>
         <p:spPr>
           <a:xfrm>
-            <a:off x="5803954" y="2834640"/>
+            <a:off x="5803938" y="2834640"/>
             <a:ext cx="2286000" cy="329184"/>
           </a:xfrm>
           <a:prstGeom prst="rect">
@@ -5811,7 +5811,7 @@
                 </a:solidFill>
                 <a:latin typeface="Helvetica Neue"/>
               </a:rPr>
-              <a:t>100,997   (63 posts · 1,603 avg)</a:t>
+              <a:t>100,998   (63 posts · 1,603 avg)</a:t>
             </a:r>
           </a:p>
         </p:txBody>
@@ -5859,7 +5859,7 @@
         <p:spPr>
           <a:xfrm>
             <a:off x="3383280" y="3191256"/>
-            <a:ext cx="1270554" cy="192024"/>
+            <a:ext cx="1270556" cy="192024"/>
           </a:xfrm>
           <a:prstGeom prst="rect">
             <a:avLst/>
@@ -5902,7 +5902,7 @@
         </p:nvSpPr>
         <p:spPr>
           <a:xfrm>
-            <a:off x="4745274" y="3163824"/>
+            <a:off x="4745276" y="3163824"/>
             <a:ext cx="2286000" cy="329184"/>
           </a:xfrm>
           <a:prstGeom prst="rect">
@@ -5923,7 +5923,7 @@
                 </a:solidFill>
                 <a:latin typeface="Helvetica Neue"/>
               </a:rPr>
-              <a:t>55,092   (45 posts · 1,224 avg)</a:t>
+              <a:t>55,093   (45 posts · 1,224 avg)</a:t>
             </a:r>
           </a:p>
         </p:txBody>
@@ -5971,7 +5971,7 @@
         <p:spPr>
           <a:xfrm>
             <a:off x="3383280" y="3520440"/>
-            <a:ext cx="1199014" cy="192024"/>
+            <a:ext cx="1198994" cy="192024"/>
           </a:xfrm>
           <a:prstGeom prst="rect">
             <a:avLst/>
@@ -6014,7 +6014,7 @@
         </p:nvSpPr>
         <p:spPr>
           <a:xfrm>
-            <a:off x="4673734" y="3493008"/>
+            <a:off x="4673714" y="3493008"/>
             <a:ext cx="2286000" cy="329184"/>
           </a:xfrm>
           <a:prstGeom prst="rect">
@@ -6083,7 +6083,7 @@
         <p:spPr>
           <a:xfrm>
             <a:off x="3383280" y="3849624"/>
-            <a:ext cx="1192557" cy="192024"/>
+            <a:ext cx="1192537" cy="192024"/>
           </a:xfrm>
           <a:prstGeom prst="rect">
             <a:avLst/>
@@ -6126,7 +6126,7 @@
         </p:nvSpPr>
         <p:spPr>
           <a:xfrm>
-            <a:off x="4667277" y="3822192"/>
+            <a:off x="4667257" y="3822192"/>
             <a:ext cx="2286000" cy="329184"/>
           </a:xfrm>
           <a:prstGeom prst="rect">
@@ -6195,7 +6195,7 @@
         <p:spPr>
           <a:xfrm>
             <a:off x="3383280" y="4178807"/>
-            <a:ext cx="949502" cy="192024"/>
+            <a:ext cx="949486" cy="192024"/>
           </a:xfrm>
           <a:prstGeom prst="rect">
             <a:avLst/>
@@ -6238,7 +6238,7 @@
         </p:nvSpPr>
         <p:spPr>
           <a:xfrm>
-            <a:off x="4424222" y="4151376"/>
+            <a:off x="4424206" y="4151376"/>
             <a:ext cx="2286000" cy="329184"/>
           </a:xfrm>
           <a:prstGeom prst="rect">
@@ -6307,7 +6307,7 @@
         <p:spPr>
           <a:xfrm>
             <a:off x="3383280" y="4507992"/>
-            <a:ext cx="812419" cy="192024"/>
+            <a:ext cx="812452" cy="192024"/>
           </a:xfrm>
           <a:prstGeom prst="rect">
             <a:avLst/>
@@ -6350,7 +6350,7 @@
         </p:nvSpPr>
         <p:spPr>
           <a:xfrm>
-            <a:off x="4287139" y="4480560"/>
+            <a:off x="4287172" y="4480560"/>
             <a:ext cx="2286000" cy="329184"/>
           </a:xfrm>
           <a:prstGeom prst="rect">
@@ -6371,7 +6371,7 @@
                 </a:solidFill>
                 <a:latin typeface="Helvetica Neue"/>
               </a:rPr>
-              <a:t>35,227   (37 posts · 952 avg)</a:t>
+              <a:t>35,229   (37 posts · 952 avg)</a:t>
             </a:r>
           </a:p>
         </p:txBody>
@@ -6419,7 +6419,7 @@
         <p:spPr>
           <a:xfrm>
             <a:off x="3383280" y="4837176"/>
-            <a:ext cx="792655" cy="192024"/>
+            <a:ext cx="792664" cy="192024"/>
           </a:xfrm>
           <a:prstGeom prst="rect">
             <a:avLst/>
@@ -6462,7 +6462,7 @@
         </p:nvSpPr>
         <p:spPr>
           <a:xfrm>
-            <a:off x="4267375" y="4809744"/>
+            <a:off x="4267384" y="4809744"/>
             <a:ext cx="2286000" cy="329184"/>
           </a:xfrm>
           <a:prstGeom prst="rect">
@@ -6483,7 +6483,7 @@
                 </a:solidFill>
                 <a:latin typeface="Helvetica Neue"/>
               </a:rPr>
-              <a:t>34,370   (29 posts · 1,185 avg)</a:t>
+              <a:t>34,371   (29 posts · 1,185 avg)</a:t>
             </a:r>
           </a:p>
         </p:txBody>
@@ -6531,7 +6531,7 @@
         <p:spPr>
           <a:xfrm>
             <a:off x="3383280" y="5166359"/>
-            <a:ext cx="661660" cy="192024"/>
+            <a:ext cx="661649" cy="192024"/>
           </a:xfrm>
           <a:prstGeom prst="rect">
             <a:avLst/>
@@ -6574,7 +6574,7 @@
         </p:nvSpPr>
         <p:spPr>
           <a:xfrm>
-            <a:off x="4136380" y="5138928"/>
+            <a:off x="4136369" y="5138928"/>
             <a:ext cx="2286000" cy="329184"/>
           </a:xfrm>
           <a:prstGeom prst="rect">
@@ -6643,7 +6643,7 @@
         <p:spPr>
           <a:xfrm>
             <a:off x="3383280" y="5495543"/>
-            <a:ext cx="635669" cy="192024"/>
+            <a:ext cx="635658" cy="192024"/>
           </a:xfrm>
           <a:prstGeom prst="rect">
             <a:avLst/>
@@ -6686,7 +6686,7 @@
         </p:nvSpPr>
         <p:spPr>
           <a:xfrm>
-            <a:off x="4110389" y="5468112"/>
+            <a:off x="4110378" y="5468112"/>
             <a:ext cx="2286000" cy="329184"/>
           </a:xfrm>
           <a:prstGeom prst="rect">
@@ -6755,7 +6755,7 @@
         <p:spPr>
           <a:xfrm>
             <a:off x="3383280" y="5824728"/>
-            <a:ext cx="479997" cy="192024"/>
+            <a:ext cx="479989" cy="192024"/>
           </a:xfrm>
           <a:prstGeom prst="rect">
             <a:avLst/>
@@ -6798,7 +6798,7 @@
         </p:nvSpPr>
         <p:spPr>
           <a:xfrm>
-            <a:off x="3954717" y="5797296"/>
+            <a:off x="3954709" y="5797296"/>
             <a:ext cx="2286000" cy="329184"/>
           </a:xfrm>
           <a:prstGeom prst="rect">

</xml_diff>

<commit_message>
Recategorize Other (32% -> 0.1% of views); add categories + split overall ranking across 2 pages
</commit_message>
<xml_diff>
--- a/OVERALL_REPORT.pptx
+++ b/OVERALL_REPORT.pptx
@@ -10,6 +10,8 @@
     <p:sldId id="258" r:id="rId9"/>
     <p:sldId id="259" r:id="rId10"/>
     <p:sldId id="260" r:id="rId11"/>
+    <p:sldId id="261" r:id="rId12"/>
+    <p:sldId id="262" r:id="rId13"/>
   </p:sldIdLst>
   <p:sldSz cx="12191695" cy="6858000" type="screen4x3"/>
   <p:notesSz cx="6858000" cy="9144000"/>
@@ -5407,7 +5409,7 @@
                 </a:solidFill>
                 <a:latin typeface="Helvetica Neue"/>
               </a:rPr>
-              <a:t>ALL-TIME CATEGORY RANKING</a:t>
+              <a:t>ALL-TIME CATEGORY RANKING · 1 OF 3</a:t>
             </a:r>
           </a:p>
         </p:txBody>
@@ -5509,7 +5511,7 @@
                 </a:solidFill>
                 <a:latin typeface="Helvetica Neue"/>
               </a:rPr>
-              <a:t>Other</a:t>
+              <a:t>1. Military Service</a:t>
             </a:r>
           </a:p>
         </p:txBody>
@@ -5529,7 +5531,7 @@
             <a:avLst/>
           </a:prstGeom>
           <a:solidFill>
-            <a:srgbClr val="6B7082"/>
+            <a:srgbClr val="C9A227"/>
           </a:solidFill>
           <a:ln>
             <a:noFill/>
@@ -5587,7 +5589,7 @@
                 </a:solidFill>
                 <a:latin typeface="Helvetica Neue"/>
               </a:rPr>
-              <a:t>297,372   (214 posts · 1,390 avg)</a:t>
+              <a:t>286,423   (69 posts · 4,151 avg)</a:t>
             </a:r>
           </a:p>
         </p:txBody>
@@ -5621,7 +5623,7 @@
                 </a:solidFill>
                 <a:latin typeface="Helvetica Neue"/>
               </a:rPr>
-              <a:t>military_service</a:t>
+              <a:t>2. Food</a:t>
             </a:r>
           </a:p>
         </p:txBody>
@@ -5635,119 +5637,7 @@
         <p:spPr>
           <a:xfrm>
             <a:off x="3383280" y="2532888"/>
-            <a:ext cx="2419436" cy="192024"/>
-          </a:xfrm>
-          <a:prstGeom prst="rect">
-            <a:avLst/>
-          </a:prstGeom>
-          <a:solidFill>
-            <a:srgbClr val="6B7082"/>
-          </a:solidFill>
-          <a:ln>
-            <a:noFill/>
-          </a:ln>
-          <a:effectLst/>
-        </p:spPr>
-        <p:style>
-          <a:lnRef idx="1">
-            <a:schemeClr val="accent1"/>
-          </a:lnRef>
-          <a:fillRef idx="3">
-            <a:schemeClr val="accent1"/>
-          </a:fillRef>
-          <a:effectRef idx="2">
-            <a:schemeClr val="accent1"/>
-          </a:effectRef>
-          <a:fontRef idx="minor">
-            <a:schemeClr val="lt1"/>
-          </a:fontRef>
-        </p:style>
-        <p:txBody>
-          <a:bodyPr rtlCol="0" anchor="ctr"/>
-          <a:lstStyle/>
-          <a:p>
-            <a:pPr algn="ctr"/>
-          </a:p>
-        </p:txBody>
-      </p:sp>
-      <p:sp>
-        <p:nvSpPr>
-          <p:cNvPr id="11" name="TextBox 10"/>
-          <p:cNvSpPr txBox="1"/>
-          <p:nvPr/>
-        </p:nvSpPr>
-        <p:spPr>
-          <a:xfrm>
-            <a:off x="5894156" y="2505456"/>
-            <a:ext cx="2286000" cy="329184"/>
-          </a:xfrm>
-          <a:prstGeom prst="rect">
-            <a:avLst/>
-          </a:prstGeom>
-          <a:noFill/>
-        </p:spPr>
-        <p:txBody>
-          <a:bodyPr wrap="square" lIns="0" rIns="0" tIns="0" bIns="0">
-            <a:spAutoFit/>
-          </a:bodyPr>
-          <a:lstStyle/>
-          <a:p>
-            <a:r>
-              <a:rPr sz="1000" b="0">
-                <a:solidFill>
-                  <a:srgbClr val="6B7082"/>
-                </a:solidFill>
-                <a:latin typeface="Helvetica Neue"/>
-              </a:rPr>
-              <a:t>104,910   (48 posts · 2,186 avg)</a:t>
-            </a:r>
-          </a:p>
-        </p:txBody>
-      </p:sp>
-      <p:sp>
-        <p:nvSpPr>
-          <p:cNvPr id="12" name="TextBox 11"/>
-          <p:cNvSpPr txBox="1"/>
-          <p:nvPr/>
-        </p:nvSpPr>
-        <p:spPr>
-          <a:xfrm>
-            <a:off x="731520" y="2834640"/>
-            <a:ext cx="2468880" cy="329184"/>
-          </a:xfrm>
-          <a:prstGeom prst="rect">
-            <a:avLst/>
-          </a:prstGeom>
-          <a:noFill/>
-        </p:spPr>
-        <p:txBody>
-          <a:bodyPr wrap="square" lIns="0" rIns="0" tIns="0" bIns="0">
-            <a:spAutoFit/>
-          </a:bodyPr>
-          <a:lstStyle/>
-          <a:p>
-            <a:r>
-              <a:rPr sz="1100" b="1">
-                <a:solidFill>
-                  <a:srgbClr val="141833"/>
-                </a:solidFill>
-                <a:latin typeface="Helvetica Neue"/>
-              </a:rPr>
-              <a:t>Food</a:t>
-            </a:r>
-          </a:p>
-        </p:txBody>
-      </p:sp>
-      <p:sp>
-        <p:nvSpPr>
-          <p:cNvPr id="13" name="Rectangle 12"/>
-          <p:cNvSpPr/>
-          <p:nvPr/>
-        </p:nvSpPr>
-        <p:spPr>
-          <a:xfrm>
-            <a:off x="3383280" y="2862072"/>
-            <a:ext cx="2329218" cy="192024"/>
+            <a:ext cx="2741806" cy="192024"/>
           </a:xfrm>
           <a:prstGeom prst="rect">
             <a:avLst/>
@@ -5784,13 +5674,13 @@
       </p:sp>
       <p:sp>
         <p:nvSpPr>
-          <p:cNvPr id="14" name="TextBox 13"/>
-          <p:cNvSpPr txBox="1"/>
-          <p:nvPr/>
-        </p:nvSpPr>
-        <p:spPr>
-          <a:xfrm>
-            <a:off x="5803938" y="2834640"/>
+          <p:cNvPr id="11" name="TextBox 10"/>
+          <p:cNvSpPr txBox="1"/>
+          <p:nvPr/>
+        </p:nvSpPr>
+        <p:spPr>
+          <a:xfrm>
+            <a:off x="6216526" y="2505456"/>
             <a:ext cx="2286000" cy="329184"/>
           </a:xfrm>
           <a:prstGeom prst="rect">
@@ -5811,20 +5701,20 @@
                 </a:solidFill>
                 <a:latin typeface="Helvetica Neue"/>
               </a:rPr>
-              <a:t>100,998   (63 posts · 1,603 avg)</a:t>
-            </a:r>
-          </a:p>
-        </p:txBody>
-      </p:sp>
-      <p:sp>
-        <p:nvSpPr>
-          <p:cNvPr id="15" name="TextBox 14"/>
-          <p:cNvSpPr txBox="1"/>
-          <p:nvPr/>
-        </p:nvSpPr>
-        <p:spPr>
-          <a:xfrm>
-            <a:off x="731520" y="3163824"/>
+              <a:t>114,511   (73 posts · 1,569 avg)</a:t>
+            </a:r>
+          </a:p>
+        </p:txBody>
+      </p:sp>
+      <p:sp>
+        <p:nvSpPr>
+          <p:cNvPr id="12" name="TextBox 11"/>
+          <p:cNvSpPr txBox="1"/>
+          <p:nvPr/>
+        </p:nvSpPr>
+        <p:spPr>
+          <a:xfrm>
+            <a:off x="731520" y="2834640"/>
             <a:ext cx="2468880" cy="329184"/>
           </a:xfrm>
           <a:prstGeom prst="rect">
@@ -5839,27 +5729,27 @@
           <a:lstStyle/>
           <a:p>
             <a:r>
-              <a:rPr sz="1100" b="0">
+              <a:rPr sz="1100" b="1">
                 <a:solidFill>
                   <a:srgbClr val="141833"/>
                 </a:solidFill>
                 <a:latin typeface="Helvetica Neue"/>
               </a:rPr>
-              <a:t>Community Local</a:t>
-            </a:r>
-          </a:p>
-        </p:txBody>
-      </p:sp>
-      <p:sp>
-        <p:nvSpPr>
-          <p:cNvPr id="16" name="Rectangle 15"/>
+              <a:t>3. Community Local</a:t>
+            </a:r>
+          </a:p>
+        </p:txBody>
+      </p:sp>
+      <p:sp>
+        <p:nvSpPr>
+          <p:cNvPr id="13" name="Rectangle 12"/>
           <p:cNvSpPr/>
           <p:nvPr/>
         </p:nvSpPr>
         <p:spPr>
           <a:xfrm>
-            <a:off x="3383280" y="3191256"/>
-            <a:ext cx="1270556" cy="192024"/>
+            <a:off x="3383280" y="2862072"/>
+            <a:ext cx="1319125" cy="192024"/>
           </a:xfrm>
           <a:prstGeom prst="rect">
             <a:avLst/>
@@ -5896,13 +5786,13 @@
       </p:sp>
       <p:sp>
         <p:nvSpPr>
-          <p:cNvPr id="17" name="TextBox 16"/>
-          <p:cNvSpPr txBox="1"/>
-          <p:nvPr/>
-        </p:nvSpPr>
-        <p:spPr>
-          <a:xfrm>
-            <a:off x="4745276" y="3163824"/>
+          <p:cNvPr id="14" name="TextBox 13"/>
+          <p:cNvSpPr txBox="1"/>
+          <p:nvPr/>
+        </p:nvSpPr>
+        <p:spPr>
+          <a:xfrm>
+            <a:off x="4793845" y="2834640"/>
             <a:ext cx="2286000" cy="329184"/>
           </a:xfrm>
           <a:prstGeom prst="rect">
@@ -5930,13 +5820,13 @@
       </p:sp>
       <p:sp>
         <p:nvSpPr>
-          <p:cNvPr id="18" name="TextBox 17"/>
-          <p:cNvSpPr txBox="1"/>
-          <p:nvPr/>
-        </p:nvSpPr>
-        <p:spPr>
-          <a:xfrm>
-            <a:off x="731520" y="3493008"/>
+          <p:cNvPr id="15" name="TextBox 14"/>
+          <p:cNvSpPr txBox="1"/>
+          <p:nvPr/>
+        </p:nvSpPr>
+        <p:spPr>
+          <a:xfrm>
+            <a:off x="731520" y="3163824"/>
             <a:ext cx="2468880" cy="329184"/>
           </a:xfrm>
           <a:prstGeom prst="rect">
@@ -5957,21 +5847,21 @@
                 </a:solidFill>
                 <a:latin typeface="Helvetica Neue"/>
               </a:rPr>
-              <a:t>FIFA — Positive</a:t>
-            </a:r>
-          </a:p>
-        </p:txBody>
-      </p:sp>
-      <p:sp>
-        <p:nvSpPr>
-          <p:cNvPr id="19" name="Rectangle 18"/>
+              <a:t>4. FIFA — Positive</a:t>
+            </a:r>
+          </a:p>
+        </p:txBody>
+      </p:sp>
+      <p:sp>
+        <p:nvSpPr>
+          <p:cNvPr id="16" name="Rectangle 15"/>
           <p:cNvSpPr/>
           <p:nvPr/>
         </p:nvSpPr>
         <p:spPr>
           <a:xfrm>
-            <a:off x="3383280" y="3520440"/>
-            <a:ext cx="1198994" cy="192024"/>
+            <a:off x="3383280" y="3191256"/>
+            <a:ext cx="1244828" cy="192024"/>
           </a:xfrm>
           <a:prstGeom prst="rect">
             <a:avLst/>
@@ -6008,13 +5898,13 @@
       </p:sp>
       <p:sp>
         <p:nvSpPr>
-          <p:cNvPr id="20" name="TextBox 19"/>
-          <p:cNvSpPr txBox="1"/>
-          <p:nvPr/>
-        </p:nvSpPr>
-        <p:spPr>
-          <a:xfrm>
-            <a:off x="4673714" y="3493008"/>
+          <p:cNvPr id="17" name="TextBox 16"/>
+          <p:cNvSpPr txBox="1"/>
+          <p:nvPr/>
+        </p:nvSpPr>
+        <p:spPr>
+          <a:xfrm>
+            <a:off x="4719548" y="3163824"/>
             <a:ext cx="2286000" cy="329184"/>
           </a:xfrm>
           <a:prstGeom prst="rect">
@@ -6042,13 +5932,13 @@
       </p:sp>
       <p:sp>
         <p:nvSpPr>
-          <p:cNvPr id="21" name="TextBox 20"/>
-          <p:cNvSpPr txBox="1"/>
-          <p:nvPr/>
-        </p:nvSpPr>
-        <p:spPr>
-          <a:xfrm>
-            <a:off x="731520" y="3822192"/>
+          <p:cNvPr id="18" name="TextBox 17"/>
+          <p:cNvSpPr txBox="1"/>
+          <p:nvPr/>
+        </p:nvSpPr>
+        <p:spPr>
+          <a:xfrm>
+            <a:off x="731520" y="3493008"/>
             <a:ext cx="2468880" cy="329184"/>
           </a:xfrm>
           <a:prstGeom prst="rect">
@@ -6069,21 +5959,21 @@
                 </a:solidFill>
                 <a:latin typeface="Helvetica Neue"/>
               </a:rPr>
-              <a:t>Downtown Development</a:t>
-            </a:r>
-          </a:p>
-        </p:txBody>
-      </p:sp>
-      <p:sp>
-        <p:nvSpPr>
-          <p:cNvPr id="22" name="Rectangle 21"/>
+              <a:t>5. Downtown Development</a:t>
+            </a:r>
+          </a:p>
+        </p:txBody>
+      </p:sp>
+      <p:sp>
+        <p:nvSpPr>
+          <p:cNvPr id="19" name="Rectangle 18"/>
           <p:cNvSpPr/>
           <p:nvPr/>
         </p:nvSpPr>
         <p:spPr>
           <a:xfrm>
-            <a:off x="3383280" y="3849624"/>
-            <a:ext cx="1192537" cy="192024"/>
+            <a:off x="3383280" y="3520440"/>
+            <a:ext cx="1238123" cy="192024"/>
           </a:xfrm>
           <a:prstGeom prst="rect">
             <a:avLst/>
@@ -6120,13 +6010,13 @@
       </p:sp>
       <p:sp>
         <p:nvSpPr>
-          <p:cNvPr id="23" name="TextBox 22"/>
-          <p:cNvSpPr txBox="1"/>
-          <p:nvPr/>
-        </p:nvSpPr>
-        <p:spPr>
-          <a:xfrm>
-            <a:off x="4667257" y="3822192"/>
+          <p:cNvPr id="20" name="TextBox 19"/>
+          <p:cNvSpPr txBox="1"/>
+          <p:nvPr/>
+        </p:nvSpPr>
+        <p:spPr>
+          <a:xfrm>
+            <a:off x="4712843" y="3493008"/>
             <a:ext cx="2286000" cy="329184"/>
           </a:xfrm>
           <a:prstGeom prst="rect">
@@ -6154,13 +6044,13 @@
       </p:sp>
       <p:sp>
         <p:nvSpPr>
-          <p:cNvPr id="24" name="TextBox 23"/>
-          <p:cNvSpPr txBox="1"/>
-          <p:nvPr/>
-        </p:nvSpPr>
-        <p:spPr>
-          <a:xfrm>
-            <a:off x="731520" y="4151376"/>
+          <p:cNvPr id="21" name="TextBox 20"/>
+          <p:cNvSpPr txBox="1"/>
+          <p:nvPr/>
+        </p:nvSpPr>
+        <p:spPr>
+          <a:xfrm>
+            <a:off x="731520" y="3822192"/>
             <a:ext cx="2468880" cy="329184"/>
           </a:xfrm>
           <a:prstGeom prst="rect">
@@ -6181,21 +6071,21 @@
                 </a:solidFill>
                 <a:latin typeface="Helvetica Neue"/>
               </a:rPr>
-              <a:t>Trujillo Scandal</a:t>
-            </a:r>
-          </a:p>
-        </p:txBody>
-      </p:sp>
-      <p:sp>
-        <p:nvSpPr>
-          <p:cNvPr id="25" name="Rectangle 24"/>
+              <a:t>6. Trujillo Scandal</a:t>
+            </a:r>
+          </a:p>
+        </p:txBody>
+      </p:sp>
+      <p:sp>
+        <p:nvSpPr>
+          <p:cNvPr id="22" name="Rectangle 21"/>
           <p:cNvSpPr/>
           <p:nvPr/>
         </p:nvSpPr>
         <p:spPr>
           <a:xfrm>
-            <a:off x="3383280" y="4178807"/>
-            <a:ext cx="949486" cy="192024"/>
+            <a:off x="3383280" y="3849624"/>
+            <a:ext cx="985782" cy="192024"/>
           </a:xfrm>
           <a:prstGeom prst="rect">
             <a:avLst/>
@@ -6232,13 +6122,13 @@
       </p:sp>
       <p:sp>
         <p:nvSpPr>
-          <p:cNvPr id="26" name="TextBox 25"/>
-          <p:cNvSpPr txBox="1"/>
-          <p:nvPr/>
-        </p:nvSpPr>
-        <p:spPr>
-          <a:xfrm>
-            <a:off x="4424206" y="4151376"/>
+          <p:cNvPr id="23" name="TextBox 22"/>
+          <p:cNvSpPr txBox="1"/>
+          <p:nvPr/>
+        </p:nvSpPr>
+        <p:spPr>
+          <a:xfrm>
+            <a:off x="4460502" y="3822192"/>
             <a:ext cx="2286000" cy="329184"/>
           </a:xfrm>
           <a:prstGeom prst="rect">
@@ -6266,13 +6156,13 @@
       </p:sp>
       <p:sp>
         <p:nvSpPr>
-          <p:cNvPr id="27" name="TextBox 26"/>
-          <p:cNvSpPr txBox="1"/>
-          <p:nvPr/>
-        </p:nvSpPr>
-        <p:spPr>
-          <a:xfrm>
-            <a:off x="731520" y="4480560"/>
+          <p:cNvPr id="24" name="TextBox 23"/>
+          <p:cNvSpPr txBox="1"/>
+          <p:nvPr/>
+        </p:nvSpPr>
+        <p:spPr>
+          <a:xfrm>
+            <a:off x="731520" y="4151376"/>
             <a:ext cx="2468880" cy="329184"/>
           </a:xfrm>
           <a:prstGeom prst="rect">
@@ -6293,21 +6183,21 @@
                 </a:solidFill>
                 <a:latin typeface="Helvetica Neue"/>
               </a:rPr>
-              <a:t>Political Highlight</a:t>
-            </a:r>
-          </a:p>
-        </p:txBody>
-      </p:sp>
-      <p:sp>
-        <p:nvSpPr>
-          <p:cNvPr id="28" name="Rectangle 27"/>
+              <a:t>7. Political Highlight</a:t>
+            </a:r>
+          </a:p>
+        </p:txBody>
+      </p:sp>
+      <p:sp>
+        <p:nvSpPr>
+          <p:cNvPr id="25" name="Rectangle 24"/>
           <p:cNvSpPr/>
           <p:nvPr/>
         </p:nvSpPr>
         <p:spPr>
           <a:xfrm>
-            <a:off x="3383280" y="4507992"/>
-            <a:ext cx="812452" cy="192024"/>
+            <a:off x="3383280" y="4178807"/>
+            <a:ext cx="843509" cy="192024"/>
           </a:xfrm>
           <a:prstGeom prst="rect">
             <a:avLst/>
@@ -6344,13 +6234,13 @@
       </p:sp>
       <p:sp>
         <p:nvSpPr>
-          <p:cNvPr id="29" name="TextBox 28"/>
-          <p:cNvSpPr txBox="1"/>
-          <p:nvPr/>
-        </p:nvSpPr>
-        <p:spPr>
-          <a:xfrm>
-            <a:off x="4287172" y="4480560"/>
+          <p:cNvPr id="26" name="TextBox 25"/>
+          <p:cNvSpPr txBox="1"/>
+          <p:nvPr/>
+        </p:nvSpPr>
+        <p:spPr>
+          <a:xfrm>
+            <a:off x="4318229" y="4151376"/>
             <a:ext cx="2286000" cy="329184"/>
           </a:xfrm>
           <a:prstGeom prst="rect">
@@ -6378,13 +6268,13 @@
       </p:sp>
       <p:sp>
         <p:nvSpPr>
-          <p:cNvPr id="30" name="TextBox 29"/>
-          <p:cNvSpPr txBox="1"/>
-          <p:nvPr/>
-        </p:nvSpPr>
-        <p:spPr>
-          <a:xfrm>
-            <a:off x="731520" y="4809744"/>
+          <p:cNvPr id="27" name="TextBox 26"/>
+          <p:cNvSpPr txBox="1"/>
+          <p:nvPr/>
+        </p:nvSpPr>
+        <p:spPr>
+          <a:xfrm>
+            <a:off x="731520" y="4480560"/>
             <a:ext cx="2468880" cy="329184"/>
           </a:xfrm>
           <a:prstGeom prst="rect">
@@ -6405,21 +6295,21 @@
                 </a:solidFill>
                 <a:latin typeface="Helvetica Neue"/>
               </a:rPr>
-              <a:t>Politics (other)</a:t>
-            </a:r>
-          </a:p>
-        </p:txBody>
-      </p:sp>
-      <p:sp>
-        <p:nvSpPr>
-          <p:cNvPr id="31" name="Rectangle 30"/>
+              <a:t>8. Politics (other)</a:t>
+            </a:r>
+          </a:p>
+        </p:txBody>
+      </p:sp>
+      <p:sp>
+        <p:nvSpPr>
+          <p:cNvPr id="28" name="Rectangle 27"/>
           <p:cNvSpPr/>
           <p:nvPr/>
         </p:nvSpPr>
         <p:spPr>
           <a:xfrm>
-            <a:off x="3383280" y="4837176"/>
-            <a:ext cx="792664" cy="192024"/>
+            <a:off x="3383280" y="4507992"/>
+            <a:ext cx="822965" cy="192024"/>
           </a:xfrm>
           <a:prstGeom prst="rect">
             <a:avLst/>
@@ -6456,13 +6346,125 @@
       </p:sp>
       <p:sp>
         <p:nvSpPr>
+          <p:cNvPr id="29" name="TextBox 28"/>
+          <p:cNvSpPr txBox="1"/>
+          <p:nvPr/>
+        </p:nvSpPr>
+        <p:spPr>
+          <a:xfrm>
+            <a:off x="4297685" y="4480560"/>
+            <a:ext cx="2286000" cy="329184"/>
+          </a:xfrm>
+          <a:prstGeom prst="rect">
+            <a:avLst/>
+          </a:prstGeom>
+          <a:noFill/>
+        </p:spPr>
+        <p:txBody>
+          <a:bodyPr wrap="square" lIns="0" rIns="0" tIns="0" bIns="0">
+            <a:spAutoFit/>
+          </a:bodyPr>
+          <a:lstStyle/>
+          <a:p>
+            <a:r>
+              <a:rPr sz="1000" b="0">
+                <a:solidFill>
+                  <a:srgbClr val="6B7082"/>
+                </a:solidFill>
+                <a:latin typeface="Helvetica Neue"/>
+              </a:rPr>
+              <a:t>34,371   (29 posts · 1,185 avg)</a:t>
+            </a:r>
+          </a:p>
+        </p:txBody>
+      </p:sp>
+      <p:sp>
+        <p:nvSpPr>
+          <p:cNvPr id="30" name="TextBox 29"/>
+          <p:cNvSpPr txBox="1"/>
+          <p:nvPr/>
+        </p:nvSpPr>
+        <p:spPr>
+          <a:xfrm>
+            <a:off x="731520" y="4809744"/>
+            <a:ext cx="2468880" cy="329184"/>
+          </a:xfrm>
+          <a:prstGeom prst="rect">
+            <a:avLst/>
+          </a:prstGeom>
+          <a:noFill/>
+        </p:spPr>
+        <p:txBody>
+          <a:bodyPr wrap="square" lIns="0" rIns="0" tIns="0" bIns="0">
+            <a:spAutoFit/>
+          </a:bodyPr>
+          <a:lstStyle/>
+          <a:p>
+            <a:r>
+              <a:rPr sz="1100" b="0">
+                <a:solidFill>
+                  <a:srgbClr val="141833"/>
+                </a:solidFill>
+                <a:latin typeface="Helvetica Neue"/>
+              </a:rPr>
+              <a:t>9. Judicial</a:t>
+            </a:r>
+          </a:p>
+        </p:txBody>
+      </p:sp>
+      <p:sp>
+        <p:nvSpPr>
+          <p:cNvPr id="31" name="Rectangle 30"/>
+          <p:cNvSpPr/>
+          <p:nvPr/>
+        </p:nvSpPr>
+        <p:spPr>
+          <a:xfrm>
+            <a:off x="3383280" y="4837176"/>
+            <a:ext cx="800410" cy="192024"/>
+          </a:xfrm>
+          <a:prstGeom prst="rect">
+            <a:avLst/>
+          </a:prstGeom>
+          <a:solidFill>
+            <a:srgbClr val="2F3C7E"/>
+          </a:solidFill>
+          <a:ln>
+            <a:noFill/>
+          </a:ln>
+          <a:effectLst/>
+        </p:spPr>
+        <p:style>
+          <a:lnRef idx="1">
+            <a:schemeClr val="accent1"/>
+          </a:lnRef>
+          <a:fillRef idx="3">
+            <a:schemeClr val="accent1"/>
+          </a:fillRef>
+          <a:effectRef idx="2">
+            <a:schemeClr val="accent1"/>
+          </a:effectRef>
+          <a:fontRef idx="minor">
+            <a:schemeClr val="lt1"/>
+          </a:fontRef>
+        </p:style>
+        <p:txBody>
+          <a:bodyPr rtlCol="0" anchor="ctr"/>
+          <a:lstStyle/>
+          <a:p>
+            <a:pPr algn="ctr"/>
+          </a:p>
+        </p:txBody>
+      </p:sp>
+      <p:sp>
+        <p:nvSpPr>
           <p:cNvPr id="32" name="TextBox 31"/>
           <p:cNvSpPr txBox="1"/>
           <p:nvPr/>
         </p:nvSpPr>
         <p:spPr>
           <a:xfrm>
-            <a:off x="4267384" y="4809744"/>
+            <a:off x="4275130" y="4809744"/>
             <a:ext cx="2286000" cy="329184"/>
           </a:xfrm>
           <a:prstGeom prst="rect">
@@ -6483,7 +6485,7 @@
                 </a:solidFill>
                 <a:latin typeface="Helvetica Neue"/>
               </a:rPr>
-              <a:t>34,371   (29 posts · 1,185 avg)</a:t>
+              <a:t>33,429   (78 posts · 429 avg)</a:t>
             </a:r>
           </a:p>
         </p:txBody>
@@ -6517,7 +6519,7 @@
                 </a:solidFill>
                 <a:latin typeface="Helvetica Neue"/>
               </a:rPr>
-              <a:t>Council Chaos</a:t>
+              <a:t>10. City Hall &amp; Civic</a:t>
             </a:r>
           </a:p>
         </p:txBody>
@@ -6531,7 +6533,231 @@
         <p:spPr>
           <a:xfrm>
             <a:off x="3383280" y="5166359"/>
-            <a:ext cx="661649" cy="192024"/>
+            <a:ext cx="719385" cy="192024"/>
+          </a:xfrm>
+          <a:prstGeom prst="rect">
+            <a:avLst/>
+          </a:prstGeom>
+          <a:solidFill>
+            <a:srgbClr val="2F3C7E"/>
+          </a:solidFill>
+          <a:ln>
+            <a:noFill/>
+          </a:ln>
+          <a:effectLst/>
+        </p:spPr>
+        <p:style>
+          <a:lnRef idx="1">
+            <a:schemeClr val="accent1"/>
+          </a:lnRef>
+          <a:fillRef idx="3">
+            <a:schemeClr val="accent1"/>
+          </a:fillRef>
+          <a:effectRef idx="2">
+            <a:schemeClr val="accent1"/>
+          </a:effectRef>
+          <a:fontRef idx="minor">
+            <a:schemeClr val="lt1"/>
+          </a:fontRef>
+        </p:style>
+        <p:txBody>
+          <a:bodyPr rtlCol="0" anchor="ctr"/>
+          <a:lstStyle/>
+          <a:p>
+            <a:pPr algn="ctr"/>
+          </a:p>
+        </p:txBody>
+      </p:sp>
+      <p:sp>
+        <p:nvSpPr>
+          <p:cNvPr id="35" name="TextBox 34"/>
+          <p:cNvSpPr txBox="1"/>
+          <p:nvPr/>
+        </p:nvSpPr>
+        <p:spPr>
+          <a:xfrm>
+            <a:off x="4194105" y="5138928"/>
+            <a:ext cx="2286000" cy="329184"/>
+          </a:xfrm>
+          <a:prstGeom prst="rect">
+            <a:avLst/>
+          </a:prstGeom>
+          <a:noFill/>
+        </p:spPr>
+        <p:txBody>
+          <a:bodyPr wrap="square" lIns="0" rIns="0" tIns="0" bIns="0">
+            <a:spAutoFit/>
+          </a:bodyPr>
+          <a:lstStyle/>
+          <a:p>
+            <a:r>
+              <a:rPr sz="1000" b="0">
+                <a:solidFill>
+                  <a:srgbClr val="6B7082"/>
+                </a:solidFill>
+                <a:latin typeface="Helvetica Neue"/>
+              </a:rPr>
+              <a:t>30,045   (42 posts · 715 avg)</a:t>
+            </a:r>
+          </a:p>
+        </p:txBody>
+      </p:sp>
+      <p:sp>
+        <p:nvSpPr>
+          <p:cNvPr id="36" name="TextBox 35"/>
+          <p:cNvSpPr txBox="1"/>
+          <p:nvPr/>
+        </p:nvSpPr>
+        <p:spPr>
+          <a:xfrm>
+            <a:off x="731520" y="5468112"/>
+            <a:ext cx="2468880" cy="329184"/>
+          </a:xfrm>
+          <a:prstGeom prst="rect">
+            <a:avLst/>
+          </a:prstGeom>
+          <a:noFill/>
+        </p:spPr>
+        <p:txBody>
+          <a:bodyPr wrap="square" lIns="0" rIns="0" tIns="0" bIns="0">
+            <a:spAutoFit/>
+          </a:bodyPr>
+          <a:lstStyle/>
+          <a:p>
+            <a:r>
+              <a:rPr sz="1100" b="0">
+                <a:solidFill>
+                  <a:srgbClr val="141833"/>
+                </a:solidFill>
+                <a:latin typeface="Helvetica Neue"/>
+              </a:rPr>
+              <a:t>11. Elections</a:t>
+            </a:r>
+          </a:p>
+        </p:txBody>
+      </p:sp>
+      <p:sp>
+        <p:nvSpPr>
+          <p:cNvPr id="37" name="Rectangle 36"/>
+          <p:cNvSpPr/>
+          <p:nvPr/>
+        </p:nvSpPr>
+        <p:spPr>
+          <a:xfrm>
+            <a:off x="3383280" y="5495543"/>
+            <a:ext cx="715746" cy="192024"/>
+          </a:xfrm>
+          <a:prstGeom prst="rect">
+            <a:avLst/>
+          </a:prstGeom>
+          <a:solidFill>
+            <a:srgbClr val="2F3C7E"/>
+          </a:solidFill>
+          <a:ln>
+            <a:noFill/>
+          </a:ln>
+          <a:effectLst/>
+        </p:spPr>
+        <p:style>
+          <a:lnRef idx="1">
+            <a:schemeClr val="accent1"/>
+          </a:lnRef>
+          <a:fillRef idx="3">
+            <a:schemeClr val="accent1"/>
+          </a:fillRef>
+          <a:effectRef idx="2">
+            <a:schemeClr val="accent1"/>
+          </a:effectRef>
+          <a:fontRef idx="minor">
+            <a:schemeClr val="lt1"/>
+          </a:fontRef>
+        </p:style>
+        <p:txBody>
+          <a:bodyPr rtlCol="0" anchor="ctr"/>
+          <a:lstStyle/>
+          <a:p>
+            <a:pPr algn="ctr"/>
+          </a:p>
+        </p:txBody>
+      </p:sp>
+      <p:sp>
+        <p:nvSpPr>
+          <p:cNvPr id="38" name="TextBox 37"/>
+          <p:cNvSpPr txBox="1"/>
+          <p:nvPr/>
+        </p:nvSpPr>
+        <p:spPr>
+          <a:xfrm>
+            <a:off x="4190466" y="5468112"/>
+            <a:ext cx="2286000" cy="329184"/>
+          </a:xfrm>
+          <a:prstGeom prst="rect">
+            <a:avLst/>
+          </a:prstGeom>
+          <a:noFill/>
+        </p:spPr>
+        <p:txBody>
+          <a:bodyPr wrap="square" lIns="0" rIns="0" tIns="0" bIns="0">
+            <a:spAutoFit/>
+          </a:bodyPr>
+          <a:lstStyle/>
+          <a:p>
+            <a:r>
+              <a:rPr sz="1000" b="0">
+                <a:solidFill>
+                  <a:srgbClr val="6B7082"/>
+                </a:solidFill>
+                <a:latin typeface="Helvetica Neue"/>
+              </a:rPr>
+              <a:t>29,893   (39 posts · 766 avg)</a:t>
+            </a:r>
+          </a:p>
+        </p:txBody>
+      </p:sp>
+      <p:sp>
+        <p:nvSpPr>
+          <p:cNvPr id="39" name="TextBox 38"/>
+          <p:cNvSpPr txBox="1"/>
+          <p:nvPr/>
+        </p:nvSpPr>
+        <p:spPr>
+          <a:xfrm>
+            <a:off x="731520" y="5797296"/>
+            <a:ext cx="2468880" cy="329184"/>
+          </a:xfrm>
+          <a:prstGeom prst="rect">
+            <a:avLst/>
+          </a:prstGeom>
+          <a:noFill/>
+        </p:spPr>
+        <p:txBody>
+          <a:bodyPr wrap="square" lIns="0" rIns="0" tIns="0" bIns="0">
+            <a:spAutoFit/>
+          </a:bodyPr>
+          <a:lstStyle/>
+          <a:p>
+            <a:r>
+              <a:rPr sz="1100" b="0">
+                <a:solidFill>
+                  <a:srgbClr val="141833"/>
+                </a:solidFill>
+                <a:latin typeface="Helvetica Neue"/>
+              </a:rPr>
+              <a:t>12. Council Chaos</a:t>
+            </a:r>
+          </a:p>
+        </p:txBody>
+      </p:sp>
+      <p:sp>
+        <p:nvSpPr>
+          <p:cNvPr id="40" name="Rectangle 39"/>
+          <p:cNvSpPr/>
+          <p:nvPr/>
+        </p:nvSpPr>
+        <p:spPr>
+          <a:xfrm>
+            <a:off x="3383280" y="5824728"/>
+            <a:ext cx="686942" cy="192024"/>
           </a:xfrm>
           <a:prstGeom prst="rect">
             <a:avLst/>
@@ -6568,13 +6794,13 @@
       </p:sp>
       <p:sp>
         <p:nvSpPr>
-          <p:cNvPr id="35" name="TextBox 34"/>
-          <p:cNvSpPr txBox="1"/>
-          <p:nvPr/>
-        </p:nvSpPr>
-        <p:spPr>
-          <a:xfrm>
-            <a:off x="4136369" y="5138928"/>
+          <p:cNvPr id="41" name="TextBox 40"/>
+          <p:cNvSpPr txBox="1"/>
+          <p:nvPr/>
+        </p:nvSpPr>
+        <p:spPr>
+          <a:xfrm>
+            <a:off x="4161662" y="5797296"/>
             <a:ext cx="2286000" cy="329184"/>
           </a:xfrm>
           <a:prstGeom prst="rect">
@@ -6596,230 +6822,6 @@
                 <a:latin typeface="Helvetica Neue"/>
               </a:rPr>
               <a:t>28,690   (6 posts · 4,782 avg)</a:t>
-            </a:r>
-          </a:p>
-        </p:txBody>
-      </p:sp>
-      <p:sp>
-        <p:nvSpPr>
-          <p:cNvPr id="36" name="TextBox 35"/>
-          <p:cNvSpPr txBox="1"/>
-          <p:nvPr/>
-        </p:nvSpPr>
-        <p:spPr>
-          <a:xfrm>
-            <a:off x="731520" y="5468112"/>
-            <a:ext cx="2468880" cy="329184"/>
-          </a:xfrm>
-          <a:prstGeom prst="rect">
-            <a:avLst/>
-          </a:prstGeom>
-          <a:noFill/>
-        </p:spPr>
-        <p:txBody>
-          <a:bodyPr wrap="square" lIns="0" rIns="0" tIns="0" bIns="0">
-            <a:spAutoFit/>
-          </a:bodyPr>
-          <a:lstStyle/>
-          <a:p>
-            <a:r>
-              <a:rPr sz="1100" b="0">
-                <a:solidFill>
-                  <a:srgbClr val="141833"/>
-                </a:solidFill>
-                <a:latin typeface="Helvetica Neue"/>
-              </a:rPr>
-              <a:t>Elections</a:t>
-            </a:r>
-          </a:p>
-        </p:txBody>
-      </p:sp>
-      <p:sp>
-        <p:nvSpPr>
-          <p:cNvPr id="37" name="Rectangle 36"/>
-          <p:cNvSpPr/>
-          <p:nvPr/>
-        </p:nvSpPr>
-        <p:spPr>
-          <a:xfrm>
-            <a:off x="3383280" y="5495543"/>
-            <a:ext cx="635658" cy="192024"/>
-          </a:xfrm>
-          <a:prstGeom prst="rect">
-            <a:avLst/>
-          </a:prstGeom>
-          <a:solidFill>
-            <a:srgbClr val="2F3C7E"/>
-          </a:solidFill>
-          <a:ln>
-            <a:noFill/>
-          </a:ln>
-          <a:effectLst/>
-        </p:spPr>
-        <p:style>
-          <a:lnRef idx="1">
-            <a:schemeClr val="accent1"/>
-          </a:lnRef>
-          <a:fillRef idx="3">
-            <a:schemeClr val="accent1"/>
-          </a:fillRef>
-          <a:effectRef idx="2">
-            <a:schemeClr val="accent1"/>
-          </a:effectRef>
-          <a:fontRef idx="minor">
-            <a:schemeClr val="lt1"/>
-          </a:fontRef>
-        </p:style>
-        <p:txBody>
-          <a:bodyPr rtlCol="0" anchor="ctr"/>
-          <a:lstStyle/>
-          <a:p>
-            <a:pPr algn="ctr"/>
-          </a:p>
-        </p:txBody>
-      </p:sp>
-      <p:sp>
-        <p:nvSpPr>
-          <p:cNvPr id="38" name="TextBox 37"/>
-          <p:cNvSpPr txBox="1"/>
-          <p:nvPr/>
-        </p:nvSpPr>
-        <p:spPr>
-          <a:xfrm>
-            <a:off x="4110378" y="5468112"/>
-            <a:ext cx="2286000" cy="329184"/>
-          </a:xfrm>
-          <a:prstGeom prst="rect">
-            <a:avLst/>
-          </a:prstGeom>
-          <a:noFill/>
-        </p:spPr>
-        <p:txBody>
-          <a:bodyPr wrap="square" lIns="0" rIns="0" tIns="0" bIns="0">
-            <a:spAutoFit/>
-          </a:bodyPr>
-          <a:lstStyle/>
-          <a:p>
-            <a:r>
-              <a:rPr sz="1000" b="0">
-                <a:solidFill>
-                  <a:srgbClr val="6B7082"/>
-                </a:solidFill>
-                <a:latin typeface="Helvetica Neue"/>
-              </a:rPr>
-              <a:t>27,563   (33 posts · 835 avg)</a:t>
-            </a:r>
-          </a:p>
-        </p:txBody>
-      </p:sp>
-      <p:sp>
-        <p:nvSpPr>
-          <p:cNvPr id="39" name="TextBox 38"/>
-          <p:cNvSpPr txBox="1"/>
-          <p:nvPr/>
-        </p:nvSpPr>
-        <p:spPr>
-          <a:xfrm>
-            <a:off x="731520" y="5797296"/>
-            <a:ext cx="2468880" cy="329184"/>
-          </a:xfrm>
-          <a:prstGeom prst="rect">
-            <a:avLst/>
-          </a:prstGeom>
-          <a:noFill/>
-        </p:spPr>
-        <p:txBody>
-          <a:bodyPr wrap="square" lIns="0" rIns="0" tIns="0" bIns="0">
-            <a:spAutoFit/>
-          </a:bodyPr>
-          <a:lstStyle/>
-          <a:p>
-            <a:r>
-              <a:rPr sz="1100" b="0">
-                <a:solidFill>
-                  <a:srgbClr val="141833"/>
-                </a:solidFill>
-                <a:latin typeface="Helvetica Neue"/>
-              </a:rPr>
-              <a:t>Judicial</a:t>
-            </a:r>
-          </a:p>
-        </p:txBody>
-      </p:sp>
-      <p:sp>
-        <p:nvSpPr>
-          <p:cNvPr id="40" name="Rectangle 39"/>
-          <p:cNvSpPr/>
-          <p:nvPr/>
-        </p:nvSpPr>
-        <p:spPr>
-          <a:xfrm>
-            <a:off x="3383280" y="5824728"/>
-            <a:ext cx="479989" cy="192024"/>
-          </a:xfrm>
-          <a:prstGeom prst="rect">
-            <a:avLst/>
-          </a:prstGeom>
-          <a:solidFill>
-            <a:srgbClr val="2F3C7E"/>
-          </a:solidFill>
-          <a:ln>
-            <a:noFill/>
-          </a:ln>
-          <a:effectLst/>
-        </p:spPr>
-        <p:style>
-          <a:lnRef idx="1">
-            <a:schemeClr val="accent1"/>
-          </a:lnRef>
-          <a:fillRef idx="3">
-            <a:schemeClr val="accent1"/>
-          </a:fillRef>
-          <a:effectRef idx="2">
-            <a:schemeClr val="accent1"/>
-          </a:effectRef>
-          <a:fontRef idx="minor">
-            <a:schemeClr val="lt1"/>
-          </a:fontRef>
-        </p:style>
-        <p:txBody>
-          <a:bodyPr rtlCol="0" anchor="ctr"/>
-          <a:lstStyle/>
-          <a:p>
-            <a:pPr algn="ctr"/>
-          </a:p>
-        </p:txBody>
-      </p:sp>
-      <p:sp>
-        <p:nvSpPr>
-          <p:cNvPr id="41" name="TextBox 40"/>
-          <p:cNvSpPr txBox="1"/>
-          <p:nvPr/>
-        </p:nvSpPr>
-        <p:spPr>
-          <a:xfrm>
-            <a:off x="3954709" y="5797296"/>
-            <a:ext cx="2286000" cy="329184"/>
-          </a:xfrm>
-          <a:prstGeom prst="rect">
-            <a:avLst/>
-          </a:prstGeom>
-          <a:noFill/>
-        </p:spPr>
-        <p:txBody>
-          <a:bodyPr wrap="square" lIns="0" rIns="0" tIns="0" bIns="0">
-            <a:spAutoFit/>
-          </a:bodyPr>
-          <a:lstStyle/>
-          <a:p>
-            <a:r>
-              <a:rPr sz="1000" b="0">
-                <a:solidFill>
-                  <a:srgbClr val="6B7082"/>
-                </a:solidFill>
-                <a:latin typeface="Helvetica Neue"/>
-              </a:rPr>
-              <a:t>20,813   (49 posts · 425 avg)</a:t>
             </a:r>
           </a:p>
         </p:txBody>
@@ -6949,7 +6951,7 @@
                 </a:solidFill>
                 <a:latin typeface="Helvetica Neue"/>
               </a:rPr>
-              <a:t>ALL-TIME TOP 10 POSTS</a:t>
+              <a:t>ALL-TIME CATEGORY RANKING · 2 OF 3</a:t>
             </a:r>
           </a:p>
         </p:txBody>
@@ -6983,7 +6985,7 @@
                 </a:solidFill>
                 <a:latin typeface="Georgia"/>
               </a:rPr>
-              <a:t>The peak performers since Jun 8</a:t>
+              <a:t>The rest of the field</a:t>
             </a:r>
           </a:p>
         </p:txBody>
@@ -7017,21 +7019,839 @@
                 </a:solidFill>
                 <a:latin typeface="Helvetica Neue"/>
               </a:rPr>
-              <a:t>Individual URLs ranked by views. These are the moments the audience shows up hardest.</a:t>
-            </a:r>
-          </a:p>
-        </p:txBody>
-      </p:sp>
-      <p:sp>
-        <p:nvSpPr>
-          <p:cNvPr id="6" name="Rectangle 5"/>
+              <a:t>Categories ranked #13 and below. Same bar scale as page 1, so lengths compare directly.</a:t>
+            </a:r>
+          </a:p>
+        </p:txBody>
+      </p:sp>
+      <p:sp>
+        <p:nvSpPr>
+          <p:cNvPr id="6" name="TextBox 5"/>
+          <p:cNvSpPr txBox="1"/>
+          <p:nvPr/>
+        </p:nvSpPr>
+        <p:spPr>
+          <a:xfrm>
+            <a:off x="731520" y="2176272"/>
+            <a:ext cx="2468880" cy="329184"/>
+          </a:xfrm>
+          <a:prstGeom prst="rect">
+            <a:avLst/>
+          </a:prstGeom>
+          <a:noFill/>
+        </p:spPr>
+        <p:txBody>
+          <a:bodyPr wrap="square" lIns="0" rIns="0" tIns="0" bIns="0">
+            <a:spAutoFit/>
+          </a:bodyPr>
+          <a:lstStyle/>
+          <a:p>
+            <a:r>
+              <a:rPr sz="1100" b="0">
+                <a:solidFill>
+                  <a:srgbClr val="141833"/>
+                </a:solidFill>
+                <a:latin typeface="Helvetica Neue"/>
+              </a:rPr>
+              <a:t>13. Community Events</a:t>
+            </a:r>
+          </a:p>
+        </p:txBody>
+      </p:sp>
+      <p:sp>
+        <p:nvSpPr>
+          <p:cNvPr id="7" name="Rectangle 6"/>
           <p:cNvSpPr/>
           <p:nvPr/>
         </p:nvSpPr>
         <p:spPr>
           <a:xfrm>
-            <a:off x="548640" y="2194560"/>
-            <a:ext cx="11064240" cy="384048"/>
+            <a:off x="3383280" y="2203704"/>
+            <a:ext cx="489694" cy="192024"/>
+          </a:xfrm>
+          <a:prstGeom prst="rect">
+            <a:avLst/>
+          </a:prstGeom>
+          <a:solidFill>
+            <a:srgbClr val="141833"/>
+          </a:solidFill>
+          <a:ln>
+            <a:noFill/>
+          </a:ln>
+          <a:effectLst/>
+        </p:spPr>
+        <p:style>
+          <a:lnRef idx="1">
+            <a:schemeClr val="accent1"/>
+          </a:lnRef>
+          <a:fillRef idx="3">
+            <a:schemeClr val="accent1"/>
+          </a:fillRef>
+          <a:effectRef idx="2">
+            <a:schemeClr val="accent1"/>
+          </a:effectRef>
+          <a:fontRef idx="minor">
+            <a:schemeClr val="lt1"/>
+          </a:fontRef>
+        </p:style>
+        <p:txBody>
+          <a:bodyPr rtlCol="0" anchor="ctr"/>
+          <a:lstStyle/>
+          <a:p>
+            <a:pPr algn="ctr"/>
+          </a:p>
+        </p:txBody>
+      </p:sp>
+      <p:sp>
+        <p:nvSpPr>
+          <p:cNvPr id="8" name="TextBox 7"/>
+          <p:cNvSpPr txBox="1"/>
+          <p:nvPr/>
+        </p:nvSpPr>
+        <p:spPr>
+          <a:xfrm>
+            <a:off x="3964414" y="2176272"/>
+            <a:ext cx="2286000" cy="329184"/>
+          </a:xfrm>
+          <a:prstGeom prst="rect">
+            <a:avLst/>
+          </a:prstGeom>
+          <a:noFill/>
+        </p:spPr>
+        <p:txBody>
+          <a:bodyPr wrap="square" lIns="0" rIns="0" tIns="0" bIns="0">
+            <a:spAutoFit/>
+          </a:bodyPr>
+          <a:lstStyle/>
+          <a:p>
+            <a:r>
+              <a:rPr sz="1000" b="0">
+                <a:solidFill>
+                  <a:srgbClr val="6B7082"/>
+                </a:solidFill>
+                <a:latin typeface="Helvetica Neue"/>
+              </a:rPr>
+              <a:t>20,452   (26 posts · 787 avg)</a:t>
+            </a:r>
+          </a:p>
+        </p:txBody>
+      </p:sp>
+      <p:sp>
+        <p:nvSpPr>
+          <p:cNvPr id="9" name="TextBox 8"/>
+          <p:cNvSpPr txBox="1"/>
+          <p:nvPr/>
+        </p:nvSpPr>
+        <p:spPr>
+          <a:xfrm>
+            <a:off x="731520" y="2505456"/>
+            <a:ext cx="2468880" cy="329184"/>
+          </a:xfrm>
+          <a:prstGeom prst="rect">
+            <a:avLst/>
+          </a:prstGeom>
+          <a:noFill/>
+        </p:spPr>
+        <p:txBody>
+          <a:bodyPr wrap="square" lIns="0" rIns="0" tIns="0" bIns="0">
+            <a:spAutoFit/>
+          </a:bodyPr>
+          <a:lstStyle/>
+          <a:p>
+            <a:r>
+              <a:rPr sz="1100" b="0">
+                <a:solidFill>
+                  <a:srgbClr val="141833"/>
+                </a:solidFill>
+                <a:latin typeface="Helvetica Neue"/>
+              </a:rPr>
+              <a:t>14. AI Fake News</a:t>
+            </a:r>
+          </a:p>
+        </p:txBody>
+      </p:sp>
+      <p:sp>
+        <p:nvSpPr>
+          <p:cNvPr id="10" name="Rectangle 9"/>
+          <p:cNvSpPr/>
+          <p:nvPr/>
+        </p:nvSpPr>
+        <p:spPr>
+          <a:xfrm>
+            <a:off x="3383280" y="2532888"/>
+            <a:ext cx="316199" cy="192024"/>
+          </a:xfrm>
+          <a:prstGeom prst="rect">
+            <a:avLst/>
+          </a:prstGeom>
+          <a:solidFill>
+            <a:srgbClr val="990011"/>
+          </a:solidFill>
+          <a:ln>
+            <a:noFill/>
+          </a:ln>
+          <a:effectLst/>
+        </p:spPr>
+        <p:style>
+          <a:lnRef idx="1">
+            <a:schemeClr val="accent1"/>
+          </a:lnRef>
+          <a:fillRef idx="3">
+            <a:schemeClr val="accent1"/>
+          </a:fillRef>
+          <a:effectRef idx="2">
+            <a:schemeClr val="accent1"/>
+          </a:effectRef>
+          <a:fontRef idx="minor">
+            <a:schemeClr val="lt1"/>
+          </a:fontRef>
+        </p:style>
+        <p:txBody>
+          <a:bodyPr rtlCol="0" anchor="ctr"/>
+          <a:lstStyle/>
+          <a:p>
+            <a:pPr algn="ctr"/>
+          </a:p>
+        </p:txBody>
+      </p:sp>
+      <p:sp>
+        <p:nvSpPr>
+          <p:cNvPr id="11" name="TextBox 10"/>
+          <p:cNvSpPr txBox="1"/>
+          <p:nvPr/>
+        </p:nvSpPr>
+        <p:spPr>
+          <a:xfrm>
+            <a:off x="3790919" y="2505456"/>
+            <a:ext cx="2286000" cy="329184"/>
+          </a:xfrm>
+          <a:prstGeom prst="rect">
+            <a:avLst/>
+          </a:prstGeom>
+          <a:noFill/>
+        </p:spPr>
+        <p:txBody>
+          <a:bodyPr wrap="square" lIns="0" rIns="0" tIns="0" bIns="0">
+            <a:spAutoFit/>
+          </a:bodyPr>
+          <a:lstStyle/>
+          <a:p>
+            <a:r>
+              <a:rPr sz="1000" b="0">
+                <a:solidFill>
+                  <a:srgbClr val="6B7082"/>
+                </a:solidFill>
+                <a:latin typeface="Helvetica Neue"/>
+              </a:rPr>
+              <a:t>13,206   (8 posts · 1,651 avg)</a:t>
+            </a:r>
+          </a:p>
+        </p:txBody>
+      </p:sp>
+      <p:sp>
+        <p:nvSpPr>
+          <p:cNvPr id="12" name="TextBox 11"/>
+          <p:cNvSpPr txBox="1"/>
+          <p:nvPr/>
+        </p:nvSpPr>
+        <p:spPr>
+          <a:xfrm>
+            <a:off x="731520" y="2834640"/>
+            <a:ext cx="2468880" cy="329184"/>
+          </a:xfrm>
+          <a:prstGeom prst="rect">
+            <a:avLst/>
+          </a:prstGeom>
+          <a:noFill/>
+        </p:spPr>
+        <p:txBody>
+          <a:bodyPr wrap="square" lIns="0" rIns="0" tIns="0" bIns="0">
+            <a:spAutoFit/>
+          </a:bodyPr>
+          <a:lstStyle/>
+          <a:p>
+            <a:r>
+              <a:rPr sz="1100" b="0">
+                <a:solidFill>
+                  <a:srgbClr val="141833"/>
+                </a:solidFill>
+                <a:latin typeface="Helvetica Neue"/>
+              </a:rPr>
+              <a:t>15. Lisette Scandal</a:t>
+            </a:r>
+          </a:p>
+        </p:txBody>
+      </p:sp>
+      <p:sp>
+        <p:nvSpPr>
+          <p:cNvPr id="13" name="Rectangle 12"/>
+          <p:cNvSpPr/>
+          <p:nvPr/>
+        </p:nvSpPr>
+        <p:spPr>
+          <a:xfrm>
+            <a:off x="3383280" y="2862072"/>
+            <a:ext cx="299750" cy="192024"/>
+          </a:xfrm>
+          <a:prstGeom prst="rect">
+            <a:avLst/>
+          </a:prstGeom>
+          <a:solidFill>
+            <a:srgbClr val="990011"/>
+          </a:solidFill>
+          <a:ln>
+            <a:noFill/>
+          </a:ln>
+          <a:effectLst/>
+        </p:spPr>
+        <p:style>
+          <a:lnRef idx="1">
+            <a:schemeClr val="accent1"/>
+          </a:lnRef>
+          <a:fillRef idx="3">
+            <a:schemeClr val="accent1"/>
+          </a:fillRef>
+          <a:effectRef idx="2">
+            <a:schemeClr val="accent1"/>
+          </a:effectRef>
+          <a:fontRef idx="minor">
+            <a:schemeClr val="lt1"/>
+          </a:fontRef>
+        </p:style>
+        <p:txBody>
+          <a:bodyPr rtlCol="0" anchor="ctr"/>
+          <a:lstStyle/>
+          <a:p>
+            <a:pPr algn="ctr"/>
+          </a:p>
+        </p:txBody>
+      </p:sp>
+      <p:sp>
+        <p:nvSpPr>
+          <p:cNvPr id="14" name="TextBox 13"/>
+          <p:cNvSpPr txBox="1"/>
+          <p:nvPr/>
+        </p:nvSpPr>
+        <p:spPr>
+          <a:xfrm>
+            <a:off x="3774470" y="2834640"/>
+            <a:ext cx="2286000" cy="329184"/>
+          </a:xfrm>
+          <a:prstGeom prst="rect">
+            <a:avLst/>
+          </a:prstGeom>
+          <a:noFill/>
+        </p:spPr>
+        <p:txBody>
+          <a:bodyPr wrap="square" lIns="0" rIns="0" tIns="0" bIns="0">
+            <a:spAutoFit/>
+          </a:bodyPr>
+          <a:lstStyle/>
+          <a:p>
+            <a:r>
+              <a:rPr sz="1000" b="0">
+                <a:solidFill>
+                  <a:srgbClr val="6B7082"/>
+                </a:solidFill>
+                <a:latin typeface="Helvetica Neue"/>
+              </a:rPr>
+              <a:t>12,519   (12 posts · 1,043 avg)</a:t>
+            </a:r>
+          </a:p>
+        </p:txBody>
+      </p:sp>
+      <p:sp>
+        <p:nvSpPr>
+          <p:cNvPr id="15" name="TextBox 14"/>
+          <p:cNvSpPr txBox="1"/>
+          <p:nvPr/>
+        </p:nvSpPr>
+        <p:spPr>
+          <a:xfrm>
+            <a:off x="731520" y="3163824"/>
+            <a:ext cx="2468880" cy="329184"/>
+          </a:xfrm>
+          <a:prstGeom prst="rect">
+            <a:avLst/>
+          </a:prstGeom>
+          <a:noFill/>
+        </p:spPr>
+        <p:txBody>
+          <a:bodyPr wrap="square" lIns="0" rIns="0" tIns="0" bIns="0">
+            <a:spAutoFit/>
+          </a:bodyPr>
+          <a:lstStyle/>
+          <a:p>
+            <a:r>
+              <a:rPr sz="1100" b="0">
+                <a:solidFill>
+                  <a:srgbClr val="141833"/>
+                </a:solidFill>
+                <a:latin typeface="Helvetica Neue"/>
+              </a:rPr>
+              <a:t>16. FIFA — Critique</a:t>
+            </a:r>
+          </a:p>
+        </p:txBody>
+      </p:sp>
+      <p:sp>
+        <p:nvSpPr>
+          <p:cNvPr id="16" name="Rectangle 15"/>
+          <p:cNvSpPr/>
+          <p:nvPr/>
+        </p:nvSpPr>
+        <p:spPr>
+          <a:xfrm>
+            <a:off x="3383280" y="3191256"/>
+            <a:ext cx="296373" cy="192024"/>
+          </a:xfrm>
+          <a:prstGeom prst="rect">
+            <a:avLst/>
+          </a:prstGeom>
+          <a:solidFill>
+            <a:srgbClr val="6B7082"/>
+          </a:solidFill>
+          <a:ln>
+            <a:noFill/>
+          </a:ln>
+          <a:effectLst/>
+        </p:spPr>
+        <p:style>
+          <a:lnRef idx="1">
+            <a:schemeClr val="accent1"/>
+          </a:lnRef>
+          <a:fillRef idx="3">
+            <a:schemeClr val="accent1"/>
+          </a:fillRef>
+          <a:effectRef idx="2">
+            <a:schemeClr val="accent1"/>
+          </a:effectRef>
+          <a:fontRef idx="minor">
+            <a:schemeClr val="lt1"/>
+          </a:fontRef>
+        </p:style>
+        <p:txBody>
+          <a:bodyPr rtlCol="0" anchor="ctr"/>
+          <a:lstStyle/>
+          <a:p>
+            <a:pPr algn="ctr"/>
+          </a:p>
+        </p:txBody>
+      </p:sp>
+      <p:sp>
+        <p:nvSpPr>
+          <p:cNvPr id="17" name="TextBox 16"/>
+          <p:cNvSpPr txBox="1"/>
+          <p:nvPr/>
+        </p:nvSpPr>
+        <p:spPr>
+          <a:xfrm>
+            <a:off x="3771093" y="3163824"/>
+            <a:ext cx="2286000" cy="329184"/>
+          </a:xfrm>
+          <a:prstGeom prst="rect">
+            <a:avLst/>
+          </a:prstGeom>
+          <a:noFill/>
+        </p:spPr>
+        <p:txBody>
+          <a:bodyPr wrap="square" lIns="0" rIns="0" tIns="0" bIns="0">
+            <a:spAutoFit/>
+          </a:bodyPr>
+          <a:lstStyle/>
+          <a:p>
+            <a:r>
+              <a:rPr sz="1000" b="0">
+                <a:solidFill>
+                  <a:srgbClr val="6B7082"/>
+                </a:solidFill>
+                <a:latin typeface="Helvetica Neue"/>
+              </a:rPr>
+              <a:t>12,378   (10 posts · 1,238 avg)</a:t>
+            </a:r>
+          </a:p>
+        </p:txBody>
+      </p:sp>
+      <p:sp>
+        <p:nvSpPr>
+          <p:cNvPr id="18" name="TextBox 17"/>
+          <p:cNvSpPr txBox="1"/>
+          <p:nvPr/>
+        </p:nvSpPr>
+        <p:spPr>
+          <a:xfrm>
+            <a:off x="731520" y="3493008"/>
+            <a:ext cx="2468880" cy="329184"/>
+          </a:xfrm>
+          <a:prstGeom prst="rect">
+            <a:avLst/>
+          </a:prstGeom>
+          <a:noFill/>
+        </p:spPr>
+        <p:txBody>
+          <a:bodyPr wrap="square" lIns="0" rIns="0" tIns="0" bIns="0">
+            <a:spAutoFit/>
+          </a:bodyPr>
+          <a:lstStyle/>
+          <a:p>
+            <a:r>
+              <a:rPr sz="1100" b="0">
+                <a:solidFill>
+                  <a:srgbClr val="141833"/>
+                </a:solidFill>
+                <a:latin typeface="Helvetica Neue"/>
+              </a:rPr>
+              <a:t>17. Sports</a:t>
+            </a:r>
+          </a:p>
+        </p:txBody>
+      </p:sp>
+      <p:sp>
+        <p:nvSpPr>
+          <p:cNvPr id="19" name="Rectangle 18"/>
+          <p:cNvSpPr/>
+          <p:nvPr/>
+        </p:nvSpPr>
+        <p:spPr>
+          <a:xfrm>
+            <a:off x="3383280" y="3520440"/>
+            <a:ext cx="290220" cy="192024"/>
+          </a:xfrm>
+          <a:prstGeom prst="rect">
+            <a:avLst/>
+          </a:prstGeom>
+          <a:solidFill>
+            <a:srgbClr val="6B7082"/>
+          </a:solidFill>
+          <a:ln>
+            <a:noFill/>
+          </a:ln>
+          <a:effectLst/>
+        </p:spPr>
+        <p:style>
+          <a:lnRef idx="1">
+            <a:schemeClr val="accent1"/>
+          </a:lnRef>
+          <a:fillRef idx="3">
+            <a:schemeClr val="accent1"/>
+          </a:fillRef>
+          <a:effectRef idx="2">
+            <a:schemeClr val="accent1"/>
+          </a:effectRef>
+          <a:fontRef idx="minor">
+            <a:schemeClr val="lt1"/>
+          </a:fontRef>
+        </p:style>
+        <p:txBody>
+          <a:bodyPr rtlCol="0" anchor="ctr"/>
+          <a:lstStyle/>
+          <a:p>
+            <a:pPr algn="ctr"/>
+          </a:p>
+        </p:txBody>
+      </p:sp>
+      <p:sp>
+        <p:nvSpPr>
+          <p:cNvPr id="20" name="TextBox 19"/>
+          <p:cNvSpPr txBox="1"/>
+          <p:nvPr/>
+        </p:nvSpPr>
+        <p:spPr>
+          <a:xfrm>
+            <a:off x="3764940" y="3493008"/>
+            <a:ext cx="2286000" cy="329184"/>
+          </a:xfrm>
+          <a:prstGeom prst="rect">
+            <a:avLst/>
+          </a:prstGeom>
+          <a:noFill/>
+        </p:spPr>
+        <p:txBody>
+          <a:bodyPr wrap="square" lIns="0" rIns="0" tIns="0" bIns="0">
+            <a:spAutoFit/>
+          </a:bodyPr>
+          <a:lstStyle/>
+          <a:p>
+            <a:r>
+              <a:rPr sz="1000" b="0">
+                <a:solidFill>
+                  <a:srgbClr val="6B7082"/>
+                </a:solidFill>
+                <a:latin typeface="Helvetica Neue"/>
+              </a:rPr>
+              <a:t>12,121   (16 posts · 758 avg)</a:t>
+            </a:r>
+          </a:p>
+        </p:txBody>
+      </p:sp>
+      <p:sp>
+        <p:nvSpPr>
+          <p:cNvPr id="21" name="TextBox 20"/>
+          <p:cNvSpPr txBox="1"/>
+          <p:nvPr/>
+        </p:nvSpPr>
+        <p:spPr>
+          <a:xfrm>
+            <a:off x="731520" y="3822192"/>
+            <a:ext cx="2468880" cy="329184"/>
+          </a:xfrm>
+          <a:prstGeom prst="rect">
+            <a:avLst/>
+          </a:prstGeom>
+          <a:noFill/>
+        </p:spPr>
+        <p:txBody>
+          <a:bodyPr wrap="square" lIns="0" rIns="0" tIns="0" bIns="0">
+            <a:spAutoFit/>
+          </a:bodyPr>
+          <a:lstStyle/>
+          <a:p>
+            <a:r>
+              <a:rPr sz="1100" b="0">
+                <a:solidFill>
+                  <a:srgbClr val="141833"/>
+                </a:solidFill>
+                <a:latin typeface="Helvetica Neue"/>
+              </a:rPr>
+              <a:t>18. Resident Highlight</a:t>
+            </a:r>
+          </a:p>
+        </p:txBody>
+      </p:sp>
+      <p:sp>
+        <p:nvSpPr>
+          <p:cNvPr id="22" name="Rectangle 21"/>
+          <p:cNvSpPr/>
+          <p:nvPr/>
+        </p:nvSpPr>
+        <p:spPr>
+          <a:xfrm>
+            <a:off x="3383280" y="3849624"/>
+            <a:ext cx="281121" cy="192024"/>
+          </a:xfrm>
+          <a:prstGeom prst="rect">
+            <a:avLst/>
+          </a:prstGeom>
+          <a:solidFill>
+            <a:srgbClr val="1B7A43"/>
+          </a:solidFill>
+          <a:ln>
+            <a:noFill/>
+          </a:ln>
+          <a:effectLst/>
+        </p:spPr>
+        <p:style>
+          <a:lnRef idx="1">
+            <a:schemeClr val="accent1"/>
+          </a:lnRef>
+          <a:fillRef idx="3">
+            <a:schemeClr val="accent1"/>
+          </a:fillRef>
+          <a:effectRef idx="2">
+            <a:schemeClr val="accent1"/>
+          </a:effectRef>
+          <a:fontRef idx="minor">
+            <a:schemeClr val="lt1"/>
+          </a:fontRef>
+        </p:style>
+        <p:txBody>
+          <a:bodyPr rtlCol="0" anchor="ctr"/>
+          <a:lstStyle/>
+          <a:p>
+            <a:pPr algn="ctr"/>
+          </a:p>
+        </p:txBody>
+      </p:sp>
+      <p:sp>
+        <p:nvSpPr>
+          <p:cNvPr id="23" name="TextBox 22"/>
+          <p:cNvSpPr txBox="1"/>
+          <p:nvPr/>
+        </p:nvSpPr>
+        <p:spPr>
+          <a:xfrm>
+            <a:off x="3755841" y="3822192"/>
+            <a:ext cx="2286000" cy="329184"/>
+          </a:xfrm>
+          <a:prstGeom prst="rect">
+            <a:avLst/>
+          </a:prstGeom>
+          <a:noFill/>
+        </p:spPr>
+        <p:txBody>
+          <a:bodyPr wrap="square" lIns="0" rIns="0" tIns="0" bIns="0">
+            <a:spAutoFit/>
+          </a:bodyPr>
+          <a:lstStyle/>
+          <a:p>
+            <a:r>
+              <a:rPr sz="1000" b="0">
+                <a:solidFill>
+                  <a:srgbClr val="6B7082"/>
+                </a:solidFill>
+                <a:latin typeface="Helvetica Neue"/>
+              </a:rPr>
+              <a:t>11,741   (13 posts · 903 avg)</a:t>
+            </a:r>
+          </a:p>
+        </p:txBody>
+      </p:sp>
+      <p:sp>
+        <p:nvSpPr>
+          <p:cNvPr id="24" name="TextBox 23"/>
+          <p:cNvSpPr txBox="1"/>
+          <p:nvPr/>
+        </p:nvSpPr>
+        <p:spPr>
+          <a:xfrm>
+            <a:off x="731520" y="4151376"/>
+            <a:ext cx="2468880" cy="329184"/>
+          </a:xfrm>
+          <a:prstGeom prst="rect">
+            <a:avLst/>
+          </a:prstGeom>
+          <a:noFill/>
+        </p:spPr>
+        <p:txBody>
+          <a:bodyPr wrap="square" lIns="0" rIns="0" tIns="0" bIns="0">
+            <a:spAutoFit/>
+          </a:bodyPr>
+          <a:lstStyle/>
+          <a:p>
+            <a:r>
+              <a:rPr sz="1100" b="0">
+                <a:solidFill>
+                  <a:srgbClr val="141833"/>
+                </a:solidFill>
+                <a:latin typeface="Helvetica Neue"/>
+              </a:rPr>
+              <a:t>19. Downtown Nightlife</a:t>
+            </a:r>
+          </a:p>
+        </p:txBody>
+      </p:sp>
+      <p:sp>
+        <p:nvSpPr>
+          <p:cNvPr id="25" name="Rectangle 24"/>
+          <p:cNvSpPr/>
+          <p:nvPr/>
+        </p:nvSpPr>
+        <p:spPr>
+          <a:xfrm>
+            <a:off x="3383280" y="4178807"/>
+            <a:ext cx="280331" cy="192024"/>
+          </a:xfrm>
+          <a:prstGeom prst="rect">
+            <a:avLst/>
+          </a:prstGeom>
+          <a:solidFill>
+            <a:srgbClr val="990011"/>
+          </a:solidFill>
+          <a:ln>
+            <a:noFill/>
+          </a:ln>
+          <a:effectLst/>
+        </p:spPr>
+        <p:style>
+          <a:lnRef idx="1">
+            <a:schemeClr val="accent1"/>
+          </a:lnRef>
+          <a:fillRef idx="3">
+            <a:schemeClr val="accent1"/>
+          </a:fillRef>
+          <a:effectRef idx="2">
+            <a:schemeClr val="accent1"/>
+          </a:effectRef>
+          <a:fontRef idx="minor">
+            <a:schemeClr val="lt1"/>
+          </a:fontRef>
+        </p:style>
+        <p:txBody>
+          <a:bodyPr rtlCol="0" anchor="ctr"/>
+          <a:lstStyle/>
+          <a:p>
+            <a:pPr algn="ctr"/>
+          </a:p>
+        </p:txBody>
+      </p:sp>
+      <p:sp>
+        <p:nvSpPr>
+          <p:cNvPr id="26" name="TextBox 25"/>
+          <p:cNvSpPr txBox="1"/>
+          <p:nvPr/>
+        </p:nvSpPr>
+        <p:spPr>
+          <a:xfrm>
+            <a:off x="3755051" y="4151376"/>
+            <a:ext cx="2286000" cy="329184"/>
+          </a:xfrm>
+          <a:prstGeom prst="rect">
+            <a:avLst/>
+          </a:prstGeom>
+          <a:noFill/>
+        </p:spPr>
+        <p:txBody>
+          <a:bodyPr wrap="square" lIns="0" rIns="0" tIns="0" bIns="0">
+            <a:spAutoFit/>
+          </a:bodyPr>
+          <a:lstStyle/>
+          <a:p>
+            <a:r>
+              <a:rPr sz="1000" b="0">
+                <a:solidFill>
+                  <a:srgbClr val="6B7082"/>
+                </a:solidFill>
+                <a:latin typeface="Helvetica Neue"/>
+              </a:rPr>
+              <a:t>11,708   (7 posts · 1,673 avg)</a:t>
+            </a:r>
+          </a:p>
+        </p:txBody>
+      </p:sp>
+      <p:sp>
+        <p:nvSpPr>
+          <p:cNvPr id="27" name="TextBox 26"/>
+          <p:cNvSpPr txBox="1"/>
+          <p:nvPr/>
+        </p:nvSpPr>
+        <p:spPr>
+          <a:xfrm>
+            <a:off x="731520" y="4480560"/>
+            <a:ext cx="2468880" cy="329184"/>
+          </a:xfrm>
+          <a:prstGeom prst="rect">
+            <a:avLst/>
+          </a:prstGeom>
+          <a:noFill/>
+        </p:spPr>
+        <p:txBody>
+          <a:bodyPr wrap="square" lIns="0" rIns="0" tIns="0" bIns="0">
+            <a:spAutoFit/>
+          </a:bodyPr>
+          <a:lstStyle/>
+          <a:p>
+            <a:r>
+              <a:rPr sz="1100" b="0">
+                <a:solidFill>
+                  <a:srgbClr val="141833"/>
+                </a:solidFill>
+                <a:latin typeface="Helvetica Neue"/>
+              </a:rPr>
+              <a:t>20. Legislation Watch</a:t>
+            </a:r>
+          </a:p>
+        </p:txBody>
+      </p:sp>
+      <p:sp>
+        <p:nvSpPr>
+          <p:cNvPr id="28" name="Rectangle 27"/>
+          <p:cNvSpPr/>
+          <p:nvPr/>
+        </p:nvSpPr>
+        <p:spPr>
+          <a:xfrm>
+            <a:off x="3383280" y="4507992"/>
+            <a:ext cx="260817" cy="192024"/>
           </a:xfrm>
           <a:prstGeom prst="rect">
             <a:avLst/>
@@ -7068,218 +7888,194 @@
       </p:sp>
       <p:sp>
         <p:nvSpPr>
-          <p:cNvPr id="7" name="TextBox 6"/>
-          <p:cNvSpPr txBox="1"/>
-          <p:nvPr/>
-        </p:nvSpPr>
-        <p:spPr>
-          <a:xfrm>
-            <a:off x="640080" y="2267712"/>
-            <a:ext cx="274320" cy="274320"/>
-          </a:xfrm>
-          <a:prstGeom prst="rect">
-            <a:avLst/>
-          </a:prstGeom>
-          <a:noFill/>
-        </p:spPr>
-        <p:txBody>
-          <a:bodyPr wrap="square" lIns="0" rIns="0" tIns="0" bIns="0">
-            <a:spAutoFit/>
-          </a:bodyPr>
-          <a:lstStyle/>
-          <a:p>
-            <a:r>
-              <a:rPr sz="1000" b="1">
-                <a:solidFill>
-                  <a:srgbClr val="FCF6F5"/>
-                </a:solidFill>
-                <a:latin typeface="Helvetica Neue"/>
-              </a:rPr>
-              <a:t>#</a:t>
-            </a:r>
-          </a:p>
-        </p:txBody>
-      </p:sp>
-      <p:sp>
-        <p:nvSpPr>
-          <p:cNvPr id="8" name="TextBox 7"/>
-          <p:cNvSpPr txBox="1"/>
-          <p:nvPr/>
-        </p:nvSpPr>
-        <p:spPr>
-          <a:xfrm>
-            <a:off x="1097280" y="2267712"/>
-            <a:ext cx="731520" cy="274320"/>
-          </a:xfrm>
-          <a:prstGeom prst="rect">
-            <a:avLst/>
-          </a:prstGeom>
-          <a:noFill/>
-        </p:spPr>
-        <p:txBody>
-          <a:bodyPr wrap="square" lIns="0" rIns="0" tIns="0" bIns="0">
-            <a:spAutoFit/>
-          </a:bodyPr>
-          <a:lstStyle/>
-          <a:p>
-            <a:r>
-              <a:rPr sz="1000" b="1">
-                <a:solidFill>
-                  <a:srgbClr val="FCF6F5"/>
-                </a:solidFill>
-                <a:latin typeface="Helvetica Neue"/>
-              </a:rPr>
-              <a:t>PLATFORM</a:t>
-            </a:r>
-          </a:p>
-        </p:txBody>
-      </p:sp>
-      <p:sp>
-        <p:nvSpPr>
-          <p:cNvPr id="9" name="TextBox 8"/>
-          <p:cNvSpPr txBox="1"/>
-          <p:nvPr/>
-        </p:nvSpPr>
-        <p:spPr>
-          <a:xfrm>
-            <a:off x="2011680" y="2267712"/>
-            <a:ext cx="5669280" cy="274320"/>
-          </a:xfrm>
-          <a:prstGeom prst="rect">
-            <a:avLst/>
-          </a:prstGeom>
-          <a:noFill/>
-        </p:spPr>
-        <p:txBody>
-          <a:bodyPr wrap="square" lIns="0" rIns="0" tIns="0" bIns="0">
-            <a:spAutoFit/>
-          </a:bodyPr>
-          <a:lstStyle/>
-          <a:p>
-            <a:r>
-              <a:rPr sz="1000" b="1">
-                <a:solidFill>
-                  <a:srgbClr val="FCF6F5"/>
-                </a:solidFill>
-                <a:latin typeface="Helvetica Neue"/>
-              </a:rPr>
-              <a:t>POST</a:t>
-            </a:r>
-          </a:p>
-        </p:txBody>
-      </p:sp>
-      <p:sp>
-        <p:nvSpPr>
-          <p:cNvPr id="10" name="TextBox 9"/>
-          <p:cNvSpPr txBox="1"/>
-          <p:nvPr/>
-        </p:nvSpPr>
-        <p:spPr>
-          <a:xfrm>
-            <a:off x="7863840" y="2267712"/>
-            <a:ext cx="1097280" cy="274320"/>
-          </a:xfrm>
-          <a:prstGeom prst="rect">
-            <a:avLst/>
-          </a:prstGeom>
-          <a:noFill/>
-        </p:spPr>
-        <p:txBody>
-          <a:bodyPr wrap="square" lIns="0" rIns="0" tIns="0" bIns="0">
-            <a:spAutoFit/>
-          </a:bodyPr>
-          <a:lstStyle/>
-          <a:p>
-            <a:r>
-              <a:rPr sz="1000" b="1">
-                <a:solidFill>
-                  <a:srgbClr val="FCF6F5"/>
-                </a:solidFill>
-                <a:latin typeface="Helvetica Neue"/>
-              </a:rPr>
-              <a:t>VIEWS</a:t>
-            </a:r>
-          </a:p>
-        </p:txBody>
-      </p:sp>
-      <p:sp>
-        <p:nvSpPr>
-          <p:cNvPr id="11" name="TextBox 10"/>
-          <p:cNvSpPr txBox="1"/>
-          <p:nvPr/>
-        </p:nvSpPr>
-        <p:spPr>
-          <a:xfrm>
-            <a:off x="9144000" y="2267712"/>
-            <a:ext cx="1097280" cy="274320"/>
-          </a:xfrm>
-          <a:prstGeom prst="rect">
-            <a:avLst/>
-          </a:prstGeom>
-          <a:noFill/>
-        </p:spPr>
-        <p:txBody>
-          <a:bodyPr wrap="square" lIns="0" rIns="0" tIns="0" bIns="0">
-            <a:spAutoFit/>
-          </a:bodyPr>
-          <a:lstStyle/>
-          <a:p>
-            <a:r>
-              <a:rPr sz="1000" b="1">
-                <a:solidFill>
-                  <a:srgbClr val="FCF6F5"/>
-                </a:solidFill>
-                <a:latin typeface="Helvetica Neue"/>
-              </a:rPr>
-              <a:t>LIKES</a:t>
-            </a:r>
-          </a:p>
-        </p:txBody>
-      </p:sp>
-      <p:sp>
-        <p:nvSpPr>
-          <p:cNvPr id="12" name="TextBox 11"/>
-          <p:cNvSpPr txBox="1"/>
-          <p:nvPr/>
-        </p:nvSpPr>
-        <p:spPr>
-          <a:xfrm>
-            <a:off x="10424160" y="2267712"/>
-            <a:ext cx="1097280" cy="274320"/>
-          </a:xfrm>
-          <a:prstGeom prst="rect">
-            <a:avLst/>
-          </a:prstGeom>
-          <a:noFill/>
-        </p:spPr>
-        <p:txBody>
-          <a:bodyPr wrap="square" lIns="0" rIns="0" tIns="0" bIns="0">
-            <a:spAutoFit/>
-          </a:bodyPr>
-          <a:lstStyle/>
-          <a:p>
-            <a:r>
-              <a:rPr sz="1000" b="1">
-                <a:solidFill>
-                  <a:srgbClr val="FCF6F5"/>
-                </a:solidFill>
-                <a:latin typeface="Helvetica Neue"/>
-              </a:rPr>
-              <a:t>CATEGORY</a:t>
-            </a:r>
-          </a:p>
-        </p:txBody>
-      </p:sp>
-      <p:sp>
-        <p:nvSpPr>
-          <p:cNvPr id="13" name="Rectangle 12"/>
+          <p:cNvPr id="29" name="TextBox 28"/>
+          <p:cNvSpPr txBox="1"/>
+          <p:nvPr/>
+        </p:nvSpPr>
+        <p:spPr>
+          <a:xfrm>
+            <a:off x="3735537" y="4480560"/>
+            <a:ext cx="2286000" cy="329184"/>
+          </a:xfrm>
+          <a:prstGeom prst="rect">
+            <a:avLst/>
+          </a:prstGeom>
+          <a:noFill/>
+        </p:spPr>
+        <p:txBody>
+          <a:bodyPr wrap="square" lIns="0" rIns="0" tIns="0" bIns="0">
+            <a:spAutoFit/>
+          </a:bodyPr>
+          <a:lstStyle/>
+          <a:p>
+            <a:r>
+              <a:rPr sz="1000" b="0">
+                <a:solidFill>
+                  <a:srgbClr val="6B7082"/>
+                </a:solidFill>
+                <a:latin typeface="Helvetica Neue"/>
+              </a:rPr>
+              <a:t>10,893   (25 posts · 436 avg)</a:t>
+            </a:r>
+          </a:p>
+        </p:txBody>
+      </p:sp>
+      <p:sp>
+        <p:nvSpPr>
+          <p:cNvPr id="30" name="TextBox 29"/>
+          <p:cNvSpPr txBox="1"/>
+          <p:nvPr/>
+        </p:nvSpPr>
+        <p:spPr>
+          <a:xfrm>
+            <a:off x="731520" y="4809744"/>
+            <a:ext cx="2468880" cy="329184"/>
+          </a:xfrm>
+          <a:prstGeom prst="rect">
+            <a:avLst/>
+          </a:prstGeom>
+          <a:noFill/>
+        </p:spPr>
+        <p:txBody>
+          <a:bodyPr wrap="square" lIns="0" rIns="0" tIns="0" bIns="0">
+            <a:spAutoFit/>
+          </a:bodyPr>
+          <a:lstStyle/>
+          <a:p>
+            <a:r>
+              <a:rPr sz="1100" b="0">
+                <a:solidFill>
+                  <a:srgbClr val="141833"/>
+                </a:solidFill>
+                <a:latin typeface="Helvetica Neue"/>
+              </a:rPr>
+              <a:t>21. State Policy</a:t>
+            </a:r>
+          </a:p>
+        </p:txBody>
+      </p:sp>
+      <p:sp>
+        <p:nvSpPr>
+          <p:cNvPr id="31" name="Rectangle 30"/>
           <p:cNvSpPr/>
           <p:nvPr/>
         </p:nvSpPr>
         <p:spPr>
           <a:xfrm>
-            <a:off x="548640" y="2578608"/>
-            <a:ext cx="54864" cy="384048"/>
+            <a:off x="3383280" y="4837176"/>
+            <a:ext cx="210895" cy="192024"/>
+          </a:xfrm>
+          <a:prstGeom prst="rect">
+            <a:avLst/>
+          </a:prstGeom>
+          <a:solidFill>
+            <a:srgbClr val="2F3C7E"/>
+          </a:solidFill>
+          <a:ln>
+            <a:noFill/>
+          </a:ln>
+          <a:effectLst/>
+        </p:spPr>
+        <p:style>
+          <a:lnRef idx="1">
+            <a:schemeClr val="accent1"/>
+          </a:lnRef>
+          <a:fillRef idx="3">
+            <a:schemeClr val="accent1"/>
+          </a:fillRef>
+          <a:effectRef idx="2">
+            <a:schemeClr val="accent1"/>
+          </a:effectRef>
+          <a:fontRef idx="minor">
+            <a:schemeClr val="lt1"/>
+          </a:fontRef>
+        </p:style>
+        <p:txBody>
+          <a:bodyPr rtlCol="0" anchor="ctr"/>
+          <a:lstStyle/>
+          <a:p>
+            <a:pPr algn="ctr"/>
+          </a:p>
+        </p:txBody>
+      </p:sp>
+      <p:sp>
+        <p:nvSpPr>
+          <p:cNvPr id="32" name="TextBox 31"/>
+          <p:cNvSpPr txBox="1"/>
+          <p:nvPr/>
+        </p:nvSpPr>
+        <p:spPr>
+          <a:xfrm>
+            <a:off x="3685615" y="4809744"/>
+            <a:ext cx="2286000" cy="329184"/>
+          </a:xfrm>
+          <a:prstGeom prst="rect">
+            <a:avLst/>
+          </a:prstGeom>
+          <a:noFill/>
+        </p:spPr>
+        <p:txBody>
+          <a:bodyPr wrap="square" lIns="0" rIns="0" tIns="0" bIns="0">
+            <a:spAutoFit/>
+          </a:bodyPr>
+          <a:lstStyle/>
+          <a:p>
+            <a:r>
+              <a:rPr sz="1000" b="0">
+                <a:solidFill>
+                  <a:srgbClr val="6B7082"/>
+                </a:solidFill>
+                <a:latin typeface="Helvetica Neue"/>
+              </a:rPr>
+              <a:t>8,808   (17 posts · 518 avg)</a:t>
+            </a:r>
+          </a:p>
+        </p:txBody>
+      </p:sp>
+      <p:sp>
+        <p:nvSpPr>
+          <p:cNvPr id="33" name="TextBox 32"/>
+          <p:cNvSpPr txBox="1"/>
+          <p:nvPr/>
+        </p:nvSpPr>
+        <p:spPr>
+          <a:xfrm>
+            <a:off x="731520" y="5138928"/>
+            <a:ext cx="2468880" cy="329184"/>
+          </a:xfrm>
+          <a:prstGeom prst="rect">
+            <a:avLst/>
+          </a:prstGeom>
+          <a:noFill/>
+        </p:spPr>
+        <p:txBody>
+          <a:bodyPr wrap="square" lIns="0" rIns="0" tIns="0" bIns="0">
+            <a:spAutoFit/>
+          </a:bodyPr>
+          <a:lstStyle/>
+          <a:p>
+            <a:r>
+              <a:rPr sz="1100" b="0">
+                <a:solidFill>
+                  <a:srgbClr val="141833"/>
+                </a:solidFill>
+                <a:latin typeface="Helvetica Neue"/>
+              </a:rPr>
+              <a:t>22. American Pride</a:t>
+            </a:r>
+          </a:p>
+        </p:txBody>
+      </p:sp>
+      <p:sp>
+        <p:nvSpPr>
+          <p:cNvPr id="34" name="Rectangle 33"/>
+          <p:cNvSpPr/>
+          <p:nvPr/>
+        </p:nvSpPr>
+        <p:spPr>
+          <a:xfrm>
+            <a:off x="3383280" y="5166359"/>
+            <a:ext cx="186017" cy="192024"/>
           </a:xfrm>
           <a:prstGeom prst="rect">
             <a:avLst/>
@@ -7316,6 +8112,1176 @@
       </p:sp>
       <p:sp>
         <p:nvSpPr>
+          <p:cNvPr id="35" name="TextBox 34"/>
+          <p:cNvSpPr txBox="1"/>
+          <p:nvPr/>
+        </p:nvSpPr>
+        <p:spPr>
+          <a:xfrm>
+            <a:off x="3660737" y="5138928"/>
+            <a:ext cx="2286000" cy="329184"/>
+          </a:xfrm>
+          <a:prstGeom prst="rect">
+            <a:avLst/>
+          </a:prstGeom>
+          <a:noFill/>
+        </p:spPr>
+        <p:txBody>
+          <a:bodyPr wrap="square" lIns="0" rIns="0" tIns="0" bIns="0">
+            <a:spAutoFit/>
+          </a:bodyPr>
+          <a:lstStyle/>
+          <a:p>
+            <a:r>
+              <a:rPr sz="1000" b="0">
+                <a:solidFill>
+                  <a:srgbClr val="6B7082"/>
+                </a:solidFill>
+                <a:latin typeface="Helvetica Neue"/>
+              </a:rPr>
+              <a:t>7,769   (15 posts · 518 avg)</a:t>
+            </a:r>
+          </a:p>
+        </p:txBody>
+      </p:sp>
+      <p:sp>
+        <p:nvSpPr>
+          <p:cNvPr id="36" name="TextBox 35"/>
+          <p:cNvSpPr txBox="1"/>
+          <p:nvPr/>
+        </p:nvSpPr>
+        <p:spPr>
+          <a:xfrm>
+            <a:off x="731520" y="5468112"/>
+            <a:ext cx="2468880" cy="329184"/>
+          </a:xfrm>
+          <a:prstGeom prst="rect">
+            <a:avLst/>
+          </a:prstGeom>
+          <a:noFill/>
+        </p:spPr>
+        <p:txBody>
+          <a:bodyPr wrap="square" lIns="0" rIns="0" tIns="0" bIns="0">
+            <a:spAutoFit/>
+          </a:bodyPr>
+          <a:lstStyle/>
+          <a:p>
+            <a:r>
+              <a:rPr sz="1100" b="0">
+                <a:solidFill>
+                  <a:srgbClr val="141833"/>
+                </a:solidFill>
+                <a:latin typeface="Helvetica Neue"/>
+              </a:rPr>
+              <a:t>23. ICE / Immigration</a:t>
+            </a:r>
+          </a:p>
+        </p:txBody>
+      </p:sp>
+      <p:sp>
+        <p:nvSpPr>
+          <p:cNvPr id="37" name="Rectangle 36"/>
+          <p:cNvSpPr/>
+          <p:nvPr/>
+        </p:nvSpPr>
+        <p:spPr>
+          <a:xfrm>
+            <a:off x="3383280" y="5495543"/>
+            <a:ext cx="161020" cy="192024"/>
+          </a:xfrm>
+          <a:prstGeom prst="rect">
+            <a:avLst/>
+          </a:prstGeom>
+          <a:solidFill>
+            <a:srgbClr val="990011"/>
+          </a:solidFill>
+          <a:ln>
+            <a:noFill/>
+          </a:ln>
+          <a:effectLst/>
+        </p:spPr>
+        <p:style>
+          <a:lnRef idx="1">
+            <a:schemeClr val="accent1"/>
+          </a:lnRef>
+          <a:fillRef idx="3">
+            <a:schemeClr val="accent1"/>
+          </a:fillRef>
+          <a:effectRef idx="2">
+            <a:schemeClr val="accent1"/>
+          </a:effectRef>
+          <a:fontRef idx="minor">
+            <a:schemeClr val="lt1"/>
+          </a:fontRef>
+        </p:style>
+        <p:txBody>
+          <a:bodyPr rtlCol="0" anchor="ctr"/>
+          <a:lstStyle/>
+          <a:p>
+            <a:pPr algn="ctr"/>
+          </a:p>
+        </p:txBody>
+      </p:sp>
+      <p:sp>
+        <p:nvSpPr>
+          <p:cNvPr id="38" name="TextBox 37"/>
+          <p:cNvSpPr txBox="1"/>
+          <p:nvPr/>
+        </p:nvSpPr>
+        <p:spPr>
+          <a:xfrm>
+            <a:off x="3635740" y="5468112"/>
+            <a:ext cx="2286000" cy="329184"/>
+          </a:xfrm>
+          <a:prstGeom prst="rect">
+            <a:avLst/>
+          </a:prstGeom>
+          <a:noFill/>
+        </p:spPr>
+        <p:txBody>
+          <a:bodyPr wrap="square" lIns="0" rIns="0" tIns="0" bIns="0">
+            <a:spAutoFit/>
+          </a:bodyPr>
+          <a:lstStyle/>
+          <a:p>
+            <a:r>
+              <a:rPr sz="1000" b="0">
+                <a:solidFill>
+                  <a:srgbClr val="6B7082"/>
+                </a:solidFill>
+                <a:latin typeface="Helvetica Neue"/>
+              </a:rPr>
+              <a:t>6,725   (5 posts · 1,345 avg)</a:t>
+            </a:r>
+          </a:p>
+        </p:txBody>
+      </p:sp>
+      <p:sp>
+        <p:nvSpPr>
+          <p:cNvPr id="39" name="TextBox 38"/>
+          <p:cNvSpPr txBox="1"/>
+          <p:nvPr/>
+        </p:nvSpPr>
+        <p:spPr>
+          <a:xfrm>
+            <a:off x="731520" y="5797296"/>
+            <a:ext cx="2468880" cy="329184"/>
+          </a:xfrm>
+          <a:prstGeom prst="rect">
+            <a:avLst/>
+          </a:prstGeom>
+          <a:noFill/>
+        </p:spPr>
+        <p:txBody>
+          <a:bodyPr wrap="square" lIns="0" rIns="0" tIns="0" bIns="0">
+            <a:spAutoFit/>
+          </a:bodyPr>
+          <a:lstStyle/>
+          <a:p>
+            <a:r>
+              <a:rPr sz="1100" b="0">
+                <a:solidFill>
+                  <a:srgbClr val="141833"/>
+                </a:solidFill>
+                <a:latin typeface="Helvetica Neue"/>
+              </a:rPr>
+              <a:t>24. Leadership &amp; Life</a:t>
+            </a:r>
+          </a:p>
+        </p:txBody>
+      </p:sp>
+      <p:sp>
+        <p:nvSpPr>
+          <p:cNvPr id="40" name="Rectangle 39"/>
+          <p:cNvSpPr/>
+          <p:nvPr/>
+        </p:nvSpPr>
+        <p:spPr>
+          <a:xfrm>
+            <a:off x="3383280" y="5824728"/>
+            <a:ext cx="144858" cy="192024"/>
+          </a:xfrm>
+          <a:prstGeom prst="rect">
+            <a:avLst/>
+          </a:prstGeom>
+          <a:solidFill>
+            <a:srgbClr val="2E86AB"/>
+          </a:solidFill>
+          <a:ln>
+            <a:noFill/>
+          </a:ln>
+          <a:effectLst/>
+        </p:spPr>
+        <p:style>
+          <a:lnRef idx="1">
+            <a:schemeClr val="accent1"/>
+          </a:lnRef>
+          <a:fillRef idx="3">
+            <a:schemeClr val="accent1"/>
+          </a:fillRef>
+          <a:effectRef idx="2">
+            <a:schemeClr val="accent1"/>
+          </a:effectRef>
+          <a:fontRef idx="minor">
+            <a:schemeClr val="lt1"/>
+          </a:fontRef>
+        </p:style>
+        <p:txBody>
+          <a:bodyPr rtlCol="0" anchor="ctr"/>
+          <a:lstStyle/>
+          <a:p>
+            <a:pPr algn="ctr"/>
+          </a:p>
+        </p:txBody>
+      </p:sp>
+      <p:sp>
+        <p:nvSpPr>
+          <p:cNvPr id="41" name="TextBox 40"/>
+          <p:cNvSpPr txBox="1"/>
+          <p:nvPr/>
+        </p:nvSpPr>
+        <p:spPr>
+          <a:xfrm>
+            <a:off x="3619578" y="5797296"/>
+            <a:ext cx="2286000" cy="329184"/>
+          </a:xfrm>
+          <a:prstGeom prst="rect">
+            <a:avLst/>
+          </a:prstGeom>
+          <a:noFill/>
+        </p:spPr>
+        <p:txBody>
+          <a:bodyPr wrap="square" lIns="0" rIns="0" tIns="0" bIns="0">
+            <a:spAutoFit/>
+          </a:bodyPr>
+          <a:lstStyle/>
+          <a:p>
+            <a:r>
+              <a:rPr sz="1000" b="0">
+                <a:solidFill>
+                  <a:srgbClr val="6B7082"/>
+                </a:solidFill>
+                <a:latin typeface="Helvetica Neue"/>
+              </a:rPr>
+              <a:t>6,050   (21 posts · 288 avg)</a:t>
+            </a:r>
+          </a:p>
+        </p:txBody>
+      </p:sp>
+      <p:sp>
+        <p:nvSpPr>
+          <p:cNvPr id="42" name="TextBox 41"/>
+          <p:cNvSpPr txBox="1"/>
+          <p:nvPr/>
+        </p:nvSpPr>
+        <p:spPr>
+          <a:xfrm>
+            <a:off x="731520" y="6263640"/>
+            <a:ext cx="10698480" cy="457200"/>
+          </a:xfrm>
+          <a:prstGeom prst="rect">
+            <a:avLst/>
+          </a:prstGeom>
+          <a:noFill/>
+        </p:spPr>
+        <p:txBody>
+          <a:bodyPr wrap="square" lIns="0" rIns="0" tIns="0" bIns="0">
+            <a:spAutoFit/>
+          </a:bodyPr>
+          <a:lstStyle/>
+          <a:p>
+            <a:r>
+              <a:rPr sz="1200" b="1">
+                <a:solidFill>
+                  <a:srgbClr val="141833"/>
+                </a:solidFill>
+                <a:latin typeface="Helvetica Neue"/>
+              </a:rPr>
+              <a:t>Smaller lanes aren't failures — they're where a single breakout post can move the whole ranking.</a:t>
+            </a:r>
+          </a:p>
+        </p:txBody>
+      </p:sp>
+    </p:spTree>
+  </p:cSld>
+  <p:clrMapOvr>
+    <a:masterClrMapping/>
+  </p:clrMapOvr>
+</p:sld>
+</file>
+
+<file path=ppt/slides/slide6.xml><?xml version="1.0" encoding="utf-8"?>
+<p:sld xmlns:a="http://schemas.openxmlformats.org/drawingml/2006/main" xmlns:p="http://schemas.openxmlformats.org/presentationml/2006/main" xmlns:r="http://schemas.openxmlformats.org/officeDocument/2006/relationships">
+  <p:cSld>
+    <p:spTree>
+      <p:nvGrpSpPr>
+        <p:cNvPr id="1" name=""/>
+        <p:cNvGrpSpPr/>
+        <p:nvPr/>
+      </p:nvGrpSpPr>
+      <p:grpSpPr/>
+      <p:sp>
+        <p:nvSpPr>
+          <p:cNvPr id="2" name="Rectangle 1"/>
+          <p:cNvSpPr/>
+          <p:nvPr/>
+        </p:nvSpPr>
+        <p:spPr>
+          <a:xfrm>
+            <a:off x="0" y="0"/>
+            <a:ext cx="12191695" cy="6858000"/>
+          </a:xfrm>
+          <a:prstGeom prst="rect">
+            <a:avLst/>
+          </a:prstGeom>
+          <a:solidFill>
+            <a:srgbClr val="FCF6F5"/>
+          </a:solidFill>
+          <a:ln>
+            <a:noFill/>
+          </a:ln>
+          <a:effectLst/>
+        </p:spPr>
+        <p:style>
+          <a:lnRef idx="1">
+            <a:schemeClr val="accent1"/>
+          </a:lnRef>
+          <a:fillRef idx="3">
+            <a:schemeClr val="accent1"/>
+          </a:fillRef>
+          <a:effectRef idx="2">
+            <a:schemeClr val="accent1"/>
+          </a:effectRef>
+          <a:fontRef idx="minor">
+            <a:schemeClr val="lt1"/>
+          </a:fontRef>
+        </p:style>
+        <p:txBody>
+          <a:bodyPr rtlCol="0" anchor="ctr"/>
+          <a:lstStyle/>
+          <a:p>
+            <a:pPr algn="ctr"/>
+          </a:p>
+        </p:txBody>
+      </p:sp>
+      <p:sp>
+        <p:nvSpPr>
+          <p:cNvPr id="3" name="TextBox 2"/>
+          <p:cNvSpPr txBox="1"/>
+          <p:nvPr/>
+        </p:nvSpPr>
+        <p:spPr>
+          <a:xfrm>
+            <a:off x="731520" y="457200"/>
+            <a:ext cx="10698480" cy="365760"/>
+          </a:xfrm>
+          <a:prstGeom prst="rect">
+            <a:avLst/>
+          </a:prstGeom>
+          <a:noFill/>
+        </p:spPr>
+        <p:txBody>
+          <a:bodyPr wrap="square" lIns="0" rIns="0" tIns="0" bIns="0">
+            <a:spAutoFit/>
+          </a:bodyPr>
+          <a:lstStyle/>
+          <a:p>
+            <a:r>
+              <a:rPr sz="1200" b="1">
+                <a:solidFill>
+                  <a:srgbClr val="990011"/>
+                </a:solidFill>
+                <a:latin typeface="Helvetica Neue"/>
+              </a:rPr>
+              <a:t>ALL-TIME CATEGORY RANKING · 3 OF 3</a:t>
+            </a:r>
+          </a:p>
+        </p:txBody>
+      </p:sp>
+      <p:sp>
+        <p:nvSpPr>
+          <p:cNvPr id="4" name="TextBox 3"/>
+          <p:cNvSpPr txBox="1"/>
+          <p:nvPr/>
+        </p:nvSpPr>
+        <p:spPr>
+          <a:xfrm>
+            <a:off x="731520" y="822960"/>
+            <a:ext cx="10698480" cy="822960"/>
+          </a:xfrm>
+          <a:prstGeom prst="rect">
+            <a:avLst/>
+          </a:prstGeom>
+          <a:noFill/>
+        </p:spPr>
+        <p:txBody>
+          <a:bodyPr wrap="square" lIns="0" rIns="0" tIns="0" bIns="0">
+            <a:spAutoFit/>
+          </a:bodyPr>
+          <a:lstStyle/>
+          <a:p>
+            <a:r>
+              <a:rPr sz="3000" b="1">
+                <a:solidFill>
+                  <a:srgbClr val="2F3C7E"/>
+                </a:solidFill>
+                <a:latin typeface="Georgia"/>
+              </a:rPr>
+              <a:t>The rest of the field</a:t>
+            </a:r>
+          </a:p>
+        </p:txBody>
+      </p:sp>
+      <p:sp>
+        <p:nvSpPr>
+          <p:cNvPr id="5" name="TextBox 4"/>
+          <p:cNvSpPr txBox="1"/>
+          <p:nvPr/>
+        </p:nvSpPr>
+        <p:spPr>
+          <a:xfrm>
+            <a:off x="731520" y="1600200"/>
+            <a:ext cx="10698480" cy="365760"/>
+          </a:xfrm>
+          <a:prstGeom prst="rect">
+            <a:avLst/>
+          </a:prstGeom>
+          <a:noFill/>
+        </p:spPr>
+        <p:txBody>
+          <a:bodyPr wrap="square" lIns="0" rIns="0" tIns="0" bIns="0">
+            <a:spAutoFit/>
+          </a:bodyPr>
+          <a:lstStyle/>
+          <a:p>
+            <a:r>
+              <a:rPr sz="1200" b="0">
+                <a:solidFill>
+                  <a:srgbClr val="6B7082"/>
+                </a:solidFill>
+                <a:latin typeface="Helvetica Neue"/>
+              </a:rPr>
+              <a:t>Categories ranked #25 and below. Same bar scale as page 1, so lengths compare directly.</a:t>
+            </a:r>
+          </a:p>
+        </p:txBody>
+      </p:sp>
+      <p:sp>
+        <p:nvSpPr>
+          <p:cNvPr id="6" name="TextBox 5"/>
+          <p:cNvSpPr txBox="1"/>
+          <p:nvPr/>
+        </p:nvSpPr>
+        <p:spPr>
+          <a:xfrm>
+            <a:off x="731520" y="2176272"/>
+            <a:ext cx="2468880" cy="329184"/>
+          </a:xfrm>
+          <a:prstGeom prst="rect">
+            <a:avLst/>
+          </a:prstGeom>
+          <a:noFill/>
+        </p:spPr>
+        <p:txBody>
+          <a:bodyPr wrap="square" lIns="0" rIns="0" tIns="0" bIns="0">
+            <a:spAutoFit/>
+          </a:bodyPr>
+          <a:lstStyle/>
+          <a:p>
+            <a:r>
+              <a:rPr sz="1100" b="0">
+                <a:solidFill>
+                  <a:srgbClr val="141833"/>
+                </a:solidFill>
+                <a:latin typeface="Helvetica Neue"/>
+              </a:rPr>
+              <a:t>25. Brand Growth</a:t>
+            </a:r>
+          </a:p>
+        </p:txBody>
+      </p:sp>
+      <p:sp>
+        <p:nvSpPr>
+          <p:cNvPr id="7" name="Rectangle 6"/>
+          <p:cNvSpPr/>
+          <p:nvPr/>
+        </p:nvSpPr>
+        <p:spPr>
+          <a:xfrm>
+            <a:off x="3383280" y="2203704"/>
+            <a:ext cx="53011" cy="192024"/>
+          </a:xfrm>
+          <a:prstGeom prst="rect">
+            <a:avLst/>
+          </a:prstGeom>
+          <a:solidFill>
+            <a:srgbClr val="E87E8F"/>
+          </a:solidFill>
+          <a:ln>
+            <a:noFill/>
+          </a:ln>
+          <a:effectLst/>
+        </p:spPr>
+        <p:style>
+          <a:lnRef idx="1">
+            <a:schemeClr val="accent1"/>
+          </a:lnRef>
+          <a:fillRef idx="3">
+            <a:schemeClr val="accent1"/>
+          </a:fillRef>
+          <a:effectRef idx="2">
+            <a:schemeClr val="accent1"/>
+          </a:effectRef>
+          <a:fontRef idx="minor">
+            <a:schemeClr val="lt1"/>
+          </a:fontRef>
+        </p:style>
+        <p:txBody>
+          <a:bodyPr rtlCol="0" anchor="ctr"/>
+          <a:lstStyle/>
+          <a:p>
+            <a:pPr algn="ctr"/>
+          </a:p>
+        </p:txBody>
+      </p:sp>
+      <p:sp>
+        <p:nvSpPr>
+          <p:cNvPr id="8" name="TextBox 7"/>
+          <p:cNvSpPr txBox="1"/>
+          <p:nvPr/>
+        </p:nvSpPr>
+        <p:spPr>
+          <a:xfrm>
+            <a:off x="3527731" y="2176272"/>
+            <a:ext cx="2286000" cy="329184"/>
+          </a:xfrm>
+          <a:prstGeom prst="rect">
+            <a:avLst/>
+          </a:prstGeom>
+          <a:noFill/>
+        </p:spPr>
+        <p:txBody>
+          <a:bodyPr wrap="square" lIns="0" rIns="0" tIns="0" bIns="0">
+            <a:spAutoFit/>
+          </a:bodyPr>
+          <a:lstStyle/>
+          <a:p>
+            <a:r>
+              <a:rPr sz="1000" b="0">
+                <a:solidFill>
+                  <a:srgbClr val="6B7082"/>
+                </a:solidFill>
+                <a:latin typeface="Helvetica Neue"/>
+              </a:rPr>
+              <a:t>2,214   (4 posts · 554 avg)</a:t>
+            </a:r>
+          </a:p>
+        </p:txBody>
+      </p:sp>
+      <p:sp>
+        <p:nvSpPr>
+          <p:cNvPr id="9" name="TextBox 8"/>
+          <p:cNvSpPr txBox="1"/>
+          <p:nvPr/>
+        </p:nvSpPr>
+        <p:spPr>
+          <a:xfrm>
+            <a:off x="731520" y="2505456"/>
+            <a:ext cx="2468880" cy="329184"/>
+          </a:xfrm>
+          <a:prstGeom prst="rect">
+            <a:avLst/>
+          </a:prstGeom>
+          <a:noFill/>
+        </p:spPr>
+        <p:txBody>
+          <a:bodyPr wrap="square" lIns="0" rIns="0" tIns="0" bIns="0">
+            <a:spAutoFit/>
+          </a:bodyPr>
+          <a:lstStyle/>
+          <a:p>
+            <a:r>
+              <a:rPr sz="1100" b="0">
+                <a:solidFill>
+                  <a:srgbClr val="141833"/>
+                </a:solidFill>
+                <a:latin typeface="Helvetica Neue"/>
+              </a:rPr>
+              <a:t>26. Other</a:t>
+            </a:r>
+          </a:p>
+        </p:txBody>
+      </p:sp>
+      <p:sp>
+        <p:nvSpPr>
+          <p:cNvPr id="10" name="Rectangle 9"/>
+          <p:cNvSpPr/>
+          <p:nvPr/>
+        </p:nvSpPr>
+        <p:spPr>
+          <a:xfrm>
+            <a:off x="3383280" y="2532888"/>
+            <a:ext cx="45720" cy="192024"/>
+          </a:xfrm>
+          <a:prstGeom prst="rect">
+            <a:avLst/>
+          </a:prstGeom>
+          <a:solidFill>
+            <a:srgbClr val="6B7082"/>
+          </a:solidFill>
+          <a:ln>
+            <a:noFill/>
+          </a:ln>
+          <a:effectLst/>
+        </p:spPr>
+        <p:style>
+          <a:lnRef idx="1">
+            <a:schemeClr val="accent1"/>
+          </a:lnRef>
+          <a:fillRef idx="3">
+            <a:schemeClr val="accent1"/>
+          </a:fillRef>
+          <a:effectRef idx="2">
+            <a:schemeClr val="accent1"/>
+          </a:effectRef>
+          <a:fontRef idx="minor">
+            <a:schemeClr val="lt1"/>
+          </a:fontRef>
+        </p:style>
+        <p:txBody>
+          <a:bodyPr rtlCol="0" anchor="ctr"/>
+          <a:lstStyle/>
+          <a:p>
+            <a:pPr algn="ctr"/>
+          </a:p>
+        </p:txBody>
+      </p:sp>
+      <p:sp>
+        <p:nvSpPr>
+          <p:cNvPr id="11" name="TextBox 10"/>
+          <p:cNvSpPr txBox="1"/>
+          <p:nvPr/>
+        </p:nvSpPr>
+        <p:spPr>
+          <a:xfrm>
+            <a:off x="3520440" y="2505456"/>
+            <a:ext cx="2286000" cy="329184"/>
+          </a:xfrm>
+          <a:prstGeom prst="rect">
+            <a:avLst/>
+          </a:prstGeom>
+          <a:noFill/>
+        </p:spPr>
+        <p:txBody>
+          <a:bodyPr wrap="square" lIns="0" rIns="0" tIns="0" bIns="0">
+            <a:spAutoFit/>
+          </a:bodyPr>
+          <a:lstStyle/>
+          <a:p>
+            <a:r>
+              <a:rPr sz="1000" b="0">
+                <a:solidFill>
+                  <a:srgbClr val="6B7082"/>
+                </a:solidFill>
+                <a:latin typeface="Helvetica Neue"/>
+              </a:rPr>
+              <a:t>1,297   (25 posts · 52 avg)</a:t>
+            </a:r>
+          </a:p>
+        </p:txBody>
+      </p:sp>
+      <p:sp>
+        <p:nvSpPr>
+          <p:cNvPr id="12" name="TextBox 11"/>
+          <p:cNvSpPr txBox="1"/>
+          <p:nvPr/>
+        </p:nvSpPr>
+        <p:spPr>
+          <a:xfrm>
+            <a:off x="731520" y="6263640"/>
+            <a:ext cx="10698480" cy="457200"/>
+          </a:xfrm>
+          <a:prstGeom prst="rect">
+            <a:avLst/>
+          </a:prstGeom>
+          <a:noFill/>
+        </p:spPr>
+        <p:txBody>
+          <a:bodyPr wrap="square" lIns="0" rIns="0" tIns="0" bIns="0">
+            <a:spAutoFit/>
+          </a:bodyPr>
+          <a:lstStyle/>
+          <a:p>
+            <a:r>
+              <a:rPr sz="1200" b="1">
+                <a:solidFill>
+                  <a:srgbClr val="141833"/>
+                </a:solidFill>
+                <a:latin typeface="Helvetica Neue"/>
+              </a:rPr>
+              <a:t>Smaller lanes aren't failures — they're where a single breakout post can move the whole ranking.</a:t>
+            </a:r>
+          </a:p>
+        </p:txBody>
+      </p:sp>
+    </p:spTree>
+  </p:cSld>
+  <p:clrMapOvr>
+    <a:masterClrMapping/>
+  </p:clrMapOvr>
+</p:sld>
+</file>
+
+<file path=ppt/slides/slide7.xml><?xml version="1.0" encoding="utf-8"?>
+<p:sld xmlns:a="http://schemas.openxmlformats.org/drawingml/2006/main" xmlns:p="http://schemas.openxmlformats.org/presentationml/2006/main" xmlns:r="http://schemas.openxmlformats.org/officeDocument/2006/relationships">
+  <p:cSld>
+    <p:spTree>
+      <p:nvGrpSpPr>
+        <p:cNvPr id="1" name=""/>
+        <p:cNvGrpSpPr/>
+        <p:nvPr/>
+      </p:nvGrpSpPr>
+      <p:grpSpPr/>
+      <p:sp>
+        <p:nvSpPr>
+          <p:cNvPr id="2" name="Rectangle 1"/>
+          <p:cNvSpPr/>
+          <p:nvPr/>
+        </p:nvSpPr>
+        <p:spPr>
+          <a:xfrm>
+            <a:off x="0" y="0"/>
+            <a:ext cx="12191695" cy="6858000"/>
+          </a:xfrm>
+          <a:prstGeom prst="rect">
+            <a:avLst/>
+          </a:prstGeom>
+          <a:solidFill>
+            <a:srgbClr val="FCF6F5"/>
+          </a:solidFill>
+          <a:ln>
+            <a:noFill/>
+          </a:ln>
+          <a:effectLst/>
+        </p:spPr>
+        <p:style>
+          <a:lnRef idx="1">
+            <a:schemeClr val="accent1"/>
+          </a:lnRef>
+          <a:fillRef idx="3">
+            <a:schemeClr val="accent1"/>
+          </a:fillRef>
+          <a:effectRef idx="2">
+            <a:schemeClr val="accent1"/>
+          </a:effectRef>
+          <a:fontRef idx="minor">
+            <a:schemeClr val="lt1"/>
+          </a:fontRef>
+        </p:style>
+        <p:txBody>
+          <a:bodyPr rtlCol="0" anchor="ctr"/>
+          <a:lstStyle/>
+          <a:p>
+            <a:pPr algn="ctr"/>
+          </a:p>
+        </p:txBody>
+      </p:sp>
+      <p:sp>
+        <p:nvSpPr>
+          <p:cNvPr id="3" name="TextBox 2"/>
+          <p:cNvSpPr txBox="1"/>
+          <p:nvPr/>
+        </p:nvSpPr>
+        <p:spPr>
+          <a:xfrm>
+            <a:off x="731520" y="457200"/>
+            <a:ext cx="10698480" cy="365760"/>
+          </a:xfrm>
+          <a:prstGeom prst="rect">
+            <a:avLst/>
+          </a:prstGeom>
+          <a:noFill/>
+        </p:spPr>
+        <p:txBody>
+          <a:bodyPr wrap="square" lIns="0" rIns="0" tIns="0" bIns="0">
+            <a:spAutoFit/>
+          </a:bodyPr>
+          <a:lstStyle/>
+          <a:p>
+            <a:r>
+              <a:rPr sz="1200" b="1">
+                <a:solidFill>
+                  <a:srgbClr val="990011"/>
+                </a:solidFill>
+                <a:latin typeface="Helvetica Neue"/>
+              </a:rPr>
+              <a:t>ALL-TIME TOP 10 POSTS</a:t>
+            </a:r>
+          </a:p>
+        </p:txBody>
+      </p:sp>
+      <p:sp>
+        <p:nvSpPr>
+          <p:cNvPr id="4" name="TextBox 3"/>
+          <p:cNvSpPr txBox="1"/>
+          <p:nvPr/>
+        </p:nvSpPr>
+        <p:spPr>
+          <a:xfrm>
+            <a:off x="731520" y="822960"/>
+            <a:ext cx="10698480" cy="822960"/>
+          </a:xfrm>
+          <a:prstGeom prst="rect">
+            <a:avLst/>
+          </a:prstGeom>
+          <a:noFill/>
+        </p:spPr>
+        <p:txBody>
+          <a:bodyPr wrap="square" lIns="0" rIns="0" tIns="0" bIns="0">
+            <a:spAutoFit/>
+          </a:bodyPr>
+          <a:lstStyle/>
+          <a:p>
+            <a:r>
+              <a:rPr sz="3000" b="1">
+                <a:solidFill>
+                  <a:srgbClr val="2F3C7E"/>
+                </a:solidFill>
+                <a:latin typeface="Georgia"/>
+              </a:rPr>
+              <a:t>The peak performers since Jun 8</a:t>
+            </a:r>
+          </a:p>
+        </p:txBody>
+      </p:sp>
+      <p:sp>
+        <p:nvSpPr>
+          <p:cNvPr id="5" name="TextBox 4"/>
+          <p:cNvSpPr txBox="1"/>
+          <p:nvPr/>
+        </p:nvSpPr>
+        <p:spPr>
+          <a:xfrm>
+            <a:off x="731520" y="1600200"/>
+            <a:ext cx="10698480" cy="365760"/>
+          </a:xfrm>
+          <a:prstGeom prst="rect">
+            <a:avLst/>
+          </a:prstGeom>
+          <a:noFill/>
+        </p:spPr>
+        <p:txBody>
+          <a:bodyPr wrap="square" lIns="0" rIns="0" tIns="0" bIns="0">
+            <a:spAutoFit/>
+          </a:bodyPr>
+          <a:lstStyle/>
+          <a:p>
+            <a:r>
+              <a:rPr sz="1200" b="0">
+                <a:solidFill>
+                  <a:srgbClr val="6B7082"/>
+                </a:solidFill>
+                <a:latin typeface="Helvetica Neue"/>
+              </a:rPr>
+              <a:t>Individual URLs ranked by views. These are the moments the audience shows up hardest.</a:t>
+            </a:r>
+          </a:p>
+        </p:txBody>
+      </p:sp>
+      <p:sp>
+        <p:nvSpPr>
+          <p:cNvPr id="6" name="Rectangle 5"/>
+          <p:cNvSpPr/>
+          <p:nvPr/>
+        </p:nvSpPr>
+        <p:spPr>
+          <a:xfrm>
+            <a:off x="548640" y="2194560"/>
+            <a:ext cx="11064240" cy="384048"/>
+          </a:xfrm>
+          <a:prstGeom prst="rect">
+            <a:avLst/>
+          </a:prstGeom>
+          <a:solidFill>
+            <a:srgbClr val="2F3C7E"/>
+          </a:solidFill>
+          <a:ln>
+            <a:noFill/>
+          </a:ln>
+          <a:effectLst/>
+        </p:spPr>
+        <p:style>
+          <a:lnRef idx="1">
+            <a:schemeClr val="accent1"/>
+          </a:lnRef>
+          <a:fillRef idx="3">
+            <a:schemeClr val="accent1"/>
+          </a:fillRef>
+          <a:effectRef idx="2">
+            <a:schemeClr val="accent1"/>
+          </a:effectRef>
+          <a:fontRef idx="minor">
+            <a:schemeClr val="lt1"/>
+          </a:fontRef>
+        </p:style>
+        <p:txBody>
+          <a:bodyPr rtlCol="0" anchor="ctr"/>
+          <a:lstStyle/>
+          <a:p>
+            <a:pPr algn="ctr"/>
+          </a:p>
+        </p:txBody>
+      </p:sp>
+      <p:sp>
+        <p:nvSpPr>
+          <p:cNvPr id="7" name="TextBox 6"/>
+          <p:cNvSpPr txBox="1"/>
+          <p:nvPr/>
+        </p:nvSpPr>
+        <p:spPr>
+          <a:xfrm>
+            <a:off x="640080" y="2267712"/>
+            <a:ext cx="274320" cy="274320"/>
+          </a:xfrm>
+          <a:prstGeom prst="rect">
+            <a:avLst/>
+          </a:prstGeom>
+          <a:noFill/>
+        </p:spPr>
+        <p:txBody>
+          <a:bodyPr wrap="square" lIns="0" rIns="0" tIns="0" bIns="0">
+            <a:spAutoFit/>
+          </a:bodyPr>
+          <a:lstStyle/>
+          <a:p>
+            <a:r>
+              <a:rPr sz="1000" b="1">
+                <a:solidFill>
+                  <a:srgbClr val="FCF6F5"/>
+                </a:solidFill>
+                <a:latin typeface="Helvetica Neue"/>
+              </a:rPr>
+              <a:t>#</a:t>
+            </a:r>
+          </a:p>
+        </p:txBody>
+      </p:sp>
+      <p:sp>
+        <p:nvSpPr>
+          <p:cNvPr id="8" name="TextBox 7"/>
+          <p:cNvSpPr txBox="1"/>
+          <p:nvPr/>
+        </p:nvSpPr>
+        <p:spPr>
+          <a:xfrm>
+            <a:off x="1097280" y="2267712"/>
+            <a:ext cx="731520" cy="274320"/>
+          </a:xfrm>
+          <a:prstGeom prst="rect">
+            <a:avLst/>
+          </a:prstGeom>
+          <a:noFill/>
+        </p:spPr>
+        <p:txBody>
+          <a:bodyPr wrap="square" lIns="0" rIns="0" tIns="0" bIns="0">
+            <a:spAutoFit/>
+          </a:bodyPr>
+          <a:lstStyle/>
+          <a:p>
+            <a:r>
+              <a:rPr sz="1000" b="1">
+                <a:solidFill>
+                  <a:srgbClr val="FCF6F5"/>
+                </a:solidFill>
+                <a:latin typeface="Helvetica Neue"/>
+              </a:rPr>
+              <a:t>PLATFORM</a:t>
+            </a:r>
+          </a:p>
+        </p:txBody>
+      </p:sp>
+      <p:sp>
+        <p:nvSpPr>
+          <p:cNvPr id="9" name="TextBox 8"/>
+          <p:cNvSpPr txBox="1"/>
+          <p:nvPr/>
+        </p:nvSpPr>
+        <p:spPr>
+          <a:xfrm>
+            <a:off x="2011680" y="2267712"/>
+            <a:ext cx="5669280" cy="274320"/>
+          </a:xfrm>
+          <a:prstGeom prst="rect">
+            <a:avLst/>
+          </a:prstGeom>
+          <a:noFill/>
+        </p:spPr>
+        <p:txBody>
+          <a:bodyPr wrap="square" lIns="0" rIns="0" tIns="0" bIns="0">
+            <a:spAutoFit/>
+          </a:bodyPr>
+          <a:lstStyle/>
+          <a:p>
+            <a:r>
+              <a:rPr sz="1000" b="1">
+                <a:solidFill>
+                  <a:srgbClr val="FCF6F5"/>
+                </a:solidFill>
+                <a:latin typeface="Helvetica Neue"/>
+              </a:rPr>
+              <a:t>POST</a:t>
+            </a:r>
+          </a:p>
+        </p:txBody>
+      </p:sp>
+      <p:sp>
+        <p:nvSpPr>
+          <p:cNvPr id="10" name="TextBox 9"/>
+          <p:cNvSpPr txBox="1"/>
+          <p:nvPr/>
+        </p:nvSpPr>
+        <p:spPr>
+          <a:xfrm>
+            <a:off x="7863840" y="2267712"/>
+            <a:ext cx="1097280" cy="274320"/>
+          </a:xfrm>
+          <a:prstGeom prst="rect">
+            <a:avLst/>
+          </a:prstGeom>
+          <a:noFill/>
+        </p:spPr>
+        <p:txBody>
+          <a:bodyPr wrap="square" lIns="0" rIns="0" tIns="0" bIns="0">
+            <a:spAutoFit/>
+          </a:bodyPr>
+          <a:lstStyle/>
+          <a:p>
+            <a:r>
+              <a:rPr sz="1000" b="1">
+                <a:solidFill>
+                  <a:srgbClr val="FCF6F5"/>
+                </a:solidFill>
+                <a:latin typeface="Helvetica Neue"/>
+              </a:rPr>
+              <a:t>VIEWS</a:t>
+            </a:r>
+          </a:p>
+        </p:txBody>
+      </p:sp>
+      <p:sp>
+        <p:nvSpPr>
+          <p:cNvPr id="11" name="TextBox 10"/>
+          <p:cNvSpPr txBox="1"/>
+          <p:nvPr/>
+        </p:nvSpPr>
+        <p:spPr>
+          <a:xfrm>
+            <a:off x="9144000" y="2267712"/>
+            <a:ext cx="1097280" cy="274320"/>
+          </a:xfrm>
+          <a:prstGeom prst="rect">
+            <a:avLst/>
+          </a:prstGeom>
+          <a:noFill/>
+        </p:spPr>
+        <p:txBody>
+          <a:bodyPr wrap="square" lIns="0" rIns="0" tIns="0" bIns="0">
+            <a:spAutoFit/>
+          </a:bodyPr>
+          <a:lstStyle/>
+          <a:p>
+            <a:r>
+              <a:rPr sz="1000" b="1">
+                <a:solidFill>
+                  <a:srgbClr val="FCF6F5"/>
+                </a:solidFill>
+                <a:latin typeface="Helvetica Neue"/>
+              </a:rPr>
+              <a:t>LIKES</a:t>
+            </a:r>
+          </a:p>
+        </p:txBody>
+      </p:sp>
+      <p:sp>
+        <p:nvSpPr>
+          <p:cNvPr id="12" name="TextBox 11"/>
+          <p:cNvSpPr txBox="1"/>
+          <p:nvPr/>
+        </p:nvSpPr>
+        <p:spPr>
+          <a:xfrm>
+            <a:off x="10424160" y="2267712"/>
+            <a:ext cx="1097280" cy="274320"/>
+          </a:xfrm>
+          <a:prstGeom prst="rect">
+            <a:avLst/>
+          </a:prstGeom>
+          <a:noFill/>
+        </p:spPr>
+        <p:txBody>
+          <a:bodyPr wrap="square" lIns="0" rIns="0" tIns="0" bIns="0">
+            <a:spAutoFit/>
+          </a:bodyPr>
+          <a:lstStyle/>
+          <a:p>
+            <a:r>
+              <a:rPr sz="1000" b="1">
+                <a:solidFill>
+                  <a:srgbClr val="FCF6F5"/>
+                </a:solidFill>
+                <a:latin typeface="Helvetica Neue"/>
+              </a:rPr>
+              <a:t>CATEGORY</a:t>
+            </a:r>
+          </a:p>
+        </p:txBody>
+      </p:sp>
+      <p:sp>
+        <p:nvSpPr>
+          <p:cNvPr id="13" name="Rectangle 12"/>
+          <p:cNvSpPr/>
+          <p:nvPr/>
+        </p:nvSpPr>
+        <p:spPr>
+          <a:xfrm>
+            <a:off x="548640" y="2578608"/>
+            <a:ext cx="54864" cy="384048"/>
+          </a:xfrm>
+          <a:prstGeom prst="rect">
+            <a:avLst/>
+          </a:prstGeom>
+          <a:solidFill>
+            <a:srgbClr val="990011"/>
+          </a:solidFill>
+          <a:ln>
+            <a:noFill/>
+          </a:ln>
+          <a:effectLst/>
+        </p:spPr>
+        <p:style>
+          <a:lnRef idx="1">
+            <a:schemeClr val="accent1"/>
+          </a:lnRef>
+          <a:fillRef idx="3">
+            <a:schemeClr val="accent1"/>
+          </a:fillRef>
+          <a:effectRef idx="2">
+            <a:schemeClr val="accent1"/>
+          </a:effectRef>
+          <a:fontRef idx="minor">
+            <a:schemeClr val="lt1"/>
+          </a:fontRef>
+        </p:style>
+        <p:txBody>
+          <a:bodyPr rtlCol="0" anchor="ctr"/>
+          <a:lstStyle/>
+          <a:p>
+            <a:pPr algn="ctr"/>
+          </a:p>
+        </p:txBody>
+      </p:sp>
+      <p:sp>
+        <p:nvSpPr>
           <p:cNvPr id="14" name="TextBox 13"/>
           <p:cNvSpPr txBox="1"/>
           <p:nvPr/>
@@ -7513,7 +9479,7 @@
                 </a:solidFill>
                 <a:latin typeface="Helvetica Neue"/>
               </a:rPr>
-              <a:t>Other</a:t>
+              <a:t>Military Service</a:t>
             </a:r>
           </a:p>
         </p:txBody>
@@ -7805,7 +9771,7 @@
                 </a:solidFill>
                 <a:latin typeface="Helvetica Neue"/>
               </a:rPr>
-              <a:t>Other</a:t>
+              <a:t>Military Service</a:t>
             </a:r>
           </a:p>
         </p:txBody>

</xml_diff>

<commit_message>
Overall deck: categories split evenly across exactly 2 pages
</commit_message>
<xml_diff>
--- a/OVERALL_REPORT.pptx
+++ b/OVERALL_REPORT.pptx
@@ -11,7 +11,6 @@
     <p:sldId id="259" r:id="rId10"/>
     <p:sldId id="260" r:id="rId11"/>
     <p:sldId id="261" r:id="rId12"/>
-    <p:sldId id="262" r:id="rId13"/>
   </p:sldIdLst>
   <p:sldSz cx="12191695" cy="6858000" type="screen4x3"/>
   <p:notesSz cx="6858000" cy="9144000"/>
@@ -5409,7 +5408,7 @@
                 </a:solidFill>
                 <a:latin typeface="Helvetica Neue"/>
               </a:rPr>
-              <a:t>ALL-TIME CATEGORY RANKING · 1 OF 3</a:t>
+              <a:t>ALL-TIME CATEGORY RANKING · 1 OF 2</a:t>
             </a:r>
           </a:p>
         </p:txBody>
@@ -5491,7 +5490,7 @@
         <p:spPr>
           <a:xfrm>
             <a:off x="731520" y="2176272"/>
-            <a:ext cx="2468880" cy="329184"/>
+            <a:ext cx="2468880" cy="313006"/>
           </a:xfrm>
           <a:prstGeom prst="rect">
             <a:avLst/>
@@ -5525,7 +5524,7 @@
         <p:spPr>
           <a:xfrm>
             <a:off x="3383280" y="2203704"/>
-            <a:ext cx="6858000" cy="192024"/>
+            <a:ext cx="6858000" cy="175846"/>
           </a:xfrm>
           <a:prstGeom prst="rect">
             <a:avLst/>
@@ -5569,7 +5568,7 @@
         <p:spPr>
           <a:xfrm>
             <a:off x="10332719" y="2176272"/>
-            <a:ext cx="2286000" cy="329184"/>
+            <a:ext cx="2286000" cy="313006"/>
           </a:xfrm>
           <a:prstGeom prst="rect">
             <a:avLst/>
@@ -5602,8 +5601,8 @@
         </p:nvSpPr>
         <p:spPr>
           <a:xfrm>
-            <a:off x="731520" y="2505456"/>
-            <a:ext cx="2468880" cy="329184"/>
+            <a:off x="731520" y="2489278"/>
+            <a:ext cx="2468880" cy="313006"/>
           </a:xfrm>
           <a:prstGeom prst="rect">
             <a:avLst/>
@@ -5636,8 +5635,8 @@
         </p:nvSpPr>
         <p:spPr>
           <a:xfrm>
-            <a:off x="3383280" y="2532888"/>
-            <a:ext cx="2741806" cy="192024"/>
+            <a:off x="3383280" y="2516710"/>
+            <a:ext cx="2741806" cy="175846"/>
           </a:xfrm>
           <a:prstGeom prst="rect">
             <a:avLst/>
@@ -5680,8 +5679,8 @@
         </p:nvSpPr>
         <p:spPr>
           <a:xfrm>
-            <a:off x="6216526" y="2505456"/>
-            <a:ext cx="2286000" cy="329184"/>
+            <a:off x="6216526" y="2489278"/>
+            <a:ext cx="2286000" cy="313006"/>
           </a:xfrm>
           <a:prstGeom prst="rect">
             <a:avLst/>
@@ -5714,8 +5713,8 @@
         </p:nvSpPr>
         <p:spPr>
           <a:xfrm>
-            <a:off x="731520" y="2834640"/>
-            <a:ext cx="2468880" cy="329184"/>
+            <a:off x="731520" y="2802284"/>
+            <a:ext cx="2468880" cy="313006"/>
           </a:xfrm>
           <a:prstGeom prst="rect">
             <a:avLst/>
@@ -5748,8 +5747,8 @@
         </p:nvSpPr>
         <p:spPr>
           <a:xfrm>
-            <a:off x="3383280" y="2862072"/>
-            <a:ext cx="1319125" cy="192024"/>
+            <a:off x="3383280" y="2829716"/>
+            <a:ext cx="1319125" cy="175846"/>
           </a:xfrm>
           <a:prstGeom prst="rect">
             <a:avLst/>
@@ -5792,8 +5791,8 @@
         </p:nvSpPr>
         <p:spPr>
           <a:xfrm>
-            <a:off x="4793845" y="2834640"/>
-            <a:ext cx="2286000" cy="329184"/>
+            <a:off x="4793845" y="2802284"/>
+            <a:ext cx="2286000" cy="313006"/>
           </a:xfrm>
           <a:prstGeom prst="rect">
             <a:avLst/>
@@ -5826,8 +5825,8 @@
         </p:nvSpPr>
         <p:spPr>
           <a:xfrm>
-            <a:off x="731520" y="3163824"/>
-            <a:ext cx="2468880" cy="329184"/>
+            <a:off x="731520" y="3115290"/>
+            <a:ext cx="2468880" cy="313006"/>
           </a:xfrm>
           <a:prstGeom prst="rect">
             <a:avLst/>
@@ -5860,8 +5859,8 @@
         </p:nvSpPr>
         <p:spPr>
           <a:xfrm>
-            <a:off x="3383280" y="3191256"/>
-            <a:ext cx="1244828" cy="192024"/>
+            <a:off x="3383280" y="3142722"/>
+            <a:ext cx="1244828" cy="175846"/>
           </a:xfrm>
           <a:prstGeom prst="rect">
             <a:avLst/>
@@ -5904,8 +5903,8 @@
         </p:nvSpPr>
         <p:spPr>
           <a:xfrm>
-            <a:off x="4719548" y="3163824"/>
-            <a:ext cx="2286000" cy="329184"/>
+            <a:off x="4719548" y="3115290"/>
+            <a:ext cx="2286000" cy="313006"/>
           </a:xfrm>
           <a:prstGeom prst="rect">
             <a:avLst/>
@@ -5938,8 +5937,8 @@
         </p:nvSpPr>
         <p:spPr>
           <a:xfrm>
-            <a:off x="731520" y="3493008"/>
-            <a:ext cx="2468880" cy="329184"/>
+            <a:off x="731520" y="3428296"/>
+            <a:ext cx="2468880" cy="313006"/>
           </a:xfrm>
           <a:prstGeom prst="rect">
             <a:avLst/>
@@ -5972,8 +5971,8 @@
         </p:nvSpPr>
         <p:spPr>
           <a:xfrm>
-            <a:off x="3383280" y="3520440"/>
-            <a:ext cx="1238123" cy="192024"/>
+            <a:off x="3383280" y="3455728"/>
+            <a:ext cx="1238123" cy="175846"/>
           </a:xfrm>
           <a:prstGeom prst="rect">
             <a:avLst/>
@@ -6016,8 +6015,8 @@
         </p:nvSpPr>
         <p:spPr>
           <a:xfrm>
-            <a:off x="4712843" y="3493008"/>
-            <a:ext cx="2286000" cy="329184"/>
+            <a:off x="4712843" y="3428296"/>
+            <a:ext cx="2286000" cy="313006"/>
           </a:xfrm>
           <a:prstGeom prst="rect">
             <a:avLst/>
@@ -6050,8 +6049,8 @@
         </p:nvSpPr>
         <p:spPr>
           <a:xfrm>
-            <a:off x="731520" y="3822192"/>
-            <a:ext cx="2468880" cy="329184"/>
+            <a:off x="731520" y="3741302"/>
+            <a:ext cx="2468880" cy="313006"/>
           </a:xfrm>
           <a:prstGeom prst="rect">
             <a:avLst/>
@@ -6084,8 +6083,8 @@
         </p:nvSpPr>
         <p:spPr>
           <a:xfrm>
-            <a:off x="3383280" y="3849624"/>
-            <a:ext cx="985782" cy="192024"/>
+            <a:off x="3383280" y="3768734"/>
+            <a:ext cx="985782" cy="175846"/>
           </a:xfrm>
           <a:prstGeom prst="rect">
             <a:avLst/>
@@ -6128,8 +6127,8 @@
         </p:nvSpPr>
         <p:spPr>
           <a:xfrm>
-            <a:off x="4460502" y="3822192"/>
-            <a:ext cx="2286000" cy="329184"/>
+            <a:off x="4460502" y="3741302"/>
+            <a:ext cx="2286000" cy="313006"/>
           </a:xfrm>
           <a:prstGeom prst="rect">
             <a:avLst/>
@@ -6162,8 +6161,8 @@
         </p:nvSpPr>
         <p:spPr>
           <a:xfrm>
-            <a:off x="731520" y="4151376"/>
-            <a:ext cx="2468880" cy="329184"/>
+            <a:off x="731520" y="4054308"/>
+            <a:ext cx="2468880" cy="313006"/>
           </a:xfrm>
           <a:prstGeom prst="rect">
             <a:avLst/>
@@ -6196,8 +6195,8 @@
         </p:nvSpPr>
         <p:spPr>
           <a:xfrm>
-            <a:off x="3383280" y="4178807"/>
-            <a:ext cx="843509" cy="192024"/>
+            <a:off x="3383280" y="4081740"/>
+            <a:ext cx="843509" cy="175846"/>
           </a:xfrm>
           <a:prstGeom prst="rect">
             <a:avLst/>
@@ -6240,8 +6239,8 @@
         </p:nvSpPr>
         <p:spPr>
           <a:xfrm>
-            <a:off x="4318229" y="4151376"/>
-            <a:ext cx="2286000" cy="329184"/>
+            <a:off x="4318229" y="4054308"/>
+            <a:ext cx="2286000" cy="313006"/>
           </a:xfrm>
           <a:prstGeom prst="rect">
             <a:avLst/>
@@ -6274,8 +6273,8 @@
         </p:nvSpPr>
         <p:spPr>
           <a:xfrm>
-            <a:off x="731520" y="4480560"/>
-            <a:ext cx="2468880" cy="329184"/>
+            <a:off x="731520" y="4367315"/>
+            <a:ext cx="2468880" cy="313006"/>
           </a:xfrm>
           <a:prstGeom prst="rect">
             <a:avLst/>
@@ -6308,8 +6307,8 @@
         </p:nvSpPr>
         <p:spPr>
           <a:xfrm>
-            <a:off x="3383280" y="4507992"/>
-            <a:ext cx="822965" cy="192024"/>
+            <a:off x="3383280" y="4394747"/>
+            <a:ext cx="822965" cy="175846"/>
           </a:xfrm>
           <a:prstGeom prst="rect">
             <a:avLst/>
@@ -6352,8 +6351,8 @@
         </p:nvSpPr>
         <p:spPr>
           <a:xfrm>
-            <a:off x="4297685" y="4480560"/>
-            <a:ext cx="2286000" cy="329184"/>
+            <a:off x="4297685" y="4367315"/>
+            <a:ext cx="2286000" cy="313006"/>
           </a:xfrm>
           <a:prstGeom prst="rect">
             <a:avLst/>
@@ -6386,8 +6385,8 @@
         </p:nvSpPr>
         <p:spPr>
           <a:xfrm>
-            <a:off x="731520" y="4809744"/>
-            <a:ext cx="2468880" cy="329184"/>
+            <a:off x="731520" y="4680321"/>
+            <a:ext cx="2468880" cy="313006"/>
           </a:xfrm>
           <a:prstGeom prst="rect">
             <a:avLst/>
@@ -6420,8 +6419,8 @@
         </p:nvSpPr>
         <p:spPr>
           <a:xfrm>
-            <a:off x="3383280" y="4837176"/>
-            <a:ext cx="800410" cy="192024"/>
+            <a:off x="3383280" y="4707753"/>
+            <a:ext cx="800410" cy="175846"/>
           </a:xfrm>
           <a:prstGeom prst="rect">
             <a:avLst/>
@@ -6464,8 +6463,8 @@
         </p:nvSpPr>
         <p:spPr>
           <a:xfrm>
-            <a:off x="4275130" y="4809744"/>
-            <a:ext cx="2286000" cy="329184"/>
+            <a:off x="4275130" y="4680321"/>
+            <a:ext cx="2286000" cy="313006"/>
           </a:xfrm>
           <a:prstGeom prst="rect">
             <a:avLst/>
@@ -6498,8 +6497,8 @@
         </p:nvSpPr>
         <p:spPr>
           <a:xfrm>
-            <a:off x="731520" y="5138928"/>
-            <a:ext cx="2468880" cy="329184"/>
+            <a:off x="731520" y="4993327"/>
+            <a:ext cx="2468880" cy="313006"/>
           </a:xfrm>
           <a:prstGeom prst="rect">
             <a:avLst/>
@@ -6532,8 +6531,8 @@
         </p:nvSpPr>
         <p:spPr>
           <a:xfrm>
-            <a:off x="3383280" y="5166359"/>
-            <a:ext cx="719385" cy="192024"/>
+            <a:off x="3383280" y="5020759"/>
+            <a:ext cx="719385" cy="175846"/>
           </a:xfrm>
           <a:prstGeom prst="rect">
             <a:avLst/>
@@ -6576,8 +6575,8 @@
         </p:nvSpPr>
         <p:spPr>
           <a:xfrm>
-            <a:off x="4194105" y="5138928"/>
-            <a:ext cx="2286000" cy="329184"/>
+            <a:off x="4194105" y="4993327"/>
+            <a:ext cx="2286000" cy="313006"/>
           </a:xfrm>
           <a:prstGeom prst="rect">
             <a:avLst/>
@@ -6610,8 +6609,8 @@
         </p:nvSpPr>
         <p:spPr>
           <a:xfrm>
-            <a:off x="731520" y="5468112"/>
-            <a:ext cx="2468880" cy="329184"/>
+            <a:off x="731520" y="5306333"/>
+            <a:ext cx="2468880" cy="313006"/>
           </a:xfrm>
           <a:prstGeom prst="rect">
             <a:avLst/>
@@ -6644,8 +6643,8 @@
         </p:nvSpPr>
         <p:spPr>
           <a:xfrm>
-            <a:off x="3383280" y="5495543"/>
-            <a:ext cx="715746" cy="192024"/>
+            <a:off x="3383280" y="5333765"/>
+            <a:ext cx="715746" cy="175846"/>
           </a:xfrm>
           <a:prstGeom prst="rect">
             <a:avLst/>
@@ -6688,8 +6687,8 @@
         </p:nvSpPr>
         <p:spPr>
           <a:xfrm>
-            <a:off x="4190466" y="5468112"/>
-            <a:ext cx="2286000" cy="329184"/>
+            <a:off x="4190466" y="5306333"/>
+            <a:ext cx="2286000" cy="313006"/>
           </a:xfrm>
           <a:prstGeom prst="rect">
             <a:avLst/>
@@ -6722,8 +6721,8 @@
         </p:nvSpPr>
         <p:spPr>
           <a:xfrm>
-            <a:off x="731520" y="5797296"/>
-            <a:ext cx="2468880" cy="329184"/>
+            <a:off x="731520" y="5619339"/>
+            <a:ext cx="2468880" cy="313006"/>
           </a:xfrm>
           <a:prstGeom prst="rect">
             <a:avLst/>
@@ -6756,8 +6755,8 @@
         </p:nvSpPr>
         <p:spPr>
           <a:xfrm>
-            <a:off x="3383280" y="5824728"/>
-            <a:ext cx="686942" cy="192024"/>
+            <a:off x="3383280" y="5646771"/>
+            <a:ext cx="686942" cy="175846"/>
           </a:xfrm>
           <a:prstGeom prst="rect">
             <a:avLst/>
@@ -6800,8 +6799,8 @@
         </p:nvSpPr>
         <p:spPr>
           <a:xfrm>
-            <a:off x="4161662" y="5797296"/>
-            <a:ext cx="2286000" cy="329184"/>
+            <a:off x="4161662" y="5619339"/>
+            <a:ext cx="2286000" cy="313006"/>
           </a:xfrm>
           <a:prstGeom prst="rect">
             <a:avLst/>
@@ -6829,6 +6828,118 @@
       <p:sp>
         <p:nvSpPr>
           <p:cNvPr id="42" name="TextBox 41"/>
+          <p:cNvSpPr txBox="1"/>
+          <p:nvPr/>
+        </p:nvSpPr>
+        <p:spPr>
+          <a:xfrm>
+            <a:off x="731520" y="5932345"/>
+            <a:ext cx="2468880" cy="313006"/>
+          </a:xfrm>
+          <a:prstGeom prst="rect">
+            <a:avLst/>
+          </a:prstGeom>
+          <a:noFill/>
+        </p:spPr>
+        <p:txBody>
+          <a:bodyPr wrap="square" lIns="0" rIns="0" tIns="0" bIns="0">
+            <a:spAutoFit/>
+          </a:bodyPr>
+          <a:lstStyle/>
+          <a:p>
+            <a:r>
+              <a:rPr sz="1100" b="0">
+                <a:solidFill>
+                  <a:srgbClr val="141833"/>
+                </a:solidFill>
+                <a:latin typeface="Helvetica Neue"/>
+              </a:rPr>
+              <a:t>13. Community Events</a:t>
+            </a:r>
+          </a:p>
+        </p:txBody>
+      </p:sp>
+      <p:sp>
+        <p:nvSpPr>
+          <p:cNvPr id="43" name="Rectangle 42"/>
+          <p:cNvSpPr/>
+          <p:nvPr/>
+        </p:nvSpPr>
+        <p:spPr>
+          <a:xfrm>
+            <a:off x="3383280" y="5959777"/>
+            <a:ext cx="489694" cy="175846"/>
+          </a:xfrm>
+          <a:prstGeom prst="rect">
+            <a:avLst/>
+          </a:prstGeom>
+          <a:solidFill>
+            <a:srgbClr val="141833"/>
+          </a:solidFill>
+          <a:ln>
+            <a:noFill/>
+          </a:ln>
+          <a:effectLst/>
+        </p:spPr>
+        <p:style>
+          <a:lnRef idx="1">
+            <a:schemeClr val="accent1"/>
+          </a:lnRef>
+          <a:fillRef idx="3">
+            <a:schemeClr val="accent1"/>
+          </a:fillRef>
+          <a:effectRef idx="2">
+            <a:schemeClr val="accent1"/>
+          </a:effectRef>
+          <a:fontRef idx="minor">
+            <a:schemeClr val="lt1"/>
+          </a:fontRef>
+        </p:style>
+        <p:txBody>
+          <a:bodyPr rtlCol="0" anchor="ctr"/>
+          <a:lstStyle/>
+          <a:p>
+            <a:pPr algn="ctr"/>
+          </a:p>
+        </p:txBody>
+      </p:sp>
+      <p:sp>
+        <p:nvSpPr>
+          <p:cNvPr id="44" name="TextBox 43"/>
+          <p:cNvSpPr txBox="1"/>
+          <p:nvPr/>
+        </p:nvSpPr>
+        <p:spPr>
+          <a:xfrm>
+            <a:off x="3964414" y="5932345"/>
+            <a:ext cx="2286000" cy="313006"/>
+          </a:xfrm>
+          <a:prstGeom prst="rect">
+            <a:avLst/>
+          </a:prstGeom>
+          <a:noFill/>
+        </p:spPr>
+        <p:txBody>
+          <a:bodyPr wrap="square" lIns="0" rIns="0" tIns="0" bIns="0">
+            <a:spAutoFit/>
+          </a:bodyPr>
+          <a:lstStyle/>
+          <a:p>
+            <a:r>
+              <a:rPr sz="1000" b="0">
+                <a:solidFill>
+                  <a:srgbClr val="6B7082"/>
+                </a:solidFill>
+                <a:latin typeface="Helvetica Neue"/>
+              </a:rPr>
+              <a:t>20,452   (26 posts · 787 avg)</a:t>
+            </a:r>
+          </a:p>
+        </p:txBody>
+      </p:sp>
+      <p:sp>
+        <p:nvSpPr>
+          <p:cNvPr id="45" name="TextBox 44"/>
           <p:cNvSpPr txBox="1"/>
           <p:nvPr/>
         </p:nvSpPr>
@@ -6951,7 +7062,7 @@
                 </a:solidFill>
                 <a:latin typeface="Helvetica Neue"/>
               </a:rPr>
-              <a:t>ALL-TIME CATEGORY RANKING · 2 OF 3</a:t>
+              <a:t>ALL-TIME CATEGORY RANKING · 2 OF 2</a:t>
             </a:r>
           </a:p>
         </p:txBody>
@@ -7019,7 +7130,7 @@
                 </a:solidFill>
                 <a:latin typeface="Helvetica Neue"/>
               </a:rPr>
-              <a:t>Categories ranked #13 and below. Same bar scale as page 1, so lengths compare directly.</a:t>
+              <a:t>Categories ranked #14 and below. Same bar scale as page 1, so lengths compare directly.</a:t>
             </a:r>
           </a:p>
         </p:txBody>
@@ -7033,7 +7144,7 @@
         <p:spPr>
           <a:xfrm>
             <a:off x="731520" y="2176272"/>
-            <a:ext cx="2468880" cy="329184"/>
+            <a:ext cx="2468880" cy="313006"/>
           </a:xfrm>
           <a:prstGeom prst="rect">
             <a:avLst/>
@@ -7053,7 +7164,7 @@
                 </a:solidFill>
                 <a:latin typeface="Helvetica Neue"/>
               </a:rPr>
-              <a:t>13. Community Events</a:t>
+              <a:t>14. AI Fake News</a:t>
             </a:r>
           </a:p>
         </p:txBody>
@@ -7067,119 +7178,7 @@
         <p:spPr>
           <a:xfrm>
             <a:off x="3383280" y="2203704"/>
-            <a:ext cx="489694" cy="192024"/>
-          </a:xfrm>
-          <a:prstGeom prst="rect">
-            <a:avLst/>
-          </a:prstGeom>
-          <a:solidFill>
-            <a:srgbClr val="141833"/>
-          </a:solidFill>
-          <a:ln>
-            <a:noFill/>
-          </a:ln>
-          <a:effectLst/>
-        </p:spPr>
-        <p:style>
-          <a:lnRef idx="1">
-            <a:schemeClr val="accent1"/>
-          </a:lnRef>
-          <a:fillRef idx="3">
-            <a:schemeClr val="accent1"/>
-          </a:fillRef>
-          <a:effectRef idx="2">
-            <a:schemeClr val="accent1"/>
-          </a:effectRef>
-          <a:fontRef idx="minor">
-            <a:schemeClr val="lt1"/>
-          </a:fontRef>
-        </p:style>
-        <p:txBody>
-          <a:bodyPr rtlCol="0" anchor="ctr"/>
-          <a:lstStyle/>
-          <a:p>
-            <a:pPr algn="ctr"/>
-          </a:p>
-        </p:txBody>
-      </p:sp>
-      <p:sp>
-        <p:nvSpPr>
-          <p:cNvPr id="8" name="TextBox 7"/>
-          <p:cNvSpPr txBox="1"/>
-          <p:nvPr/>
-        </p:nvSpPr>
-        <p:spPr>
-          <a:xfrm>
-            <a:off x="3964414" y="2176272"/>
-            <a:ext cx="2286000" cy="329184"/>
-          </a:xfrm>
-          <a:prstGeom prst="rect">
-            <a:avLst/>
-          </a:prstGeom>
-          <a:noFill/>
-        </p:spPr>
-        <p:txBody>
-          <a:bodyPr wrap="square" lIns="0" rIns="0" tIns="0" bIns="0">
-            <a:spAutoFit/>
-          </a:bodyPr>
-          <a:lstStyle/>
-          <a:p>
-            <a:r>
-              <a:rPr sz="1000" b="0">
-                <a:solidFill>
-                  <a:srgbClr val="6B7082"/>
-                </a:solidFill>
-                <a:latin typeface="Helvetica Neue"/>
-              </a:rPr>
-              <a:t>20,452   (26 posts · 787 avg)</a:t>
-            </a:r>
-          </a:p>
-        </p:txBody>
-      </p:sp>
-      <p:sp>
-        <p:nvSpPr>
-          <p:cNvPr id="9" name="TextBox 8"/>
-          <p:cNvSpPr txBox="1"/>
-          <p:nvPr/>
-        </p:nvSpPr>
-        <p:spPr>
-          <a:xfrm>
-            <a:off x="731520" y="2505456"/>
-            <a:ext cx="2468880" cy="329184"/>
-          </a:xfrm>
-          <a:prstGeom prst="rect">
-            <a:avLst/>
-          </a:prstGeom>
-          <a:noFill/>
-        </p:spPr>
-        <p:txBody>
-          <a:bodyPr wrap="square" lIns="0" rIns="0" tIns="0" bIns="0">
-            <a:spAutoFit/>
-          </a:bodyPr>
-          <a:lstStyle/>
-          <a:p>
-            <a:r>
-              <a:rPr sz="1100" b="0">
-                <a:solidFill>
-                  <a:srgbClr val="141833"/>
-                </a:solidFill>
-                <a:latin typeface="Helvetica Neue"/>
-              </a:rPr>
-              <a:t>14. AI Fake News</a:t>
-            </a:r>
-          </a:p>
-        </p:txBody>
-      </p:sp>
-      <p:sp>
-        <p:nvSpPr>
-          <p:cNvPr id="10" name="Rectangle 9"/>
-          <p:cNvSpPr/>
-          <p:nvPr/>
-        </p:nvSpPr>
-        <p:spPr>
-          <a:xfrm>
-            <a:off x="3383280" y="2532888"/>
-            <a:ext cx="316199" cy="192024"/>
+            <a:ext cx="316199" cy="175846"/>
           </a:xfrm>
           <a:prstGeom prst="rect">
             <a:avLst/>
@@ -7216,14 +7215,14 @@
       </p:sp>
       <p:sp>
         <p:nvSpPr>
-          <p:cNvPr id="11" name="TextBox 10"/>
-          <p:cNvSpPr txBox="1"/>
-          <p:nvPr/>
-        </p:nvSpPr>
-        <p:spPr>
-          <a:xfrm>
-            <a:off x="3790919" y="2505456"/>
-            <a:ext cx="2286000" cy="329184"/>
+          <p:cNvPr id="8" name="TextBox 7"/>
+          <p:cNvSpPr txBox="1"/>
+          <p:nvPr/>
+        </p:nvSpPr>
+        <p:spPr>
+          <a:xfrm>
+            <a:off x="3790919" y="2176272"/>
+            <a:ext cx="2286000" cy="313006"/>
           </a:xfrm>
           <a:prstGeom prst="rect">
             <a:avLst/>
@@ -7250,14 +7249,14 @@
       </p:sp>
       <p:sp>
         <p:nvSpPr>
-          <p:cNvPr id="12" name="TextBox 11"/>
-          <p:cNvSpPr txBox="1"/>
-          <p:nvPr/>
-        </p:nvSpPr>
-        <p:spPr>
-          <a:xfrm>
-            <a:off x="731520" y="2834640"/>
-            <a:ext cx="2468880" cy="329184"/>
+          <p:cNvPr id="9" name="TextBox 8"/>
+          <p:cNvSpPr txBox="1"/>
+          <p:nvPr/>
+        </p:nvSpPr>
+        <p:spPr>
+          <a:xfrm>
+            <a:off x="731520" y="2489278"/>
+            <a:ext cx="2468880" cy="313006"/>
           </a:xfrm>
           <a:prstGeom prst="rect">
             <a:avLst/>
@@ -7284,14 +7283,14 @@
       </p:sp>
       <p:sp>
         <p:nvSpPr>
-          <p:cNvPr id="13" name="Rectangle 12"/>
+          <p:cNvPr id="10" name="Rectangle 9"/>
           <p:cNvSpPr/>
           <p:nvPr/>
         </p:nvSpPr>
         <p:spPr>
           <a:xfrm>
-            <a:off x="3383280" y="2862072"/>
-            <a:ext cx="299750" cy="192024"/>
+            <a:off x="3383280" y="2516710"/>
+            <a:ext cx="299750" cy="175846"/>
           </a:xfrm>
           <a:prstGeom prst="rect">
             <a:avLst/>
@@ -7328,14 +7327,14 @@
       </p:sp>
       <p:sp>
         <p:nvSpPr>
-          <p:cNvPr id="14" name="TextBox 13"/>
-          <p:cNvSpPr txBox="1"/>
-          <p:nvPr/>
-        </p:nvSpPr>
-        <p:spPr>
-          <a:xfrm>
-            <a:off x="3774470" y="2834640"/>
-            <a:ext cx="2286000" cy="329184"/>
+          <p:cNvPr id="11" name="TextBox 10"/>
+          <p:cNvSpPr txBox="1"/>
+          <p:nvPr/>
+        </p:nvSpPr>
+        <p:spPr>
+          <a:xfrm>
+            <a:off x="3774470" y="2489278"/>
+            <a:ext cx="2286000" cy="313006"/>
           </a:xfrm>
           <a:prstGeom prst="rect">
             <a:avLst/>
@@ -7362,14 +7361,14 @@
       </p:sp>
       <p:sp>
         <p:nvSpPr>
-          <p:cNvPr id="15" name="TextBox 14"/>
-          <p:cNvSpPr txBox="1"/>
-          <p:nvPr/>
-        </p:nvSpPr>
-        <p:spPr>
-          <a:xfrm>
-            <a:off x="731520" y="3163824"/>
-            <a:ext cx="2468880" cy="329184"/>
+          <p:cNvPr id="12" name="TextBox 11"/>
+          <p:cNvSpPr txBox="1"/>
+          <p:nvPr/>
+        </p:nvSpPr>
+        <p:spPr>
+          <a:xfrm>
+            <a:off x="731520" y="2802284"/>
+            <a:ext cx="2468880" cy="313006"/>
           </a:xfrm>
           <a:prstGeom prst="rect">
             <a:avLst/>
@@ -7396,14 +7395,14 @@
       </p:sp>
       <p:sp>
         <p:nvSpPr>
-          <p:cNvPr id="16" name="Rectangle 15"/>
+          <p:cNvPr id="13" name="Rectangle 12"/>
           <p:cNvSpPr/>
           <p:nvPr/>
         </p:nvSpPr>
         <p:spPr>
           <a:xfrm>
-            <a:off x="3383280" y="3191256"/>
-            <a:ext cx="296373" cy="192024"/>
+            <a:off x="3383280" y="2829716"/>
+            <a:ext cx="296373" cy="175846"/>
           </a:xfrm>
           <a:prstGeom prst="rect">
             <a:avLst/>
@@ -7440,14 +7439,14 @@
       </p:sp>
       <p:sp>
         <p:nvSpPr>
-          <p:cNvPr id="17" name="TextBox 16"/>
-          <p:cNvSpPr txBox="1"/>
-          <p:nvPr/>
-        </p:nvSpPr>
-        <p:spPr>
-          <a:xfrm>
-            <a:off x="3771093" y="3163824"/>
-            <a:ext cx="2286000" cy="329184"/>
+          <p:cNvPr id="14" name="TextBox 13"/>
+          <p:cNvSpPr txBox="1"/>
+          <p:nvPr/>
+        </p:nvSpPr>
+        <p:spPr>
+          <a:xfrm>
+            <a:off x="3771093" y="2802284"/>
+            <a:ext cx="2286000" cy="313006"/>
           </a:xfrm>
           <a:prstGeom prst="rect">
             <a:avLst/>
@@ -7474,14 +7473,14 @@
       </p:sp>
       <p:sp>
         <p:nvSpPr>
-          <p:cNvPr id="18" name="TextBox 17"/>
-          <p:cNvSpPr txBox="1"/>
-          <p:nvPr/>
-        </p:nvSpPr>
-        <p:spPr>
-          <a:xfrm>
-            <a:off x="731520" y="3493008"/>
-            <a:ext cx="2468880" cy="329184"/>
+          <p:cNvPr id="15" name="TextBox 14"/>
+          <p:cNvSpPr txBox="1"/>
+          <p:nvPr/>
+        </p:nvSpPr>
+        <p:spPr>
+          <a:xfrm>
+            <a:off x="731520" y="3115290"/>
+            <a:ext cx="2468880" cy="313006"/>
           </a:xfrm>
           <a:prstGeom prst="rect">
             <a:avLst/>
@@ -7508,14 +7507,14 @@
       </p:sp>
       <p:sp>
         <p:nvSpPr>
-          <p:cNvPr id="19" name="Rectangle 18"/>
+          <p:cNvPr id="16" name="Rectangle 15"/>
           <p:cNvSpPr/>
           <p:nvPr/>
         </p:nvSpPr>
         <p:spPr>
           <a:xfrm>
-            <a:off x="3383280" y="3520440"/>
-            <a:ext cx="290220" cy="192024"/>
+            <a:off x="3383280" y="3142722"/>
+            <a:ext cx="290220" cy="175846"/>
           </a:xfrm>
           <a:prstGeom prst="rect">
             <a:avLst/>
@@ -7552,14 +7551,14 @@
       </p:sp>
       <p:sp>
         <p:nvSpPr>
-          <p:cNvPr id="20" name="TextBox 19"/>
-          <p:cNvSpPr txBox="1"/>
-          <p:nvPr/>
-        </p:nvSpPr>
-        <p:spPr>
-          <a:xfrm>
-            <a:off x="3764940" y="3493008"/>
-            <a:ext cx="2286000" cy="329184"/>
+          <p:cNvPr id="17" name="TextBox 16"/>
+          <p:cNvSpPr txBox="1"/>
+          <p:nvPr/>
+        </p:nvSpPr>
+        <p:spPr>
+          <a:xfrm>
+            <a:off x="3764940" y="3115290"/>
+            <a:ext cx="2286000" cy="313006"/>
           </a:xfrm>
           <a:prstGeom prst="rect">
             <a:avLst/>
@@ -7586,14 +7585,14 @@
       </p:sp>
       <p:sp>
         <p:nvSpPr>
-          <p:cNvPr id="21" name="TextBox 20"/>
-          <p:cNvSpPr txBox="1"/>
-          <p:nvPr/>
-        </p:nvSpPr>
-        <p:spPr>
-          <a:xfrm>
-            <a:off x="731520" y="3822192"/>
-            <a:ext cx="2468880" cy="329184"/>
+          <p:cNvPr id="18" name="TextBox 17"/>
+          <p:cNvSpPr txBox="1"/>
+          <p:nvPr/>
+        </p:nvSpPr>
+        <p:spPr>
+          <a:xfrm>
+            <a:off x="731520" y="3428296"/>
+            <a:ext cx="2468880" cy="313006"/>
           </a:xfrm>
           <a:prstGeom prst="rect">
             <a:avLst/>
@@ -7620,14 +7619,14 @@
       </p:sp>
       <p:sp>
         <p:nvSpPr>
-          <p:cNvPr id="22" name="Rectangle 21"/>
+          <p:cNvPr id="19" name="Rectangle 18"/>
           <p:cNvSpPr/>
           <p:nvPr/>
         </p:nvSpPr>
         <p:spPr>
           <a:xfrm>
-            <a:off x="3383280" y="3849624"/>
-            <a:ext cx="281121" cy="192024"/>
+            <a:off x="3383280" y="3455728"/>
+            <a:ext cx="281121" cy="175846"/>
           </a:xfrm>
           <a:prstGeom prst="rect">
             <a:avLst/>
@@ -7664,14 +7663,14 @@
       </p:sp>
       <p:sp>
         <p:nvSpPr>
-          <p:cNvPr id="23" name="TextBox 22"/>
-          <p:cNvSpPr txBox="1"/>
-          <p:nvPr/>
-        </p:nvSpPr>
-        <p:spPr>
-          <a:xfrm>
-            <a:off x="3755841" y="3822192"/>
-            <a:ext cx="2286000" cy="329184"/>
+          <p:cNvPr id="20" name="TextBox 19"/>
+          <p:cNvSpPr txBox="1"/>
+          <p:nvPr/>
+        </p:nvSpPr>
+        <p:spPr>
+          <a:xfrm>
+            <a:off x="3755841" y="3428296"/>
+            <a:ext cx="2286000" cy="313006"/>
           </a:xfrm>
           <a:prstGeom prst="rect">
             <a:avLst/>
@@ -7698,14 +7697,14 @@
       </p:sp>
       <p:sp>
         <p:nvSpPr>
-          <p:cNvPr id="24" name="TextBox 23"/>
-          <p:cNvSpPr txBox="1"/>
-          <p:nvPr/>
-        </p:nvSpPr>
-        <p:spPr>
-          <a:xfrm>
-            <a:off x="731520" y="4151376"/>
-            <a:ext cx="2468880" cy="329184"/>
+          <p:cNvPr id="21" name="TextBox 20"/>
+          <p:cNvSpPr txBox="1"/>
+          <p:nvPr/>
+        </p:nvSpPr>
+        <p:spPr>
+          <a:xfrm>
+            <a:off x="731520" y="3741302"/>
+            <a:ext cx="2468880" cy="313006"/>
           </a:xfrm>
           <a:prstGeom prst="rect">
             <a:avLst/>
@@ -7732,14 +7731,14 @@
       </p:sp>
       <p:sp>
         <p:nvSpPr>
-          <p:cNvPr id="25" name="Rectangle 24"/>
+          <p:cNvPr id="22" name="Rectangle 21"/>
           <p:cNvSpPr/>
           <p:nvPr/>
         </p:nvSpPr>
         <p:spPr>
           <a:xfrm>
-            <a:off x="3383280" y="4178807"/>
-            <a:ext cx="280331" cy="192024"/>
+            <a:off x="3383280" y="3768734"/>
+            <a:ext cx="280331" cy="175846"/>
           </a:xfrm>
           <a:prstGeom prst="rect">
             <a:avLst/>
@@ -7776,14 +7775,14 @@
       </p:sp>
       <p:sp>
         <p:nvSpPr>
-          <p:cNvPr id="26" name="TextBox 25"/>
-          <p:cNvSpPr txBox="1"/>
-          <p:nvPr/>
-        </p:nvSpPr>
-        <p:spPr>
-          <a:xfrm>
-            <a:off x="3755051" y="4151376"/>
-            <a:ext cx="2286000" cy="329184"/>
+          <p:cNvPr id="23" name="TextBox 22"/>
+          <p:cNvSpPr txBox="1"/>
+          <p:nvPr/>
+        </p:nvSpPr>
+        <p:spPr>
+          <a:xfrm>
+            <a:off x="3755051" y="3741302"/>
+            <a:ext cx="2286000" cy="313006"/>
           </a:xfrm>
           <a:prstGeom prst="rect">
             <a:avLst/>
@@ -7810,14 +7809,14 @@
       </p:sp>
       <p:sp>
         <p:nvSpPr>
-          <p:cNvPr id="27" name="TextBox 26"/>
-          <p:cNvSpPr txBox="1"/>
-          <p:nvPr/>
-        </p:nvSpPr>
-        <p:spPr>
-          <a:xfrm>
-            <a:off x="731520" y="4480560"/>
-            <a:ext cx="2468880" cy="329184"/>
+          <p:cNvPr id="24" name="TextBox 23"/>
+          <p:cNvSpPr txBox="1"/>
+          <p:nvPr/>
+        </p:nvSpPr>
+        <p:spPr>
+          <a:xfrm>
+            <a:off x="731520" y="4054308"/>
+            <a:ext cx="2468880" cy="313006"/>
           </a:xfrm>
           <a:prstGeom prst="rect">
             <a:avLst/>
@@ -7844,14 +7843,14 @@
       </p:sp>
       <p:sp>
         <p:nvSpPr>
-          <p:cNvPr id="28" name="Rectangle 27"/>
+          <p:cNvPr id="25" name="Rectangle 24"/>
           <p:cNvSpPr/>
           <p:nvPr/>
         </p:nvSpPr>
         <p:spPr>
           <a:xfrm>
-            <a:off x="3383280" y="4507992"/>
-            <a:ext cx="260817" cy="192024"/>
+            <a:off x="3383280" y="4081740"/>
+            <a:ext cx="260817" cy="175846"/>
           </a:xfrm>
           <a:prstGeom prst="rect">
             <a:avLst/>
@@ -7888,14 +7887,14 @@
       </p:sp>
       <p:sp>
         <p:nvSpPr>
-          <p:cNvPr id="29" name="TextBox 28"/>
-          <p:cNvSpPr txBox="1"/>
-          <p:nvPr/>
-        </p:nvSpPr>
-        <p:spPr>
-          <a:xfrm>
-            <a:off x="3735537" y="4480560"/>
-            <a:ext cx="2286000" cy="329184"/>
+          <p:cNvPr id="26" name="TextBox 25"/>
+          <p:cNvSpPr txBox="1"/>
+          <p:nvPr/>
+        </p:nvSpPr>
+        <p:spPr>
+          <a:xfrm>
+            <a:off x="3735537" y="4054308"/>
+            <a:ext cx="2286000" cy="313006"/>
           </a:xfrm>
           <a:prstGeom prst="rect">
             <a:avLst/>
@@ -7922,14 +7921,14 @@
       </p:sp>
       <p:sp>
         <p:nvSpPr>
-          <p:cNvPr id="30" name="TextBox 29"/>
-          <p:cNvSpPr txBox="1"/>
-          <p:nvPr/>
-        </p:nvSpPr>
-        <p:spPr>
-          <a:xfrm>
-            <a:off x="731520" y="4809744"/>
-            <a:ext cx="2468880" cy="329184"/>
+          <p:cNvPr id="27" name="TextBox 26"/>
+          <p:cNvSpPr txBox="1"/>
+          <p:nvPr/>
+        </p:nvSpPr>
+        <p:spPr>
+          <a:xfrm>
+            <a:off x="731520" y="4367315"/>
+            <a:ext cx="2468880" cy="313006"/>
           </a:xfrm>
           <a:prstGeom prst="rect">
             <a:avLst/>
@@ -7956,14 +7955,14 @@
       </p:sp>
       <p:sp>
         <p:nvSpPr>
-          <p:cNvPr id="31" name="Rectangle 30"/>
+          <p:cNvPr id="28" name="Rectangle 27"/>
           <p:cNvSpPr/>
           <p:nvPr/>
         </p:nvSpPr>
         <p:spPr>
           <a:xfrm>
-            <a:off x="3383280" y="4837176"/>
-            <a:ext cx="210895" cy="192024"/>
+            <a:off x="3383280" y="4394747"/>
+            <a:ext cx="210895" cy="175846"/>
           </a:xfrm>
           <a:prstGeom prst="rect">
             <a:avLst/>
@@ -8000,14 +7999,14 @@
       </p:sp>
       <p:sp>
         <p:nvSpPr>
-          <p:cNvPr id="32" name="TextBox 31"/>
-          <p:cNvSpPr txBox="1"/>
-          <p:nvPr/>
-        </p:nvSpPr>
-        <p:spPr>
-          <a:xfrm>
-            <a:off x="3685615" y="4809744"/>
-            <a:ext cx="2286000" cy="329184"/>
+          <p:cNvPr id="29" name="TextBox 28"/>
+          <p:cNvSpPr txBox="1"/>
+          <p:nvPr/>
+        </p:nvSpPr>
+        <p:spPr>
+          <a:xfrm>
+            <a:off x="3685615" y="4367315"/>
+            <a:ext cx="2286000" cy="313006"/>
           </a:xfrm>
           <a:prstGeom prst="rect">
             <a:avLst/>
@@ -8034,14 +8033,14 @@
       </p:sp>
       <p:sp>
         <p:nvSpPr>
-          <p:cNvPr id="33" name="TextBox 32"/>
-          <p:cNvSpPr txBox="1"/>
-          <p:nvPr/>
-        </p:nvSpPr>
-        <p:spPr>
-          <a:xfrm>
-            <a:off x="731520" y="5138928"/>
-            <a:ext cx="2468880" cy="329184"/>
+          <p:cNvPr id="30" name="TextBox 29"/>
+          <p:cNvSpPr txBox="1"/>
+          <p:nvPr/>
+        </p:nvSpPr>
+        <p:spPr>
+          <a:xfrm>
+            <a:off x="731520" y="4680321"/>
+            <a:ext cx="2468880" cy="313006"/>
           </a:xfrm>
           <a:prstGeom prst="rect">
             <a:avLst/>
@@ -8068,14 +8067,14 @@
       </p:sp>
       <p:sp>
         <p:nvSpPr>
-          <p:cNvPr id="34" name="Rectangle 33"/>
+          <p:cNvPr id="31" name="Rectangle 30"/>
           <p:cNvSpPr/>
           <p:nvPr/>
         </p:nvSpPr>
         <p:spPr>
           <a:xfrm>
-            <a:off x="3383280" y="5166359"/>
-            <a:ext cx="186017" cy="192024"/>
+            <a:off x="3383280" y="4707753"/>
+            <a:ext cx="186017" cy="175846"/>
           </a:xfrm>
           <a:prstGeom prst="rect">
             <a:avLst/>
@@ -8112,14 +8111,14 @@
       </p:sp>
       <p:sp>
         <p:nvSpPr>
-          <p:cNvPr id="35" name="TextBox 34"/>
-          <p:cNvSpPr txBox="1"/>
-          <p:nvPr/>
-        </p:nvSpPr>
-        <p:spPr>
-          <a:xfrm>
-            <a:off x="3660737" y="5138928"/>
-            <a:ext cx="2286000" cy="329184"/>
+          <p:cNvPr id="32" name="TextBox 31"/>
+          <p:cNvSpPr txBox="1"/>
+          <p:nvPr/>
+        </p:nvSpPr>
+        <p:spPr>
+          <a:xfrm>
+            <a:off x="3660737" y="4680321"/>
+            <a:ext cx="2286000" cy="313006"/>
           </a:xfrm>
           <a:prstGeom prst="rect">
             <a:avLst/>
@@ -8146,14 +8145,14 @@
       </p:sp>
       <p:sp>
         <p:nvSpPr>
-          <p:cNvPr id="36" name="TextBox 35"/>
-          <p:cNvSpPr txBox="1"/>
-          <p:nvPr/>
-        </p:nvSpPr>
-        <p:spPr>
-          <a:xfrm>
-            <a:off x="731520" y="5468112"/>
-            <a:ext cx="2468880" cy="329184"/>
+          <p:cNvPr id="33" name="TextBox 32"/>
+          <p:cNvSpPr txBox="1"/>
+          <p:nvPr/>
+        </p:nvSpPr>
+        <p:spPr>
+          <a:xfrm>
+            <a:off x="731520" y="4993327"/>
+            <a:ext cx="2468880" cy="313006"/>
           </a:xfrm>
           <a:prstGeom prst="rect">
             <a:avLst/>
@@ -8180,14 +8179,14 @@
       </p:sp>
       <p:sp>
         <p:nvSpPr>
-          <p:cNvPr id="37" name="Rectangle 36"/>
+          <p:cNvPr id="34" name="Rectangle 33"/>
           <p:cNvSpPr/>
           <p:nvPr/>
         </p:nvSpPr>
         <p:spPr>
           <a:xfrm>
-            <a:off x="3383280" y="5495543"/>
-            <a:ext cx="161020" cy="192024"/>
+            <a:off x="3383280" y="5020759"/>
+            <a:ext cx="161020" cy="175846"/>
           </a:xfrm>
           <a:prstGeom prst="rect">
             <a:avLst/>
@@ -8224,14 +8223,14 @@
       </p:sp>
       <p:sp>
         <p:nvSpPr>
-          <p:cNvPr id="38" name="TextBox 37"/>
-          <p:cNvSpPr txBox="1"/>
-          <p:nvPr/>
-        </p:nvSpPr>
-        <p:spPr>
-          <a:xfrm>
-            <a:off x="3635740" y="5468112"/>
-            <a:ext cx="2286000" cy="329184"/>
+          <p:cNvPr id="35" name="TextBox 34"/>
+          <p:cNvSpPr txBox="1"/>
+          <p:nvPr/>
+        </p:nvSpPr>
+        <p:spPr>
+          <a:xfrm>
+            <a:off x="3635740" y="4993327"/>
+            <a:ext cx="2286000" cy="313006"/>
           </a:xfrm>
           <a:prstGeom prst="rect">
             <a:avLst/>
@@ -8258,14 +8257,14 @@
       </p:sp>
       <p:sp>
         <p:nvSpPr>
-          <p:cNvPr id="39" name="TextBox 38"/>
-          <p:cNvSpPr txBox="1"/>
-          <p:nvPr/>
-        </p:nvSpPr>
-        <p:spPr>
-          <a:xfrm>
-            <a:off x="731520" y="5797296"/>
-            <a:ext cx="2468880" cy="329184"/>
+          <p:cNvPr id="36" name="TextBox 35"/>
+          <p:cNvSpPr txBox="1"/>
+          <p:nvPr/>
+        </p:nvSpPr>
+        <p:spPr>
+          <a:xfrm>
+            <a:off x="731520" y="5306333"/>
+            <a:ext cx="2468880" cy="313006"/>
           </a:xfrm>
           <a:prstGeom prst="rect">
             <a:avLst/>
@@ -8292,14 +8291,14 @@
       </p:sp>
       <p:sp>
         <p:nvSpPr>
-          <p:cNvPr id="40" name="Rectangle 39"/>
+          <p:cNvPr id="37" name="Rectangle 36"/>
           <p:cNvSpPr/>
           <p:nvPr/>
         </p:nvSpPr>
         <p:spPr>
           <a:xfrm>
-            <a:off x="3383280" y="5824728"/>
-            <a:ext cx="144858" cy="192024"/>
+            <a:off x="3383280" y="5333765"/>
+            <a:ext cx="144858" cy="175846"/>
           </a:xfrm>
           <a:prstGeom prst="rect">
             <a:avLst/>
@@ -8336,14 +8335,126 @@
       </p:sp>
       <p:sp>
         <p:nvSpPr>
+          <p:cNvPr id="38" name="TextBox 37"/>
+          <p:cNvSpPr txBox="1"/>
+          <p:nvPr/>
+        </p:nvSpPr>
+        <p:spPr>
+          <a:xfrm>
+            <a:off x="3619578" y="5306333"/>
+            <a:ext cx="2286000" cy="313006"/>
+          </a:xfrm>
+          <a:prstGeom prst="rect">
+            <a:avLst/>
+          </a:prstGeom>
+          <a:noFill/>
+        </p:spPr>
+        <p:txBody>
+          <a:bodyPr wrap="square" lIns="0" rIns="0" tIns="0" bIns="0">
+            <a:spAutoFit/>
+          </a:bodyPr>
+          <a:lstStyle/>
+          <a:p>
+            <a:r>
+              <a:rPr sz="1000" b="0">
+                <a:solidFill>
+                  <a:srgbClr val="6B7082"/>
+                </a:solidFill>
+                <a:latin typeface="Helvetica Neue"/>
+              </a:rPr>
+              <a:t>6,050   (21 posts · 288 avg)</a:t>
+            </a:r>
+          </a:p>
+        </p:txBody>
+      </p:sp>
+      <p:sp>
+        <p:nvSpPr>
+          <p:cNvPr id="39" name="TextBox 38"/>
+          <p:cNvSpPr txBox="1"/>
+          <p:nvPr/>
+        </p:nvSpPr>
+        <p:spPr>
+          <a:xfrm>
+            <a:off x="731520" y="5619339"/>
+            <a:ext cx="2468880" cy="313006"/>
+          </a:xfrm>
+          <a:prstGeom prst="rect">
+            <a:avLst/>
+          </a:prstGeom>
+          <a:noFill/>
+        </p:spPr>
+        <p:txBody>
+          <a:bodyPr wrap="square" lIns="0" rIns="0" tIns="0" bIns="0">
+            <a:spAutoFit/>
+          </a:bodyPr>
+          <a:lstStyle/>
+          <a:p>
+            <a:r>
+              <a:rPr sz="1100" b="0">
+                <a:solidFill>
+                  <a:srgbClr val="141833"/>
+                </a:solidFill>
+                <a:latin typeface="Helvetica Neue"/>
+              </a:rPr>
+              <a:t>25. Brand Growth</a:t>
+            </a:r>
+          </a:p>
+        </p:txBody>
+      </p:sp>
+      <p:sp>
+        <p:nvSpPr>
+          <p:cNvPr id="40" name="Rectangle 39"/>
+          <p:cNvSpPr/>
+          <p:nvPr/>
+        </p:nvSpPr>
+        <p:spPr>
+          <a:xfrm>
+            <a:off x="3383280" y="5646771"/>
+            <a:ext cx="53011" cy="175846"/>
+          </a:xfrm>
+          <a:prstGeom prst="rect">
+            <a:avLst/>
+          </a:prstGeom>
+          <a:solidFill>
+            <a:srgbClr val="E87E8F"/>
+          </a:solidFill>
+          <a:ln>
+            <a:noFill/>
+          </a:ln>
+          <a:effectLst/>
+        </p:spPr>
+        <p:style>
+          <a:lnRef idx="1">
+            <a:schemeClr val="accent1"/>
+          </a:lnRef>
+          <a:fillRef idx="3">
+            <a:schemeClr val="accent1"/>
+          </a:fillRef>
+          <a:effectRef idx="2">
+            <a:schemeClr val="accent1"/>
+          </a:effectRef>
+          <a:fontRef idx="minor">
+            <a:schemeClr val="lt1"/>
+          </a:fontRef>
+        </p:style>
+        <p:txBody>
+          <a:bodyPr rtlCol="0" anchor="ctr"/>
+          <a:lstStyle/>
+          <a:p>
+            <a:pPr algn="ctr"/>
+          </a:p>
+        </p:txBody>
+      </p:sp>
+      <p:sp>
+        <p:nvSpPr>
           <p:cNvPr id="41" name="TextBox 40"/>
           <p:cNvSpPr txBox="1"/>
           <p:nvPr/>
         </p:nvSpPr>
         <p:spPr>
           <a:xfrm>
-            <a:off x="3619578" y="5797296"/>
-            <a:ext cx="2286000" cy="329184"/>
+            <a:off x="3527731" y="5619339"/>
+            <a:ext cx="2286000" cy="313006"/>
           </a:xfrm>
           <a:prstGeom prst="rect">
             <a:avLst/>
@@ -8363,7 +8474,7 @@
                 </a:solidFill>
                 <a:latin typeface="Helvetica Neue"/>
               </a:rPr>
-              <a:t>6,050   (21 posts · 288 avg)</a:t>
+              <a:t>2,214   (4 posts · 554 avg)</a:t>
             </a:r>
           </a:p>
         </p:txBody>
@@ -8371,6 +8482,118 @@
       <p:sp>
         <p:nvSpPr>
           <p:cNvPr id="42" name="TextBox 41"/>
+          <p:cNvSpPr txBox="1"/>
+          <p:nvPr/>
+        </p:nvSpPr>
+        <p:spPr>
+          <a:xfrm>
+            <a:off x="731520" y="5932345"/>
+            <a:ext cx="2468880" cy="313006"/>
+          </a:xfrm>
+          <a:prstGeom prst="rect">
+            <a:avLst/>
+          </a:prstGeom>
+          <a:noFill/>
+        </p:spPr>
+        <p:txBody>
+          <a:bodyPr wrap="square" lIns="0" rIns="0" tIns="0" bIns="0">
+            <a:spAutoFit/>
+          </a:bodyPr>
+          <a:lstStyle/>
+          <a:p>
+            <a:r>
+              <a:rPr sz="1100" b="0">
+                <a:solidFill>
+                  <a:srgbClr val="141833"/>
+                </a:solidFill>
+                <a:latin typeface="Helvetica Neue"/>
+              </a:rPr>
+              <a:t>26. Other</a:t>
+            </a:r>
+          </a:p>
+        </p:txBody>
+      </p:sp>
+      <p:sp>
+        <p:nvSpPr>
+          <p:cNvPr id="43" name="Rectangle 42"/>
+          <p:cNvSpPr/>
+          <p:nvPr/>
+        </p:nvSpPr>
+        <p:spPr>
+          <a:xfrm>
+            <a:off x="3383280" y="5959777"/>
+            <a:ext cx="45720" cy="175846"/>
+          </a:xfrm>
+          <a:prstGeom prst="rect">
+            <a:avLst/>
+          </a:prstGeom>
+          <a:solidFill>
+            <a:srgbClr val="6B7082"/>
+          </a:solidFill>
+          <a:ln>
+            <a:noFill/>
+          </a:ln>
+          <a:effectLst/>
+        </p:spPr>
+        <p:style>
+          <a:lnRef idx="1">
+            <a:schemeClr val="accent1"/>
+          </a:lnRef>
+          <a:fillRef idx="3">
+            <a:schemeClr val="accent1"/>
+          </a:fillRef>
+          <a:effectRef idx="2">
+            <a:schemeClr val="accent1"/>
+          </a:effectRef>
+          <a:fontRef idx="minor">
+            <a:schemeClr val="lt1"/>
+          </a:fontRef>
+        </p:style>
+        <p:txBody>
+          <a:bodyPr rtlCol="0" anchor="ctr"/>
+          <a:lstStyle/>
+          <a:p>
+            <a:pPr algn="ctr"/>
+          </a:p>
+        </p:txBody>
+      </p:sp>
+      <p:sp>
+        <p:nvSpPr>
+          <p:cNvPr id="44" name="TextBox 43"/>
+          <p:cNvSpPr txBox="1"/>
+          <p:nvPr/>
+        </p:nvSpPr>
+        <p:spPr>
+          <a:xfrm>
+            <a:off x="3520440" y="5932345"/>
+            <a:ext cx="2286000" cy="313006"/>
+          </a:xfrm>
+          <a:prstGeom prst="rect">
+            <a:avLst/>
+          </a:prstGeom>
+          <a:noFill/>
+        </p:spPr>
+        <p:txBody>
+          <a:bodyPr wrap="square" lIns="0" rIns="0" tIns="0" bIns="0">
+            <a:spAutoFit/>
+          </a:bodyPr>
+          <a:lstStyle/>
+          <a:p>
+            <a:r>
+              <a:rPr sz="1000" b="0">
+                <a:solidFill>
+                  <a:srgbClr val="6B7082"/>
+                </a:solidFill>
+                <a:latin typeface="Helvetica Neue"/>
+              </a:rPr>
+              <a:t>1,297   (25 posts · 52 avg)</a:t>
+            </a:r>
+          </a:p>
+        </p:txBody>
+      </p:sp>
+      <p:sp>
+        <p:nvSpPr>
+          <p:cNvPr id="45" name="TextBox 44"/>
           <p:cNvSpPr txBox="1"/>
           <p:nvPr/>
         </p:nvSpPr>
@@ -8411,428 +8634,6 @@
 </file>
 
 <file path=ppt/slides/slide6.xml><?xml version="1.0" encoding="utf-8"?>
-<p:sld xmlns:a="http://schemas.openxmlformats.org/drawingml/2006/main" xmlns:p="http://schemas.openxmlformats.org/presentationml/2006/main" xmlns:r="http://schemas.openxmlformats.org/officeDocument/2006/relationships">
-  <p:cSld>
-    <p:spTree>
-      <p:nvGrpSpPr>
-        <p:cNvPr id="1" name=""/>
-        <p:cNvGrpSpPr/>
-        <p:nvPr/>
-      </p:nvGrpSpPr>
-      <p:grpSpPr/>
-      <p:sp>
-        <p:nvSpPr>
-          <p:cNvPr id="2" name="Rectangle 1"/>
-          <p:cNvSpPr/>
-          <p:nvPr/>
-        </p:nvSpPr>
-        <p:spPr>
-          <a:xfrm>
-            <a:off x="0" y="0"/>
-            <a:ext cx="12191695" cy="6858000"/>
-          </a:xfrm>
-          <a:prstGeom prst="rect">
-            <a:avLst/>
-          </a:prstGeom>
-          <a:solidFill>
-            <a:srgbClr val="FCF6F5"/>
-          </a:solidFill>
-          <a:ln>
-            <a:noFill/>
-          </a:ln>
-          <a:effectLst/>
-        </p:spPr>
-        <p:style>
-          <a:lnRef idx="1">
-            <a:schemeClr val="accent1"/>
-          </a:lnRef>
-          <a:fillRef idx="3">
-            <a:schemeClr val="accent1"/>
-          </a:fillRef>
-          <a:effectRef idx="2">
-            <a:schemeClr val="accent1"/>
-          </a:effectRef>
-          <a:fontRef idx="minor">
-            <a:schemeClr val="lt1"/>
-          </a:fontRef>
-        </p:style>
-        <p:txBody>
-          <a:bodyPr rtlCol="0" anchor="ctr"/>
-          <a:lstStyle/>
-          <a:p>
-            <a:pPr algn="ctr"/>
-          </a:p>
-        </p:txBody>
-      </p:sp>
-      <p:sp>
-        <p:nvSpPr>
-          <p:cNvPr id="3" name="TextBox 2"/>
-          <p:cNvSpPr txBox="1"/>
-          <p:nvPr/>
-        </p:nvSpPr>
-        <p:spPr>
-          <a:xfrm>
-            <a:off x="731520" y="457200"/>
-            <a:ext cx="10698480" cy="365760"/>
-          </a:xfrm>
-          <a:prstGeom prst="rect">
-            <a:avLst/>
-          </a:prstGeom>
-          <a:noFill/>
-        </p:spPr>
-        <p:txBody>
-          <a:bodyPr wrap="square" lIns="0" rIns="0" tIns="0" bIns="0">
-            <a:spAutoFit/>
-          </a:bodyPr>
-          <a:lstStyle/>
-          <a:p>
-            <a:r>
-              <a:rPr sz="1200" b="1">
-                <a:solidFill>
-                  <a:srgbClr val="990011"/>
-                </a:solidFill>
-                <a:latin typeface="Helvetica Neue"/>
-              </a:rPr>
-              <a:t>ALL-TIME CATEGORY RANKING · 3 OF 3</a:t>
-            </a:r>
-          </a:p>
-        </p:txBody>
-      </p:sp>
-      <p:sp>
-        <p:nvSpPr>
-          <p:cNvPr id="4" name="TextBox 3"/>
-          <p:cNvSpPr txBox="1"/>
-          <p:nvPr/>
-        </p:nvSpPr>
-        <p:spPr>
-          <a:xfrm>
-            <a:off x="731520" y="822960"/>
-            <a:ext cx="10698480" cy="822960"/>
-          </a:xfrm>
-          <a:prstGeom prst="rect">
-            <a:avLst/>
-          </a:prstGeom>
-          <a:noFill/>
-        </p:spPr>
-        <p:txBody>
-          <a:bodyPr wrap="square" lIns="0" rIns="0" tIns="0" bIns="0">
-            <a:spAutoFit/>
-          </a:bodyPr>
-          <a:lstStyle/>
-          <a:p>
-            <a:r>
-              <a:rPr sz="3000" b="1">
-                <a:solidFill>
-                  <a:srgbClr val="2F3C7E"/>
-                </a:solidFill>
-                <a:latin typeface="Georgia"/>
-              </a:rPr>
-              <a:t>The rest of the field</a:t>
-            </a:r>
-          </a:p>
-        </p:txBody>
-      </p:sp>
-      <p:sp>
-        <p:nvSpPr>
-          <p:cNvPr id="5" name="TextBox 4"/>
-          <p:cNvSpPr txBox="1"/>
-          <p:nvPr/>
-        </p:nvSpPr>
-        <p:spPr>
-          <a:xfrm>
-            <a:off x="731520" y="1600200"/>
-            <a:ext cx="10698480" cy="365760"/>
-          </a:xfrm>
-          <a:prstGeom prst="rect">
-            <a:avLst/>
-          </a:prstGeom>
-          <a:noFill/>
-        </p:spPr>
-        <p:txBody>
-          <a:bodyPr wrap="square" lIns="0" rIns="0" tIns="0" bIns="0">
-            <a:spAutoFit/>
-          </a:bodyPr>
-          <a:lstStyle/>
-          <a:p>
-            <a:r>
-              <a:rPr sz="1200" b="0">
-                <a:solidFill>
-                  <a:srgbClr val="6B7082"/>
-                </a:solidFill>
-                <a:latin typeface="Helvetica Neue"/>
-              </a:rPr>
-              <a:t>Categories ranked #25 and below. Same bar scale as page 1, so lengths compare directly.</a:t>
-            </a:r>
-          </a:p>
-        </p:txBody>
-      </p:sp>
-      <p:sp>
-        <p:nvSpPr>
-          <p:cNvPr id="6" name="TextBox 5"/>
-          <p:cNvSpPr txBox="1"/>
-          <p:nvPr/>
-        </p:nvSpPr>
-        <p:spPr>
-          <a:xfrm>
-            <a:off x="731520" y="2176272"/>
-            <a:ext cx="2468880" cy="329184"/>
-          </a:xfrm>
-          <a:prstGeom prst="rect">
-            <a:avLst/>
-          </a:prstGeom>
-          <a:noFill/>
-        </p:spPr>
-        <p:txBody>
-          <a:bodyPr wrap="square" lIns="0" rIns="0" tIns="0" bIns="0">
-            <a:spAutoFit/>
-          </a:bodyPr>
-          <a:lstStyle/>
-          <a:p>
-            <a:r>
-              <a:rPr sz="1100" b="0">
-                <a:solidFill>
-                  <a:srgbClr val="141833"/>
-                </a:solidFill>
-                <a:latin typeface="Helvetica Neue"/>
-              </a:rPr>
-              <a:t>25. Brand Growth</a:t>
-            </a:r>
-          </a:p>
-        </p:txBody>
-      </p:sp>
-      <p:sp>
-        <p:nvSpPr>
-          <p:cNvPr id="7" name="Rectangle 6"/>
-          <p:cNvSpPr/>
-          <p:nvPr/>
-        </p:nvSpPr>
-        <p:spPr>
-          <a:xfrm>
-            <a:off x="3383280" y="2203704"/>
-            <a:ext cx="53011" cy="192024"/>
-          </a:xfrm>
-          <a:prstGeom prst="rect">
-            <a:avLst/>
-          </a:prstGeom>
-          <a:solidFill>
-            <a:srgbClr val="E87E8F"/>
-          </a:solidFill>
-          <a:ln>
-            <a:noFill/>
-          </a:ln>
-          <a:effectLst/>
-        </p:spPr>
-        <p:style>
-          <a:lnRef idx="1">
-            <a:schemeClr val="accent1"/>
-          </a:lnRef>
-          <a:fillRef idx="3">
-            <a:schemeClr val="accent1"/>
-          </a:fillRef>
-          <a:effectRef idx="2">
-            <a:schemeClr val="accent1"/>
-          </a:effectRef>
-          <a:fontRef idx="minor">
-            <a:schemeClr val="lt1"/>
-          </a:fontRef>
-        </p:style>
-        <p:txBody>
-          <a:bodyPr rtlCol="0" anchor="ctr"/>
-          <a:lstStyle/>
-          <a:p>
-            <a:pPr algn="ctr"/>
-          </a:p>
-        </p:txBody>
-      </p:sp>
-      <p:sp>
-        <p:nvSpPr>
-          <p:cNvPr id="8" name="TextBox 7"/>
-          <p:cNvSpPr txBox="1"/>
-          <p:nvPr/>
-        </p:nvSpPr>
-        <p:spPr>
-          <a:xfrm>
-            <a:off x="3527731" y="2176272"/>
-            <a:ext cx="2286000" cy="329184"/>
-          </a:xfrm>
-          <a:prstGeom prst="rect">
-            <a:avLst/>
-          </a:prstGeom>
-          <a:noFill/>
-        </p:spPr>
-        <p:txBody>
-          <a:bodyPr wrap="square" lIns="0" rIns="0" tIns="0" bIns="0">
-            <a:spAutoFit/>
-          </a:bodyPr>
-          <a:lstStyle/>
-          <a:p>
-            <a:r>
-              <a:rPr sz="1000" b="0">
-                <a:solidFill>
-                  <a:srgbClr val="6B7082"/>
-                </a:solidFill>
-                <a:latin typeface="Helvetica Neue"/>
-              </a:rPr>
-              <a:t>2,214   (4 posts · 554 avg)</a:t>
-            </a:r>
-          </a:p>
-        </p:txBody>
-      </p:sp>
-      <p:sp>
-        <p:nvSpPr>
-          <p:cNvPr id="9" name="TextBox 8"/>
-          <p:cNvSpPr txBox="1"/>
-          <p:nvPr/>
-        </p:nvSpPr>
-        <p:spPr>
-          <a:xfrm>
-            <a:off x="731520" y="2505456"/>
-            <a:ext cx="2468880" cy="329184"/>
-          </a:xfrm>
-          <a:prstGeom prst="rect">
-            <a:avLst/>
-          </a:prstGeom>
-          <a:noFill/>
-        </p:spPr>
-        <p:txBody>
-          <a:bodyPr wrap="square" lIns="0" rIns="0" tIns="0" bIns="0">
-            <a:spAutoFit/>
-          </a:bodyPr>
-          <a:lstStyle/>
-          <a:p>
-            <a:r>
-              <a:rPr sz="1100" b="0">
-                <a:solidFill>
-                  <a:srgbClr val="141833"/>
-                </a:solidFill>
-                <a:latin typeface="Helvetica Neue"/>
-              </a:rPr>
-              <a:t>26. Other</a:t>
-            </a:r>
-          </a:p>
-        </p:txBody>
-      </p:sp>
-      <p:sp>
-        <p:nvSpPr>
-          <p:cNvPr id="10" name="Rectangle 9"/>
-          <p:cNvSpPr/>
-          <p:nvPr/>
-        </p:nvSpPr>
-        <p:spPr>
-          <a:xfrm>
-            <a:off x="3383280" y="2532888"/>
-            <a:ext cx="45720" cy="192024"/>
-          </a:xfrm>
-          <a:prstGeom prst="rect">
-            <a:avLst/>
-          </a:prstGeom>
-          <a:solidFill>
-            <a:srgbClr val="6B7082"/>
-          </a:solidFill>
-          <a:ln>
-            <a:noFill/>
-          </a:ln>
-          <a:effectLst/>
-        </p:spPr>
-        <p:style>
-          <a:lnRef idx="1">
-            <a:schemeClr val="accent1"/>
-          </a:lnRef>
-          <a:fillRef idx="3">
-            <a:schemeClr val="accent1"/>
-          </a:fillRef>
-          <a:effectRef idx="2">
-            <a:schemeClr val="accent1"/>
-          </a:effectRef>
-          <a:fontRef idx="minor">
-            <a:schemeClr val="lt1"/>
-          </a:fontRef>
-        </p:style>
-        <p:txBody>
-          <a:bodyPr rtlCol="0" anchor="ctr"/>
-          <a:lstStyle/>
-          <a:p>
-            <a:pPr algn="ctr"/>
-          </a:p>
-        </p:txBody>
-      </p:sp>
-      <p:sp>
-        <p:nvSpPr>
-          <p:cNvPr id="11" name="TextBox 10"/>
-          <p:cNvSpPr txBox="1"/>
-          <p:nvPr/>
-        </p:nvSpPr>
-        <p:spPr>
-          <a:xfrm>
-            <a:off x="3520440" y="2505456"/>
-            <a:ext cx="2286000" cy="329184"/>
-          </a:xfrm>
-          <a:prstGeom prst="rect">
-            <a:avLst/>
-          </a:prstGeom>
-          <a:noFill/>
-        </p:spPr>
-        <p:txBody>
-          <a:bodyPr wrap="square" lIns="0" rIns="0" tIns="0" bIns="0">
-            <a:spAutoFit/>
-          </a:bodyPr>
-          <a:lstStyle/>
-          <a:p>
-            <a:r>
-              <a:rPr sz="1000" b="0">
-                <a:solidFill>
-                  <a:srgbClr val="6B7082"/>
-                </a:solidFill>
-                <a:latin typeface="Helvetica Neue"/>
-              </a:rPr>
-              <a:t>1,297   (25 posts · 52 avg)</a:t>
-            </a:r>
-          </a:p>
-        </p:txBody>
-      </p:sp>
-      <p:sp>
-        <p:nvSpPr>
-          <p:cNvPr id="12" name="TextBox 11"/>
-          <p:cNvSpPr txBox="1"/>
-          <p:nvPr/>
-        </p:nvSpPr>
-        <p:spPr>
-          <a:xfrm>
-            <a:off x="731520" y="6263640"/>
-            <a:ext cx="10698480" cy="457200"/>
-          </a:xfrm>
-          <a:prstGeom prst="rect">
-            <a:avLst/>
-          </a:prstGeom>
-          <a:noFill/>
-        </p:spPr>
-        <p:txBody>
-          <a:bodyPr wrap="square" lIns="0" rIns="0" tIns="0" bIns="0">
-            <a:spAutoFit/>
-          </a:bodyPr>
-          <a:lstStyle/>
-          <a:p>
-            <a:r>
-              <a:rPr sz="1200" b="1">
-                <a:solidFill>
-                  <a:srgbClr val="141833"/>
-                </a:solidFill>
-                <a:latin typeface="Helvetica Neue"/>
-              </a:rPr>
-              <a:t>Smaller lanes aren't failures — they're where a single breakout post can move the whole ranking.</a:t>
-            </a:r>
-          </a:p>
-        </p:txBody>
-      </p:sp>
-    </p:spTree>
-  </p:cSld>
-  <p:clrMapOvr>
-    <a:masterClrMapping/>
-  </p:clrMapOvr>
-</p:sld>
-</file>
-
-<file path=ppt/slides/slide7.xml><?xml version="1.0" encoding="utf-8"?>
 <p:sld xmlns:a="http://schemas.openxmlformats.org/drawingml/2006/main" xmlns:p="http://schemas.openxmlformats.org/presentationml/2006/main" xmlns:r="http://schemas.openxmlformats.org/officeDocument/2006/relationships">
   <p:cSld>
     <p:spTree>

</xml_diff>

<commit_message>
Scheduled snapshot t46 (2026-10-30): fresh IG/FB/YT/TT + rebuilt decks
Co-Authored-By: Claude Opus 4.7 (1M context) <noreply@anthropic.com>
</commit_message>
<xml_diff>
--- a/OVERALL_REPORT.pptx
+++ b/OVERALL_REPORT.pptx
@@ -3278,7 +3278,7 @@
                 </a:solidFill>
                 <a:latin typeface="Georgia"/>
               </a:rPr>
-              <a:t>Since Jun 8, 2026 · 2026-10-23</a:t>
+              <a:t>Since Jun 8, 2026 · 2026-10-30</a:t>
             </a:r>
           </a:p>
         </p:txBody>
@@ -3579,7 +3579,7 @@
                 </a:solidFill>
                 <a:latin typeface="Georgia"/>
               </a:rPr>
-              <a:t>930,436</a:t>
+              <a:t>1,035,986</a:t>
             </a:r>
           </a:p>
         </p:txBody>
@@ -3770,7 +3770,7 @@
                 </a:solidFill>
                 <a:latin typeface="Georgia"/>
               </a:rPr>
-              <a:t>677</a:t>
+              <a:t>711</a:t>
             </a:r>
           </a:p>
         </p:txBody>
@@ -3926,7 +3926,7 @@
                 </a:solidFill>
                 <a:latin typeface="Georgia"/>
               </a:rPr>
-              <a:t>27,607</a:t>
+              <a:t>34,983</a:t>
             </a:r>
           </a:p>
         </p:txBody>
@@ -4082,7 +4082,7 @@
                 </a:solidFill>
                 <a:latin typeface="Georgia"/>
               </a:rPr>
-              <a:t>1,374</a:t>
+              <a:t>1,457</a:t>
             </a:r>
           </a:p>
         </p:txBody>
@@ -4402,7 +4402,7 @@
                 </a:solidFill>
                 <a:latin typeface="Georgia"/>
               </a:rPr>
-              <a:t>400,384</a:t>
+              <a:t>482,314</a:t>
             </a:r>
           </a:p>
         </p:txBody>
@@ -4470,7 +4470,7 @@
                 </a:solidFill>
                 <a:latin typeface="Helvetica Neue"/>
               </a:rPr>
-              <a:t>222 posts</a:t>
+              <a:t>233 posts</a:t>
             </a:r>
           </a:p>
         </p:txBody>
@@ -4504,7 +4504,7 @@
                 </a:solidFill>
                 <a:latin typeface="Helvetica Neue"/>
               </a:rPr>
-              <a:t>1,804 avg views/post</a:t>
+              <a:t>2,070 avg views/post</a:t>
             </a:r>
           </a:p>
         </p:txBody>
@@ -4660,7 +4660,7 @@
                 </a:solidFill>
                 <a:latin typeface="Georgia"/>
               </a:rPr>
-              <a:t>298,204</a:t>
+              <a:t>315,566</a:t>
             </a:r>
           </a:p>
         </p:txBody>
@@ -4728,7 +4728,7 @@
                 </a:solidFill>
                 <a:latin typeface="Helvetica Neue"/>
               </a:rPr>
-              <a:t>194 posts</a:t>
+              <a:t>204 posts</a:t>
             </a:r>
           </a:p>
         </p:txBody>
@@ -4762,7 +4762,7 @@
                 </a:solidFill>
                 <a:latin typeface="Helvetica Neue"/>
               </a:rPr>
-              <a:t>1,537 avg views/post</a:t>
+              <a:t>1,547 avg views/post</a:t>
             </a:r>
           </a:p>
         </p:txBody>
@@ -4918,7 +4918,7 @@
                 </a:solidFill>
                 <a:latin typeface="Georgia"/>
               </a:rPr>
-              <a:t>228,528</a:t>
+              <a:t>234,265</a:t>
             </a:r>
           </a:p>
         </p:txBody>
@@ -4986,7 +4986,7 @@
                 </a:solidFill>
                 <a:latin typeface="Helvetica Neue"/>
               </a:rPr>
-              <a:t>240 posts</a:t>
+              <a:t>251 posts</a:t>
             </a:r>
           </a:p>
         </p:txBody>
@@ -5020,7 +5020,7 @@
                 </a:solidFill>
                 <a:latin typeface="Helvetica Neue"/>
               </a:rPr>
-              <a:t>952 avg views/post</a:t>
+              <a:t>933 avg views/post</a:t>
             </a:r>
           </a:p>
         </p:txBody>
@@ -5176,7 +5176,7 @@
                 </a:solidFill>
                 <a:latin typeface="Georgia"/>
               </a:rPr>
-              <a:t>3,320</a:t>
+              <a:t>3,841</a:t>
             </a:r>
           </a:p>
         </p:txBody>
@@ -5244,7 +5244,7 @@
                 </a:solidFill>
                 <a:latin typeface="Helvetica Neue"/>
               </a:rPr>
-              <a:t>21 posts</a:t>
+              <a:t>23 posts</a:t>
             </a:r>
           </a:p>
         </p:txBody>
@@ -5278,7 +5278,7 @@
                 </a:solidFill>
                 <a:latin typeface="Helvetica Neue"/>
               </a:rPr>
-              <a:t>158 avg views/post</a:t>
+              <a:t>167 avg views/post</a:t>
             </a:r>
           </a:p>
         </p:txBody>
@@ -5588,7 +5588,7 @@
                 </a:solidFill>
                 <a:latin typeface="Helvetica Neue"/>
               </a:rPr>
-              <a:t>286,423   (69 posts · 4,151 avg)</a:t>
+              <a:t>286,593   (69 posts · 4,154 avg)</a:t>
             </a:r>
           </a:p>
         </p:txBody>
@@ -5636,7 +5636,7 @@
         <p:spPr>
           <a:xfrm>
             <a:off x="3383280" y="2516710"/>
-            <a:ext cx="2741806" cy="175846"/>
+            <a:ext cx="2740180" cy="175846"/>
           </a:xfrm>
           <a:prstGeom prst="rect">
             <a:avLst/>
@@ -5679,7 +5679,7 @@
         </p:nvSpPr>
         <p:spPr>
           <a:xfrm>
-            <a:off x="6216526" y="2489278"/>
+            <a:off x="6214900" y="2489278"/>
             <a:ext cx="2286000" cy="313006"/>
           </a:xfrm>
           <a:prstGeom prst="rect">
@@ -5734,7 +5734,7 @@
                 </a:solidFill>
                 <a:latin typeface="Helvetica Neue"/>
               </a:rPr>
-              <a:t>3. Community Local</a:t>
+              <a:t>3. Other</a:t>
             </a:r>
           </a:p>
         </p:txBody>
@@ -5748,7 +5748,119 @@
         <p:spPr>
           <a:xfrm>
             <a:off x="3383280" y="2829716"/>
-            <a:ext cx="1319125" cy="175846"/>
+            <a:ext cx="2082265" cy="175846"/>
+          </a:xfrm>
+          <a:prstGeom prst="rect">
+            <a:avLst/>
+          </a:prstGeom>
+          <a:solidFill>
+            <a:srgbClr val="6B7082"/>
+          </a:solidFill>
+          <a:ln>
+            <a:noFill/>
+          </a:ln>
+          <a:effectLst/>
+        </p:spPr>
+        <p:style>
+          <a:lnRef idx="1">
+            <a:schemeClr val="accent1"/>
+          </a:lnRef>
+          <a:fillRef idx="3">
+            <a:schemeClr val="accent1"/>
+          </a:fillRef>
+          <a:effectRef idx="2">
+            <a:schemeClr val="accent1"/>
+          </a:effectRef>
+          <a:fontRef idx="minor">
+            <a:schemeClr val="lt1"/>
+          </a:fontRef>
+        </p:style>
+        <p:txBody>
+          <a:bodyPr rtlCol="0" anchor="ctr"/>
+          <a:lstStyle/>
+          <a:p>
+            <a:pPr algn="ctr"/>
+          </a:p>
+        </p:txBody>
+      </p:sp>
+      <p:sp>
+        <p:nvSpPr>
+          <p:cNvPr id="14" name="TextBox 13"/>
+          <p:cNvSpPr txBox="1"/>
+          <p:nvPr/>
+        </p:nvSpPr>
+        <p:spPr>
+          <a:xfrm>
+            <a:off x="5556985" y="2802284"/>
+            <a:ext cx="2286000" cy="313006"/>
+          </a:xfrm>
+          <a:prstGeom prst="rect">
+            <a:avLst/>
+          </a:prstGeom>
+          <a:noFill/>
+        </p:spPr>
+        <p:txBody>
+          <a:bodyPr wrap="square" lIns="0" rIns="0" tIns="0" bIns="0">
+            <a:spAutoFit/>
+          </a:bodyPr>
+          <a:lstStyle/>
+          <a:p>
+            <a:r>
+              <a:rPr sz="1000" b="0">
+                <a:solidFill>
+                  <a:srgbClr val="6B7082"/>
+                </a:solidFill>
+                <a:latin typeface="Helvetica Neue"/>
+              </a:rPr>
+              <a:t>87,017   (47 posts · 1,851 avg)</a:t>
+            </a:r>
+          </a:p>
+        </p:txBody>
+      </p:sp>
+      <p:sp>
+        <p:nvSpPr>
+          <p:cNvPr id="15" name="TextBox 14"/>
+          <p:cNvSpPr txBox="1"/>
+          <p:nvPr/>
+        </p:nvSpPr>
+        <p:spPr>
+          <a:xfrm>
+            <a:off x="731520" y="3115290"/>
+            <a:ext cx="2468880" cy="313006"/>
+          </a:xfrm>
+          <a:prstGeom prst="rect">
+            <a:avLst/>
+          </a:prstGeom>
+          <a:noFill/>
+        </p:spPr>
+        <p:txBody>
+          <a:bodyPr wrap="square" lIns="0" rIns="0" tIns="0" bIns="0">
+            <a:spAutoFit/>
+          </a:bodyPr>
+          <a:lstStyle/>
+          <a:p>
+            <a:r>
+              <a:rPr sz="1100" b="0">
+                <a:solidFill>
+                  <a:srgbClr val="141833"/>
+                </a:solidFill>
+                <a:latin typeface="Helvetica Neue"/>
+              </a:rPr>
+              <a:t>4. Community Local</a:t>
+            </a:r>
+          </a:p>
+        </p:txBody>
+      </p:sp>
+      <p:sp>
+        <p:nvSpPr>
+          <p:cNvPr id="16" name="Rectangle 15"/>
+          <p:cNvSpPr/>
+          <p:nvPr/>
+        </p:nvSpPr>
+        <p:spPr>
+          <a:xfrm>
+            <a:off x="3383280" y="3142722"/>
+            <a:ext cx="1325569" cy="175846"/>
           </a:xfrm>
           <a:prstGeom prst="rect">
             <a:avLst/>
@@ -5785,13 +5897,13 @@
       </p:sp>
       <p:sp>
         <p:nvSpPr>
-          <p:cNvPr id="14" name="TextBox 13"/>
-          <p:cNvSpPr txBox="1"/>
-          <p:nvPr/>
-        </p:nvSpPr>
-        <p:spPr>
-          <a:xfrm>
-            <a:off x="4793845" y="2802284"/>
+          <p:cNvPr id="17" name="TextBox 16"/>
+          <p:cNvSpPr txBox="1"/>
+          <p:nvPr/>
+        </p:nvSpPr>
+        <p:spPr>
+          <a:xfrm>
+            <a:off x="4800289" y="3115290"/>
             <a:ext cx="2286000" cy="313006"/>
           </a:xfrm>
           <a:prstGeom prst="rect">
@@ -5812,20 +5924,20 @@
                 </a:solidFill>
                 <a:latin typeface="Helvetica Neue"/>
               </a:rPr>
-              <a:t>55,093   (45 posts · 1,224 avg)</a:t>
-            </a:r>
-          </a:p>
-        </p:txBody>
-      </p:sp>
-      <p:sp>
-        <p:nvSpPr>
-          <p:cNvPr id="15" name="TextBox 14"/>
-          <p:cNvSpPr txBox="1"/>
-          <p:nvPr/>
-        </p:nvSpPr>
-        <p:spPr>
-          <a:xfrm>
-            <a:off x="731520" y="3115290"/>
+              <a:t>55,395   (45 posts · 1,231 avg)</a:t>
+            </a:r>
+          </a:p>
+        </p:txBody>
+      </p:sp>
+      <p:sp>
+        <p:nvSpPr>
+          <p:cNvPr id="18" name="TextBox 17"/>
+          <p:cNvSpPr txBox="1"/>
+          <p:nvPr/>
+        </p:nvSpPr>
+        <p:spPr>
+          <a:xfrm>
+            <a:off x="731520" y="3428296"/>
             <a:ext cx="2468880" cy="313006"/>
           </a:xfrm>
           <a:prstGeom prst="rect">
@@ -5846,21 +5958,21 @@
                 </a:solidFill>
                 <a:latin typeface="Helvetica Neue"/>
               </a:rPr>
-              <a:t>4. FIFA — Positive</a:t>
-            </a:r>
-          </a:p>
-        </p:txBody>
-      </p:sp>
-      <p:sp>
-        <p:nvSpPr>
-          <p:cNvPr id="16" name="Rectangle 15"/>
+              <a:t>5. FIFA — Positive</a:t>
+            </a:r>
+          </a:p>
+        </p:txBody>
+      </p:sp>
+      <p:sp>
+        <p:nvSpPr>
+          <p:cNvPr id="19" name="Rectangle 18"/>
           <p:cNvSpPr/>
           <p:nvPr/>
         </p:nvSpPr>
         <p:spPr>
           <a:xfrm>
-            <a:off x="3383280" y="3142722"/>
-            <a:ext cx="1244828" cy="175846"/>
+            <a:off x="3383280" y="3455728"/>
+            <a:ext cx="1244089" cy="175846"/>
           </a:xfrm>
           <a:prstGeom prst="rect">
             <a:avLst/>
@@ -5897,13 +6009,13 @@
       </p:sp>
       <p:sp>
         <p:nvSpPr>
-          <p:cNvPr id="17" name="TextBox 16"/>
-          <p:cNvSpPr txBox="1"/>
-          <p:nvPr/>
-        </p:nvSpPr>
-        <p:spPr>
-          <a:xfrm>
-            <a:off x="4719548" y="3115290"/>
+          <p:cNvPr id="20" name="TextBox 19"/>
+          <p:cNvSpPr txBox="1"/>
+          <p:nvPr/>
+        </p:nvSpPr>
+        <p:spPr>
+          <a:xfrm>
+            <a:off x="4718809" y="3428296"/>
             <a:ext cx="2286000" cy="313006"/>
           </a:xfrm>
           <a:prstGeom prst="rect">
@@ -5931,13 +6043,13 @@
       </p:sp>
       <p:sp>
         <p:nvSpPr>
-          <p:cNvPr id="18" name="TextBox 17"/>
-          <p:cNvSpPr txBox="1"/>
-          <p:nvPr/>
-        </p:nvSpPr>
-        <p:spPr>
-          <a:xfrm>
-            <a:off x="731520" y="3428296"/>
+          <p:cNvPr id="21" name="TextBox 20"/>
+          <p:cNvSpPr txBox="1"/>
+          <p:nvPr/>
+        </p:nvSpPr>
+        <p:spPr>
+          <a:xfrm>
+            <a:off x="731520" y="3741302"/>
             <a:ext cx="2468880" cy="313006"/>
           </a:xfrm>
           <a:prstGeom prst="rect">
@@ -5958,21 +6070,21 @@
                 </a:solidFill>
                 <a:latin typeface="Helvetica Neue"/>
               </a:rPr>
-              <a:t>5. Downtown Development</a:t>
-            </a:r>
-          </a:p>
-        </p:txBody>
-      </p:sp>
-      <p:sp>
-        <p:nvSpPr>
-          <p:cNvPr id="19" name="Rectangle 18"/>
+              <a:t>6. Downtown Development</a:t>
+            </a:r>
+          </a:p>
+        </p:txBody>
+      </p:sp>
+      <p:sp>
+        <p:nvSpPr>
+          <p:cNvPr id="22" name="Rectangle 21"/>
           <p:cNvSpPr/>
           <p:nvPr/>
         </p:nvSpPr>
         <p:spPr>
           <a:xfrm>
-            <a:off x="3383280" y="3455728"/>
-            <a:ext cx="1238123" cy="175846"/>
+            <a:off x="3383280" y="3768734"/>
+            <a:ext cx="1237389" cy="175846"/>
           </a:xfrm>
           <a:prstGeom prst="rect">
             <a:avLst/>
@@ -6009,13 +6121,13 @@
       </p:sp>
       <p:sp>
         <p:nvSpPr>
-          <p:cNvPr id="20" name="TextBox 19"/>
-          <p:cNvSpPr txBox="1"/>
-          <p:nvPr/>
-        </p:nvSpPr>
-        <p:spPr>
-          <a:xfrm>
-            <a:off x="4712843" y="3428296"/>
+          <p:cNvPr id="23" name="TextBox 22"/>
+          <p:cNvSpPr txBox="1"/>
+          <p:nvPr/>
+        </p:nvSpPr>
+        <p:spPr>
+          <a:xfrm>
+            <a:off x="4712109" y="3741302"/>
             <a:ext cx="2286000" cy="313006"/>
           </a:xfrm>
           <a:prstGeom prst="rect">
@@ -6043,13 +6155,13 @@
       </p:sp>
       <p:sp>
         <p:nvSpPr>
-          <p:cNvPr id="21" name="TextBox 20"/>
-          <p:cNvSpPr txBox="1"/>
-          <p:nvPr/>
-        </p:nvSpPr>
-        <p:spPr>
-          <a:xfrm>
-            <a:off x="731520" y="3741302"/>
+          <p:cNvPr id="24" name="TextBox 23"/>
+          <p:cNvSpPr txBox="1"/>
+          <p:nvPr/>
+        </p:nvSpPr>
+        <p:spPr>
+          <a:xfrm>
+            <a:off x="731520" y="4054308"/>
             <a:ext cx="2468880" cy="313006"/>
           </a:xfrm>
           <a:prstGeom prst="rect">
@@ -6070,21 +6182,133 @@
                 </a:solidFill>
                 <a:latin typeface="Helvetica Neue"/>
               </a:rPr>
-              <a:t>6. Trujillo Scandal</a:t>
-            </a:r>
-          </a:p>
-        </p:txBody>
-      </p:sp>
-      <p:sp>
-        <p:nvSpPr>
-          <p:cNvPr id="22" name="Rectangle 21"/>
+              <a:t>7. Elections</a:t>
+            </a:r>
+          </a:p>
+        </p:txBody>
+      </p:sp>
+      <p:sp>
+        <p:nvSpPr>
+          <p:cNvPr id="25" name="Rectangle 24"/>
           <p:cNvSpPr/>
           <p:nvPr/>
         </p:nvSpPr>
         <p:spPr>
           <a:xfrm>
-            <a:off x="3383280" y="3768734"/>
-            <a:ext cx="985782" cy="175846"/>
+            <a:off x="3383280" y="4081740"/>
+            <a:ext cx="1001517" cy="175846"/>
+          </a:xfrm>
+          <a:prstGeom prst="rect">
+            <a:avLst/>
+          </a:prstGeom>
+          <a:solidFill>
+            <a:srgbClr val="2F3C7E"/>
+          </a:solidFill>
+          <a:ln>
+            <a:noFill/>
+          </a:ln>
+          <a:effectLst/>
+        </p:spPr>
+        <p:style>
+          <a:lnRef idx="1">
+            <a:schemeClr val="accent1"/>
+          </a:lnRef>
+          <a:fillRef idx="3">
+            <a:schemeClr val="accent1"/>
+          </a:fillRef>
+          <a:effectRef idx="2">
+            <a:schemeClr val="accent1"/>
+          </a:effectRef>
+          <a:fontRef idx="minor">
+            <a:schemeClr val="lt1"/>
+          </a:fontRef>
+        </p:style>
+        <p:txBody>
+          <a:bodyPr rtlCol="0" anchor="ctr"/>
+          <a:lstStyle/>
+          <a:p>
+            <a:pPr algn="ctr"/>
+          </a:p>
+        </p:txBody>
+      </p:sp>
+      <p:sp>
+        <p:nvSpPr>
+          <p:cNvPr id="26" name="TextBox 25"/>
+          <p:cNvSpPr txBox="1"/>
+          <p:nvPr/>
+        </p:nvSpPr>
+        <p:spPr>
+          <a:xfrm>
+            <a:off x="4476237" y="4054308"/>
+            <a:ext cx="2286000" cy="313006"/>
+          </a:xfrm>
+          <a:prstGeom prst="rect">
+            <a:avLst/>
+          </a:prstGeom>
+          <a:noFill/>
+        </p:spPr>
+        <p:txBody>
+          <a:bodyPr wrap="square" lIns="0" rIns="0" tIns="0" bIns="0">
+            <a:spAutoFit/>
+          </a:bodyPr>
+          <a:lstStyle/>
+          <a:p>
+            <a:r>
+              <a:rPr sz="1000" b="0">
+                <a:solidFill>
+                  <a:srgbClr val="6B7082"/>
+                </a:solidFill>
+                <a:latin typeface="Helvetica Neue"/>
+              </a:rPr>
+              <a:t>41,853   (44 posts · 951 avg)</a:t>
+            </a:r>
+          </a:p>
+        </p:txBody>
+      </p:sp>
+      <p:sp>
+        <p:nvSpPr>
+          <p:cNvPr id="27" name="TextBox 26"/>
+          <p:cNvSpPr txBox="1"/>
+          <p:nvPr/>
+        </p:nvSpPr>
+        <p:spPr>
+          <a:xfrm>
+            <a:off x="731520" y="4367315"/>
+            <a:ext cx="2468880" cy="313006"/>
+          </a:xfrm>
+          <a:prstGeom prst="rect">
+            <a:avLst/>
+          </a:prstGeom>
+          <a:noFill/>
+        </p:spPr>
+        <p:txBody>
+          <a:bodyPr wrap="square" lIns="0" rIns="0" tIns="0" bIns="0">
+            <a:spAutoFit/>
+          </a:bodyPr>
+          <a:lstStyle/>
+          <a:p>
+            <a:r>
+              <a:rPr sz="1100" b="0">
+                <a:solidFill>
+                  <a:srgbClr val="141833"/>
+                </a:solidFill>
+                <a:latin typeface="Helvetica Neue"/>
+              </a:rPr>
+              <a:t>8. Trujillo Scandal</a:t>
+            </a:r>
+          </a:p>
+        </p:txBody>
+      </p:sp>
+      <p:sp>
+        <p:nvSpPr>
+          <p:cNvPr id="28" name="Rectangle 27"/>
+          <p:cNvSpPr/>
+          <p:nvPr/>
+        </p:nvSpPr>
+        <p:spPr>
+          <a:xfrm>
+            <a:off x="3383280" y="4394747"/>
+            <a:ext cx="985269" cy="175846"/>
           </a:xfrm>
           <a:prstGeom prst="rect">
             <a:avLst/>
@@ -6121,13 +6345,13 @@
       </p:sp>
       <p:sp>
         <p:nvSpPr>
-          <p:cNvPr id="23" name="TextBox 22"/>
-          <p:cNvSpPr txBox="1"/>
-          <p:nvPr/>
-        </p:nvSpPr>
-        <p:spPr>
-          <a:xfrm>
-            <a:off x="4460502" y="3741302"/>
+          <p:cNvPr id="29" name="TextBox 28"/>
+          <p:cNvSpPr txBox="1"/>
+          <p:nvPr/>
+        </p:nvSpPr>
+        <p:spPr>
+          <a:xfrm>
+            <a:off x="4459989" y="4367315"/>
             <a:ext cx="2286000" cy="313006"/>
           </a:xfrm>
           <a:prstGeom prst="rect">
@@ -6148,20 +6372,20 @@
                 </a:solidFill>
                 <a:latin typeface="Helvetica Neue"/>
               </a:rPr>
-              <a:t>41,171   (18 posts · 2,287 avg)</a:t>
-            </a:r>
-          </a:p>
-        </p:txBody>
-      </p:sp>
-      <p:sp>
-        <p:nvSpPr>
-          <p:cNvPr id="24" name="TextBox 23"/>
-          <p:cNvSpPr txBox="1"/>
-          <p:nvPr/>
-        </p:nvSpPr>
-        <p:spPr>
-          <a:xfrm>
-            <a:off x="731520" y="4054308"/>
+              <a:t>41,174   (18 posts · 2,287 avg)</a:t>
+            </a:r>
+          </a:p>
+        </p:txBody>
+      </p:sp>
+      <p:sp>
+        <p:nvSpPr>
+          <p:cNvPr id="30" name="TextBox 29"/>
+          <p:cNvSpPr txBox="1"/>
+          <p:nvPr/>
+        </p:nvSpPr>
+        <p:spPr>
+          <a:xfrm>
+            <a:off x="731520" y="4680321"/>
             <a:ext cx="2468880" cy="313006"/>
           </a:xfrm>
           <a:prstGeom prst="rect">
@@ -6182,21 +6406,21 @@
                 </a:solidFill>
                 <a:latin typeface="Helvetica Neue"/>
               </a:rPr>
-              <a:t>7. Political Highlight</a:t>
-            </a:r>
-          </a:p>
-        </p:txBody>
-      </p:sp>
-      <p:sp>
-        <p:nvSpPr>
-          <p:cNvPr id="25" name="Rectangle 24"/>
+              <a:t>9. Political Highlight</a:t>
+            </a:r>
+          </a:p>
+        </p:txBody>
+      </p:sp>
+      <p:sp>
+        <p:nvSpPr>
+          <p:cNvPr id="31" name="Rectangle 30"/>
           <p:cNvSpPr/>
           <p:nvPr/>
         </p:nvSpPr>
         <p:spPr>
           <a:xfrm>
-            <a:off x="3383280" y="4081740"/>
-            <a:ext cx="843509" cy="175846"/>
+            <a:off x="3383280" y="4707753"/>
+            <a:ext cx="853394" cy="175846"/>
           </a:xfrm>
           <a:prstGeom prst="rect">
             <a:avLst/>
@@ -6233,13 +6457,13 @@
       </p:sp>
       <p:sp>
         <p:nvSpPr>
-          <p:cNvPr id="26" name="TextBox 25"/>
-          <p:cNvSpPr txBox="1"/>
-          <p:nvPr/>
-        </p:nvSpPr>
-        <p:spPr>
-          <a:xfrm>
-            <a:off x="4318229" y="4054308"/>
+          <p:cNvPr id="32" name="TextBox 31"/>
+          <p:cNvSpPr txBox="1"/>
+          <p:nvPr/>
+        </p:nvSpPr>
+        <p:spPr>
+          <a:xfrm>
+            <a:off x="4328114" y="4680321"/>
             <a:ext cx="2286000" cy="313006"/>
           </a:xfrm>
           <a:prstGeom prst="rect">
@@ -6260,20 +6484,20 @@
                 </a:solidFill>
                 <a:latin typeface="Helvetica Neue"/>
               </a:rPr>
-              <a:t>35,229   (37 posts · 952 avg)</a:t>
-            </a:r>
-          </a:p>
-        </p:txBody>
-      </p:sp>
-      <p:sp>
-        <p:nvSpPr>
-          <p:cNvPr id="27" name="TextBox 26"/>
-          <p:cNvSpPr txBox="1"/>
-          <p:nvPr/>
-        </p:nvSpPr>
-        <p:spPr>
-          <a:xfrm>
-            <a:off x="731520" y="4367315"/>
+              <a:t>35,663   (37 posts · 964 avg)</a:t>
+            </a:r>
+          </a:p>
+        </p:txBody>
+      </p:sp>
+      <p:sp>
+        <p:nvSpPr>
+          <p:cNvPr id="33" name="TextBox 32"/>
+          <p:cNvSpPr txBox="1"/>
+          <p:nvPr/>
+        </p:nvSpPr>
+        <p:spPr>
+          <a:xfrm>
+            <a:off x="731520" y="4993327"/>
             <a:ext cx="2468880" cy="313006"/>
           </a:xfrm>
           <a:prstGeom prst="rect">
@@ -6294,21 +6518,21 @@
                 </a:solidFill>
                 <a:latin typeface="Helvetica Neue"/>
               </a:rPr>
-              <a:t>8. Politics (other)</a:t>
-            </a:r>
-          </a:p>
-        </p:txBody>
-      </p:sp>
-      <p:sp>
-        <p:nvSpPr>
-          <p:cNvPr id="28" name="Rectangle 27"/>
+              <a:t>10. Politics (other)</a:t>
+            </a:r>
+          </a:p>
+        </p:txBody>
+      </p:sp>
+      <p:sp>
+        <p:nvSpPr>
+          <p:cNvPr id="34" name="Rectangle 33"/>
           <p:cNvSpPr/>
           <p:nvPr/>
         </p:nvSpPr>
         <p:spPr>
           <a:xfrm>
-            <a:off x="3383280" y="4394747"/>
-            <a:ext cx="822965" cy="175846"/>
+            <a:off x="3383280" y="5020759"/>
+            <a:ext cx="839730" cy="175846"/>
           </a:xfrm>
           <a:prstGeom prst="rect">
             <a:avLst/>
@@ -6345,13 +6569,13 @@
       </p:sp>
       <p:sp>
         <p:nvSpPr>
-          <p:cNvPr id="29" name="TextBox 28"/>
-          <p:cNvSpPr txBox="1"/>
-          <p:nvPr/>
-        </p:nvSpPr>
-        <p:spPr>
-          <a:xfrm>
-            <a:off x="4297685" y="4367315"/>
+          <p:cNvPr id="35" name="TextBox 34"/>
+          <p:cNvSpPr txBox="1"/>
+          <p:nvPr/>
+        </p:nvSpPr>
+        <p:spPr>
+          <a:xfrm>
+            <a:off x="4314450" y="4993327"/>
             <a:ext cx="2286000" cy="313006"/>
           </a:xfrm>
           <a:prstGeom prst="rect">
@@ -6372,20 +6596,20 @@
                 </a:solidFill>
                 <a:latin typeface="Helvetica Neue"/>
               </a:rPr>
-              <a:t>34,371   (29 posts · 1,185 avg)</a:t>
-            </a:r>
-          </a:p>
-        </p:txBody>
-      </p:sp>
-      <p:sp>
-        <p:nvSpPr>
-          <p:cNvPr id="30" name="TextBox 29"/>
-          <p:cNvSpPr txBox="1"/>
-          <p:nvPr/>
-        </p:nvSpPr>
-        <p:spPr>
-          <a:xfrm>
-            <a:off x="731520" y="4680321"/>
+              <a:t>35,092   (31 posts · 1,132 avg)</a:t>
+            </a:r>
+          </a:p>
+        </p:txBody>
+      </p:sp>
+      <p:sp>
+        <p:nvSpPr>
+          <p:cNvPr id="36" name="TextBox 35"/>
+          <p:cNvSpPr txBox="1"/>
+          <p:nvPr/>
+        </p:nvSpPr>
+        <p:spPr>
+          <a:xfrm>
+            <a:off x="731520" y="5306333"/>
             <a:ext cx="2468880" cy="313006"/>
           </a:xfrm>
           <a:prstGeom prst="rect">
@@ -6406,21 +6630,21 @@
                 </a:solidFill>
                 <a:latin typeface="Helvetica Neue"/>
               </a:rPr>
-              <a:t>9. Judicial</a:t>
-            </a:r>
-          </a:p>
-        </p:txBody>
-      </p:sp>
-      <p:sp>
-        <p:nvSpPr>
-          <p:cNvPr id="31" name="Rectangle 30"/>
+              <a:t>11. Judicial</a:t>
+            </a:r>
+          </a:p>
+        </p:txBody>
+      </p:sp>
+      <p:sp>
+        <p:nvSpPr>
+          <p:cNvPr id="37" name="Rectangle 36"/>
           <p:cNvSpPr/>
           <p:nvPr/>
         </p:nvSpPr>
         <p:spPr>
           <a:xfrm>
-            <a:off x="3383280" y="4707753"/>
-            <a:ext cx="800410" cy="175846"/>
+            <a:off x="3383280" y="5333765"/>
+            <a:ext cx="803549" cy="175846"/>
           </a:xfrm>
           <a:prstGeom prst="rect">
             <a:avLst/>
@@ -6457,13 +6681,13 @@
       </p:sp>
       <p:sp>
         <p:nvSpPr>
-          <p:cNvPr id="32" name="TextBox 31"/>
-          <p:cNvSpPr txBox="1"/>
-          <p:nvPr/>
-        </p:nvSpPr>
-        <p:spPr>
-          <a:xfrm>
-            <a:off x="4275130" y="4680321"/>
+          <p:cNvPr id="38" name="TextBox 37"/>
+          <p:cNvSpPr txBox="1"/>
+          <p:nvPr/>
+        </p:nvSpPr>
+        <p:spPr>
+          <a:xfrm>
+            <a:off x="4278269" y="5306333"/>
             <a:ext cx="2286000" cy="313006"/>
           </a:xfrm>
           <a:prstGeom prst="rect">
@@ -6484,20 +6708,20 @@
                 </a:solidFill>
                 <a:latin typeface="Helvetica Neue"/>
               </a:rPr>
-              <a:t>33,429   (78 posts · 429 avg)</a:t>
-            </a:r>
-          </a:p>
-        </p:txBody>
-      </p:sp>
-      <p:sp>
-        <p:nvSpPr>
-          <p:cNvPr id="33" name="TextBox 32"/>
-          <p:cNvSpPr txBox="1"/>
-          <p:nvPr/>
-        </p:nvSpPr>
-        <p:spPr>
-          <a:xfrm>
-            <a:off x="731520" y="4993327"/>
+              <a:t>33,580   (78 posts · 431 avg)</a:t>
+            </a:r>
+          </a:p>
+        </p:txBody>
+      </p:sp>
+      <p:sp>
+        <p:nvSpPr>
+          <p:cNvPr id="39" name="TextBox 38"/>
+          <p:cNvSpPr txBox="1"/>
+          <p:nvPr/>
+        </p:nvSpPr>
+        <p:spPr>
+          <a:xfrm>
+            <a:off x="731520" y="5619339"/>
             <a:ext cx="2468880" cy="313006"/>
           </a:xfrm>
           <a:prstGeom prst="rect">
@@ -6518,21 +6742,21 @@
                 </a:solidFill>
                 <a:latin typeface="Helvetica Neue"/>
               </a:rPr>
-              <a:t>10. City Hall &amp; Civic</a:t>
-            </a:r>
-          </a:p>
-        </p:txBody>
-      </p:sp>
-      <p:sp>
-        <p:nvSpPr>
-          <p:cNvPr id="34" name="Rectangle 33"/>
+              <a:t>12. City Hall &amp; Civic</a:t>
+            </a:r>
+          </a:p>
+        </p:txBody>
+      </p:sp>
+      <p:sp>
+        <p:nvSpPr>
+          <p:cNvPr id="40" name="Rectangle 39"/>
           <p:cNvSpPr/>
           <p:nvPr/>
         </p:nvSpPr>
         <p:spPr>
           <a:xfrm>
-            <a:off x="3383280" y="5020759"/>
-            <a:ext cx="719385" cy="175846"/>
+            <a:off x="3383280" y="5646771"/>
+            <a:ext cx="719557" cy="175846"/>
           </a:xfrm>
           <a:prstGeom prst="rect">
             <a:avLst/>
@@ -6569,13 +6793,13 @@
       </p:sp>
       <p:sp>
         <p:nvSpPr>
-          <p:cNvPr id="35" name="TextBox 34"/>
-          <p:cNvSpPr txBox="1"/>
-          <p:nvPr/>
-        </p:nvSpPr>
-        <p:spPr>
-          <a:xfrm>
-            <a:off x="4194105" y="4993327"/>
+          <p:cNvPr id="41" name="TextBox 40"/>
+          <p:cNvSpPr txBox="1"/>
+          <p:nvPr/>
+        </p:nvSpPr>
+        <p:spPr>
+          <a:xfrm>
+            <a:off x="4194277" y="5619339"/>
             <a:ext cx="2286000" cy="313006"/>
           </a:xfrm>
           <a:prstGeom prst="rect">
@@ -6596,20 +6820,20 @@
                 </a:solidFill>
                 <a:latin typeface="Helvetica Neue"/>
               </a:rPr>
-              <a:t>30,045   (42 posts · 715 avg)</a:t>
-            </a:r>
-          </a:p>
-        </p:txBody>
-      </p:sp>
-      <p:sp>
-        <p:nvSpPr>
-          <p:cNvPr id="36" name="TextBox 35"/>
-          <p:cNvSpPr txBox="1"/>
-          <p:nvPr/>
-        </p:nvSpPr>
-        <p:spPr>
-          <a:xfrm>
-            <a:off x="731520" y="5306333"/>
+              <a:t>30,070   (42 posts · 716 avg)</a:t>
+            </a:r>
+          </a:p>
+        </p:txBody>
+      </p:sp>
+      <p:sp>
+        <p:nvSpPr>
+          <p:cNvPr id="42" name="TextBox 41"/>
+          <p:cNvSpPr txBox="1"/>
+          <p:nvPr/>
+        </p:nvSpPr>
+        <p:spPr>
+          <a:xfrm>
+            <a:off x="731520" y="5932345"/>
             <a:ext cx="2468880" cy="313006"/>
           </a:xfrm>
           <a:prstGeom prst="rect">
@@ -6630,133 +6854,21 @@
                 </a:solidFill>
                 <a:latin typeface="Helvetica Neue"/>
               </a:rPr>
-              <a:t>11. Elections</a:t>
-            </a:r>
-          </a:p>
-        </p:txBody>
-      </p:sp>
-      <p:sp>
-        <p:nvSpPr>
-          <p:cNvPr id="37" name="Rectangle 36"/>
+              <a:t>13. Council Chaos</a:t>
+            </a:r>
+          </a:p>
+        </p:txBody>
+      </p:sp>
+      <p:sp>
+        <p:nvSpPr>
+          <p:cNvPr id="43" name="Rectangle 42"/>
           <p:cNvSpPr/>
           <p:nvPr/>
         </p:nvSpPr>
         <p:spPr>
           <a:xfrm>
-            <a:off x="3383280" y="5333765"/>
-            <a:ext cx="715746" cy="175846"/>
-          </a:xfrm>
-          <a:prstGeom prst="rect">
-            <a:avLst/>
-          </a:prstGeom>
-          <a:solidFill>
-            <a:srgbClr val="2F3C7E"/>
-          </a:solidFill>
-          <a:ln>
-            <a:noFill/>
-          </a:ln>
-          <a:effectLst/>
-        </p:spPr>
-        <p:style>
-          <a:lnRef idx="1">
-            <a:schemeClr val="accent1"/>
-          </a:lnRef>
-          <a:fillRef idx="3">
-            <a:schemeClr val="accent1"/>
-          </a:fillRef>
-          <a:effectRef idx="2">
-            <a:schemeClr val="accent1"/>
-          </a:effectRef>
-          <a:fontRef idx="minor">
-            <a:schemeClr val="lt1"/>
-          </a:fontRef>
-        </p:style>
-        <p:txBody>
-          <a:bodyPr rtlCol="0" anchor="ctr"/>
-          <a:lstStyle/>
-          <a:p>
-            <a:pPr algn="ctr"/>
-          </a:p>
-        </p:txBody>
-      </p:sp>
-      <p:sp>
-        <p:nvSpPr>
-          <p:cNvPr id="38" name="TextBox 37"/>
-          <p:cNvSpPr txBox="1"/>
-          <p:nvPr/>
-        </p:nvSpPr>
-        <p:spPr>
-          <a:xfrm>
-            <a:off x="4190466" y="5306333"/>
-            <a:ext cx="2286000" cy="313006"/>
-          </a:xfrm>
-          <a:prstGeom prst="rect">
-            <a:avLst/>
-          </a:prstGeom>
-          <a:noFill/>
-        </p:spPr>
-        <p:txBody>
-          <a:bodyPr wrap="square" lIns="0" rIns="0" tIns="0" bIns="0">
-            <a:spAutoFit/>
-          </a:bodyPr>
-          <a:lstStyle/>
-          <a:p>
-            <a:r>
-              <a:rPr sz="1000" b="0">
-                <a:solidFill>
-                  <a:srgbClr val="6B7082"/>
-                </a:solidFill>
-                <a:latin typeface="Helvetica Neue"/>
-              </a:rPr>
-              <a:t>29,893   (39 posts · 766 avg)</a:t>
-            </a:r>
-          </a:p>
-        </p:txBody>
-      </p:sp>
-      <p:sp>
-        <p:nvSpPr>
-          <p:cNvPr id="39" name="TextBox 38"/>
-          <p:cNvSpPr txBox="1"/>
-          <p:nvPr/>
-        </p:nvSpPr>
-        <p:spPr>
-          <a:xfrm>
-            <a:off x="731520" y="5619339"/>
-            <a:ext cx="2468880" cy="313006"/>
-          </a:xfrm>
-          <a:prstGeom prst="rect">
-            <a:avLst/>
-          </a:prstGeom>
-          <a:noFill/>
-        </p:spPr>
-        <p:txBody>
-          <a:bodyPr wrap="square" lIns="0" rIns="0" tIns="0" bIns="0">
-            <a:spAutoFit/>
-          </a:bodyPr>
-          <a:lstStyle/>
-          <a:p>
-            <a:r>
-              <a:rPr sz="1100" b="0">
-                <a:solidFill>
-                  <a:srgbClr val="141833"/>
-                </a:solidFill>
-                <a:latin typeface="Helvetica Neue"/>
-              </a:rPr>
-              <a:t>12. Council Chaos</a:t>
-            </a:r>
-          </a:p>
-        </p:txBody>
-      </p:sp>
-      <p:sp>
-        <p:nvSpPr>
-          <p:cNvPr id="40" name="Rectangle 39"/>
-          <p:cNvSpPr/>
-          <p:nvPr/>
-        </p:nvSpPr>
-        <p:spPr>
-          <a:xfrm>
-            <a:off x="3383280" y="5646771"/>
-            <a:ext cx="686942" cy="175846"/>
+            <a:off x="3383280" y="5959777"/>
+            <a:ext cx="686534" cy="175846"/>
           </a:xfrm>
           <a:prstGeom prst="rect">
             <a:avLst/>
@@ -6793,13 +6905,13 @@
       </p:sp>
       <p:sp>
         <p:nvSpPr>
-          <p:cNvPr id="41" name="TextBox 40"/>
-          <p:cNvSpPr txBox="1"/>
-          <p:nvPr/>
-        </p:nvSpPr>
-        <p:spPr>
-          <a:xfrm>
-            <a:off x="4161662" y="5619339"/>
+          <p:cNvPr id="44" name="TextBox 43"/>
+          <p:cNvSpPr txBox="1"/>
+          <p:nvPr/>
+        </p:nvSpPr>
+        <p:spPr>
+          <a:xfrm>
+            <a:off x="4161254" y="5932345"/>
             <a:ext cx="2286000" cy="313006"/>
           </a:xfrm>
           <a:prstGeom prst="rect">
@@ -6821,118 +6933,6 @@
                 <a:latin typeface="Helvetica Neue"/>
               </a:rPr>
               <a:t>28,690   (6 posts · 4,782 avg)</a:t>
-            </a:r>
-          </a:p>
-        </p:txBody>
-      </p:sp>
-      <p:sp>
-        <p:nvSpPr>
-          <p:cNvPr id="42" name="TextBox 41"/>
-          <p:cNvSpPr txBox="1"/>
-          <p:nvPr/>
-        </p:nvSpPr>
-        <p:spPr>
-          <a:xfrm>
-            <a:off x="731520" y="5932345"/>
-            <a:ext cx="2468880" cy="313006"/>
-          </a:xfrm>
-          <a:prstGeom prst="rect">
-            <a:avLst/>
-          </a:prstGeom>
-          <a:noFill/>
-        </p:spPr>
-        <p:txBody>
-          <a:bodyPr wrap="square" lIns="0" rIns="0" tIns="0" bIns="0">
-            <a:spAutoFit/>
-          </a:bodyPr>
-          <a:lstStyle/>
-          <a:p>
-            <a:r>
-              <a:rPr sz="1100" b="0">
-                <a:solidFill>
-                  <a:srgbClr val="141833"/>
-                </a:solidFill>
-                <a:latin typeface="Helvetica Neue"/>
-              </a:rPr>
-              <a:t>13. Community Events</a:t>
-            </a:r>
-          </a:p>
-        </p:txBody>
-      </p:sp>
-      <p:sp>
-        <p:nvSpPr>
-          <p:cNvPr id="43" name="Rectangle 42"/>
-          <p:cNvSpPr/>
-          <p:nvPr/>
-        </p:nvSpPr>
-        <p:spPr>
-          <a:xfrm>
-            <a:off x="3383280" y="5959777"/>
-            <a:ext cx="489694" cy="175846"/>
-          </a:xfrm>
-          <a:prstGeom prst="rect">
-            <a:avLst/>
-          </a:prstGeom>
-          <a:solidFill>
-            <a:srgbClr val="141833"/>
-          </a:solidFill>
-          <a:ln>
-            <a:noFill/>
-          </a:ln>
-          <a:effectLst/>
-        </p:spPr>
-        <p:style>
-          <a:lnRef idx="1">
-            <a:schemeClr val="accent1"/>
-          </a:lnRef>
-          <a:fillRef idx="3">
-            <a:schemeClr val="accent1"/>
-          </a:fillRef>
-          <a:effectRef idx="2">
-            <a:schemeClr val="accent1"/>
-          </a:effectRef>
-          <a:fontRef idx="minor">
-            <a:schemeClr val="lt1"/>
-          </a:fontRef>
-        </p:style>
-        <p:txBody>
-          <a:bodyPr rtlCol="0" anchor="ctr"/>
-          <a:lstStyle/>
-          <a:p>
-            <a:pPr algn="ctr"/>
-          </a:p>
-        </p:txBody>
-      </p:sp>
-      <p:sp>
-        <p:nvSpPr>
-          <p:cNvPr id="44" name="TextBox 43"/>
-          <p:cNvSpPr txBox="1"/>
-          <p:nvPr/>
-        </p:nvSpPr>
-        <p:spPr>
-          <a:xfrm>
-            <a:off x="3964414" y="5932345"/>
-            <a:ext cx="2286000" cy="313006"/>
-          </a:xfrm>
-          <a:prstGeom prst="rect">
-            <a:avLst/>
-          </a:prstGeom>
-          <a:noFill/>
-        </p:spPr>
-        <p:txBody>
-          <a:bodyPr wrap="square" lIns="0" rIns="0" tIns="0" bIns="0">
-            <a:spAutoFit/>
-          </a:bodyPr>
-          <a:lstStyle/>
-          <a:p>
-            <a:r>
-              <a:rPr sz="1000" b="0">
-                <a:solidFill>
-                  <a:srgbClr val="6B7082"/>
-                </a:solidFill>
-                <a:latin typeface="Helvetica Neue"/>
-              </a:rPr>
-              <a:t>20,452   (26 posts · 787 avg)</a:t>
             </a:r>
           </a:p>
         </p:txBody>
@@ -7164,7 +7164,7 @@
                 </a:solidFill>
                 <a:latin typeface="Helvetica Neue"/>
               </a:rPr>
-              <a:t>14. AI Fake News</a:t>
+              <a:t>14. Community Events</a:t>
             </a:r>
           </a:p>
         </p:txBody>
@@ -7178,7 +7178,119 @@
         <p:spPr>
           <a:xfrm>
             <a:off x="3383280" y="2203704"/>
-            <a:ext cx="316199" cy="175846"/>
+            <a:ext cx="489571" cy="175846"/>
+          </a:xfrm>
+          <a:prstGeom prst="rect">
+            <a:avLst/>
+          </a:prstGeom>
+          <a:solidFill>
+            <a:srgbClr val="141833"/>
+          </a:solidFill>
+          <a:ln>
+            <a:noFill/>
+          </a:ln>
+          <a:effectLst/>
+        </p:spPr>
+        <p:style>
+          <a:lnRef idx="1">
+            <a:schemeClr val="accent1"/>
+          </a:lnRef>
+          <a:fillRef idx="3">
+            <a:schemeClr val="accent1"/>
+          </a:fillRef>
+          <a:effectRef idx="2">
+            <a:schemeClr val="accent1"/>
+          </a:effectRef>
+          <a:fontRef idx="minor">
+            <a:schemeClr val="lt1"/>
+          </a:fontRef>
+        </p:style>
+        <p:txBody>
+          <a:bodyPr rtlCol="0" anchor="ctr"/>
+          <a:lstStyle/>
+          <a:p>
+            <a:pPr algn="ctr"/>
+          </a:p>
+        </p:txBody>
+      </p:sp>
+      <p:sp>
+        <p:nvSpPr>
+          <p:cNvPr id="8" name="TextBox 7"/>
+          <p:cNvSpPr txBox="1"/>
+          <p:nvPr/>
+        </p:nvSpPr>
+        <p:spPr>
+          <a:xfrm>
+            <a:off x="3964291" y="2176272"/>
+            <a:ext cx="2286000" cy="313006"/>
+          </a:xfrm>
+          <a:prstGeom prst="rect">
+            <a:avLst/>
+          </a:prstGeom>
+          <a:noFill/>
+        </p:spPr>
+        <p:txBody>
+          <a:bodyPr wrap="square" lIns="0" rIns="0" tIns="0" bIns="0">
+            <a:spAutoFit/>
+          </a:bodyPr>
+          <a:lstStyle/>
+          <a:p>
+            <a:r>
+              <a:rPr sz="1000" b="0">
+                <a:solidFill>
+                  <a:srgbClr val="6B7082"/>
+                </a:solidFill>
+                <a:latin typeface="Helvetica Neue"/>
+              </a:rPr>
+              <a:t>20,459   (26 posts · 787 avg)</a:t>
+            </a:r>
+          </a:p>
+        </p:txBody>
+      </p:sp>
+      <p:sp>
+        <p:nvSpPr>
+          <p:cNvPr id="9" name="TextBox 8"/>
+          <p:cNvSpPr txBox="1"/>
+          <p:nvPr/>
+        </p:nvSpPr>
+        <p:spPr>
+          <a:xfrm>
+            <a:off x="731520" y="2489278"/>
+            <a:ext cx="2468880" cy="313006"/>
+          </a:xfrm>
+          <a:prstGeom prst="rect">
+            <a:avLst/>
+          </a:prstGeom>
+          <a:noFill/>
+        </p:spPr>
+        <p:txBody>
+          <a:bodyPr wrap="square" lIns="0" rIns="0" tIns="0" bIns="0">
+            <a:spAutoFit/>
+          </a:bodyPr>
+          <a:lstStyle/>
+          <a:p>
+            <a:r>
+              <a:rPr sz="1100" b="0">
+                <a:solidFill>
+                  <a:srgbClr val="141833"/>
+                </a:solidFill>
+                <a:latin typeface="Helvetica Neue"/>
+              </a:rPr>
+              <a:t>15. Lisette Scandal</a:t>
+            </a:r>
+          </a:p>
+        </p:txBody>
+      </p:sp>
+      <p:sp>
+        <p:nvSpPr>
+          <p:cNvPr id="10" name="Rectangle 9"/>
+          <p:cNvSpPr/>
+          <p:nvPr/>
+        </p:nvSpPr>
+        <p:spPr>
+          <a:xfrm>
+            <a:off x="3383280" y="2516710"/>
+            <a:ext cx="329005" cy="175846"/>
           </a:xfrm>
           <a:prstGeom prst="rect">
             <a:avLst/>
@@ -7215,13 +7327,13 @@
       </p:sp>
       <p:sp>
         <p:nvSpPr>
-          <p:cNvPr id="8" name="TextBox 7"/>
-          <p:cNvSpPr txBox="1"/>
-          <p:nvPr/>
-        </p:nvSpPr>
-        <p:spPr>
-          <a:xfrm>
-            <a:off x="3790919" y="2176272"/>
+          <p:cNvPr id="11" name="TextBox 10"/>
+          <p:cNvSpPr txBox="1"/>
+          <p:nvPr/>
+        </p:nvSpPr>
+        <p:spPr>
+          <a:xfrm>
+            <a:off x="3803725" y="2489278"/>
             <a:ext cx="2286000" cy="313006"/>
           </a:xfrm>
           <a:prstGeom prst="rect">
@@ -7242,20 +7354,20 @@
                 </a:solidFill>
                 <a:latin typeface="Helvetica Neue"/>
               </a:rPr>
-              <a:t>13,206   (8 posts · 1,651 avg)</a:t>
-            </a:r>
-          </a:p>
-        </p:txBody>
-      </p:sp>
-      <p:sp>
-        <p:nvSpPr>
-          <p:cNvPr id="9" name="TextBox 8"/>
-          <p:cNvSpPr txBox="1"/>
-          <p:nvPr/>
-        </p:nvSpPr>
-        <p:spPr>
-          <a:xfrm>
-            <a:off x="731520" y="2489278"/>
+              <a:t>13,749   (12 posts · 1,146 avg)</a:t>
+            </a:r>
+          </a:p>
+        </p:txBody>
+      </p:sp>
+      <p:sp>
+        <p:nvSpPr>
+          <p:cNvPr id="12" name="TextBox 11"/>
+          <p:cNvSpPr txBox="1"/>
+          <p:nvPr/>
+        </p:nvSpPr>
+        <p:spPr>
+          <a:xfrm>
+            <a:off x="731520" y="2802284"/>
             <a:ext cx="2468880" cy="313006"/>
           </a:xfrm>
           <a:prstGeom prst="rect">
@@ -7276,21 +7388,21 @@
                 </a:solidFill>
                 <a:latin typeface="Helvetica Neue"/>
               </a:rPr>
-              <a:t>15. Lisette Scandal</a:t>
-            </a:r>
-          </a:p>
-        </p:txBody>
-      </p:sp>
-      <p:sp>
-        <p:nvSpPr>
-          <p:cNvPr id="10" name="Rectangle 9"/>
+              <a:t>16. AI Fake News</a:t>
+            </a:r>
+          </a:p>
+        </p:txBody>
+      </p:sp>
+      <p:sp>
+        <p:nvSpPr>
+          <p:cNvPr id="13" name="Rectangle 12"/>
           <p:cNvSpPr/>
           <p:nvPr/>
         </p:nvSpPr>
         <p:spPr>
           <a:xfrm>
-            <a:off x="3383280" y="2516710"/>
-            <a:ext cx="299750" cy="175846"/>
+            <a:off x="3383280" y="2829716"/>
+            <a:ext cx="316011" cy="175846"/>
           </a:xfrm>
           <a:prstGeom prst="rect">
             <a:avLst/>
@@ -7327,13 +7439,13 @@
       </p:sp>
       <p:sp>
         <p:nvSpPr>
-          <p:cNvPr id="11" name="TextBox 10"/>
-          <p:cNvSpPr txBox="1"/>
-          <p:nvPr/>
-        </p:nvSpPr>
-        <p:spPr>
-          <a:xfrm>
-            <a:off x="3774470" y="2489278"/>
+          <p:cNvPr id="14" name="TextBox 13"/>
+          <p:cNvSpPr txBox="1"/>
+          <p:nvPr/>
+        </p:nvSpPr>
+        <p:spPr>
+          <a:xfrm>
+            <a:off x="3790731" y="2802284"/>
             <a:ext cx="2286000" cy="313006"/>
           </a:xfrm>
           <a:prstGeom prst="rect">
@@ -7354,20 +7466,20 @@
                 </a:solidFill>
                 <a:latin typeface="Helvetica Neue"/>
               </a:rPr>
-              <a:t>12,519   (12 posts · 1,043 avg)</a:t>
-            </a:r>
-          </a:p>
-        </p:txBody>
-      </p:sp>
-      <p:sp>
-        <p:nvSpPr>
-          <p:cNvPr id="12" name="TextBox 11"/>
-          <p:cNvSpPr txBox="1"/>
-          <p:nvPr/>
-        </p:nvSpPr>
-        <p:spPr>
-          <a:xfrm>
-            <a:off x="731520" y="2802284"/>
+              <a:t>13,206   (8 posts · 1,651 avg)</a:t>
+            </a:r>
+          </a:p>
+        </p:txBody>
+      </p:sp>
+      <p:sp>
+        <p:nvSpPr>
+          <p:cNvPr id="15" name="TextBox 14"/>
+          <p:cNvSpPr txBox="1"/>
+          <p:nvPr/>
+        </p:nvSpPr>
+        <p:spPr>
+          <a:xfrm>
+            <a:off x="731520" y="3115290"/>
             <a:ext cx="2468880" cy="313006"/>
           </a:xfrm>
           <a:prstGeom prst="rect">
@@ -7388,21 +7500,21 @@
                 </a:solidFill>
                 <a:latin typeface="Helvetica Neue"/>
               </a:rPr>
-              <a:t>16. FIFA — Critique</a:t>
-            </a:r>
-          </a:p>
-        </p:txBody>
-      </p:sp>
-      <p:sp>
-        <p:nvSpPr>
-          <p:cNvPr id="13" name="Rectangle 12"/>
+              <a:t>17. FIFA — Critique</a:t>
+            </a:r>
+          </a:p>
+        </p:txBody>
+      </p:sp>
+      <p:sp>
+        <p:nvSpPr>
+          <p:cNvPr id="16" name="Rectangle 15"/>
           <p:cNvSpPr/>
           <p:nvPr/>
         </p:nvSpPr>
         <p:spPr>
           <a:xfrm>
-            <a:off x="3383280" y="2829716"/>
-            <a:ext cx="296373" cy="175846"/>
+            <a:off x="3383280" y="3142722"/>
+            <a:ext cx="299045" cy="175846"/>
           </a:xfrm>
           <a:prstGeom prst="rect">
             <a:avLst/>
@@ -7439,13 +7551,13 @@
       </p:sp>
       <p:sp>
         <p:nvSpPr>
-          <p:cNvPr id="14" name="TextBox 13"/>
-          <p:cNvSpPr txBox="1"/>
-          <p:nvPr/>
-        </p:nvSpPr>
-        <p:spPr>
-          <a:xfrm>
-            <a:off x="3771093" y="2802284"/>
+          <p:cNvPr id="17" name="TextBox 16"/>
+          <p:cNvSpPr txBox="1"/>
+          <p:nvPr/>
+        </p:nvSpPr>
+        <p:spPr>
+          <a:xfrm>
+            <a:off x="3773765" y="3115290"/>
             <a:ext cx="2286000" cy="313006"/>
           </a:xfrm>
           <a:prstGeom prst="rect">
@@ -7466,20 +7578,20 @@
                 </a:solidFill>
                 <a:latin typeface="Helvetica Neue"/>
               </a:rPr>
-              <a:t>12,378   (10 posts · 1,238 avg)</a:t>
-            </a:r>
-          </a:p>
-        </p:txBody>
-      </p:sp>
-      <p:sp>
-        <p:nvSpPr>
-          <p:cNvPr id="15" name="TextBox 14"/>
-          <p:cNvSpPr txBox="1"/>
-          <p:nvPr/>
-        </p:nvSpPr>
-        <p:spPr>
-          <a:xfrm>
-            <a:off x="731520" y="3115290"/>
+              <a:t>12,497   (10 posts · 1,250 avg)</a:t>
+            </a:r>
+          </a:p>
+        </p:txBody>
+      </p:sp>
+      <p:sp>
+        <p:nvSpPr>
+          <p:cNvPr id="18" name="TextBox 17"/>
+          <p:cNvSpPr txBox="1"/>
+          <p:nvPr/>
+        </p:nvSpPr>
+        <p:spPr>
+          <a:xfrm>
+            <a:off x="731520" y="3428296"/>
             <a:ext cx="2468880" cy="313006"/>
           </a:xfrm>
           <a:prstGeom prst="rect">
@@ -7500,21 +7612,133 @@
                 </a:solidFill>
                 <a:latin typeface="Helvetica Neue"/>
               </a:rPr>
-              <a:t>17. Sports</a:t>
-            </a:r>
-          </a:p>
-        </p:txBody>
-      </p:sp>
-      <p:sp>
-        <p:nvSpPr>
-          <p:cNvPr id="16" name="Rectangle 15"/>
+              <a:t>18. Legislation Watch</a:t>
+            </a:r>
+          </a:p>
+        </p:txBody>
+      </p:sp>
+      <p:sp>
+        <p:nvSpPr>
+          <p:cNvPr id="19" name="Rectangle 18"/>
           <p:cNvSpPr/>
           <p:nvPr/>
         </p:nvSpPr>
         <p:spPr>
           <a:xfrm>
-            <a:off x="3383280" y="3142722"/>
-            <a:ext cx="290220" cy="175846"/>
+            <a:off x="3383280" y="3455728"/>
+            <a:ext cx="290909" cy="175846"/>
+          </a:xfrm>
+          <a:prstGeom prst="rect">
+            <a:avLst/>
+          </a:prstGeom>
+          <a:solidFill>
+            <a:srgbClr val="2F3C7E"/>
+          </a:solidFill>
+          <a:ln>
+            <a:noFill/>
+          </a:ln>
+          <a:effectLst/>
+        </p:spPr>
+        <p:style>
+          <a:lnRef idx="1">
+            <a:schemeClr val="accent1"/>
+          </a:lnRef>
+          <a:fillRef idx="3">
+            <a:schemeClr val="accent1"/>
+          </a:fillRef>
+          <a:effectRef idx="2">
+            <a:schemeClr val="accent1"/>
+          </a:effectRef>
+          <a:fontRef idx="minor">
+            <a:schemeClr val="lt1"/>
+          </a:fontRef>
+        </p:style>
+        <p:txBody>
+          <a:bodyPr rtlCol="0" anchor="ctr"/>
+          <a:lstStyle/>
+          <a:p>
+            <a:pPr algn="ctr"/>
+          </a:p>
+        </p:txBody>
+      </p:sp>
+      <p:sp>
+        <p:nvSpPr>
+          <p:cNvPr id="20" name="TextBox 19"/>
+          <p:cNvSpPr txBox="1"/>
+          <p:nvPr/>
+        </p:nvSpPr>
+        <p:spPr>
+          <a:xfrm>
+            <a:off x="3765629" y="3428296"/>
+            <a:ext cx="2286000" cy="313006"/>
+          </a:xfrm>
+          <a:prstGeom prst="rect">
+            <a:avLst/>
+          </a:prstGeom>
+          <a:noFill/>
+        </p:spPr>
+        <p:txBody>
+          <a:bodyPr wrap="square" lIns="0" rIns="0" tIns="0" bIns="0">
+            <a:spAutoFit/>
+          </a:bodyPr>
+          <a:lstStyle/>
+          <a:p>
+            <a:r>
+              <a:rPr sz="1000" b="0">
+                <a:solidFill>
+                  <a:srgbClr val="6B7082"/>
+                </a:solidFill>
+                <a:latin typeface="Helvetica Neue"/>
+              </a:rPr>
+              <a:t>12,157   (25 posts · 486 avg)</a:t>
+            </a:r>
+          </a:p>
+        </p:txBody>
+      </p:sp>
+      <p:sp>
+        <p:nvSpPr>
+          <p:cNvPr id="21" name="TextBox 20"/>
+          <p:cNvSpPr txBox="1"/>
+          <p:nvPr/>
+        </p:nvSpPr>
+        <p:spPr>
+          <a:xfrm>
+            <a:off x="731520" y="3741302"/>
+            <a:ext cx="2468880" cy="313006"/>
+          </a:xfrm>
+          <a:prstGeom prst="rect">
+            <a:avLst/>
+          </a:prstGeom>
+          <a:noFill/>
+        </p:spPr>
+        <p:txBody>
+          <a:bodyPr wrap="square" lIns="0" rIns="0" tIns="0" bIns="0">
+            <a:spAutoFit/>
+          </a:bodyPr>
+          <a:lstStyle/>
+          <a:p>
+            <a:r>
+              <a:rPr sz="1100" b="0">
+                <a:solidFill>
+                  <a:srgbClr val="141833"/>
+                </a:solidFill>
+                <a:latin typeface="Helvetica Neue"/>
+              </a:rPr>
+              <a:t>19. Sports</a:t>
+            </a:r>
+          </a:p>
+        </p:txBody>
+      </p:sp>
+      <p:sp>
+        <p:nvSpPr>
+          <p:cNvPr id="22" name="Rectangle 21"/>
+          <p:cNvSpPr/>
+          <p:nvPr/>
+        </p:nvSpPr>
+        <p:spPr>
+          <a:xfrm>
+            <a:off x="3383280" y="3768734"/>
+            <a:ext cx="290048" cy="175846"/>
           </a:xfrm>
           <a:prstGeom prst="rect">
             <a:avLst/>
@@ -7551,13 +7775,13 @@
       </p:sp>
       <p:sp>
         <p:nvSpPr>
-          <p:cNvPr id="17" name="TextBox 16"/>
-          <p:cNvSpPr txBox="1"/>
-          <p:nvPr/>
-        </p:nvSpPr>
-        <p:spPr>
-          <a:xfrm>
-            <a:off x="3764940" y="3115290"/>
+          <p:cNvPr id="23" name="TextBox 22"/>
+          <p:cNvSpPr txBox="1"/>
+          <p:nvPr/>
+        </p:nvSpPr>
+        <p:spPr>
+          <a:xfrm>
+            <a:off x="3764768" y="3741302"/>
             <a:ext cx="2286000" cy="313006"/>
           </a:xfrm>
           <a:prstGeom prst="rect">
@@ -7585,13 +7809,13 @@
       </p:sp>
       <p:sp>
         <p:nvSpPr>
-          <p:cNvPr id="18" name="TextBox 17"/>
-          <p:cNvSpPr txBox="1"/>
-          <p:nvPr/>
-        </p:nvSpPr>
-        <p:spPr>
-          <a:xfrm>
-            <a:off x="731520" y="3428296"/>
+          <p:cNvPr id="24" name="TextBox 23"/>
+          <p:cNvSpPr txBox="1"/>
+          <p:nvPr/>
+        </p:nvSpPr>
+        <p:spPr>
+          <a:xfrm>
+            <a:off x="731520" y="4054308"/>
             <a:ext cx="2468880" cy="313006"/>
           </a:xfrm>
           <a:prstGeom prst="rect">
@@ -7612,21 +7836,133 @@
                 </a:solidFill>
                 <a:latin typeface="Helvetica Neue"/>
               </a:rPr>
-              <a:t>18. Resident Highlight</a:t>
-            </a:r>
-          </a:p>
-        </p:txBody>
-      </p:sp>
-      <p:sp>
-        <p:nvSpPr>
-          <p:cNvPr id="19" name="Rectangle 18"/>
+              <a:t>20. Downtown Nightlife</a:t>
+            </a:r>
+          </a:p>
+        </p:txBody>
+      </p:sp>
+      <p:sp>
+        <p:nvSpPr>
+          <p:cNvPr id="25" name="Rectangle 24"/>
           <p:cNvSpPr/>
           <p:nvPr/>
         </p:nvSpPr>
         <p:spPr>
           <a:xfrm>
-            <a:off x="3383280" y="3455728"/>
-            <a:ext cx="281121" cy="175846"/>
+            <a:off x="3383280" y="4081740"/>
+            <a:ext cx="281720" cy="175846"/>
+          </a:xfrm>
+          <a:prstGeom prst="rect">
+            <a:avLst/>
+          </a:prstGeom>
+          <a:solidFill>
+            <a:srgbClr val="990011"/>
+          </a:solidFill>
+          <a:ln>
+            <a:noFill/>
+          </a:ln>
+          <a:effectLst/>
+        </p:spPr>
+        <p:style>
+          <a:lnRef idx="1">
+            <a:schemeClr val="accent1"/>
+          </a:lnRef>
+          <a:fillRef idx="3">
+            <a:schemeClr val="accent1"/>
+          </a:fillRef>
+          <a:effectRef idx="2">
+            <a:schemeClr val="accent1"/>
+          </a:effectRef>
+          <a:fontRef idx="minor">
+            <a:schemeClr val="lt1"/>
+          </a:fontRef>
+        </p:style>
+        <p:txBody>
+          <a:bodyPr rtlCol="0" anchor="ctr"/>
+          <a:lstStyle/>
+          <a:p>
+            <a:pPr algn="ctr"/>
+          </a:p>
+        </p:txBody>
+      </p:sp>
+      <p:sp>
+        <p:nvSpPr>
+          <p:cNvPr id="26" name="TextBox 25"/>
+          <p:cNvSpPr txBox="1"/>
+          <p:nvPr/>
+        </p:nvSpPr>
+        <p:spPr>
+          <a:xfrm>
+            <a:off x="3756440" y="4054308"/>
+            <a:ext cx="2286000" cy="313006"/>
+          </a:xfrm>
+          <a:prstGeom prst="rect">
+            <a:avLst/>
+          </a:prstGeom>
+          <a:noFill/>
+        </p:spPr>
+        <p:txBody>
+          <a:bodyPr wrap="square" lIns="0" rIns="0" tIns="0" bIns="0">
+            <a:spAutoFit/>
+          </a:bodyPr>
+          <a:lstStyle/>
+          <a:p>
+            <a:r>
+              <a:rPr sz="1000" b="0">
+                <a:solidFill>
+                  <a:srgbClr val="6B7082"/>
+                </a:solidFill>
+                <a:latin typeface="Helvetica Neue"/>
+              </a:rPr>
+              <a:t>11,773   (7 posts · 1,682 avg)</a:t>
+            </a:r>
+          </a:p>
+        </p:txBody>
+      </p:sp>
+      <p:sp>
+        <p:nvSpPr>
+          <p:cNvPr id="27" name="TextBox 26"/>
+          <p:cNvSpPr txBox="1"/>
+          <p:nvPr/>
+        </p:nvSpPr>
+        <p:spPr>
+          <a:xfrm>
+            <a:off x="731520" y="4367315"/>
+            <a:ext cx="2468880" cy="313006"/>
+          </a:xfrm>
+          <a:prstGeom prst="rect">
+            <a:avLst/>
+          </a:prstGeom>
+          <a:noFill/>
+        </p:spPr>
+        <p:txBody>
+          <a:bodyPr wrap="square" lIns="0" rIns="0" tIns="0" bIns="0">
+            <a:spAutoFit/>
+          </a:bodyPr>
+          <a:lstStyle/>
+          <a:p>
+            <a:r>
+              <a:rPr sz="1100" b="0">
+                <a:solidFill>
+                  <a:srgbClr val="141833"/>
+                </a:solidFill>
+                <a:latin typeface="Helvetica Neue"/>
+              </a:rPr>
+              <a:t>21. Resident Highlight</a:t>
+            </a:r>
+          </a:p>
+        </p:txBody>
+      </p:sp>
+      <p:sp>
+        <p:nvSpPr>
+          <p:cNvPr id="28" name="Rectangle 27"/>
+          <p:cNvSpPr/>
+          <p:nvPr/>
+        </p:nvSpPr>
+        <p:spPr>
+          <a:xfrm>
+            <a:off x="3383280" y="4394747"/>
+            <a:ext cx="281601" cy="175846"/>
           </a:xfrm>
           <a:prstGeom prst="rect">
             <a:avLst/>
@@ -7663,13 +7999,13 @@
       </p:sp>
       <p:sp>
         <p:nvSpPr>
-          <p:cNvPr id="20" name="TextBox 19"/>
-          <p:cNvSpPr txBox="1"/>
-          <p:nvPr/>
-        </p:nvSpPr>
-        <p:spPr>
-          <a:xfrm>
-            <a:off x="3755841" y="3428296"/>
+          <p:cNvPr id="29" name="TextBox 28"/>
+          <p:cNvSpPr txBox="1"/>
+          <p:nvPr/>
+        </p:nvSpPr>
+        <p:spPr>
+          <a:xfrm>
+            <a:off x="3756321" y="4367315"/>
             <a:ext cx="2286000" cy="313006"/>
           </a:xfrm>
           <a:prstGeom prst="rect">
@@ -7690,20 +8026,20 @@
                 </a:solidFill>
                 <a:latin typeface="Helvetica Neue"/>
               </a:rPr>
-              <a:t>11,741   (13 posts · 903 avg)</a:t>
-            </a:r>
-          </a:p>
-        </p:txBody>
-      </p:sp>
-      <p:sp>
-        <p:nvSpPr>
-          <p:cNvPr id="21" name="TextBox 20"/>
-          <p:cNvSpPr txBox="1"/>
-          <p:nvPr/>
-        </p:nvSpPr>
-        <p:spPr>
-          <a:xfrm>
-            <a:off x="731520" y="3741302"/>
+              <a:t>11,768   (14 posts · 841 avg)</a:t>
+            </a:r>
+          </a:p>
+        </p:txBody>
+      </p:sp>
+      <p:sp>
+        <p:nvSpPr>
+          <p:cNvPr id="30" name="TextBox 29"/>
+          <p:cNvSpPr txBox="1"/>
+          <p:nvPr/>
+        </p:nvSpPr>
+        <p:spPr>
+          <a:xfrm>
+            <a:off x="731520" y="4680321"/>
             <a:ext cx="2468880" cy="313006"/>
           </a:xfrm>
           <a:prstGeom prst="rect">
@@ -7724,21 +8060,133 @@
                 </a:solidFill>
                 <a:latin typeface="Helvetica Neue"/>
               </a:rPr>
-              <a:t>19. Downtown Nightlife</a:t>
-            </a:r>
-          </a:p>
-        </p:txBody>
-      </p:sp>
-      <p:sp>
-        <p:nvSpPr>
-          <p:cNvPr id="22" name="Rectangle 21"/>
+              <a:t>22. State Policy</a:t>
+            </a:r>
+          </a:p>
+        </p:txBody>
+      </p:sp>
+      <p:sp>
+        <p:nvSpPr>
+          <p:cNvPr id="31" name="Rectangle 30"/>
           <p:cNvSpPr/>
           <p:nvPr/>
         </p:nvSpPr>
         <p:spPr>
           <a:xfrm>
-            <a:off x="3383280" y="3768734"/>
-            <a:ext cx="280331" cy="175846"/>
+            <a:off x="3383280" y="4707753"/>
+            <a:ext cx="218977" cy="175846"/>
+          </a:xfrm>
+          <a:prstGeom prst="rect">
+            <a:avLst/>
+          </a:prstGeom>
+          <a:solidFill>
+            <a:srgbClr val="2F3C7E"/>
+          </a:solidFill>
+          <a:ln>
+            <a:noFill/>
+          </a:ln>
+          <a:effectLst/>
+        </p:spPr>
+        <p:style>
+          <a:lnRef idx="1">
+            <a:schemeClr val="accent1"/>
+          </a:lnRef>
+          <a:fillRef idx="3">
+            <a:schemeClr val="accent1"/>
+          </a:fillRef>
+          <a:effectRef idx="2">
+            <a:schemeClr val="accent1"/>
+          </a:effectRef>
+          <a:fontRef idx="minor">
+            <a:schemeClr val="lt1"/>
+          </a:fontRef>
+        </p:style>
+        <p:txBody>
+          <a:bodyPr rtlCol="0" anchor="ctr"/>
+          <a:lstStyle/>
+          <a:p>
+            <a:pPr algn="ctr"/>
+          </a:p>
+        </p:txBody>
+      </p:sp>
+      <p:sp>
+        <p:nvSpPr>
+          <p:cNvPr id="32" name="TextBox 31"/>
+          <p:cNvSpPr txBox="1"/>
+          <p:nvPr/>
+        </p:nvSpPr>
+        <p:spPr>
+          <a:xfrm>
+            <a:off x="3693697" y="4680321"/>
+            <a:ext cx="2286000" cy="313006"/>
+          </a:xfrm>
+          <a:prstGeom prst="rect">
+            <a:avLst/>
+          </a:prstGeom>
+          <a:noFill/>
+        </p:spPr>
+        <p:txBody>
+          <a:bodyPr wrap="square" lIns="0" rIns="0" tIns="0" bIns="0">
+            <a:spAutoFit/>
+          </a:bodyPr>
+          <a:lstStyle/>
+          <a:p>
+            <a:r>
+              <a:rPr sz="1000" b="0">
+                <a:solidFill>
+                  <a:srgbClr val="6B7082"/>
+                </a:solidFill>
+                <a:latin typeface="Helvetica Neue"/>
+              </a:rPr>
+              <a:t>9,151   (18 posts · 508 avg)</a:t>
+            </a:r>
+          </a:p>
+        </p:txBody>
+      </p:sp>
+      <p:sp>
+        <p:nvSpPr>
+          <p:cNvPr id="33" name="TextBox 32"/>
+          <p:cNvSpPr txBox="1"/>
+          <p:nvPr/>
+        </p:nvSpPr>
+        <p:spPr>
+          <a:xfrm>
+            <a:off x="731520" y="4993327"/>
+            <a:ext cx="2468880" cy="313006"/>
+          </a:xfrm>
+          <a:prstGeom prst="rect">
+            <a:avLst/>
+          </a:prstGeom>
+          <a:noFill/>
+        </p:spPr>
+        <p:txBody>
+          <a:bodyPr wrap="square" lIns="0" rIns="0" tIns="0" bIns="0">
+            <a:spAutoFit/>
+          </a:bodyPr>
+          <a:lstStyle/>
+          <a:p>
+            <a:r>
+              <a:rPr sz="1100" b="0">
+                <a:solidFill>
+                  <a:srgbClr val="141833"/>
+                </a:solidFill>
+                <a:latin typeface="Helvetica Neue"/>
+              </a:rPr>
+              <a:t>23. ICE / Immigration</a:t>
+            </a:r>
+          </a:p>
+        </p:txBody>
+      </p:sp>
+      <p:sp>
+        <p:nvSpPr>
+          <p:cNvPr id="34" name="Rectangle 33"/>
+          <p:cNvSpPr/>
+          <p:nvPr/>
+        </p:nvSpPr>
+        <p:spPr>
+          <a:xfrm>
+            <a:off x="3383280" y="5020759"/>
+            <a:ext cx="210554" cy="175846"/>
           </a:xfrm>
           <a:prstGeom prst="rect">
             <a:avLst/>
@@ -7775,13 +8223,13 @@
       </p:sp>
       <p:sp>
         <p:nvSpPr>
-          <p:cNvPr id="23" name="TextBox 22"/>
-          <p:cNvSpPr txBox="1"/>
-          <p:nvPr/>
-        </p:nvSpPr>
-        <p:spPr>
-          <a:xfrm>
-            <a:off x="3755051" y="3741302"/>
+          <p:cNvPr id="35" name="TextBox 34"/>
+          <p:cNvSpPr txBox="1"/>
+          <p:nvPr/>
+        </p:nvSpPr>
+        <p:spPr>
+          <a:xfrm>
+            <a:off x="3685274" y="4993327"/>
             <a:ext cx="2286000" cy="313006"/>
           </a:xfrm>
           <a:prstGeom prst="rect">
@@ -7802,20 +8250,20 @@
                 </a:solidFill>
                 <a:latin typeface="Helvetica Neue"/>
               </a:rPr>
-              <a:t>11,708   (7 posts · 1,673 avg)</a:t>
-            </a:r>
-          </a:p>
-        </p:txBody>
-      </p:sp>
-      <p:sp>
-        <p:nvSpPr>
-          <p:cNvPr id="24" name="TextBox 23"/>
-          <p:cNvSpPr txBox="1"/>
-          <p:nvPr/>
-        </p:nvSpPr>
-        <p:spPr>
-          <a:xfrm>
-            <a:off x="731520" y="4054308"/>
+              <a:t>8,799   (7 posts · 1,257 avg)</a:t>
+            </a:r>
+          </a:p>
+        </p:txBody>
+      </p:sp>
+      <p:sp>
+        <p:nvSpPr>
+          <p:cNvPr id="36" name="TextBox 35"/>
+          <p:cNvSpPr txBox="1"/>
+          <p:nvPr/>
+        </p:nvSpPr>
+        <p:spPr>
+          <a:xfrm>
+            <a:off x="731520" y="5306333"/>
             <a:ext cx="2468880" cy="313006"/>
           </a:xfrm>
           <a:prstGeom prst="rect">
@@ -7836,245 +8284,21 @@
                 </a:solidFill>
                 <a:latin typeface="Helvetica Neue"/>
               </a:rPr>
-              <a:t>20. Legislation Watch</a:t>
-            </a:r>
-          </a:p>
-        </p:txBody>
-      </p:sp>
-      <p:sp>
-        <p:nvSpPr>
-          <p:cNvPr id="25" name="Rectangle 24"/>
+              <a:t>24. American Pride</a:t>
+            </a:r>
+          </a:p>
+        </p:txBody>
+      </p:sp>
+      <p:sp>
+        <p:nvSpPr>
+          <p:cNvPr id="37" name="Rectangle 36"/>
           <p:cNvSpPr/>
           <p:nvPr/>
         </p:nvSpPr>
         <p:spPr>
           <a:xfrm>
-            <a:off x="3383280" y="4081740"/>
-            <a:ext cx="260817" cy="175846"/>
-          </a:xfrm>
-          <a:prstGeom prst="rect">
-            <a:avLst/>
-          </a:prstGeom>
-          <a:solidFill>
-            <a:srgbClr val="2F3C7E"/>
-          </a:solidFill>
-          <a:ln>
-            <a:noFill/>
-          </a:ln>
-          <a:effectLst/>
-        </p:spPr>
-        <p:style>
-          <a:lnRef idx="1">
-            <a:schemeClr val="accent1"/>
-          </a:lnRef>
-          <a:fillRef idx="3">
-            <a:schemeClr val="accent1"/>
-          </a:fillRef>
-          <a:effectRef idx="2">
-            <a:schemeClr val="accent1"/>
-          </a:effectRef>
-          <a:fontRef idx="minor">
-            <a:schemeClr val="lt1"/>
-          </a:fontRef>
-        </p:style>
-        <p:txBody>
-          <a:bodyPr rtlCol="0" anchor="ctr"/>
-          <a:lstStyle/>
-          <a:p>
-            <a:pPr algn="ctr"/>
-          </a:p>
-        </p:txBody>
-      </p:sp>
-      <p:sp>
-        <p:nvSpPr>
-          <p:cNvPr id="26" name="TextBox 25"/>
-          <p:cNvSpPr txBox="1"/>
-          <p:nvPr/>
-        </p:nvSpPr>
-        <p:spPr>
-          <a:xfrm>
-            <a:off x="3735537" y="4054308"/>
-            <a:ext cx="2286000" cy="313006"/>
-          </a:xfrm>
-          <a:prstGeom prst="rect">
-            <a:avLst/>
-          </a:prstGeom>
-          <a:noFill/>
-        </p:spPr>
-        <p:txBody>
-          <a:bodyPr wrap="square" lIns="0" rIns="0" tIns="0" bIns="0">
-            <a:spAutoFit/>
-          </a:bodyPr>
-          <a:lstStyle/>
-          <a:p>
-            <a:r>
-              <a:rPr sz="1000" b="0">
-                <a:solidFill>
-                  <a:srgbClr val="6B7082"/>
-                </a:solidFill>
-                <a:latin typeface="Helvetica Neue"/>
-              </a:rPr>
-              <a:t>10,893   (25 posts · 436 avg)</a:t>
-            </a:r>
-          </a:p>
-        </p:txBody>
-      </p:sp>
-      <p:sp>
-        <p:nvSpPr>
-          <p:cNvPr id="27" name="TextBox 26"/>
-          <p:cNvSpPr txBox="1"/>
-          <p:nvPr/>
-        </p:nvSpPr>
-        <p:spPr>
-          <a:xfrm>
-            <a:off x="731520" y="4367315"/>
-            <a:ext cx="2468880" cy="313006"/>
-          </a:xfrm>
-          <a:prstGeom prst="rect">
-            <a:avLst/>
-          </a:prstGeom>
-          <a:noFill/>
-        </p:spPr>
-        <p:txBody>
-          <a:bodyPr wrap="square" lIns="0" rIns="0" tIns="0" bIns="0">
-            <a:spAutoFit/>
-          </a:bodyPr>
-          <a:lstStyle/>
-          <a:p>
-            <a:r>
-              <a:rPr sz="1100" b="0">
-                <a:solidFill>
-                  <a:srgbClr val="141833"/>
-                </a:solidFill>
-                <a:latin typeface="Helvetica Neue"/>
-              </a:rPr>
-              <a:t>21. State Policy</a:t>
-            </a:r>
-          </a:p>
-        </p:txBody>
-      </p:sp>
-      <p:sp>
-        <p:nvSpPr>
-          <p:cNvPr id="28" name="Rectangle 27"/>
-          <p:cNvSpPr/>
-          <p:nvPr/>
-        </p:nvSpPr>
-        <p:spPr>
-          <a:xfrm>
-            <a:off x="3383280" y="4394747"/>
-            <a:ext cx="210895" cy="175846"/>
-          </a:xfrm>
-          <a:prstGeom prst="rect">
-            <a:avLst/>
-          </a:prstGeom>
-          <a:solidFill>
-            <a:srgbClr val="2F3C7E"/>
-          </a:solidFill>
-          <a:ln>
-            <a:noFill/>
-          </a:ln>
-          <a:effectLst/>
-        </p:spPr>
-        <p:style>
-          <a:lnRef idx="1">
-            <a:schemeClr val="accent1"/>
-          </a:lnRef>
-          <a:fillRef idx="3">
-            <a:schemeClr val="accent1"/>
-          </a:fillRef>
-          <a:effectRef idx="2">
-            <a:schemeClr val="accent1"/>
-          </a:effectRef>
-          <a:fontRef idx="minor">
-            <a:schemeClr val="lt1"/>
-          </a:fontRef>
-        </p:style>
-        <p:txBody>
-          <a:bodyPr rtlCol="0" anchor="ctr"/>
-          <a:lstStyle/>
-          <a:p>
-            <a:pPr algn="ctr"/>
-          </a:p>
-        </p:txBody>
-      </p:sp>
-      <p:sp>
-        <p:nvSpPr>
-          <p:cNvPr id="29" name="TextBox 28"/>
-          <p:cNvSpPr txBox="1"/>
-          <p:nvPr/>
-        </p:nvSpPr>
-        <p:spPr>
-          <a:xfrm>
-            <a:off x="3685615" y="4367315"/>
-            <a:ext cx="2286000" cy="313006"/>
-          </a:xfrm>
-          <a:prstGeom prst="rect">
-            <a:avLst/>
-          </a:prstGeom>
-          <a:noFill/>
-        </p:spPr>
-        <p:txBody>
-          <a:bodyPr wrap="square" lIns="0" rIns="0" tIns="0" bIns="0">
-            <a:spAutoFit/>
-          </a:bodyPr>
-          <a:lstStyle/>
-          <a:p>
-            <a:r>
-              <a:rPr sz="1000" b="0">
-                <a:solidFill>
-                  <a:srgbClr val="6B7082"/>
-                </a:solidFill>
-                <a:latin typeface="Helvetica Neue"/>
-              </a:rPr>
-              <a:t>8,808   (17 posts · 518 avg)</a:t>
-            </a:r>
-          </a:p>
-        </p:txBody>
-      </p:sp>
-      <p:sp>
-        <p:nvSpPr>
-          <p:cNvPr id="30" name="TextBox 29"/>
-          <p:cNvSpPr txBox="1"/>
-          <p:nvPr/>
-        </p:nvSpPr>
-        <p:spPr>
-          <a:xfrm>
-            <a:off x="731520" y="4680321"/>
-            <a:ext cx="2468880" cy="313006"/>
-          </a:xfrm>
-          <a:prstGeom prst="rect">
-            <a:avLst/>
-          </a:prstGeom>
-          <a:noFill/>
-        </p:spPr>
-        <p:txBody>
-          <a:bodyPr wrap="square" lIns="0" rIns="0" tIns="0" bIns="0">
-            <a:spAutoFit/>
-          </a:bodyPr>
-          <a:lstStyle/>
-          <a:p>
-            <a:r>
-              <a:rPr sz="1100" b="0">
-                <a:solidFill>
-                  <a:srgbClr val="141833"/>
-                </a:solidFill>
-                <a:latin typeface="Helvetica Neue"/>
-              </a:rPr>
-              <a:t>22. American Pride</a:t>
-            </a:r>
-          </a:p>
-        </p:txBody>
-      </p:sp>
-      <p:sp>
-        <p:nvSpPr>
-          <p:cNvPr id="31" name="Rectangle 30"/>
-          <p:cNvSpPr/>
-          <p:nvPr/>
-        </p:nvSpPr>
-        <p:spPr>
-          <a:xfrm>
-            <a:off x="3383280" y="4707753"/>
-            <a:ext cx="186017" cy="175846"/>
+            <a:off x="3383280" y="5333765"/>
+            <a:ext cx="208281" cy="175846"/>
           </a:xfrm>
           <a:prstGeom prst="rect">
             <a:avLst/>
@@ -8111,13 +8335,13 @@
       </p:sp>
       <p:sp>
         <p:nvSpPr>
-          <p:cNvPr id="32" name="TextBox 31"/>
-          <p:cNvSpPr txBox="1"/>
-          <p:nvPr/>
-        </p:nvSpPr>
-        <p:spPr>
-          <a:xfrm>
-            <a:off x="3660737" y="4680321"/>
+          <p:cNvPr id="38" name="TextBox 37"/>
+          <p:cNvSpPr txBox="1"/>
+          <p:nvPr/>
+        </p:nvSpPr>
+        <p:spPr>
+          <a:xfrm>
+            <a:off x="3683001" y="5306333"/>
             <a:ext cx="2286000" cy="313006"/>
           </a:xfrm>
           <a:prstGeom prst="rect">
@@ -8138,20 +8362,20 @@
                 </a:solidFill>
                 <a:latin typeface="Helvetica Neue"/>
               </a:rPr>
-              <a:t>7,769   (15 posts · 518 avg)</a:t>
-            </a:r>
-          </a:p>
-        </p:txBody>
-      </p:sp>
-      <p:sp>
-        <p:nvSpPr>
-          <p:cNvPr id="33" name="TextBox 32"/>
-          <p:cNvSpPr txBox="1"/>
-          <p:nvPr/>
-        </p:nvSpPr>
-        <p:spPr>
-          <a:xfrm>
-            <a:off x="731520" y="4993327"/>
+              <a:t>8,704   (16 posts · 544 avg)</a:t>
+            </a:r>
+          </a:p>
+        </p:txBody>
+      </p:sp>
+      <p:sp>
+        <p:nvSpPr>
+          <p:cNvPr id="39" name="TextBox 38"/>
+          <p:cNvSpPr txBox="1"/>
+          <p:nvPr/>
+        </p:nvSpPr>
+        <p:spPr>
+          <a:xfrm>
+            <a:off x="731520" y="5619339"/>
             <a:ext cx="2468880" cy="313006"/>
           </a:xfrm>
           <a:prstGeom prst="rect">
@@ -8172,133 +8396,21 @@
                 </a:solidFill>
                 <a:latin typeface="Helvetica Neue"/>
               </a:rPr>
-              <a:t>23. ICE / Immigration</a:t>
-            </a:r>
-          </a:p>
-        </p:txBody>
-      </p:sp>
-      <p:sp>
-        <p:nvSpPr>
-          <p:cNvPr id="34" name="Rectangle 33"/>
+              <a:t>25. Leadership &amp; Life</a:t>
+            </a:r>
+          </a:p>
+        </p:txBody>
+      </p:sp>
+      <p:sp>
+        <p:nvSpPr>
+          <p:cNvPr id="40" name="Rectangle 39"/>
           <p:cNvSpPr/>
           <p:nvPr/>
         </p:nvSpPr>
         <p:spPr>
           <a:xfrm>
-            <a:off x="3383280" y="5020759"/>
-            <a:ext cx="161020" cy="175846"/>
-          </a:xfrm>
-          <a:prstGeom prst="rect">
-            <a:avLst/>
-          </a:prstGeom>
-          <a:solidFill>
-            <a:srgbClr val="990011"/>
-          </a:solidFill>
-          <a:ln>
-            <a:noFill/>
-          </a:ln>
-          <a:effectLst/>
-        </p:spPr>
-        <p:style>
-          <a:lnRef idx="1">
-            <a:schemeClr val="accent1"/>
-          </a:lnRef>
-          <a:fillRef idx="3">
-            <a:schemeClr val="accent1"/>
-          </a:fillRef>
-          <a:effectRef idx="2">
-            <a:schemeClr val="accent1"/>
-          </a:effectRef>
-          <a:fontRef idx="minor">
-            <a:schemeClr val="lt1"/>
-          </a:fontRef>
-        </p:style>
-        <p:txBody>
-          <a:bodyPr rtlCol="0" anchor="ctr"/>
-          <a:lstStyle/>
-          <a:p>
-            <a:pPr algn="ctr"/>
-          </a:p>
-        </p:txBody>
-      </p:sp>
-      <p:sp>
-        <p:nvSpPr>
-          <p:cNvPr id="35" name="TextBox 34"/>
-          <p:cNvSpPr txBox="1"/>
-          <p:nvPr/>
-        </p:nvSpPr>
-        <p:spPr>
-          <a:xfrm>
-            <a:off x="3635740" y="4993327"/>
-            <a:ext cx="2286000" cy="313006"/>
-          </a:xfrm>
-          <a:prstGeom prst="rect">
-            <a:avLst/>
-          </a:prstGeom>
-          <a:noFill/>
-        </p:spPr>
-        <p:txBody>
-          <a:bodyPr wrap="square" lIns="0" rIns="0" tIns="0" bIns="0">
-            <a:spAutoFit/>
-          </a:bodyPr>
-          <a:lstStyle/>
-          <a:p>
-            <a:r>
-              <a:rPr sz="1000" b="0">
-                <a:solidFill>
-                  <a:srgbClr val="6B7082"/>
-                </a:solidFill>
-                <a:latin typeface="Helvetica Neue"/>
-              </a:rPr>
-              <a:t>6,725   (5 posts · 1,345 avg)</a:t>
-            </a:r>
-          </a:p>
-        </p:txBody>
-      </p:sp>
-      <p:sp>
-        <p:nvSpPr>
-          <p:cNvPr id="36" name="TextBox 35"/>
-          <p:cNvSpPr txBox="1"/>
-          <p:nvPr/>
-        </p:nvSpPr>
-        <p:spPr>
-          <a:xfrm>
-            <a:off x="731520" y="5306333"/>
-            <a:ext cx="2468880" cy="313006"/>
-          </a:xfrm>
-          <a:prstGeom prst="rect">
-            <a:avLst/>
-          </a:prstGeom>
-          <a:noFill/>
-        </p:spPr>
-        <p:txBody>
-          <a:bodyPr wrap="square" lIns="0" rIns="0" tIns="0" bIns="0">
-            <a:spAutoFit/>
-          </a:bodyPr>
-          <a:lstStyle/>
-          <a:p>
-            <a:r>
-              <a:rPr sz="1100" b="0">
-                <a:solidFill>
-                  <a:srgbClr val="141833"/>
-                </a:solidFill>
-                <a:latin typeface="Helvetica Neue"/>
-              </a:rPr>
-              <a:t>24. Leadership &amp; Life</a:t>
-            </a:r>
-          </a:p>
-        </p:txBody>
-      </p:sp>
-      <p:sp>
-        <p:nvSpPr>
-          <p:cNvPr id="37" name="Rectangle 36"/>
-          <p:cNvSpPr/>
-          <p:nvPr/>
-        </p:nvSpPr>
-        <p:spPr>
-          <a:xfrm>
-            <a:off x="3383280" y="5333765"/>
-            <a:ext cx="144858" cy="175846"/>
+            <a:off x="3383280" y="5646771"/>
+            <a:ext cx="144772" cy="175846"/>
           </a:xfrm>
           <a:prstGeom prst="rect">
             <a:avLst/>
@@ -8335,13 +8447,13 @@
       </p:sp>
       <p:sp>
         <p:nvSpPr>
-          <p:cNvPr id="38" name="TextBox 37"/>
-          <p:cNvSpPr txBox="1"/>
-          <p:nvPr/>
-        </p:nvSpPr>
-        <p:spPr>
-          <a:xfrm>
-            <a:off x="3619578" y="5306333"/>
+          <p:cNvPr id="41" name="TextBox 40"/>
+          <p:cNvSpPr txBox="1"/>
+          <p:nvPr/>
+        </p:nvSpPr>
+        <p:spPr>
+          <a:xfrm>
+            <a:off x="3619492" y="5619339"/>
             <a:ext cx="2286000" cy="313006"/>
           </a:xfrm>
           <a:prstGeom prst="rect">
@@ -8369,13 +8481,13 @@
       </p:sp>
       <p:sp>
         <p:nvSpPr>
-          <p:cNvPr id="39" name="TextBox 38"/>
-          <p:cNvSpPr txBox="1"/>
-          <p:nvPr/>
-        </p:nvSpPr>
-        <p:spPr>
-          <a:xfrm>
-            <a:off x="731520" y="5619339"/>
+          <p:cNvPr id="42" name="TextBox 41"/>
+          <p:cNvSpPr txBox="1"/>
+          <p:nvPr/>
+        </p:nvSpPr>
+        <p:spPr>
+          <a:xfrm>
+            <a:off x="731520" y="5932345"/>
             <a:ext cx="2468880" cy="313006"/>
           </a:xfrm>
           <a:prstGeom prst="rect">
@@ -8396,21 +8508,21 @@
                 </a:solidFill>
                 <a:latin typeface="Helvetica Neue"/>
               </a:rPr>
-              <a:t>25. Brand Growth</a:t>
-            </a:r>
-          </a:p>
-        </p:txBody>
-      </p:sp>
-      <p:sp>
-        <p:nvSpPr>
-          <p:cNvPr id="40" name="Rectangle 39"/>
+              <a:t>26. Brand Growth</a:t>
+            </a:r>
+          </a:p>
+        </p:txBody>
+      </p:sp>
+      <p:sp>
+        <p:nvSpPr>
+          <p:cNvPr id="43" name="Rectangle 42"/>
           <p:cNvSpPr/>
           <p:nvPr/>
         </p:nvSpPr>
         <p:spPr>
           <a:xfrm>
-            <a:off x="3383280" y="5646771"/>
-            <a:ext cx="53011" cy="175846"/>
+            <a:off x="3383280" y="5959777"/>
+            <a:ext cx="52979" cy="175846"/>
           </a:xfrm>
           <a:prstGeom prst="rect">
             <a:avLst/>
@@ -8447,13 +8559,13 @@
       </p:sp>
       <p:sp>
         <p:nvSpPr>
-          <p:cNvPr id="41" name="TextBox 40"/>
-          <p:cNvSpPr txBox="1"/>
-          <p:nvPr/>
-        </p:nvSpPr>
-        <p:spPr>
-          <a:xfrm>
-            <a:off x="3527731" y="5619339"/>
+          <p:cNvPr id="44" name="TextBox 43"/>
+          <p:cNvSpPr txBox="1"/>
+          <p:nvPr/>
+        </p:nvSpPr>
+        <p:spPr>
+          <a:xfrm>
+            <a:off x="3527699" y="5932345"/>
             <a:ext cx="2286000" cy="313006"/>
           </a:xfrm>
           <a:prstGeom prst="rect">
@@ -8475,118 +8587,6 @@
                 <a:latin typeface="Helvetica Neue"/>
               </a:rPr>
               <a:t>2,214   (4 posts · 554 avg)</a:t>
-            </a:r>
-          </a:p>
-        </p:txBody>
-      </p:sp>
-      <p:sp>
-        <p:nvSpPr>
-          <p:cNvPr id="42" name="TextBox 41"/>
-          <p:cNvSpPr txBox="1"/>
-          <p:nvPr/>
-        </p:nvSpPr>
-        <p:spPr>
-          <a:xfrm>
-            <a:off x="731520" y="5932345"/>
-            <a:ext cx="2468880" cy="313006"/>
-          </a:xfrm>
-          <a:prstGeom prst="rect">
-            <a:avLst/>
-          </a:prstGeom>
-          <a:noFill/>
-        </p:spPr>
-        <p:txBody>
-          <a:bodyPr wrap="square" lIns="0" rIns="0" tIns="0" bIns="0">
-            <a:spAutoFit/>
-          </a:bodyPr>
-          <a:lstStyle/>
-          <a:p>
-            <a:r>
-              <a:rPr sz="1100" b="0">
-                <a:solidFill>
-                  <a:srgbClr val="141833"/>
-                </a:solidFill>
-                <a:latin typeface="Helvetica Neue"/>
-              </a:rPr>
-              <a:t>26. Other</a:t>
-            </a:r>
-          </a:p>
-        </p:txBody>
-      </p:sp>
-      <p:sp>
-        <p:nvSpPr>
-          <p:cNvPr id="43" name="Rectangle 42"/>
-          <p:cNvSpPr/>
-          <p:nvPr/>
-        </p:nvSpPr>
-        <p:spPr>
-          <a:xfrm>
-            <a:off x="3383280" y="5959777"/>
-            <a:ext cx="45720" cy="175846"/>
-          </a:xfrm>
-          <a:prstGeom prst="rect">
-            <a:avLst/>
-          </a:prstGeom>
-          <a:solidFill>
-            <a:srgbClr val="6B7082"/>
-          </a:solidFill>
-          <a:ln>
-            <a:noFill/>
-          </a:ln>
-          <a:effectLst/>
-        </p:spPr>
-        <p:style>
-          <a:lnRef idx="1">
-            <a:schemeClr val="accent1"/>
-          </a:lnRef>
-          <a:fillRef idx="3">
-            <a:schemeClr val="accent1"/>
-          </a:fillRef>
-          <a:effectRef idx="2">
-            <a:schemeClr val="accent1"/>
-          </a:effectRef>
-          <a:fontRef idx="minor">
-            <a:schemeClr val="lt1"/>
-          </a:fontRef>
-        </p:style>
-        <p:txBody>
-          <a:bodyPr rtlCol="0" anchor="ctr"/>
-          <a:lstStyle/>
-          <a:p>
-            <a:pPr algn="ctr"/>
-          </a:p>
-        </p:txBody>
-      </p:sp>
-      <p:sp>
-        <p:nvSpPr>
-          <p:cNvPr id="44" name="TextBox 43"/>
-          <p:cNvSpPr txBox="1"/>
-          <p:nvPr/>
-        </p:nvSpPr>
-        <p:spPr>
-          <a:xfrm>
-            <a:off x="3520440" y="5932345"/>
-            <a:ext cx="2286000" cy="313006"/>
-          </a:xfrm>
-          <a:prstGeom prst="rect">
-            <a:avLst/>
-          </a:prstGeom>
-          <a:noFill/>
-        </p:spPr>
-        <p:txBody>
-          <a:bodyPr wrap="square" lIns="0" rIns="0" tIns="0" bIns="0">
-            <a:spAutoFit/>
-          </a:bodyPr>
-          <a:lstStyle/>
-          <a:p>
-            <a:r>
-              <a:rPr sz="1000" b="0">
-                <a:solidFill>
-                  <a:srgbClr val="6B7082"/>
-                </a:solidFill>
-                <a:latin typeface="Helvetica Neue"/>
-              </a:rPr>
-              <a:t>1,297   (25 posts · 52 avg)</a:t>
             </a:r>
           </a:p>
         </p:txBody>
@@ -9932,7 +9932,7 @@
                 </a:solidFill>
                 <a:latin typeface="Helvetica Neue"/>
               </a:rPr>
-              <a:t>TT</a:t>
+              <a:t>IG</a:t>
             </a:r>
           </a:p>
         </p:txBody>
@@ -9966,7 +9966,7 @@
                 </a:solidFill>
                 <a:latin typeface="Helvetica Neue"/>
               </a:rPr>
-              <a:t>Get ready! Round One is taking over the old Sears at Stonewood Mall. This massiv</a:t>
+              <a:t>After 15 years in the trucking industry, one truth stands out: regulations can p</a:t>
             </a:r>
           </a:p>
         </p:txBody>
@@ -10000,7 +10000,7 @@
                 </a:solidFill>
                 <a:latin typeface="Helvetica Neue"/>
               </a:rPr>
-              <a:t>29,200</a:t>
+              <a:t>29,293</a:t>
             </a:r>
           </a:p>
         </p:txBody>
@@ -10034,7 +10034,7 @@
                 </a:solidFill>
                 <a:latin typeface="Helvetica Neue"/>
               </a:rPr>
-              <a:t>2,513</a:t>
+              <a:t>1,942</a:t>
             </a:r>
           </a:p>
         </p:txBody>
@@ -10068,7 +10068,7 @@
                 </a:solidFill>
                 <a:latin typeface="Helvetica Neue"/>
               </a:rPr>
-              <a:t>Downtown Development</a:t>
+              <a:t>Other</a:t>
             </a:r>
           </a:p>
         </p:txBody>
@@ -10170,7 +10170,7 @@
                 </a:solidFill>
                 <a:latin typeface="Helvetica Neue"/>
               </a:rPr>
-              <a:t>Watch party in Stonewood Mall! Over 25,000 people showed up for this epic event.</a:t>
+              <a:t>Get ready! Round One is taking over the old Sears at Stonewood Mall. This massiv</a:t>
             </a:r>
           </a:p>
         </p:txBody>
@@ -10204,7 +10204,7 @@
                 </a:solidFill>
                 <a:latin typeface="Helvetica Neue"/>
               </a:rPr>
-              <a:t>27,400</a:t>
+              <a:t>29,200</a:t>
             </a:r>
           </a:p>
         </p:txBody>
@@ -10238,7 +10238,7 @@
                 </a:solidFill>
                 <a:latin typeface="Helvetica Neue"/>
               </a:rPr>
-              <a:t>806</a:t>
+              <a:t>2,513</a:t>
             </a:r>
           </a:p>
         </p:txBody>
@@ -10272,7 +10272,7 @@
                 </a:solidFill>
                 <a:latin typeface="Helvetica Neue"/>
               </a:rPr>
-              <a:t>Fifa Positive</a:t>
+              <a:t>Downtown Development</a:t>
             </a:r>
           </a:p>
         </p:txBody>
@@ -10418,7 +10418,7 @@
                 </a:solidFill>
                 <a:latin typeface="Helvetica Neue"/>
               </a:rPr>
-              <a:t>From Las Vegas to Battalion Commander: A journey fueled by college dreams and mi</a:t>
+              <a:t>Watch party in Stonewood Mall! Over 25,000 people showed up for this epic event.</a:t>
             </a:r>
           </a:p>
         </p:txBody>
@@ -10452,7 +10452,7 @@
                 </a:solidFill>
                 <a:latin typeface="Helvetica Neue"/>
               </a:rPr>
-              <a:t>22,600</a:t>
+              <a:t>27,400</a:t>
             </a:r>
           </a:p>
         </p:txBody>
@@ -10486,7 +10486,7 @@
                 </a:solidFill>
                 <a:latin typeface="Helvetica Neue"/>
               </a:rPr>
-              <a:t>805</a:t>
+              <a:t>806</a:t>
             </a:r>
           </a:p>
         </p:txBody>
@@ -10520,7 +10520,7 @@
                 </a:solidFill>
                 <a:latin typeface="Helvetica Neue"/>
               </a:rPr>
-              <a:t>Military Service</a:t>
+              <a:t>Fifa Positive</a:t>
             </a:r>
           </a:p>
         </p:txBody>
@@ -10622,7 +10622,7 @@
                 </a:solidFill>
                 <a:latin typeface="Helvetica Neue"/>
               </a:rPr>
-              <a:t>Mama Lu's is coming to Downey! Asian community favorite, famous for their tender</a:t>
+              <a:t>From Las Vegas to Battalion Commander: A journey fueled by college dreams and mi</a:t>
             </a:r>
           </a:p>
         </p:txBody>
@@ -10656,7 +10656,7 @@
                 </a:solidFill>
                 <a:latin typeface="Helvetica Neue"/>
               </a:rPr>
-              <a:t>13,600</a:t>
+              <a:t>22,600</a:t>
             </a:r>
           </a:p>
         </p:txBody>
@@ -10690,7 +10690,7 @@
                 </a:solidFill>
                 <a:latin typeface="Helvetica Neue"/>
               </a:rPr>
-              <a:t>951</a:t>
+              <a:t>805</a:t>
             </a:r>
           </a:p>
         </p:txBody>
@@ -10724,7 +10724,7 @@
                 </a:solidFill>
                 <a:latin typeface="Helvetica Neue"/>
               </a:rPr>
-              <a:t>Food</a:t>
+              <a:t>Military Service</a:t>
             </a:r>
           </a:p>
         </p:txBody>
@@ -10836,7 +10836,7 @@
                 </a:solidFill>
                 <a:latin typeface="Helvetica Neue"/>
               </a:rPr>
-              <a:t>FB</a:t>
+              <a:t>IG</a:t>
             </a:r>
           </a:p>
         </p:txBody>
@@ -10870,7 +10870,7 @@
                 </a:solidFill>
                 <a:latin typeface="Helvetica Neue"/>
               </a:rPr>
-              <a:t>Chaos erupted at a council meeting when Ms. Rivera began screaming, refusing to </a:t>
+              <a:t>California went from a surplus to a deficit. When spending outpaces revenue, fam</a:t>
             </a:r>
           </a:p>
         </p:txBody>
@@ -10904,7 +10904,7 @@
                 </a:solidFill>
                 <a:latin typeface="Helvetica Neue"/>
               </a:rPr>
-              <a:t>11,860</a:t>
+              <a:t>16,915</a:t>
             </a:r>
           </a:p>
         </p:txBody>
@@ -10938,7 +10938,7 @@
                 </a:solidFill>
                 <a:latin typeface="Helvetica Neue"/>
               </a:rPr>
-              <a:t>47</a:t>
+              <a:t>946</a:t>
             </a:r>
           </a:p>
         </p:txBody>
@@ -10972,7 +10972,7 @@
                 </a:solidFill>
                 <a:latin typeface="Helvetica Neue"/>
               </a:rPr>
-              <a:t>Politics Other</a:t>
+              <a:t>Other</a:t>
             </a:r>
           </a:p>
         </p:txBody>
@@ -11074,7 +11074,7 @@
                 </a:solidFill>
                 <a:latin typeface="Helvetica Neue"/>
               </a:rPr>
-              <a:t>Grew up in Huntington Park and still own property there. The city's o...</a:t>
+              <a:t>Mama Lu's is coming to Downey! Asian community favorite, famous for their tender</a:t>
             </a:r>
           </a:p>
         </p:txBody>
@@ -11108,7 +11108,7 @@
                 </a:solidFill>
                 <a:latin typeface="Helvetica Neue"/>
               </a:rPr>
-              <a:t>9,839</a:t>
+              <a:t>13,600</a:t>
             </a:r>
           </a:p>
         </p:txBody>
@@ -11142,7 +11142,7 @@
                 </a:solidFill>
                 <a:latin typeface="Helvetica Neue"/>
               </a:rPr>
-              <a:t>548</a:t>
+              <a:t>951</a:t>
             </a:r>
           </a:p>
         </p:txBody>
@@ -11176,7 +11176,7 @@
                 </a:solidFill>
                 <a:latin typeface="Helvetica Neue"/>
               </a:rPr>
-              <a:t>Trujillo Scandal</a:t>
+              <a:t>Food</a:t>
             </a:r>
           </a:p>
         </p:txBody>
@@ -11288,7 +11288,7 @@
                 </a:solidFill>
                 <a:latin typeface="Helvetica Neue"/>
               </a:rPr>
-              <a:t>TT</a:t>
+              <a:t>FB</a:t>
             </a:r>
           </a:p>
         </p:txBody>
@@ -11322,7 +11322,7 @@
                 </a:solidFill>
                 <a:latin typeface="Helvetica Neue"/>
               </a:rPr>
-              <a:t>Pop's Wings just opened and it's a must-try! Their pastrami sandwich with sweet </a:t>
+              <a:t>Chaos erupted at a council meeting when Ms. Rivera began screaming, refusing to </a:t>
             </a:r>
           </a:p>
         </p:txBody>
@@ -11356,7 +11356,7 @@
                 </a:solidFill>
                 <a:latin typeface="Helvetica Neue"/>
               </a:rPr>
-              <a:t>8,352</a:t>
+              <a:t>11,860</a:t>
             </a:r>
           </a:p>
         </p:txBody>
@@ -11390,7 +11390,7 @@
                 </a:solidFill>
                 <a:latin typeface="Helvetica Neue"/>
               </a:rPr>
-              <a:t>405</a:t>
+              <a:t>47</a:t>
             </a:r>
           </a:p>
         </p:txBody>
@@ -11424,7 +11424,7 @@
                 </a:solidFill>
                 <a:latin typeface="Helvetica Neue"/>
               </a:rPr>
-              <a:t>Food</a:t>
+              <a:t>Politics Other</a:t>
             </a:r>
           </a:p>
         </p:txBody>

</xml_diff>